<commit_message>
Redraw the build-flow schematic; restyle the deck to light theme
cse_build_flow.pptx: the original schematic structure redrawn clean —
six-stage pipeline, Core+Foundation built once, dashed reuse edges into
two pilot compiler surfaces (Cray: cse/gcc + cse/cce with cray-mpich
lanes; Linux: cse/gcc + system default with openmpi lanes), user-flow
strip and legend. Deck restyled to white background with the same lane
color language; validation/vocabulary cards tightened. Both verified
slide-by-slide through Keynote PDF export.
</commit_message>
<xml_diff>
--- a/presentations/cse_lanes_model.pptx
+++ b/presentations/cse_lanes_model.pptx
@@ -3110,7 +3110,7 @@
             <a:avLst/>
           </a:prstGeom>
           <a:solidFill>
-            <a:srgbClr val="0F172A"/>
+            <a:srgbClr val="FFFFFF"/>
           </a:solidFill>
           <a:ln>
             <a:noFill/>
@@ -3154,7 +3154,7 @@
             <a:avLst/>
           </a:prstGeom>
           <a:solidFill>
-            <a:srgbClr val="1E293B"/>
+            <a:srgbClr val="F1F5F9"/>
           </a:solidFill>
           <a:ln>
             <a:noFill/>
@@ -3208,7 +3208,7 @@
             <a:pPr algn="l">
               <a:defRPr sz="4600" b="1">
                 <a:solidFill>
-                  <a:srgbClr val="FFFFFF"/>
+                  <a:srgbClr val="0F172A"/>
                 </a:solidFill>
                 <a:latin typeface="Avenir Next"/>
               </a:defRPr>
@@ -3234,7 +3234,7 @@
             <a:avLst/>
           </a:prstGeom>
           <a:solidFill>
-            <a:srgbClr val="14B8A6"/>
+            <a:srgbClr val="0D9488"/>
           </a:solidFill>
           <a:ln>
             <a:noFill/>
@@ -3288,7 +3288,7 @@
             <a:pPr algn="l">
               <a:defRPr sz="2200" b="0">
                 <a:solidFill>
-                  <a:srgbClr val="E2E8F0"/>
+                  <a:srgbClr val="334155"/>
                 </a:solidFill>
                 <a:latin typeface="Avenir Next"/>
               </a:defRPr>
@@ -3301,7 +3301,7 @@
             <a:pPr algn="l">
               <a:defRPr sz="1500" b="0">
                 <a:solidFill>
-                  <a:srgbClr val="94A3B8"/>
+                  <a:srgbClr val="64748B"/>
                 </a:solidFill>
                 <a:latin typeface="Avenir Next"/>
               </a:defRPr>
@@ -3337,7 +3337,7 @@
             <a:pPr algn="l">
               <a:defRPr sz="1200" b="0">
                 <a:solidFill>
-                  <a:srgbClr val="94A3B8"/>
+                  <a:srgbClr val="64748B"/>
                 </a:solidFill>
                 <a:latin typeface="Avenir Next"/>
               </a:defRPr>
@@ -3363,7 +3363,7 @@
             <a:avLst/>
           </a:prstGeom>
           <a:solidFill>
-            <a:srgbClr val="14B8A6"/>
+            <a:srgbClr val="0D9488"/>
           </a:solidFill>
           <a:ln>
             <a:noFill/>
@@ -3407,7 +3407,7 @@
             <a:avLst/>
           </a:prstGeom>
           <a:solidFill>
-            <a:srgbClr val="F59E0B"/>
+            <a:srgbClr val="D97706"/>
           </a:solidFill>
           <a:ln>
             <a:noFill/>
@@ -3451,7 +3451,7 @@
             <a:avLst/>
           </a:prstGeom>
           <a:solidFill>
-            <a:srgbClr val="3B82F6"/>
+            <a:srgbClr val="2563EB"/>
           </a:solidFill>
           <a:ln>
             <a:noFill/>
@@ -3495,7 +3495,7 @@
             <a:avLst/>
           </a:prstGeom>
           <a:solidFill>
-            <a:srgbClr val="8B5CF6"/>
+            <a:srgbClr val="7C3AED"/>
           </a:solidFill>
           <a:ln>
             <a:noFill/>
@@ -3557,7 +3557,7 @@
             <a:avLst/>
           </a:prstGeom>
           <a:solidFill>
-            <a:srgbClr val="0F172A"/>
+            <a:srgbClr val="FFFFFF"/>
           </a:solidFill>
           <a:ln>
             <a:noFill/>
@@ -3611,7 +3611,7 @@
             <a:pPr algn="l">
               <a:defRPr sz="1300" b="1">
                 <a:solidFill>
-                  <a:srgbClr val="14B8A6"/>
+                  <a:srgbClr val="0D9488"/>
                 </a:solidFill>
                 <a:latin typeface="Avenir Next"/>
               </a:defRPr>
@@ -3647,7 +3647,7 @@
             <a:pPr algn="l">
               <a:defRPr sz="3000" b="1">
                 <a:solidFill>
-                  <a:srgbClr val="FFFFFF"/>
+                  <a:srgbClr val="0F172A"/>
                 </a:solidFill>
                 <a:latin typeface="Avenir Next"/>
               </a:defRPr>
@@ -3673,7 +3673,7 @@
             <a:avLst/>
           </a:prstGeom>
           <a:solidFill>
-            <a:srgbClr val="14B8A6"/>
+            <a:srgbClr val="0D9488"/>
           </a:solidFill>
           <a:ln>
             <a:noFill/>
@@ -3717,7 +3717,7 @@
             <a:avLst/>
           </a:prstGeom>
           <a:solidFill>
-            <a:srgbClr val="1E293B"/>
+            <a:srgbClr val="F1F5F9"/>
           </a:solidFill>
           <a:ln>
             <a:noFill/>
@@ -3771,7 +3771,7 @@
             <a:pPr algn="l">
               <a:defRPr sz="1700" b="1">
                 <a:solidFill>
-                  <a:srgbClr val="FFFFFF"/>
+                  <a:srgbClr val="0F172A"/>
                 </a:solidFill>
                 <a:latin typeface="Avenir Next"/>
               </a:defRPr>
@@ -3807,7 +3807,7 @@
             <a:pPr algn="l">
               <a:defRPr sz="1250" b="0">
                 <a:solidFill>
-                  <a:srgbClr val="94A3B8"/>
+                  <a:srgbClr val="64748B"/>
                 </a:solidFill>
                 <a:latin typeface="Avenir Next"/>
               </a:defRPr>
@@ -3833,7 +3833,7 @@
             <a:avLst/>
           </a:prstGeom>
           <a:solidFill>
-            <a:srgbClr val="2A374D"/>
+            <a:srgbClr val="E2E8F0"/>
           </a:solidFill>
           <a:ln>
             <a:noFill/>
@@ -3861,7 +3861,7 @@
             <a:pPr algn="ctr">
               <a:defRPr sz="1200" b="0">
                 <a:solidFill>
-                  <a:srgbClr val="E2E8F0"/>
+                  <a:srgbClr val="334155"/>
                 </a:solidFill>
                 <a:latin typeface="Avenir Next"/>
               </a:defRPr>
@@ -3887,7 +3887,7 @@
             <a:avLst/>
           </a:prstGeom>
           <a:solidFill>
-            <a:srgbClr val="2A374D"/>
+            <a:srgbClr val="E2E8F0"/>
           </a:solidFill>
           <a:ln>
             <a:noFill/>
@@ -3915,7 +3915,7 @@
             <a:pPr algn="ctr">
               <a:defRPr sz="1200" b="0">
                 <a:solidFill>
-                  <a:srgbClr val="E2E8F0"/>
+                  <a:srgbClr val="334155"/>
                 </a:solidFill>
                 <a:latin typeface="Avenir Next"/>
               </a:defRPr>
@@ -3941,7 +3941,7 @@
             <a:avLst/>
           </a:prstGeom>
           <a:solidFill>
-            <a:srgbClr val="2A374D"/>
+            <a:srgbClr val="E2E8F0"/>
           </a:solidFill>
           <a:ln>
             <a:noFill/>
@@ -3969,7 +3969,7 @@
             <a:pPr algn="ctr">
               <a:defRPr sz="1200" b="0">
                 <a:solidFill>
-                  <a:srgbClr val="E2E8F0"/>
+                  <a:srgbClr val="334155"/>
                 </a:solidFill>
                 <a:latin typeface="Avenir Next"/>
               </a:defRPr>
@@ -3995,7 +3995,7 @@
             <a:avLst/>
           </a:prstGeom>
           <a:solidFill>
-            <a:srgbClr val="2A374D"/>
+            <a:srgbClr val="E2E8F0"/>
           </a:solidFill>
           <a:ln>
             <a:noFill/>
@@ -4023,7 +4023,7 @@
             <a:pPr algn="ctr">
               <a:defRPr sz="1200" b="0">
                 <a:solidFill>
-                  <a:srgbClr val="E2E8F0"/>
+                  <a:srgbClr val="334155"/>
                 </a:solidFill>
                 <a:latin typeface="Avenir Next"/>
               </a:defRPr>
@@ -4049,7 +4049,7 @@
             <a:avLst/>
           </a:prstGeom>
           <a:solidFill>
-            <a:srgbClr val="2A374D"/>
+            <a:srgbClr val="E2E8F0"/>
           </a:solidFill>
           <a:ln>
             <a:noFill/>
@@ -4077,7 +4077,7 @@
             <a:pPr algn="ctr">
               <a:defRPr sz="1200" b="0">
                 <a:solidFill>
-                  <a:srgbClr val="E2E8F0"/>
+                  <a:srgbClr val="334155"/>
                 </a:solidFill>
                 <a:latin typeface="Avenir Next"/>
               </a:defRPr>
@@ -4103,7 +4103,7 @@
             <a:avLst/>
           </a:prstGeom>
           <a:solidFill>
-            <a:srgbClr val="2A374D"/>
+            <a:srgbClr val="E2E8F0"/>
           </a:solidFill>
           <a:ln>
             <a:noFill/>
@@ -4131,7 +4131,7 @@
             <a:pPr algn="ctr">
               <a:defRPr sz="1200" b="0">
                 <a:solidFill>
-                  <a:srgbClr val="E2E8F0"/>
+                  <a:srgbClr val="334155"/>
                 </a:solidFill>
                 <a:latin typeface="Avenir Next"/>
               </a:defRPr>
@@ -4157,7 +4157,7 @@
             <a:avLst/>
           </a:prstGeom>
           <a:solidFill>
-            <a:srgbClr val="2A374D"/>
+            <a:srgbClr val="E2E8F0"/>
           </a:solidFill>
           <a:ln>
             <a:noFill/>
@@ -4185,7 +4185,7 @@
             <a:pPr algn="ctr">
               <a:defRPr sz="1200" b="0">
                 <a:solidFill>
-                  <a:srgbClr val="E2E8F0"/>
+                  <a:srgbClr val="334155"/>
                 </a:solidFill>
                 <a:latin typeface="Avenir Next"/>
               </a:defRPr>
@@ -4211,7 +4211,7 @@
             <a:avLst/>
           </a:prstGeom>
           <a:solidFill>
-            <a:srgbClr val="2A374D"/>
+            <a:srgbClr val="E2E8F0"/>
           </a:solidFill>
           <a:ln>
             <a:noFill/>
@@ -4239,7 +4239,7 @@
             <a:pPr algn="ctr">
               <a:defRPr sz="1200" b="0">
                 <a:solidFill>
-                  <a:srgbClr val="E2E8F0"/>
+                  <a:srgbClr val="334155"/>
                 </a:solidFill>
                 <a:latin typeface="Avenir Next"/>
               </a:defRPr>
@@ -4265,7 +4265,7 @@
             <a:avLst/>
           </a:prstGeom>
           <a:solidFill>
-            <a:srgbClr val="2A374D"/>
+            <a:srgbClr val="E2E8F0"/>
           </a:solidFill>
           <a:ln>
             <a:noFill/>
@@ -4293,7 +4293,7 @@
             <a:pPr algn="ctr">
               <a:defRPr sz="1200" b="0">
                 <a:solidFill>
-                  <a:srgbClr val="E2E8F0"/>
+                  <a:srgbClr val="334155"/>
                 </a:solidFill>
                 <a:latin typeface="Avenir Next"/>
               </a:defRPr>
@@ -4319,7 +4319,7 @@
             <a:avLst/>
           </a:prstGeom>
           <a:solidFill>
-            <a:srgbClr val="2A374D"/>
+            <a:srgbClr val="E2E8F0"/>
           </a:solidFill>
           <a:ln>
             <a:noFill/>
@@ -4347,7 +4347,7 @@
             <a:pPr algn="ctr">
               <a:defRPr sz="1200" b="0">
                 <a:solidFill>
-                  <a:srgbClr val="E2E8F0"/>
+                  <a:srgbClr val="334155"/>
                 </a:solidFill>
                 <a:latin typeface="Avenir Next"/>
               </a:defRPr>
@@ -4373,7 +4373,7 @@
             <a:avLst/>
           </a:prstGeom>
           <a:solidFill>
-            <a:srgbClr val="2A374D"/>
+            <a:srgbClr val="E2E8F0"/>
           </a:solidFill>
           <a:ln>
             <a:noFill/>
@@ -4401,7 +4401,7 @@
             <a:pPr algn="ctr">
               <a:defRPr sz="1200" b="0">
                 <a:solidFill>
-                  <a:srgbClr val="E2E8F0"/>
+                  <a:srgbClr val="334155"/>
                 </a:solidFill>
                 <a:latin typeface="Avenir Next"/>
               </a:defRPr>
@@ -4427,7 +4427,7 @@
             <a:avLst/>
           </a:prstGeom>
           <a:solidFill>
-            <a:srgbClr val="2A374D"/>
+            <a:srgbClr val="E2E8F0"/>
           </a:solidFill>
           <a:ln>
             <a:noFill/>
@@ -4455,7 +4455,7 @@
             <a:pPr algn="ctr">
               <a:defRPr sz="1200" b="0">
                 <a:solidFill>
-                  <a:srgbClr val="E2E8F0"/>
+                  <a:srgbClr val="334155"/>
                 </a:solidFill>
                 <a:latin typeface="Avenir Next"/>
               </a:defRPr>
@@ -4491,7 +4491,7 @@
             <a:pPr algn="l">
               <a:defRPr sz="1350" b="1">
                 <a:solidFill>
-                  <a:srgbClr val="F59E0B"/>
+                  <a:srgbClr val="D97706"/>
                 </a:solidFill>
                 <a:latin typeface="Avenir Next"/>
               </a:defRPr>
@@ -4504,7 +4504,7 @@
             <a:pPr algn="l">
               <a:defRPr sz="1250" b="0">
                 <a:solidFill>
-                  <a:srgbClr val="94A3B8"/>
+                  <a:srgbClr val="64748B"/>
                 </a:solidFill>
                 <a:latin typeface="Avenir Next"/>
               </a:defRPr>
@@ -4517,7 +4517,7 @@
             <a:pPr algn="l">
               <a:defRPr sz="1250" b="0">
                 <a:solidFill>
-                  <a:srgbClr val="94A3B8"/>
+                  <a:srgbClr val="64748B"/>
                 </a:solidFill>
                 <a:latin typeface="Avenir Next"/>
               </a:defRPr>
@@ -4543,7 +4543,7 @@
             <a:avLst/>
           </a:prstGeom>
           <a:solidFill>
-            <a:srgbClr val="1E293B"/>
+            <a:srgbClr val="F1F5F9"/>
           </a:solidFill>
           <a:ln>
             <a:noFill/>
@@ -4597,7 +4597,7 @@
             <a:pPr algn="l">
               <a:defRPr sz="1700" b="1">
                 <a:solidFill>
-                  <a:srgbClr val="FFFFFF"/>
+                  <a:srgbClr val="0F172A"/>
                 </a:solidFill>
                 <a:latin typeface="Avenir Next"/>
               </a:defRPr>
@@ -4623,10 +4623,12 @@
             <a:avLst/>
           </a:prstGeom>
           <a:solidFill>
-            <a:srgbClr val="2A374D"/>
-          </a:solidFill>
-          <a:ln>
-            <a:noFill/>
+            <a:srgbClr val="FFFFFF"/>
+          </a:solidFill>
+          <a:ln w="15875">
+            <a:solidFill>
+              <a:srgbClr val="E2E8F0"/>
+            </a:solidFill>
           </a:ln>
           <a:effectLst/>
         </p:spPr>
@@ -4651,7 +4653,7 @@
             <a:pPr algn="ctr">
               <a:defRPr sz="1300" b="1">
                 <a:solidFill>
-                  <a:srgbClr val="E2E8F0"/>
+                  <a:srgbClr val="0F172A"/>
                 </a:solidFill>
                 <a:latin typeface="Avenir Next"/>
               </a:defRPr>
@@ -4676,9 +4678,9 @@
           <a:prstGeom prst="line">
             <a:avLst/>
           </a:prstGeom>
-          <a:ln w="31750">
+          <a:ln w="28575">
             <a:solidFill>
-              <a:srgbClr val="94A3B8"/>
+              <a:srgbClr val="0D9488"/>
             </a:solidFill>
             <a:tailEnd type="triangle" w="med" len="med"/>
           </a:ln>
@@ -4714,7 +4716,7 @@
             <a:avLst/>
           </a:prstGeom>
           <a:solidFill>
-            <a:srgbClr val="14B8A6"/>
+            <a:srgbClr val="0D9488"/>
           </a:solidFill>
           <a:ln>
             <a:noFill/>
@@ -4768,7 +4770,7 @@
             <a:avLst/>
           </a:prstGeom>
           <a:solidFill>
-            <a:srgbClr val="64748B"/>
+            <a:srgbClr val="475569"/>
           </a:solidFill>
           <a:ln>
             <a:noFill/>
@@ -4821,9 +4823,9 @@
           <a:prstGeom prst="line">
             <a:avLst/>
           </a:prstGeom>
-          <a:ln w="31750">
+          <a:ln w="28575">
             <a:solidFill>
-              <a:srgbClr val="94A3B8"/>
+              <a:srgbClr val="0D9488"/>
             </a:solidFill>
             <a:tailEnd type="triangle" w="med" len="med"/>
           </a:ln>
@@ -4869,7 +4871,7 @@
             <a:pPr algn="ctr">
               <a:defRPr sz="1150" b="1">
                 <a:solidFill>
-                  <a:srgbClr val="94A3B8"/>
+                  <a:srgbClr val="64748B"/>
                 </a:solidFill>
                 <a:latin typeface="Avenir Next"/>
               </a:defRPr>
@@ -4895,7 +4897,7 @@
             <a:avLst/>
           </a:prstGeom>
           <a:solidFill>
-            <a:srgbClr val="F59E0B"/>
+            <a:srgbClr val="D97706"/>
           </a:solidFill>
           <a:ln>
             <a:noFill/>
@@ -4949,7 +4951,7 @@
             <a:avLst/>
           </a:prstGeom>
           <a:solidFill>
-            <a:srgbClr val="3B82F6"/>
+            <a:srgbClr val="2563EB"/>
           </a:solidFill>
           <a:ln>
             <a:noFill/>
@@ -5003,7 +5005,7 @@
             <a:avLst/>
           </a:prstGeom>
           <a:solidFill>
-            <a:srgbClr val="8B5CF6"/>
+            <a:srgbClr val="7C3AED"/>
           </a:solidFill>
           <a:ln>
             <a:noFill/>
@@ -5067,7 +5069,7 @@
             <a:pPr algn="l">
               <a:defRPr sz="1350" b="1">
                 <a:solidFill>
-                  <a:srgbClr val="14B8A6"/>
+                  <a:srgbClr val="0D9488"/>
                 </a:solidFill>
                 <a:latin typeface="Avenir Next"/>
               </a:defRPr>
@@ -5080,7 +5082,7 @@
             <a:pPr algn="l">
               <a:defRPr sz="1250" b="0">
                 <a:solidFill>
-                  <a:srgbClr val="94A3B8"/>
+                  <a:srgbClr val="64748B"/>
                 </a:solidFill>
                 <a:latin typeface="Avenir Next"/>
               </a:defRPr>
@@ -5093,7 +5095,7 @@
             <a:pPr algn="l">
               <a:defRPr sz="1250" b="0">
                 <a:solidFill>
-                  <a:srgbClr val="94A3B8"/>
+                  <a:srgbClr val="64748B"/>
                 </a:solidFill>
                 <a:latin typeface="Avenir Next"/>
               </a:defRPr>
@@ -5137,7 +5139,7 @@
             <a:avLst/>
           </a:prstGeom>
           <a:solidFill>
-            <a:srgbClr val="0F172A"/>
+            <a:srgbClr val="FFFFFF"/>
           </a:solidFill>
           <a:ln>
             <a:noFill/>
@@ -5191,7 +5193,7 @@
             <a:pPr algn="l">
               <a:defRPr sz="1300" b="1">
                 <a:solidFill>
-                  <a:srgbClr val="14B8A6"/>
+                  <a:srgbClr val="0D9488"/>
                 </a:solidFill>
                 <a:latin typeface="Avenir Next"/>
               </a:defRPr>
@@ -5227,7 +5229,7 @@
             <a:pPr algn="l">
               <a:defRPr sz="3000" b="1">
                 <a:solidFill>
-                  <a:srgbClr val="FFFFFF"/>
+                  <a:srgbClr val="0F172A"/>
                 </a:solidFill>
                 <a:latin typeface="Avenir Next"/>
               </a:defRPr>
@@ -5253,7 +5255,7 @@
             <a:avLst/>
           </a:prstGeom>
           <a:solidFill>
-            <a:srgbClr val="14B8A6"/>
+            <a:srgbClr val="0D9488"/>
           </a:solidFill>
           <a:ln>
             <a:noFill/>
@@ -5291,13 +5293,13 @@
         <p:spPr>
           <a:xfrm>
             <a:off x="548640" y="1600200"/>
-            <a:ext cx="3611880" cy="3977639"/>
+            <a:ext cx="3611880" cy="3566160"/>
           </a:xfrm>
           <a:prstGeom prst="roundRect">
             <a:avLst/>
           </a:prstGeom>
           <a:solidFill>
-            <a:srgbClr val="1E293B"/>
+            <a:srgbClr val="F1F5F9"/>
           </a:solidFill>
           <a:ln>
             <a:noFill/>
@@ -5341,7 +5343,7 @@
             <a:avLst/>
           </a:prstGeom>
           <a:solidFill>
-            <a:srgbClr val="3B82F6"/>
+            <a:srgbClr val="2563EB"/>
           </a:solidFill>
           <a:ln>
             <a:noFill/>
@@ -5395,7 +5397,7 @@
             <a:pPr algn="l">
               <a:defRPr sz="1450" b="1">
                 <a:solidFill>
-                  <a:srgbClr val="FFFFFF"/>
+                  <a:srgbClr val="0F172A"/>
                 </a:solidFill>
                 <a:latin typeface="Avenir Next"/>
               </a:defRPr>
@@ -5431,7 +5433,7 @@
             <a:pPr algn="l">
               <a:defRPr sz="1600" b="1">
                 <a:solidFill>
-                  <a:srgbClr val="3B82F6"/>
+                  <a:srgbClr val="2563EB"/>
                 </a:solidFill>
                 <a:latin typeface="Avenir Next"/>
               </a:defRPr>
@@ -5450,8 +5452,8 @@
         </p:nvSpPr>
         <p:spPr>
           <a:xfrm>
-            <a:off x="777240" y="3200400"/>
-            <a:ext cx="3200400" cy="2194560"/>
+            <a:off x="777240" y="3246120"/>
+            <a:ext cx="3200400" cy="1828800"/>
           </a:xfrm>
           <a:prstGeom prst="rect">
             <a:avLst/>
@@ -5467,7 +5469,7 @@
             <a:pPr algn="l">
               <a:defRPr sz="1250" b="0">
                 <a:solidFill>
-                  <a:srgbClr val="E2E8F0"/>
+                  <a:srgbClr val="334155"/>
                 </a:solidFill>
                 <a:latin typeface="Avenir Next"/>
               </a:defRPr>
@@ -5480,7 +5482,7 @@
             <a:pPr algn="l">
               <a:defRPr sz="1250" b="0">
                 <a:solidFill>
-                  <a:srgbClr val="E2E8F0"/>
+                  <a:srgbClr val="334155"/>
                 </a:solidFill>
                 <a:latin typeface="Avenir Next"/>
               </a:defRPr>
@@ -5493,7 +5495,7 @@
             <a:pPr algn="l">
               <a:defRPr sz="1250" b="0">
                 <a:solidFill>
-                  <a:srgbClr val="E2E8F0"/>
+                  <a:srgbClr val="334155"/>
                 </a:solidFill>
                 <a:latin typeface="Avenir Next"/>
               </a:defRPr>
@@ -5513,13 +5515,13 @@
         <p:spPr>
           <a:xfrm>
             <a:off x="4370831" y="1600200"/>
-            <a:ext cx="3611880" cy="3977639"/>
+            <a:ext cx="3611880" cy="3566160"/>
           </a:xfrm>
           <a:prstGeom prst="roundRect">
             <a:avLst/>
           </a:prstGeom>
           <a:solidFill>
-            <a:srgbClr val="1E293B"/>
+            <a:srgbClr val="F1F5F9"/>
           </a:solidFill>
           <a:ln>
             <a:noFill/>
@@ -5563,7 +5565,7 @@
             <a:avLst/>
           </a:prstGeom>
           <a:solidFill>
-            <a:srgbClr val="8B5CF6"/>
+            <a:srgbClr val="7C3AED"/>
           </a:solidFill>
           <a:ln>
             <a:noFill/>
@@ -5617,7 +5619,7 @@
             <a:pPr algn="l">
               <a:defRPr sz="1450" b="1">
                 <a:solidFill>
-                  <a:srgbClr val="FFFFFF"/>
+                  <a:srgbClr val="0F172A"/>
                 </a:solidFill>
                 <a:latin typeface="Avenir Next"/>
               </a:defRPr>
@@ -5653,7 +5655,7 @@
             <a:pPr algn="l">
               <a:defRPr sz="1600" b="1">
                 <a:solidFill>
-                  <a:srgbClr val="8B5CF6"/>
+                  <a:srgbClr val="7C3AED"/>
                 </a:solidFill>
                 <a:latin typeface="Avenir Next"/>
               </a:defRPr>
@@ -5672,8 +5674,8 @@
         </p:nvSpPr>
         <p:spPr>
           <a:xfrm>
-            <a:off x="4599431" y="3200400"/>
-            <a:ext cx="3200400" cy="2194560"/>
+            <a:off x="4599431" y="3246120"/>
+            <a:ext cx="3200400" cy="1828800"/>
           </a:xfrm>
           <a:prstGeom prst="rect">
             <a:avLst/>
@@ -5689,7 +5691,7 @@
             <a:pPr algn="l">
               <a:defRPr sz="1250" b="0">
                 <a:solidFill>
-                  <a:srgbClr val="E2E8F0"/>
+                  <a:srgbClr val="334155"/>
                 </a:solidFill>
                 <a:latin typeface="Avenir Next"/>
               </a:defRPr>
@@ -5702,7 +5704,7 @@
             <a:pPr algn="l">
               <a:defRPr sz="1250" b="0">
                 <a:solidFill>
-                  <a:srgbClr val="E2E8F0"/>
+                  <a:srgbClr val="334155"/>
                 </a:solidFill>
                 <a:latin typeface="Avenir Next"/>
               </a:defRPr>
@@ -5715,7 +5717,7 @@
             <a:pPr algn="l">
               <a:defRPr sz="1250" b="0">
                 <a:solidFill>
-                  <a:srgbClr val="E2E8F0"/>
+                  <a:srgbClr val="334155"/>
                 </a:solidFill>
                 <a:latin typeface="Avenir Next"/>
               </a:defRPr>
@@ -5735,13 +5737,13 @@
         <p:spPr>
           <a:xfrm>
             <a:off x="8193023" y="1600200"/>
-            <a:ext cx="3611880" cy="3977639"/>
+            <a:ext cx="3611880" cy="3566160"/>
           </a:xfrm>
           <a:prstGeom prst="roundRect">
             <a:avLst/>
           </a:prstGeom>
           <a:solidFill>
-            <a:srgbClr val="1E293B"/>
+            <a:srgbClr val="F1F5F9"/>
           </a:solidFill>
           <a:ln>
             <a:noFill/>
@@ -5785,7 +5787,7 @@
             <a:avLst/>
           </a:prstGeom>
           <a:solidFill>
-            <a:srgbClr val="14B8A6"/>
+            <a:srgbClr val="0D9488"/>
           </a:solidFill>
           <a:ln>
             <a:noFill/>
@@ -5839,7 +5841,7 @@
             <a:pPr algn="l">
               <a:defRPr sz="1450" b="1">
                 <a:solidFill>
-                  <a:srgbClr val="FFFFFF"/>
+                  <a:srgbClr val="0F172A"/>
                 </a:solidFill>
                 <a:latin typeface="Avenir Next"/>
               </a:defRPr>
@@ -5875,7 +5877,7 @@
             <a:pPr algn="l">
               <a:defRPr sz="1600" b="1">
                 <a:solidFill>
-                  <a:srgbClr val="14B8A6"/>
+                  <a:srgbClr val="0D9488"/>
                 </a:solidFill>
                 <a:latin typeface="Avenir Next"/>
               </a:defRPr>
@@ -5894,8 +5896,8 @@
         </p:nvSpPr>
         <p:spPr>
           <a:xfrm>
-            <a:off x="8421624" y="3200400"/>
-            <a:ext cx="3200400" cy="2194560"/>
+            <a:off x="8421624" y="3246120"/>
+            <a:ext cx="3200400" cy="1828800"/>
           </a:xfrm>
           <a:prstGeom prst="rect">
             <a:avLst/>
@@ -5911,7 +5913,7 @@
             <a:pPr algn="l">
               <a:defRPr sz="1250" b="0">
                 <a:solidFill>
-                  <a:srgbClr val="E2E8F0"/>
+                  <a:srgbClr val="334155"/>
                 </a:solidFill>
                 <a:latin typeface="Avenir Next"/>
               </a:defRPr>
@@ -5924,7 +5926,7 @@
             <a:pPr algn="l">
               <a:defRPr sz="1250" b="0">
                 <a:solidFill>
-                  <a:srgbClr val="E2E8F0"/>
+                  <a:srgbClr val="334155"/>
                 </a:solidFill>
                 <a:latin typeface="Avenir Next"/>
               </a:defRPr>
@@ -5937,7 +5939,7 @@
             <a:pPr algn="l">
               <a:defRPr sz="1250" b="0">
                 <a:solidFill>
-                  <a:srgbClr val="E2E8F0"/>
+                  <a:srgbClr val="334155"/>
                 </a:solidFill>
                 <a:latin typeface="Avenir Next"/>
               </a:defRPr>
@@ -5956,14 +5958,14 @@
         </p:nvSpPr>
         <p:spPr>
           <a:xfrm>
-            <a:off x="548640" y="5806440"/>
+            <a:off x="548640" y="5486400"/>
             <a:ext cx="11091672" cy="566928"/>
           </a:xfrm>
           <a:prstGeom prst="roundRect">
             <a:avLst/>
           </a:prstGeom>
           <a:solidFill>
-            <a:srgbClr val="2A374D"/>
+            <a:srgbClr val="E2E8F0"/>
           </a:solidFill>
           <a:ln>
             <a:noFill/>
@@ -5991,7 +5993,7 @@
             <a:pPr algn="ctr">
               <a:defRPr sz="1400" b="1">
                 <a:solidFill>
-                  <a:srgbClr val="FFFFFF"/>
+                  <a:srgbClr val="0F172A"/>
                 </a:solidFill>
                 <a:latin typeface="Avenir Next"/>
               </a:defRPr>
@@ -6035,7 +6037,7 @@
             <a:avLst/>
           </a:prstGeom>
           <a:solidFill>
-            <a:srgbClr val="0F172A"/>
+            <a:srgbClr val="FFFFFF"/>
           </a:solidFill>
           <a:ln>
             <a:noFill/>
@@ -6089,7 +6091,7 @@
             <a:pPr algn="l">
               <a:defRPr sz="1300" b="1">
                 <a:solidFill>
-                  <a:srgbClr val="14B8A6"/>
+                  <a:srgbClr val="0D9488"/>
                 </a:solidFill>
                 <a:latin typeface="Avenir Next"/>
               </a:defRPr>
@@ -6125,7 +6127,7 @@
             <a:pPr algn="l">
               <a:defRPr sz="3000" b="1">
                 <a:solidFill>
-                  <a:srgbClr val="FFFFFF"/>
+                  <a:srgbClr val="0F172A"/>
                 </a:solidFill>
                 <a:latin typeface="Avenir Next"/>
               </a:defRPr>
@@ -6151,7 +6153,7 @@
             <a:avLst/>
           </a:prstGeom>
           <a:solidFill>
-            <a:srgbClr val="14B8A6"/>
+            <a:srgbClr val="0D9488"/>
           </a:solidFill>
           <a:ln>
             <a:noFill/>
@@ -6195,11 +6197,11 @@
             <a:avLst/>
           </a:prstGeom>
           <a:solidFill>
-            <a:srgbClr val="1E293B"/>
-          </a:solidFill>
-          <a:ln w="19050">
+            <a:srgbClr val="F1F5F9"/>
+          </a:solidFill>
+          <a:ln w="15875">
             <a:solidFill>
-              <a:srgbClr val="14B8A6"/>
+              <a:srgbClr val="E2E8F0"/>
             </a:solidFill>
           </a:ln>
           <a:effectLst/>
@@ -6225,7 +6227,7 @@
             <a:pPr algn="ctr">
               <a:defRPr sz="1500" b="1">
                 <a:solidFill>
-                  <a:srgbClr val="FFFFFF"/>
+                  <a:srgbClr val="0F172A"/>
                 </a:solidFill>
                 <a:latin typeface="Avenir Next"/>
               </a:defRPr>
@@ -6238,7 +6240,7 @@
             <a:pPr algn="ctr">
               <a:defRPr sz="1100" b="0">
                 <a:solidFill>
-                  <a:srgbClr val="94A3B8"/>
+                  <a:srgbClr val="64748B"/>
                 </a:solidFill>
                 <a:latin typeface="Avenir Next"/>
               </a:defRPr>
@@ -6251,7 +6253,7 @@
             <a:pPr algn="ctr">
               <a:defRPr sz="1100" b="0">
                 <a:solidFill>
-                  <a:srgbClr val="94A3B8"/>
+                  <a:srgbClr val="64748B"/>
                 </a:solidFill>
                 <a:latin typeface="Avenir Next"/>
               </a:defRPr>
@@ -6276,9 +6278,9 @@
           <a:prstGeom prst="line">
             <a:avLst/>
           </a:prstGeom>
-          <a:ln w="31750">
+          <a:ln w="28575">
             <a:solidFill>
-              <a:srgbClr val="14B8A6"/>
+              <a:srgbClr val="0D9488"/>
             </a:solidFill>
             <a:tailEnd type="triangle" w="med" len="med"/>
           </a:ln>
@@ -6314,11 +6316,11 @@
             <a:avLst/>
           </a:prstGeom>
           <a:solidFill>
-            <a:srgbClr val="1E293B"/>
-          </a:solidFill>
-          <a:ln w="19050">
+            <a:srgbClr val="F1F5F9"/>
+          </a:solidFill>
+          <a:ln w="15875">
             <a:solidFill>
-              <a:srgbClr val="14B8A6"/>
+              <a:srgbClr val="E2E8F0"/>
             </a:solidFill>
           </a:ln>
           <a:effectLst/>
@@ -6344,7 +6346,7 @@
             <a:pPr algn="ctr">
               <a:defRPr sz="1500" b="1">
                 <a:solidFill>
-                  <a:srgbClr val="FFFFFF"/>
+                  <a:srgbClr val="0F172A"/>
                 </a:solidFill>
                 <a:latin typeface="Avenir Next"/>
               </a:defRPr>
@@ -6357,7 +6359,7 @@
             <a:pPr algn="ctr">
               <a:defRPr sz="1100" b="0">
                 <a:solidFill>
-                  <a:srgbClr val="94A3B8"/>
+                  <a:srgbClr val="64748B"/>
                 </a:solidFill>
                 <a:latin typeface="Avenir Next"/>
               </a:defRPr>
@@ -6370,7 +6372,7 @@
             <a:pPr algn="ctr">
               <a:defRPr sz="1100" b="0">
                 <a:solidFill>
-                  <a:srgbClr val="94A3B8"/>
+                  <a:srgbClr val="64748B"/>
                 </a:solidFill>
                 <a:latin typeface="Avenir Next"/>
               </a:defRPr>
@@ -6395,9 +6397,9 @@
           <a:prstGeom prst="line">
             <a:avLst/>
           </a:prstGeom>
-          <a:ln w="31750">
+          <a:ln w="28575">
             <a:solidFill>
-              <a:srgbClr val="14B8A6"/>
+              <a:srgbClr val="0D9488"/>
             </a:solidFill>
             <a:tailEnd type="triangle" w="med" len="med"/>
           </a:ln>
@@ -6433,11 +6435,11 @@
             <a:avLst/>
           </a:prstGeom>
           <a:solidFill>
-            <a:srgbClr val="1E293B"/>
-          </a:solidFill>
-          <a:ln w="19050">
+            <a:srgbClr val="F1F5F9"/>
+          </a:solidFill>
+          <a:ln w="15875">
             <a:solidFill>
-              <a:srgbClr val="14B8A6"/>
+              <a:srgbClr val="E2E8F0"/>
             </a:solidFill>
           </a:ln>
           <a:effectLst/>
@@ -6463,7 +6465,7 @@
             <a:pPr algn="ctr">
               <a:defRPr sz="1500" b="1">
                 <a:solidFill>
-                  <a:srgbClr val="FFFFFF"/>
+                  <a:srgbClr val="0F172A"/>
                 </a:solidFill>
                 <a:latin typeface="Avenir Next"/>
               </a:defRPr>
@@ -6476,7 +6478,7 @@
             <a:pPr algn="ctr">
               <a:defRPr sz="1100" b="0">
                 <a:solidFill>
-                  <a:srgbClr val="94A3B8"/>
+                  <a:srgbClr val="64748B"/>
                 </a:solidFill>
                 <a:latin typeface="Avenir Next"/>
               </a:defRPr>
@@ -6489,7 +6491,7 @@
             <a:pPr algn="ctr">
               <a:defRPr sz="1100" b="0">
                 <a:solidFill>
-                  <a:srgbClr val="94A3B8"/>
+                  <a:srgbClr val="64748B"/>
                 </a:solidFill>
                 <a:latin typeface="Avenir Next"/>
               </a:defRPr>
@@ -6514,9 +6516,9 @@
           <a:prstGeom prst="line">
             <a:avLst/>
           </a:prstGeom>
-          <a:ln w="31750">
+          <a:ln w="28575">
             <a:solidFill>
-              <a:srgbClr val="14B8A6"/>
+              <a:srgbClr val="0D9488"/>
             </a:solidFill>
             <a:tailEnd type="triangle" w="med" len="med"/>
           </a:ln>
@@ -6552,11 +6554,11 @@
             <a:avLst/>
           </a:prstGeom>
           <a:solidFill>
-            <a:srgbClr val="1E293B"/>
-          </a:solidFill>
-          <a:ln w="19050">
+            <a:srgbClr val="F1F5F9"/>
+          </a:solidFill>
+          <a:ln w="15875">
             <a:solidFill>
-              <a:srgbClr val="14B8A6"/>
+              <a:srgbClr val="E2E8F0"/>
             </a:solidFill>
           </a:ln>
           <a:effectLst/>
@@ -6582,7 +6584,7 @@
             <a:pPr algn="ctr">
               <a:defRPr sz="1500" b="1">
                 <a:solidFill>
-                  <a:srgbClr val="FFFFFF"/>
+                  <a:srgbClr val="0F172A"/>
                 </a:solidFill>
                 <a:latin typeface="Avenir Next"/>
               </a:defRPr>
@@ -6595,7 +6597,7 @@
             <a:pPr algn="ctr">
               <a:defRPr sz="1100" b="0">
                 <a:solidFill>
-                  <a:srgbClr val="94A3B8"/>
+                  <a:srgbClr val="64748B"/>
                 </a:solidFill>
                 <a:latin typeface="Avenir Next"/>
               </a:defRPr>
@@ -6608,7 +6610,7 @@
             <a:pPr algn="ctr">
               <a:defRPr sz="1100" b="0">
                 <a:solidFill>
-                  <a:srgbClr val="94A3B8"/>
+                  <a:srgbClr val="64748B"/>
                 </a:solidFill>
                 <a:latin typeface="Avenir Next"/>
               </a:defRPr>
@@ -6633,9 +6635,9 @@
           <a:prstGeom prst="line">
             <a:avLst/>
           </a:prstGeom>
-          <a:ln w="31750">
+          <a:ln w="28575">
             <a:solidFill>
-              <a:srgbClr val="14B8A6"/>
+              <a:srgbClr val="0D9488"/>
             </a:solidFill>
             <a:tailEnd type="triangle" w="med" len="med"/>
           </a:ln>
@@ -6671,11 +6673,11 @@
             <a:avLst/>
           </a:prstGeom>
           <a:solidFill>
-            <a:srgbClr val="1E293B"/>
-          </a:solidFill>
-          <a:ln w="19050">
+            <a:srgbClr val="F1F5F9"/>
+          </a:solidFill>
+          <a:ln w="15875">
             <a:solidFill>
-              <a:srgbClr val="14B8A6"/>
+              <a:srgbClr val="E2E8F0"/>
             </a:solidFill>
           </a:ln>
           <a:effectLst/>
@@ -6701,7 +6703,7 @@
             <a:pPr algn="ctr">
               <a:defRPr sz="1500" b="1">
                 <a:solidFill>
-                  <a:srgbClr val="FFFFFF"/>
+                  <a:srgbClr val="0F172A"/>
                 </a:solidFill>
                 <a:latin typeface="Avenir Next"/>
               </a:defRPr>
@@ -6714,7 +6716,7 @@
             <a:pPr algn="ctr">
               <a:defRPr sz="1100" b="0">
                 <a:solidFill>
-                  <a:srgbClr val="94A3B8"/>
+                  <a:srgbClr val="64748B"/>
                 </a:solidFill>
                 <a:latin typeface="Avenir Next"/>
               </a:defRPr>
@@ -6727,7 +6729,7 @@
             <a:pPr algn="ctr">
               <a:defRPr sz="1100" b="0">
                 <a:solidFill>
-                  <a:srgbClr val="94A3B8"/>
+                  <a:srgbClr val="64748B"/>
                 </a:solidFill>
                 <a:latin typeface="Avenir Next"/>
               </a:defRPr>
@@ -6753,10 +6755,12 @@
             <a:avLst/>
           </a:prstGeom>
           <a:solidFill>
-            <a:srgbClr val="2A374D"/>
-          </a:solidFill>
-          <a:ln>
-            <a:noFill/>
+            <a:srgbClr val="FFFFFF"/>
+          </a:solidFill>
+          <a:ln w="15875">
+            <a:solidFill>
+              <a:srgbClr val="0D9488"/>
+            </a:solidFill>
           </a:ln>
           <a:effectLst/>
         </p:spPr>
@@ -6781,7 +6785,7 @@
             <a:pPr algn="ctr">
               <a:defRPr sz="1450" b="1">
                 <a:solidFill>
-                  <a:srgbClr val="FFFFFF"/>
+                  <a:srgbClr val="0F172A"/>
                 </a:solidFill>
                 <a:latin typeface="Avenir Next"/>
               </a:defRPr>
@@ -6794,7 +6798,7 @@
             <a:pPr algn="ctr">
               <a:defRPr sz="1150" b="0">
                 <a:solidFill>
-                  <a:srgbClr val="94A3B8"/>
+                  <a:srgbClr val="64748B"/>
                 </a:solidFill>
                 <a:latin typeface="Avenir Next"/>
               </a:defRPr>
@@ -6819,9 +6823,9 @@
           <a:prstGeom prst="line">
             <a:avLst/>
           </a:prstGeom>
-          <a:ln w="31750">
+          <a:ln w="28575">
             <a:solidFill>
-              <a:srgbClr val="F59E0B"/>
+              <a:srgbClr val="D97706"/>
             </a:solidFill>
             <a:tailEnd type="triangle" w="med" len="med"/>
           </a:ln>
@@ -6857,7 +6861,7 @@
             <a:avLst/>
           </a:prstGeom>
           <a:solidFill>
-            <a:srgbClr val="F59E0B"/>
+            <a:srgbClr val="D97706"/>
           </a:solidFill>
           <a:ln>
             <a:noFill/>
@@ -6923,9 +6927,9 @@
           <a:prstGeom prst="line">
             <a:avLst/>
           </a:prstGeom>
-          <a:ln w="31750">
+          <a:ln w="28575">
             <a:solidFill>
-              <a:srgbClr val="3B82F6"/>
+              <a:srgbClr val="2563EB"/>
             </a:solidFill>
             <a:tailEnd type="triangle" w="med" len="med"/>
           </a:ln>
@@ -6961,7 +6965,7 @@
             <a:avLst/>
           </a:prstGeom>
           <a:solidFill>
-            <a:srgbClr val="3B82F6"/>
+            <a:srgbClr val="2563EB"/>
           </a:solidFill>
           <a:ln>
             <a:noFill/>
@@ -7027,9 +7031,9 @@
           <a:prstGeom prst="line">
             <a:avLst/>
           </a:prstGeom>
-          <a:ln w="31750">
+          <a:ln w="28575">
             <a:solidFill>
-              <a:srgbClr val="8B5CF6"/>
+              <a:srgbClr val="7C3AED"/>
             </a:solidFill>
             <a:tailEnd type="triangle" w="med" len="med"/>
           </a:ln>
@@ -7065,7 +7069,7 @@
             <a:avLst/>
           </a:prstGeom>
           <a:solidFill>
-            <a:srgbClr val="8B5CF6"/>
+            <a:srgbClr val="7C3AED"/>
           </a:solidFill>
           <a:ln>
             <a:noFill/>
@@ -7142,7 +7146,7 @@
             <a:pPr algn="l">
               <a:defRPr sz="1400" b="1">
                 <a:solidFill>
-                  <a:srgbClr val="14B8A6"/>
+                  <a:srgbClr val="0D9488"/>
                 </a:solidFill>
                 <a:latin typeface="Avenir Next"/>
               </a:defRPr>
@@ -7155,7 +7159,7 @@
             <a:pPr algn="l">
               <a:defRPr sz="1250" b="0">
                 <a:solidFill>
-                  <a:srgbClr val="94A3B8"/>
+                  <a:srgbClr val="64748B"/>
                 </a:solidFill>
                 <a:latin typeface="Avenir Next"/>
               </a:defRPr>
@@ -7199,7 +7203,7 @@
             <a:avLst/>
           </a:prstGeom>
           <a:solidFill>
-            <a:srgbClr val="0F172A"/>
+            <a:srgbClr val="FFFFFF"/>
           </a:solidFill>
           <a:ln>
             <a:noFill/>
@@ -7253,7 +7257,7 @@
             <a:pPr algn="l">
               <a:defRPr sz="1300" b="1">
                 <a:solidFill>
-                  <a:srgbClr val="14B8A6"/>
+                  <a:srgbClr val="0D9488"/>
                 </a:solidFill>
                 <a:latin typeface="Avenir Next"/>
               </a:defRPr>
@@ -7289,7 +7293,7 @@
             <a:pPr algn="l">
               <a:defRPr sz="3000" b="1">
                 <a:solidFill>
-                  <a:srgbClr val="FFFFFF"/>
+                  <a:srgbClr val="0F172A"/>
                 </a:solidFill>
                 <a:latin typeface="Avenir Next"/>
               </a:defRPr>
@@ -7315,7 +7319,7 @@
             <a:avLst/>
           </a:prstGeom>
           <a:solidFill>
-            <a:srgbClr val="14B8A6"/>
+            <a:srgbClr val="0D9488"/>
           </a:solidFill>
           <a:ln>
             <a:noFill/>
@@ -7359,10 +7363,12 @@
             <a:avLst/>
           </a:prstGeom>
           <a:solidFill>
-            <a:srgbClr val="2A374D"/>
-          </a:solidFill>
-          <a:ln>
-            <a:noFill/>
+            <a:srgbClr val="FFFFFF"/>
+          </a:solidFill>
+          <a:ln w="15875">
+            <a:solidFill>
+              <a:srgbClr val="E2E8F0"/>
+            </a:solidFill>
           </a:ln>
           <a:effectLst/>
         </p:spPr>
@@ -7387,7 +7393,7 @@
             <a:pPr algn="ctr">
               <a:defRPr sz="1600" b="1">
                 <a:solidFill>
-                  <a:srgbClr val="FFFFFF"/>
+                  <a:srgbClr val="0F172A"/>
                 </a:solidFill>
                 <a:latin typeface="Avenir Next"/>
               </a:defRPr>
@@ -7412,9 +7418,9 @@
           <a:prstGeom prst="line">
             <a:avLst/>
           </a:prstGeom>
-          <a:ln w="31750">
+          <a:ln w="28575">
             <a:solidFill>
-              <a:srgbClr val="94A3B8"/>
+              <a:srgbClr val="0D9488"/>
             </a:solidFill>
             <a:tailEnd type="triangle" w="med" len="med"/>
           </a:ln>
@@ -7450,7 +7456,7 @@
             <a:avLst/>
           </a:prstGeom>
           <a:solidFill>
-            <a:srgbClr val="14B8A6"/>
+            <a:srgbClr val="0D9488"/>
           </a:solidFill>
           <a:ln>
             <a:noFill/>
@@ -7517,7 +7523,7 @@
             <a:avLst/>
           </a:prstGeom>
           <a:solidFill>
-            <a:srgbClr val="64748B"/>
+            <a:srgbClr val="475569"/>
           </a:solidFill>
           <a:ln>
             <a:noFill/>
@@ -7583,9 +7589,9 @@
           <a:prstGeom prst="line">
             <a:avLst/>
           </a:prstGeom>
-          <a:ln w="31750">
+          <a:ln w="28575">
             <a:solidFill>
-              <a:srgbClr val="94A3B8"/>
+              <a:srgbClr val="0D9488"/>
             </a:solidFill>
             <a:tailEnd type="triangle" w="med" len="med"/>
           </a:ln>
@@ -7631,7 +7637,7 @@
             <a:pPr algn="ctr">
               <a:defRPr sz="1250" b="1">
                 <a:solidFill>
-                  <a:srgbClr val="94A3B8"/>
+                  <a:srgbClr val="64748B"/>
                 </a:solidFill>
                 <a:latin typeface="Avenir Next"/>
               </a:defRPr>
@@ -7657,7 +7663,7 @@
             <a:avLst/>
           </a:prstGeom>
           <a:solidFill>
-            <a:srgbClr val="F59E0B"/>
+            <a:srgbClr val="D97706"/>
           </a:solidFill>
           <a:ln>
             <a:noFill/>
@@ -7724,7 +7730,7 @@
             <a:avLst/>
           </a:prstGeom>
           <a:solidFill>
-            <a:srgbClr val="3B82F6"/>
+            <a:srgbClr val="2563EB"/>
           </a:solidFill>
           <a:ln>
             <a:noFill/>
@@ -7791,7 +7797,7 @@
             <a:avLst/>
           </a:prstGeom>
           <a:solidFill>
-            <a:srgbClr val="8B5CF6"/>
+            <a:srgbClr val="7C3AED"/>
           </a:solidFill>
           <a:ln>
             <a:noFill/>
@@ -7858,7 +7864,7 @@
             <a:avLst/>
           </a:prstGeom>
           <a:solidFill>
-            <a:srgbClr val="1E293B"/>
+            <a:srgbClr val="F1F5F9"/>
           </a:solidFill>
           <a:ln>
             <a:noFill/>
@@ -7886,7 +7892,7 @@
             <a:pPr algn="ctr">
               <a:defRPr sz="1350" b="1">
                 <a:solidFill>
-                  <a:srgbClr val="FFFFFF"/>
+                  <a:srgbClr val="0F172A"/>
                 </a:solidFill>
                 <a:latin typeface="Avenir Next"/>
               </a:defRPr>
@@ -7899,7 +7905,7 @@
             <a:pPr algn="ctr">
               <a:defRPr sz="1200" b="0">
                 <a:solidFill>
-                  <a:srgbClr val="94A3B8"/>
+                  <a:srgbClr val="64748B"/>
                 </a:solidFill>
                 <a:latin typeface="Avenir Next"/>
               </a:defRPr>
@@ -7943,7 +7949,7 @@
             <a:avLst/>
           </a:prstGeom>
           <a:solidFill>
-            <a:srgbClr val="0F172A"/>
+            <a:srgbClr val="FFFFFF"/>
           </a:solidFill>
           <a:ln>
             <a:noFill/>
@@ -7997,7 +8003,7 @@
             <a:pPr algn="l">
               <a:defRPr sz="1300" b="1">
                 <a:solidFill>
-                  <a:srgbClr val="14B8A6"/>
+                  <a:srgbClr val="0D9488"/>
                 </a:solidFill>
                 <a:latin typeface="Avenir Next"/>
               </a:defRPr>
@@ -8033,7 +8039,7 @@
             <a:pPr algn="l">
               <a:defRPr sz="3000" b="1">
                 <a:solidFill>
-                  <a:srgbClr val="FFFFFF"/>
+                  <a:srgbClr val="0F172A"/>
                 </a:solidFill>
                 <a:latin typeface="Avenir Next"/>
               </a:defRPr>
@@ -8059,7 +8065,7 @@
             <a:avLst/>
           </a:prstGeom>
           <a:solidFill>
-            <a:srgbClr val="14B8A6"/>
+            <a:srgbClr val="0D9488"/>
           </a:solidFill>
           <a:ln>
             <a:noFill/>
@@ -8097,13 +8103,13 @@
         <p:spPr>
           <a:xfrm>
             <a:off x="548640" y="1645920"/>
-            <a:ext cx="2743200" cy="3840480"/>
+            <a:ext cx="2743200" cy="3246120"/>
           </a:xfrm>
           <a:prstGeom prst="roundRect">
             <a:avLst/>
           </a:prstGeom>
           <a:solidFill>
-            <a:srgbClr val="1E293B"/>
+            <a:srgbClr val="F1F5F9"/>
           </a:solidFill>
           <a:ln>
             <a:noFill/>
@@ -8147,7 +8153,7 @@
             <a:avLst/>
           </a:prstGeom>
           <a:solidFill>
-            <a:srgbClr val="14B8A6"/>
+            <a:srgbClr val="0D9488"/>
           </a:solidFill>
           <a:ln>
             <a:noFill/>
@@ -8221,7 +8227,7 @@
         <p:spPr>
           <a:xfrm>
             <a:off x="749808" y="2514600"/>
-            <a:ext cx="2377440" cy="1828800"/>
+            <a:ext cx="2377440" cy="1554480"/>
           </a:xfrm>
           <a:prstGeom prst="rect">
             <a:avLst/>
@@ -8237,7 +8243,7 @@
             <a:pPr algn="l">
               <a:defRPr sz="1250" b="0">
                 <a:solidFill>
-                  <a:srgbClr val="E2E8F0"/>
+                  <a:srgbClr val="334155"/>
                 </a:solidFill>
                 <a:latin typeface="Avenir Next"/>
               </a:defRPr>
@@ -8256,8 +8262,8 @@
         </p:nvSpPr>
         <p:spPr>
           <a:xfrm>
-            <a:off x="749808" y="4480560"/>
-            <a:ext cx="2377440" cy="822960"/>
+            <a:off x="749808" y="4160520"/>
+            <a:ext cx="2377440" cy="640080"/>
           </a:xfrm>
           <a:prstGeom prst="rect">
             <a:avLst/>
@@ -8273,7 +8279,7 @@
             <a:pPr algn="l">
               <a:defRPr sz="1150" b="0">
                 <a:solidFill>
-                  <a:srgbClr val="94A3B8"/>
+                  <a:srgbClr val="64748B"/>
                 </a:solidFill>
                 <a:latin typeface="Avenir Next"/>
               </a:defRPr>
@@ -8293,13 +8299,13 @@
         <p:spPr>
           <a:xfrm>
             <a:off x="3493008" y="1645920"/>
-            <a:ext cx="2743200" cy="3840480"/>
+            <a:ext cx="2743200" cy="3246120"/>
           </a:xfrm>
           <a:prstGeom prst="roundRect">
             <a:avLst/>
           </a:prstGeom>
           <a:solidFill>
-            <a:srgbClr val="1E293B"/>
+            <a:srgbClr val="F1F5F9"/>
           </a:solidFill>
           <a:ln>
             <a:noFill/>
@@ -8343,7 +8349,7 @@
             <a:avLst/>
           </a:prstGeom>
           <a:solidFill>
-            <a:srgbClr val="F59E0B"/>
+            <a:srgbClr val="D97706"/>
           </a:solidFill>
           <a:ln>
             <a:noFill/>
@@ -8417,7 +8423,7 @@
         <p:spPr>
           <a:xfrm>
             <a:off x="3694176" y="2514600"/>
-            <a:ext cx="2377440" cy="1828800"/>
+            <a:ext cx="2377440" cy="1554480"/>
           </a:xfrm>
           <a:prstGeom prst="rect">
             <a:avLst/>
@@ -8433,7 +8439,7 @@
             <a:pPr algn="l">
               <a:defRPr sz="1250" b="0">
                 <a:solidFill>
-                  <a:srgbClr val="E2E8F0"/>
+                  <a:srgbClr val="334155"/>
                 </a:solidFill>
                 <a:latin typeface="Avenir Next"/>
               </a:defRPr>
@@ -8452,8 +8458,8 @@
         </p:nvSpPr>
         <p:spPr>
           <a:xfrm>
-            <a:off x="3694176" y="4480560"/>
-            <a:ext cx="2377440" cy="822960"/>
+            <a:off x="3694176" y="4160520"/>
+            <a:ext cx="2377440" cy="640080"/>
           </a:xfrm>
           <a:prstGeom prst="rect">
             <a:avLst/>
@@ -8469,7 +8475,7 @@
             <a:pPr algn="l">
               <a:defRPr sz="1150" b="0">
                 <a:solidFill>
-                  <a:srgbClr val="94A3B8"/>
+                  <a:srgbClr val="64748B"/>
                 </a:solidFill>
                 <a:latin typeface="Avenir Next"/>
               </a:defRPr>
@@ -8489,13 +8495,13 @@
         <p:spPr>
           <a:xfrm>
             <a:off x="6437376" y="1645920"/>
-            <a:ext cx="2743200" cy="3840480"/>
+            <a:ext cx="2743200" cy="3246120"/>
           </a:xfrm>
           <a:prstGeom prst="roundRect">
             <a:avLst/>
           </a:prstGeom>
           <a:solidFill>
-            <a:srgbClr val="1E293B"/>
+            <a:srgbClr val="F1F5F9"/>
           </a:solidFill>
           <a:ln>
             <a:noFill/>
@@ -8539,7 +8545,7 @@
             <a:avLst/>
           </a:prstGeom>
           <a:solidFill>
-            <a:srgbClr val="3B82F6"/>
+            <a:srgbClr val="2563EB"/>
           </a:solidFill>
           <a:ln>
             <a:noFill/>
@@ -8613,7 +8619,7 @@
         <p:spPr>
           <a:xfrm>
             <a:off x="6638544" y="2514600"/>
-            <a:ext cx="2377440" cy="1828800"/>
+            <a:ext cx="2377440" cy="1554480"/>
           </a:xfrm>
           <a:prstGeom prst="rect">
             <a:avLst/>
@@ -8629,7 +8635,7 @@
             <a:pPr algn="l">
               <a:defRPr sz="1250" b="0">
                 <a:solidFill>
-                  <a:srgbClr val="E2E8F0"/>
+                  <a:srgbClr val="334155"/>
                 </a:solidFill>
                 <a:latin typeface="Avenir Next"/>
               </a:defRPr>
@@ -8648,8 +8654,8 @@
         </p:nvSpPr>
         <p:spPr>
           <a:xfrm>
-            <a:off x="6638544" y="4480560"/>
-            <a:ext cx="2377440" cy="822960"/>
+            <a:off x="6638544" y="4160520"/>
+            <a:ext cx="2377440" cy="640080"/>
           </a:xfrm>
           <a:prstGeom prst="rect">
             <a:avLst/>
@@ -8665,7 +8671,7 @@
             <a:pPr algn="l">
               <a:defRPr sz="1150" b="0">
                 <a:solidFill>
-                  <a:srgbClr val="94A3B8"/>
+                  <a:srgbClr val="64748B"/>
                 </a:solidFill>
                 <a:latin typeface="Avenir Next"/>
               </a:defRPr>
@@ -8685,13 +8691,13 @@
         <p:spPr>
           <a:xfrm>
             <a:off x="9381744" y="1645920"/>
-            <a:ext cx="2743200" cy="3840480"/>
+            <a:ext cx="2743200" cy="3246120"/>
           </a:xfrm>
           <a:prstGeom prst="roundRect">
             <a:avLst/>
           </a:prstGeom>
           <a:solidFill>
-            <a:srgbClr val="1E293B"/>
+            <a:srgbClr val="F1F5F9"/>
           </a:solidFill>
           <a:ln>
             <a:noFill/>
@@ -8735,7 +8741,7 @@
             <a:avLst/>
           </a:prstGeom>
           <a:solidFill>
-            <a:srgbClr val="8B5CF6"/>
+            <a:srgbClr val="7C3AED"/>
           </a:solidFill>
           <a:ln>
             <a:noFill/>
@@ -8809,7 +8815,7 @@
         <p:spPr>
           <a:xfrm>
             <a:off x="9582912" y="2514600"/>
-            <a:ext cx="2377440" cy="1828800"/>
+            <a:ext cx="2377440" cy="1554480"/>
           </a:xfrm>
           <a:prstGeom prst="rect">
             <a:avLst/>
@@ -8825,7 +8831,7 @@
             <a:pPr algn="l">
               <a:defRPr sz="1250" b="0">
                 <a:solidFill>
-                  <a:srgbClr val="E2E8F0"/>
+                  <a:srgbClr val="334155"/>
                 </a:solidFill>
                 <a:latin typeface="Avenir Next"/>
               </a:defRPr>
@@ -8844,8 +8850,8 @@
         </p:nvSpPr>
         <p:spPr>
           <a:xfrm>
-            <a:off x="9582912" y="4480560"/>
-            <a:ext cx="2377440" cy="822960"/>
+            <a:off x="9582912" y="4160520"/>
+            <a:ext cx="2377440" cy="640080"/>
           </a:xfrm>
           <a:prstGeom prst="rect">
             <a:avLst/>
@@ -8861,7 +8867,7 @@
             <a:pPr algn="l">
               <a:defRPr sz="1150" b="0">
                 <a:solidFill>
-                  <a:srgbClr val="94A3B8"/>
+                  <a:srgbClr val="64748B"/>
                 </a:solidFill>
                 <a:latin typeface="Avenir Next"/>
               </a:defRPr>
@@ -8880,14 +8886,14 @@
         </p:nvSpPr>
         <p:spPr>
           <a:xfrm>
-            <a:off x="548640" y="5760720"/>
+            <a:off x="548640" y="5257800"/>
             <a:ext cx="11091672" cy="566928"/>
           </a:xfrm>
           <a:prstGeom prst="roundRect">
             <a:avLst/>
           </a:prstGeom>
           <a:solidFill>
-            <a:srgbClr val="2A374D"/>
+            <a:srgbClr val="E2E8F0"/>
           </a:solidFill>
           <a:ln>
             <a:noFill/>
@@ -8915,7 +8921,7 @@
             <a:pPr algn="ctr">
               <a:defRPr sz="1400" b="1">
                 <a:solidFill>
-                  <a:srgbClr val="FFFFFF"/>
+                  <a:srgbClr val="0F172A"/>
                 </a:solidFill>
                 <a:latin typeface="Avenir Next"/>
               </a:defRPr>
@@ -8959,7 +8965,7 @@
             <a:avLst/>
           </a:prstGeom>
           <a:solidFill>
-            <a:srgbClr val="0F172A"/>
+            <a:srgbClr val="FFFFFF"/>
           </a:solidFill>
           <a:ln>
             <a:noFill/>
@@ -9013,7 +9019,7 @@
             <a:pPr algn="l">
               <a:defRPr sz="1300" b="1">
                 <a:solidFill>
-                  <a:srgbClr val="14B8A6"/>
+                  <a:srgbClr val="0D9488"/>
                 </a:solidFill>
                 <a:latin typeface="Avenir Next"/>
               </a:defRPr>
@@ -9049,7 +9055,7 @@
             <a:pPr algn="l">
               <a:defRPr sz="3000" b="1">
                 <a:solidFill>
-                  <a:srgbClr val="FFFFFF"/>
+                  <a:srgbClr val="0F172A"/>
                 </a:solidFill>
                 <a:latin typeface="Avenir Next"/>
               </a:defRPr>
@@ -9075,7 +9081,7 @@
             <a:avLst/>
           </a:prstGeom>
           <a:solidFill>
-            <a:srgbClr val="14B8A6"/>
+            <a:srgbClr val="0D9488"/>
           </a:solidFill>
           <a:ln>
             <a:noFill/>
@@ -9119,7 +9125,7 @@
             <a:avLst/>
           </a:prstGeom>
           <a:solidFill>
-            <a:srgbClr val="1E293B"/>
+            <a:srgbClr val="F1F5F9"/>
           </a:solidFill>
           <a:ln>
             <a:noFill/>
@@ -9173,7 +9179,7 @@
             <a:pPr algn="l">
               <a:defRPr sz="1600" b="1">
                 <a:solidFill>
-                  <a:srgbClr val="FFFFFF"/>
+                  <a:srgbClr val="0F172A"/>
                 </a:solidFill>
                 <a:latin typeface="Avenir Next"/>
               </a:defRPr>
@@ -9209,7 +9215,7 @@
             <a:pPr algn="l">
               <a:defRPr sz="1200" b="0">
                 <a:solidFill>
-                  <a:srgbClr val="94A3B8"/>
+                  <a:srgbClr val="64748B"/>
                 </a:solidFill>
                 <a:latin typeface="Avenir Next"/>
               </a:defRPr>
@@ -9235,7 +9241,7 @@
             <a:avLst/>
           </a:prstGeom>
           <a:solidFill>
-            <a:srgbClr val="14B8A6"/>
+            <a:srgbClr val="0D9488"/>
           </a:solidFill>
           <a:ln>
             <a:noFill/>
@@ -9289,7 +9295,7 @@
             <a:avLst/>
           </a:prstGeom>
           <a:solidFill>
-            <a:srgbClr val="64748B"/>
+            <a:srgbClr val="475569"/>
           </a:solidFill>
           <a:ln>
             <a:noFill/>
@@ -9343,7 +9349,7 @@
             <a:avLst/>
           </a:prstGeom>
           <a:solidFill>
-            <a:srgbClr val="F59E0B"/>
+            <a:srgbClr val="D97706"/>
           </a:solidFill>
           <a:ln>
             <a:noFill/>
@@ -9397,7 +9403,7 @@
             <a:avLst/>
           </a:prstGeom>
           <a:solidFill>
-            <a:srgbClr val="3B82F6"/>
+            <a:srgbClr val="2563EB"/>
           </a:solidFill>
           <a:ln>
             <a:noFill/>
@@ -9451,7 +9457,7 @@
             <a:avLst/>
           </a:prstGeom>
           <a:solidFill>
-            <a:srgbClr val="8B5CF6"/>
+            <a:srgbClr val="7C3AED"/>
           </a:solidFill>
           <a:ln>
             <a:noFill/>
@@ -9505,7 +9511,7 @@
             <a:avLst/>
           </a:prstGeom>
           <a:solidFill>
-            <a:srgbClr val="1E293B"/>
+            <a:srgbClr val="F1F5F9"/>
           </a:solidFill>
           <a:ln>
             <a:noFill/>
@@ -9559,7 +9565,7 @@
             <a:pPr algn="l">
               <a:defRPr sz="1600" b="1">
                 <a:solidFill>
-                  <a:srgbClr val="FFFFFF"/>
+                  <a:srgbClr val="0F172A"/>
                 </a:solidFill>
                 <a:latin typeface="Avenir Next"/>
               </a:defRPr>
@@ -9595,7 +9601,7 @@
             <a:pPr algn="l">
               <a:defRPr sz="1200" b="0">
                 <a:solidFill>
-                  <a:srgbClr val="94A3B8"/>
+                  <a:srgbClr val="64748B"/>
                 </a:solidFill>
                 <a:latin typeface="Avenir Next"/>
               </a:defRPr>
@@ -9621,7 +9627,7 @@
             <a:avLst/>
           </a:prstGeom>
           <a:solidFill>
-            <a:srgbClr val="14B8A6"/>
+            <a:srgbClr val="0D9488"/>
           </a:solidFill>
           <a:ln>
             <a:noFill/>
@@ -9675,7 +9681,7 @@
             <a:avLst/>
           </a:prstGeom>
           <a:solidFill>
-            <a:srgbClr val="64748B"/>
+            <a:srgbClr val="475569"/>
           </a:solidFill>
           <a:ln>
             <a:noFill/>
@@ -9729,7 +9735,7 @@
             <a:avLst/>
           </a:prstGeom>
           <a:solidFill>
-            <a:srgbClr val="F59E0B"/>
+            <a:srgbClr val="D97706"/>
           </a:solidFill>
           <a:ln>
             <a:noFill/>
@@ -9783,7 +9789,7 @@
             <a:avLst/>
           </a:prstGeom>
           <a:solidFill>
-            <a:srgbClr val="3B82F6"/>
+            <a:srgbClr val="2563EB"/>
           </a:solidFill>
           <a:ln>
             <a:noFill/>
@@ -9837,7 +9843,7 @@
             <a:avLst/>
           </a:prstGeom>
           <a:solidFill>
-            <a:srgbClr val="8B5CF6"/>
+            <a:srgbClr val="7C3AED"/>
           </a:solidFill>
           <a:ln>
             <a:noFill/>
@@ -9901,7 +9907,7 @@
             <a:pPr algn="l">
               <a:defRPr sz="1300" b="1">
                 <a:solidFill>
-                  <a:srgbClr val="FFFFFF"/>
+                  <a:srgbClr val="0F172A"/>
                 </a:solidFill>
                 <a:latin typeface="Avenir Next"/>
               </a:defRPr>
@@ -9927,7 +9933,7 @@
             <a:avLst/>
           </a:prstGeom>
           <a:solidFill>
-            <a:srgbClr val="2A374D"/>
+            <a:srgbClr val="E2E8F0"/>
           </a:solidFill>
           <a:ln>
             <a:noFill/>
@@ -9955,7 +9961,7 @@
             <a:pPr algn="ctr">
               <a:defRPr sz="1200" b="0">
                 <a:solidFill>
-                  <a:srgbClr val="E2E8F0"/>
+                  <a:srgbClr val="334155"/>
                 </a:solidFill>
                 <a:latin typeface="Avenir Next"/>
               </a:defRPr>
@@ -9981,7 +9987,7 @@
             <a:avLst/>
           </a:prstGeom>
           <a:solidFill>
-            <a:srgbClr val="2A374D"/>
+            <a:srgbClr val="E2E8F0"/>
           </a:solidFill>
           <a:ln>
             <a:noFill/>
@@ -10009,7 +10015,7 @@
             <a:pPr algn="ctr">
               <a:defRPr sz="1200" b="0">
                 <a:solidFill>
-                  <a:srgbClr val="E2E8F0"/>
+                  <a:srgbClr val="334155"/>
                 </a:solidFill>
                 <a:latin typeface="Avenir Next"/>
               </a:defRPr>
@@ -10035,7 +10041,7 @@
             <a:avLst/>
           </a:prstGeom>
           <a:solidFill>
-            <a:srgbClr val="2A374D"/>
+            <a:srgbClr val="E2E8F0"/>
           </a:solidFill>
           <a:ln>
             <a:noFill/>
@@ -10063,7 +10069,7 @@
             <a:pPr algn="ctr">
               <a:defRPr sz="1200" b="0">
                 <a:solidFill>
-                  <a:srgbClr val="E2E8F0"/>
+                  <a:srgbClr val="334155"/>
                 </a:solidFill>
                 <a:latin typeface="Avenir Next"/>
               </a:defRPr>
@@ -10089,7 +10095,7 @@
             <a:avLst/>
           </a:prstGeom>
           <a:solidFill>
-            <a:srgbClr val="2A374D"/>
+            <a:srgbClr val="E2E8F0"/>
           </a:solidFill>
           <a:ln>
             <a:noFill/>
@@ -10117,7 +10123,7 @@
             <a:pPr algn="ctr">
               <a:defRPr sz="1200" b="0">
                 <a:solidFill>
-                  <a:srgbClr val="E2E8F0"/>
+                  <a:srgbClr val="334155"/>
                 </a:solidFill>
                 <a:latin typeface="Avenir Next"/>
               </a:defRPr>
@@ -10143,7 +10149,7 @@
             <a:avLst/>
           </a:prstGeom>
           <a:solidFill>
-            <a:srgbClr val="2A374D"/>
+            <a:srgbClr val="E2E8F0"/>
           </a:solidFill>
           <a:ln>
             <a:noFill/>
@@ -10171,7 +10177,7 @@
             <a:pPr algn="ctr">
               <a:defRPr sz="1200" b="0">
                 <a:solidFill>
-                  <a:srgbClr val="E2E8F0"/>
+                  <a:srgbClr val="334155"/>
                 </a:solidFill>
                 <a:latin typeface="Avenir Next"/>
               </a:defRPr>
@@ -10197,7 +10203,7 @@
             <a:avLst/>
           </a:prstGeom>
           <a:solidFill>
-            <a:srgbClr val="2A374D"/>
+            <a:srgbClr val="E2E8F0"/>
           </a:solidFill>
           <a:ln>
             <a:noFill/>
@@ -10225,7 +10231,7 @@
             <a:pPr algn="ctr">
               <a:defRPr sz="1200" b="0">
                 <a:solidFill>
-                  <a:srgbClr val="E2E8F0"/>
+                  <a:srgbClr val="334155"/>
                 </a:solidFill>
                 <a:latin typeface="Avenir Next"/>
               </a:defRPr>
@@ -10251,7 +10257,7 @@
             <a:avLst/>
           </a:prstGeom>
           <a:solidFill>
-            <a:srgbClr val="2A374D"/>
+            <a:srgbClr val="E2E8F0"/>
           </a:solidFill>
           <a:ln>
             <a:noFill/>
@@ -10279,7 +10285,7 @@
             <a:pPr algn="ctr">
               <a:defRPr sz="1200" b="0">
                 <a:solidFill>
-                  <a:srgbClr val="E2E8F0"/>
+                  <a:srgbClr val="334155"/>
                 </a:solidFill>
                 <a:latin typeface="Avenir Next"/>
               </a:defRPr>
@@ -10305,7 +10311,7 @@
             <a:avLst/>
           </a:prstGeom>
           <a:solidFill>
-            <a:srgbClr val="2A374D"/>
+            <a:srgbClr val="E2E8F0"/>
           </a:solidFill>
           <a:ln>
             <a:noFill/>
@@ -10333,7 +10339,7 @@
             <a:pPr algn="ctr">
               <a:defRPr sz="1200" b="0">
                 <a:solidFill>
-                  <a:srgbClr val="E2E8F0"/>
+                  <a:srgbClr val="334155"/>
                 </a:solidFill>
                 <a:latin typeface="Avenir Next"/>
               </a:defRPr>
@@ -10359,7 +10365,7 @@
             <a:avLst/>
           </a:prstGeom>
           <a:solidFill>
-            <a:srgbClr val="2A374D"/>
+            <a:srgbClr val="E2E8F0"/>
           </a:solidFill>
           <a:ln>
             <a:noFill/>
@@ -10387,7 +10393,7 @@
             <a:pPr algn="ctr">
               <a:defRPr sz="1200" b="0">
                 <a:solidFill>
-                  <a:srgbClr val="E2E8F0"/>
+                  <a:srgbClr val="334155"/>
                 </a:solidFill>
                 <a:latin typeface="Avenir Next"/>
               </a:defRPr>
@@ -10413,7 +10419,7 @@
             <a:avLst/>
           </a:prstGeom>
           <a:solidFill>
-            <a:srgbClr val="2A374D"/>
+            <a:srgbClr val="E2E8F0"/>
           </a:solidFill>
           <a:ln>
             <a:noFill/>
@@ -10441,7 +10447,7 @@
             <a:pPr algn="ctr">
               <a:defRPr sz="1200" b="0">
                 <a:solidFill>
-                  <a:srgbClr val="E2E8F0"/>
+                  <a:srgbClr val="334155"/>
                 </a:solidFill>
                 <a:latin typeface="Avenir Next"/>
               </a:defRPr>
@@ -10467,7 +10473,7 @@
             <a:avLst/>
           </a:prstGeom>
           <a:solidFill>
-            <a:srgbClr val="2A374D"/>
+            <a:srgbClr val="E2E8F0"/>
           </a:solidFill>
           <a:ln>
             <a:noFill/>
@@ -10495,7 +10501,7 @@
             <a:pPr algn="ctr">
               <a:defRPr sz="1200" b="0">
                 <a:solidFill>
-                  <a:srgbClr val="E2E8F0"/>
+                  <a:srgbClr val="334155"/>
                 </a:solidFill>
                 <a:latin typeface="Avenir Next"/>
               </a:defRPr>
@@ -10521,7 +10527,7 @@
             <a:avLst/>
           </a:prstGeom>
           <a:solidFill>
-            <a:srgbClr val="2A374D"/>
+            <a:srgbClr val="E2E8F0"/>
           </a:solidFill>
           <a:ln>
             <a:noFill/>
@@ -10549,7 +10555,7 @@
             <a:pPr algn="ctr">
               <a:defRPr sz="1200" b="0">
                 <a:solidFill>
-                  <a:srgbClr val="E2E8F0"/>
+                  <a:srgbClr val="334155"/>
                 </a:solidFill>
                 <a:latin typeface="Avenir Next"/>
               </a:defRPr>
@@ -10575,7 +10581,7 @@
             <a:avLst/>
           </a:prstGeom>
           <a:solidFill>
-            <a:srgbClr val="2A374D"/>
+            <a:srgbClr val="E2E8F0"/>
           </a:solidFill>
           <a:ln>
             <a:noFill/>
@@ -10603,7 +10609,7 @@
             <a:pPr algn="ctr">
               <a:defRPr sz="1200" b="0">
                 <a:solidFill>
-                  <a:srgbClr val="E2E8F0"/>
+                  <a:srgbClr val="334155"/>
                 </a:solidFill>
                 <a:latin typeface="Avenir Next"/>
               </a:defRPr>
@@ -10639,7 +10645,7 @@
             <a:pPr algn="l">
               <a:defRPr sz="1200" b="0">
                 <a:solidFill>
-                  <a:srgbClr val="94A3B8"/>
+                  <a:srgbClr val="64748B"/>
                 </a:solidFill>
                 <a:latin typeface="Avenir Next"/>
               </a:defRPr>
@@ -10683,7 +10689,7 @@
             <a:avLst/>
           </a:prstGeom>
           <a:solidFill>
-            <a:srgbClr val="0F172A"/>
+            <a:srgbClr val="FFFFFF"/>
           </a:solidFill>
           <a:ln>
             <a:noFill/>
@@ -10737,7 +10743,7 @@
             <a:pPr algn="l">
               <a:defRPr sz="1300" b="1">
                 <a:solidFill>
-                  <a:srgbClr val="14B8A6"/>
+                  <a:srgbClr val="0D9488"/>
                 </a:solidFill>
                 <a:latin typeface="Avenir Next"/>
               </a:defRPr>
@@ -10773,7 +10779,7 @@
             <a:pPr algn="l">
               <a:defRPr sz="3000" b="1">
                 <a:solidFill>
-                  <a:srgbClr val="FFFFFF"/>
+                  <a:srgbClr val="0F172A"/>
                 </a:solidFill>
                 <a:latin typeface="Avenir Next"/>
               </a:defRPr>
@@ -10799,7 +10805,7 @@
             <a:avLst/>
           </a:prstGeom>
           <a:solidFill>
-            <a:srgbClr val="14B8A6"/>
+            <a:srgbClr val="0D9488"/>
           </a:solidFill>
           <a:ln>
             <a:noFill/>
@@ -10843,7 +10849,7 @@
             <a:avLst/>
           </a:prstGeom>
           <a:solidFill>
-            <a:srgbClr val="1E293B"/>
+            <a:srgbClr val="F1F5F9"/>
           </a:solidFill>
           <a:ln>
             <a:noFill/>
@@ -10897,7 +10903,7 @@
             <a:pPr algn="l">
               <a:defRPr sz="1700" b="1">
                 <a:solidFill>
-                  <a:srgbClr val="22C55E"/>
+                  <a:srgbClr val="15803D"/>
                 </a:solidFill>
                 <a:latin typeface="Avenir Next"/>
               </a:defRPr>
@@ -10933,7 +10939,7 @@
             <a:pPr algn="l">
               <a:defRPr sz="1600" b="1">
                 <a:solidFill>
-                  <a:srgbClr val="22C55E"/>
+                  <a:srgbClr val="15803D"/>
                 </a:solidFill>
                 <a:latin typeface="Avenir Next"/>
               </a:defRPr>
@@ -10969,7 +10975,7 @@
             <a:pPr algn="l">
               <a:defRPr sz="1300" b="0">
                 <a:solidFill>
-                  <a:srgbClr val="E2E8F0"/>
+                  <a:srgbClr val="334155"/>
                 </a:solidFill>
                 <a:latin typeface="Avenir Next"/>
               </a:defRPr>
@@ -11005,7 +11011,7 @@
             <a:pPr algn="l">
               <a:defRPr sz="1600" b="1">
                 <a:solidFill>
-                  <a:srgbClr val="22C55E"/>
+                  <a:srgbClr val="15803D"/>
                 </a:solidFill>
                 <a:latin typeface="Avenir Next"/>
               </a:defRPr>
@@ -11041,7 +11047,7 @@
             <a:pPr algn="l">
               <a:defRPr sz="1300" b="0">
                 <a:solidFill>
-                  <a:srgbClr val="E2E8F0"/>
+                  <a:srgbClr val="334155"/>
                 </a:solidFill>
                 <a:latin typeface="Avenir Next"/>
               </a:defRPr>
@@ -11077,7 +11083,7 @@
             <a:pPr algn="l">
               <a:defRPr sz="1600" b="1">
                 <a:solidFill>
-                  <a:srgbClr val="22C55E"/>
+                  <a:srgbClr val="15803D"/>
                 </a:solidFill>
                 <a:latin typeface="Avenir Next"/>
               </a:defRPr>
@@ -11113,7 +11119,7 @@
             <a:pPr algn="l">
               <a:defRPr sz="1300" b="0">
                 <a:solidFill>
-                  <a:srgbClr val="E2E8F0"/>
+                  <a:srgbClr val="334155"/>
                 </a:solidFill>
                 <a:latin typeface="Avenir Next"/>
               </a:defRPr>
@@ -11139,7 +11145,7 @@
             <a:avLst/>
           </a:prstGeom>
           <a:solidFill>
-            <a:srgbClr val="1E293B"/>
+            <a:srgbClr val="F1F5F9"/>
           </a:solidFill>
           <a:ln>
             <a:noFill/>
@@ -11193,7 +11199,7 @@
             <a:pPr algn="l">
               <a:defRPr sz="1700" b="1">
                 <a:solidFill>
-                  <a:srgbClr val="F59E0B"/>
+                  <a:srgbClr val="D97706"/>
                 </a:solidFill>
                 <a:latin typeface="Avenir Next"/>
               </a:defRPr>
@@ -11229,7 +11235,7 @@
             <a:pPr algn="l">
               <a:defRPr sz="1600" b="1">
                 <a:solidFill>
-                  <a:srgbClr val="F59E0B"/>
+                  <a:srgbClr val="D97706"/>
                 </a:solidFill>
                 <a:latin typeface="Avenir Next"/>
               </a:defRPr>
@@ -11265,7 +11271,7 @@
             <a:pPr algn="l">
               <a:defRPr sz="1300" b="0">
                 <a:solidFill>
-                  <a:srgbClr val="E2E8F0"/>
+                  <a:srgbClr val="334155"/>
                 </a:solidFill>
                 <a:latin typeface="Avenir Next"/>
               </a:defRPr>
@@ -11301,7 +11307,7 @@
             <a:pPr algn="l">
               <a:defRPr sz="1600" b="1">
                 <a:solidFill>
-                  <a:srgbClr val="F59E0B"/>
+                  <a:srgbClr val="D97706"/>
                 </a:solidFill>
                 <a:latin typeface="Avenir Next"/>
               </a:defRPr>
@@ -11337,7 +11343,7 @@
             <a:pPr algn="l">
               <a:defRPr sz="1300" b="0">
                 <a:solidFill>
-                  <a:srgbClr val="E2E8F0"/>
+                  <a:srgbClr val="334155"/>
                 </a:solidFill>
                 <a:latin typeface="Avenir Next"/>
               </a:defRPr>
@@ -11373,7 +11379,7 @@
             <a:pPr algn="l">
               <a:defRPr sz="1600" b="1">
                 <a:solidFill>
-                  <a:srgbClr val="F59E0B"/>
+                  <a:srgbClr val="D97706"/>
                 </a:solidFill>
                 <a:latin typeface="Avenir Next"/>
               </a:defRPr>
@@ -11409,7 +11415,7 @@
             <a:pPr algn="l">
               <a:defRPr sz="1300" b="0">
                 <a:solidFill>
-                  <a:srgbClr val="E2E8F0"/>
+                  <a:srgbClr val="334155"/>
                 </a:solidFill>
                 <a:latin typeface="Avenir Next"/>
               </a:defRPr>

</xml_diff>

<commit_message>
Adopt the two-layer lane naming; update deck vocabulary to match
Public module names are CSE/<Compiler>/<Lane> with capitalized Serial/
MPI/GPU, qualified only when the system is ambiguous (two MPIs ->
MPI-<impl> plus a GPU lane per MPI; two GPU archs -> GPU-<arch>).
Internal rendered lane ids keep the fully-qualified facts for machines
and oracle diffs. Deck slides (lane pills, module load commands, pilot
surfaces, vocabulary cards) updated to the new syntax; verified through
Keynote export.
</commit_message>
<xml_diff>
--- a/presentations/cse_lanes_model.pptx
+++ b/presentations/cse_lanes_model.pptx
@@ -4659,7 +4659,7 @@
               </a:defRPr>
             </a:pPr>
             <a:r>
-              <a:t>module load cse/gcc</a:t>
+              <a:t>module load CSE/GCC</a:t>
             </a:r>
           </a:p>
         </p:txBody>
@@ -4931,7 +4931,7 @@
               </a:defRPr>
             </a:pPr>
             <a:r>
-              <a:t>serial</a:t>
+              <a:t>Serial</a:t>
             </a:r>
           </a:p>
         </p:txBody>
@@ -4985,7 +4985,7 @@
               </a:defRPr>
             </a:pPr>
             <a:r>
-              <a:t>mpi</a:t>
+              <a:t>MPI</a:t>
             </a:r>
           </a:p>
         </p:txBody>
@@ -5039,7 +5039,7 @@
               </a:defRPr>
             </a:pPr>
             <a:r>
-              <a:t>gpu</a:t>
+              <a:t>GPU</a:t>
             </a:r>
           </a:p>
         </p:txBody>
@@ -6895,7 +6895,7 @@
               </a:defRPr>
             </a:pPr>
             <a:r>
-              <a:t>serial</a:t>
+              <a:t>Serial</a:t>
             </a:r>
           </a:p>
           <a:p>
@@ -6999,7 +6999,7 @@
               </a:defRPr>
             </a:pPr>
             <a:r>
-              <a:t>mpi-craympich</a:t>
+              <a:t>MPI</a:t>
             </a:r>
           </a:p>
           <a:p>
@@ -7012,7 +7012,7 @@
               </a:defRPr>
             </a:pPr>
             <a:r>
-              <a:t>hdf5+mpi · netcdf · tau</a:t>
+              <a:t>Cray MPICH · hdf5+mpi · netcdf · tau</a:t>
             </a:r>
           </a:p>
         </p:txBody>
@@ -7103,7 +7103,7 @@
               </a:defRPr>
             </a:pPr>
             <a:r>
-              <a:t>gpu-craympich-gfx942</a:t>
+              <a:t>GPU</a:t>
             </a:r>
           </a:p>
           <a:p>
@@ -7116,7 +7116,7 @@
               </a:defRPr>
             </a:pPr>
             <a:r>
-              <a:t>kokkos — arch from the probe</a:t>
+              <a:t>kokkos · rocm — arch from the probe</a:t>
             </a:r>
           </a:p>
         </p:txBody>
@@ -7399,7 +7399,7 @@
               </a:defRPr>
             </a:pPr>
             <a:r>
-              <a:t>$ module load cse/gcc</a:t>
+              <a:t>$ module load CSE/GCC</a:t>
             </a:r>
           </a:p>
         </p:txBody>
@@ -7697,7 +7697,7 @@
               </a:defRPr>
             </a:pPr>
             <a:r>
-              <a:t>serial</a:t>
+              <a:t>Serial</a:t>
             </a:r>
           </a:p>
           <a:p>
@@ -7764,7 +7764,7 @@
               </a:defRPr>
             </a:pPr>
             <a:r>
-              <a:t>mpi-craympich</a:t>
+              <a:t>MPI</a:t>
             </a:r>
           </a:p>
           <a:p>
@@ -7777,7 +7777,7 @@
               </a:defRPr>
             </a:pPr>
             <a:r>
-              <a:t>hdf5+mpi · netcdf · tau</a:t>
+              <a:t>Cray MPICH · hdf5+mpi · netcdf · tau</a:t>
             </a:r>
           </a:p>
         </p:txBody>
@@ -7831,7 +7831,7 @@
               </a:defRPr>
             </a:pPr>
             <a:r>
-              <a:t>gpu-craympich-gfx942</a:t>
+              <a:t>GPU</a:t>
             </a:r>
           </a:p>
           <a:p>
@@ -8213,7 +8213,7 @@
               </a:defRPr>
             </a:pPr>
             <a:r>
-              <a:t>core</a:t>
+              <a:t>Core</a:t>
             </a:r>
           </a:p>
         </p:txBody>
@@ -8249,7 +8249,7 @@
               </a:defRPr>
             </a:pPr>
             <a:r>
-              <a:t>No MPI implementation exists for it, or it is a compiler-agnostic building block.</a:t>
+              <a:t>No MPI implementation exists for it, or it is a compiler-agnostic building block. Loads with the surface.</a:t>
             </a:r>
           </a:p>
         </p:txBody>
@@ -8409,7 +8409,7 @@
               </a:defRPr>
             </a:pPr>
             <a:r>
-              <a:t>serial</a:t>
+              <a:t>Serial</a:t>
             </a:r>
           </a:p>
         </p:txBody>
@@ -8605,7 +8605,7 @@
               </a:defRPr>
             </a:pPr>
             <a:r>
-              <a:t>mpi-&lt;impl&gt;</a:t>
+              <a:t>MPI</a:t>
             </a:r>
           </a:p>
         </p:txBody>
@@ -8641,7 +8641,7 @@
               </a:defRPr>
             </a:pPr>
             <a:r>
-              <a:t>Built against the named MPI implementation.</a:t>
+              <a:t>Built against the system MPI. Qualified only when the system offers more than one.</a:t>
             </a:r>
           </a:p>
         </p:txBody>
@@ -8677,7 +8677,7 @@
               </a:defRPr>
             </a:pPr>
             <a:r>
-              <a:t>mpi-craympich · mpi-openmpi</a:t>
+              <a:t>MPI  ·  or MPI-openmpi / MPI-mpich</a:t>
             </a:r>
           </a:p>
         </p:txBody>
@@ -8801,7 +8801,7 @@
               </a:defRPr>
             </a:pPr>
             <a:r>
-              <a:t>gpu-&lt;impl&gt;-&lt;arch&gt;</a:t>
+              <a:t>GPU</a:t>
             </a:r>
           </a:p>
         </p:txBody>
@@ -8837,7 +8837,7 @@
               </a:defRPr>
             </a:pPr>
             <a:r>
-              <a:t>GPU backend over GPU-aware MPI, targeted at the probed architecture.</a:t>
+              <a:t>GPU backend over GPU-aware MPI. Qualified by MPI or arch only when the system is ambiguous.</a:t>
             </a:r>
           </a:p>
         </p:txBody>
@@ -8873,7 +8873,7 @@
               </a:defRPr>
             </a:pPr>
             <a:r>
-              <a:t>gpu-craympich-gfx942</a:t>
+              <a:t>GPU  ·  or GPU-gfx90a / GPU-gfx942</a:t>
             </a:r>
           </a:p>
         </p:txBody>
@@ -8927,7 +8927,7 @@
               </a:defRPr>
             </a:pPr>
             <a:r>
-              <a:t>The GPU lane is called gpu-craympich-gfx942 — never gpu-kokkos. Kokkos is what it carries today.</a:t>
+              <a:t>Modules: CSE/&lt;Compiler&gt;/&lt;Lane&gt; — named by facts, qualified only when ambiguous, never by contents (GPU, not GPU-kokkos).</a:t>
             </a:r>
           </a:p>
         </p:txBody>
@@ -9185,7 +9185,7 @@
               </a:defRPr>
             </a:pPr>
             <a:r>
-              <a:t>cse/&lt;system-default&gt;</a:t>
+              <a:t>CSE/&lt;SystemDefault&gt;</a:t>
             </a:r>
           </a:p>
         </p:txBody>
@@ -9275,7 +9275,7 @@
               </a:defRPr>
             </a:pPr>
             <a:r>
-              <a:t>core (automatic)</a:t>
+              <a:t>Core (automatic)</a:t>
             </a:r>
           </a:p>
         </p:txBody>
@@ -9329,7 +9329,7 @@
               </a:defRPr>
             </a:pPr>
             <a:r>
-              <a:t>foundation (view)</a:t>
+              <a:t>Foundation (view)</a:t>
             </a:r>
           </a:p>
         </p:txBody>
@@ -9383,7 +9383,7 @@
               </a:defRPr>
             </a:pPr>
             <a:r>
-              <a:t>serial</a:t>
+              <a:t>Serial</a:t>
             </a:r>
           </a:p>
         </p:txBody>
@@ -9437,7 +9437,7 @@
               </a:defRPr>
             </a:pPr>
             <a:r>
-              <a:t>mpi</a:t>
+              <a:t>MPI</a:t>
             </a:r>
           </a:p>
         </p:txBody>
@@ -9491,7 +9491,7 @@
               </a:defRPr>
             </a:pPr>
             <a:r>
-              <a:t>gpu</a:t>
+              <a:t>GPU</a:t>
             </a:r>
           </a:p>
         </p:txBody>
@@ -9571,7 +9571,7 @@
               </a:defRPr>
             </a:pPr>
             <a:r>
-              <a:t>cse/gcc</a:t>
+              <a:t>CSE/GCC</a:t>
             </a:r>
           </a:p>
         </p:txBody>
@@ -9661,7 +9661,7 @@
               </a:defRPr>
             </a:pPr>
             <a:r>
-              <a:t>core (automatic)</a:t>
+              <a:t>Core (automatic)</a:t>
             </a:r>
           </a:p>
         </p:txBody>
@@ -9715,7 +9715,7 @@
               </a:defRPr>
             </a:pPr>
             <a:r>
-              <a:t>foundation (view)</a:t>
+              <a:t>Foundation (view)</a:t>
             </a:r>
           </a:p>
         </p:txBody>
@@ -9769,7 +9769,7 @@
               </a:defRPr>
             </a:pPr>
             <a:r>
-              <a:t>serial</a:t>
+              <a:t>Serial</a:t>
             </a:r>
           </a:p>
         </p:txBody>
@@ -9823,7 +9823,7 @@
               </a:defRPr>
             </a:pPr>
             <a:r>
-              <a:t>mpi</a:t>
+              <a:t>MPI</a:t>
             </a:r>
           </a:p>
         </p:txBody>
@@ -9877,7 +9877,7 @@
               </a:defRPr>
             </a:pPr>
             <a:r>
-              <a:t>gpu</a:t>
+              <a:t>GPU</a:t>
             </a:r>
           </a:p>
         </p:txBody>

</xml_diff>

<commit_message>
Document lane exposure and module compatibility policy
</commit_message>
<xml_diff>
--- a/presentations/cse_lanes_model.pptx
+++ b/presentations/cse_lanes_model.pptx
@@ -4510,7 +4510,7 @@
               </a:defRPr>
             </a:pPr>
             <a:r>
-              <a:t>Conflicts avoided by convention · MPI/GPU surfaces not isolated ·</a:t>
+              <a:t>GPU is a complete MPI-capable lane when the selected toolchain supports it ·</a:t>
             </a:r>
           </a:p>
           <a:p>
@@ -4523,7 +4523,7 @@
               </a:defRPr>
             </a:pPr>
             <a:r>
-              <a:t>hand-curated per system — upgrades mean rebuilding everything</a:t>
+              <a:t>package modules prevent incompatible version mixes</a:t>
             </a:r>
           </a:p>
         </p:txBody>
@@ -4659,7 +4659,7 @@
               </a:defRPr>
             </a:pPr>
             <a:r>
-              <a:t>module load CSE/GCC</a:t>
+              <a:t>module load cse/GCC</a:t>
             </a:r>
           </a:p>
         </p:txBody>
@@ -5101,7 +5101,7 @@
               </a:defRPr>
             </a:pPr>
             <a:r>
-              <a:t>versions inside a lane stay a one-at-a-time module choice</a:t>
+              <a:t>versions inside a lane stay a policy-backed module choice</a:t>
             </a:r>
           </a:p>
         </p:txBody>
@@ -7399,7 +7399,7 @@
               </a:defRPr>
             </a:pPr>
             <a:r>
-              <a:t>$ module load CSE/GCC</a:t>
+              <a:t>$ module load cse/GCC</a:t>
             </a:r>
           </a:p>
         </p:txBody>
@@ -7844,7 +7844,7 @@
               </a:defRPr>
             </a:pPr>
             <a:r>
-              <a:t>kokkos +rocm gfx942</a:t>
+              <a:t>GPU-aware MPI · kokkos +rocm gfx942</a:t>
             </a:r>
           </a:p>
         </p:txBody>
@@ -7898,7 +7898,7 @@
               </a:defRPr>
             </a:pPr>
             <a:r>
-              <a:t>Only the chosen lane is visible — no contamination, no accidental MPI/GPU linkage.</a:t>
+              <a:t>Only the chosen lane is visible — GPU includes its compatible MPI surface.</a:t>
             </a:r>
           </a:p>
           <a:p>
@@ -7911,7 +7911,7 @@
               </a:defRPr>
             </a:pPr>
             <a:r>
-              <a:t>Two HDF5 versions in a lane? The same one-at-a-time module choice users already know.</a:t>
+              <a:t>Clean module names stay; module metadata blocks incompatible HDF5/NetCDF-style version mixes.</a:t>
             </a:r>
           </a:p>
         </p:txBody>
@@ -8837,7 +8837,7 @@
               </a:defRPr>
             </a:pPr>
             <a:r>
-              <a:t>GPU backend over GPU-aware MPI. Qualified by MPI or arch only when the system is ambiguous.</a:t>
+              <a:t>Complete MPI+GPU lane over a compatible compiler, MPI, and GPU toolkit. Load GPU instead of MPI, not in addition to it.</a:t>
             </a:r>
           </a:p>
         </p:txBody>
@@ -8927,7 +8927,7 @@
               </a:defRPr>
             </a:pPr>
             <a:r>
-              <a:t>Modules: CSE/&lt;Compiler&gt;/&lt;Lane&gt; — named by facts, qualified only when ambiguous, never by contents (GPU, not GPU-kokkos).</a:t>
+              <a:t>Modules: cse/&lt;Compiler&gt;/&lt;Lane&gt; — short names for users; dependency compatibility is enforced by module metadata.</a:t>
             </a:r>
           </a:p>
         </p:txBody>
@@ -9185,7 +9185,7 @@
               </a:defRPr>
             </a:pPr>
             <a:r>
-              <a:t>CSE/&lt;SystemDefault&gt;</a:t>
+              <a:t>cse/&lt;SystemDefault&gt;</a:t>
             </a:r>
           </a:p>
         </p:txBody>
@@ -9571,7 +9571,7 @@
               </a:defRPr>
             </a:pPr>
             <a:r>
-              <a:t>CSE/GCC</a:t>
+              <a:t>cse/GCC</a:t>
             </a:r>
           </a:p>
         </p:txBody>
@@ -10651,7 +10651,7 @@
               </a:defRPr>
             </a:pPr>
             <a:r>
-              <a:t>Multi-version by policy: unify:false lanes · single-version pinned foundation · conflicts stay a module choice</a:t>
+              <a:t>Multi-version by policy: clean package names · compatible chains load · incompatible mixes fail clearly</a:t>
             </a:r>
           </a:p>
         </p:txBody>
@@ -11277,7 +11277,7 @@
               </a:defRPr>
             </a:pPr>
             <a:r>
-              <a:t>Build the science lanes on the Cray system; verify the module/view front door</a:t>
+              <a:t>Build science lanes on Cray and Linux systems; verify the module/view front door</a:t>
             </a:r>
           </a:p>
         </p:txBody>
@@ -11349,7 +11349,7 @@
               </a:defRPr>
             </a:pPr>
             <a:r>
-              <a:t>Add the second compiler surface, then the NVIDIA system in parallel</a:t>
+              <a:t>Encode module compatibility checks for multi-version package chains</a:t>
             </a:r>
           </a:p>
         </p:txBody>

</xml_diff>

<commit_message>
Team-facing wording pass on the SOP and deck
Unify on the team term "common compiler-dependent packages" (the schema
key stays lane_agnostic), replace compressed dash-chain phrasing in SOP
section 6 and the deck appendix notes with plain sentences, and reword
the status-slide roster line.
</commit_message>
<xml_diff>
--- a/presentations/cse_lanes_model.pptx
+++ b/presentations/cse_lanes_model.pptx
@@ -4319,7 +4319,7 @@
                         </a:defRPr>
                       </a:pPr>
                       <a:r>
-                        <a:t>~mpi — dual-build: the MPI lane carries its own +mpi boost</a:t>
+                        <a:t>~mpi here; the MPI lane carries its own +mpi build</a:t>
                       </a:r>
                     </a:p>
                   </a:txBody>
@@ -4345,7 +4345,7 @@
                         </a:defRPr>
                       </a:pPr>
                       <a:r>
-                        <a:t>Lane-agnostic — built here once, module-visible in every lane</a:t>
+                        <a:t>Common compiler-dependent — built here once, available in every lane</a:t>
                       </a:r>
                     </a:p>
                   </a:txBody>
@@ -4435,7 +4435,7 @@
                         </a:defRPr>
                       </a:pPr>
                       <a:r>
-                        <a:t>performance-sensitive so payload, not core — BLAS for all lanes</a:t>
+                        <a:t>performance-sensitive, so payload rather than core; the BLAS every lane links</a:t>
                       </a:r>
                     </a:p>
                   </a:txBody>
@@ -4509,7 +4509,7 @@
                         </a:defRPr>
                       </a:pPr>
                       <a:r>
-                        <a:t>reference LAPACK alongside openblas — flagged for team review</a:t>
+                        <a:t>reference LAPACK alongside openblas (flagged for team review)</a:t>
                       </a:r>
                     </a:p>
                   </a:txBody>
@@ -4583,7 +4583,7 @@
                         </a:defRPr>
                       </a:pPr>
                       <a:r>
-                        <a:t>needs the surface's compiler for compatibility — payload, not core</a:t>
+                        <a:t>needs the surface's compiler, so payload rather than core</a:t>
                       </a:r>
                     </a:p>
                   </a:txBody>
@@ -5426,7 +5426,7 @@
                         </a:defRPr>
                       </a:pPr>
                       <a:r>
-                        <a:t>+mpi — dual-build with the serial lane's ~mpi boost</a:t>
+                        <a:t>+mpi; the Serial lane carries its own ~mpi build</a:t>
                       </a:r>
                     </a:p>
                   </a:txBody>
@@ -5716,7 +5716,7 @@
                         </a:defRPr>
                       </a:pPr>
                       <a:r>
-                        <a:t>Lane-agnostic — one serial-lane build, exposed here too</a:t>
+                        <a:t>Common compiler-dependent — the Serial-lane build, available here too</a:t>
                       </a:r>
                     </a:p>
                   </a:txBody>
@@ -5758,7 +5758,7 @@
                         </a:defRPr>
                       </a:pPr>
                       <a:r>
-                        <a:t>lane-agnostic set</a:t>
+                        <a:t>common packages</a:t>
                       </a:r>
                     </a:p>
                   </a:txBody>
@@ -5806,7 +5806,7 @@
                         </a:defRPr>
                       </a:pPr>
                       <a:r>
-                        <a:t>openblas · netlib-lapack · gnuplot — same modules via the shared root, no rebuild</a:t>
+                        <a:t>openblas · netlib-lapack · gnuplot: the same modules through the shared root, nothing rebuilt</a:t>
                       </a:r>
                     </a:p>
                   </a:txBody>
@@ -13574,7 +13574,7 @@
               </a:defRPr>
             </a:pPr>
             <a:r>
-              <a:t>Science stack — four lanes, two-version roster — renders clean today</a:t>
+              <a:t>Science stack renders clean today: four lanes, two-version roster</a:t>
             </a:r>
           </a:p>
         </p:txBody>

</xml_diff>

<commit_message>
Deck: bring lane descriptions current; add layer-stacking appendix slide
The lane vocabulary and example slides still described the pre-exposure
model. Serial now names its two classes (non-MPI builds of MPI-capable
packages; common compiler-dependent packages every lane can load), GPU is
described as the full MPI roster plus the GPU payload, and the lane
example boxes on the build/user-flow slides use the current rosters. New
first appendix slide shows the layer stacking: one payload choice over the
common packages, Core, Foundation, and the compiler surface. Roster chips
gain Dakota and Gnuplot.
</commit_message>
<xml_diff>
--- a/presentations/cse_lanes_model.pptx
+++ b/presentations/cse_lanes_model.pptx
@@ -16,6 +16,7 @@
     <p:sldId id="264" r:id="rId15"/>
     <p:sldId id="265" r:id="rId16"/>
     <p:sldId id="266" r:id="rId17"/>
+    <p:sldId id="267" r:id="rId18"/>
   </p:sldIdLst>
   <p:sldSz cx="12191695" cy="6858000" type="screen4x3"/>
   <p:notesSz cx="6858000" cy="9144000"/>
@@ -3536,6 +3537,1178 @@
 </file>
 
 <file path=ppt/slides/slide10.xml><?xml version="1.0" encoding="utf-8"?>
+<p:sld xmlns:a="http://schemas.openxmlformats.org/drawingml/2006/main" xmlns:p="http://schemas.openxmlformats.org/presentationml/2006/main" xmlns:r="http://schemas.openxmlformats.org/officeDocument/2006/relationships">
+  <p:cSld>
+    <p:spTree>
+      <p:nvGrpSpPr>
+        <p:cNvPr id="1" name=""/>
+        <p:cNvGrpSpPr/>
+        <p:nvPr/>
+      </p:nvGrpSpPr>
+      <p:grpSpPr/>
+      <p:sp>
+        <p:nvSpPr>
+          <p:cNvPr id="2" name="Rectangle 1"/>
+          <p:cNvSpPr/>
+          <p:nvPr/>
+        </p:nvSpPr>
+        <p:spPr>
+          <a:xfrm>
+            <a:off x="0" y="0"/>
+            <a:ext cx="12191695" cy="6858000"/>
+          </a:xfrm>
+          <a:prstGeom prst="rect">
+            <a:avLst/>
+          </a:prstGeom>
+          <a:solidFill>
+            <a:srgbClr val="FFFFFF"/>
+          </a:solidFill>
+          <a:ln>
+            <a:noFill/>
+          </a:ln>
+          <a:effectLst/>
+        </p:spPr>
+        <p:style>
+          <a:lnRef idx="1">
+            <a:schemeClr val="accent1"/>
+          </a:lnRef>
+          <a:fillRef idx="3">
+            <a:schemeClr val="accent1"/>
+          </a:fillRef>
+          <a:effectRef idx="2">
+            <a:schemeClr val="accent1"/>
+          </a:effectRef>
+          <a:fontRef idx="minor">
+            <a:schemeClr val="lt1"/>
+          </a:fontRef>
+        </p:style>
+        <p:txBody>
+          <a:bodyPr rtlCol="0" anchor="ctr"/>
+          <a:lstStyle/>
+          <a:p>
+            <a:pPr algn="ctr"/>
+          </a:p>
+        </p:txBody>
+      </p:sp>
+      <p:sp>
+        <p:nvSpPr>
+          <p:cNvPr id="3" name="TextBox 2"/>
+          <p:cNvSpPr txBox="1"/>
+          <p:nvPr/>
+        </p:nvSpPr>
+        <p:spPr>
+          <a:xfrm>
+            <a:off x="548640" y="256032"/>
+            <a:ext cx="10972800" cy="365760"/>
+          </a:xfrm>
+          <a:prstGeom prst="rect">
+            <a:avLst/>
+          </a:prstGeom>
+          <a:noFill/>
+        </p:spPr>
+        <p:txBody>
+          <a:bodyPr wrap="square" anchor="t">
+            <a:spAutoFit/>
+          </a:bodyPr>
+          <a:lstStyle/>
+          <a:p>
+            <a:pPr algn="l">
+              <a:defRPr sz="1300" b="1">
+                <a:solidFill>
+                  <a:srgbClr val="0D9488"/>
+                </a:solidFill>
+                <a:latin typeface="Avenir Next"/>
+              </a:defRPr>
+            </a:pPr>
+            <a:r>
+              <a:t>APPENDIX · EXACT BUILD ROOTS</a:t>
+            </a:r>
+          </a:p>
+        </p:txBody>
+      </p:sp>
+      <p:sp>
+        <p:nvSpPr>
+          <p:cNvPr id="4" name="TextBox 3"/>
+          <p:cNvSpPr txBox="1"/>
+          <p:nvPr/>
+        </p:nvSpPr>
+        <p:spPr>
+          <a:xfrm>
+            <a:off x="548640" y="566928"/>
+            <a:ext cx="11064240" cy="731520"/>
+          </a:xfrm>
+          <a:prstGeom prst="rect">
+            <a:avLst/>
+          </a:prstGeom>
+          <a:noFill/>
+        </p:spPr>
+        <p:txBody>
+          <a:bodyPr wrap="square" anchor="t">
+            <a:spAutoFit/>
+          </a:bodyPr>
+          <a:lstStyle/>
+          <a:p>
+            <a:pPr algn="l">
+              <a:defRPr sz="3000" b="1">
+                <a:solidFill>
+                  <a:srgbClr val="0F172A"/>
+                </a:solidFill>
+                <a:latin typeface="Avenir Next"/>
+              </a:defRPr>
+            </a:pPr>
+            <a:r>
+              <a:t>Core and foundation — built once per compiler surface</a:t>
+            </a:r>
+          </a:p>
+        </p:txBody>
+      </p:sp>
+      <p:sp>
+        <p:nvSpPr>
+          <p:cNvPr id="5" name="Rectangle 4"/>
+          <p:cNvSpPr/>
+          <p:nvPr/>
+        </p:nvSpPr>
+        <p:spPr>
+          <a:xfrm>
+            <a:off x="566928" y="1298448"/>
+            <a:ext cx="1463040" cy="41148"/>
+          </a:xfrm>
+          <a:prstGeom prst="rect">
+            <a:avLst/>
+          </a:prstGeom>
+          <a:solidFill>
+            <a:srgbClr val="0D9488"/>
+          </a:solidFill>
+          <a:ln>
+            <a:noFill/>
+          </a:ln>
+          <a:effectLst/>
+        </p:spPr>
+        <p:style>
+          <a:lnRef idx="1">
+            <a:schemeClr val="accent1"/>
+          </a:lnRef>
+          <a:fillRef idx="3">
+            <a:schemeClr val="accent1"/>
+          </a:fillRef>
+          <a:effectRef idx="2">
+            <a:schemeClr val="accent1"/>
+          </a:effectRef>
+          <a:fontRef idx="minor">
+            <a:schemeClr val="lt1"/>
+          </a:fontRef>
+        </p:style>
+        <p:txBody>
+          <a:bodyPr rtlCol="0" anchor="ctr"/>
+          <a:lstStyle/>
+          <a:p>
+            <a:pPr algn="ctr"/>
+          </a:p>
+        </p:txBody>
+      </p:sp>
+      <p:graphicFrame>
+        <p:nvGraphicFramePr>
+          <p:cNvPr id="6" name="Table 5"/>
+          <p:cNvGraphicFramePr>
+            <a:graphicFrameLocks noGrp="1"/>
+          </p:cNvGraphicFramePr>
+          <p:nvPr/>
+        </p:nvGraphicFramePr>
+        <p:xfrm>
+          <a:off x="548640" y="1481328"/>
+          <a:ext cx="11091672" cy="4224528"/>
+        </p:xfrm>
+        <a:graphic>
+          <a:graphicData uri="http://schemas.openxmlformats.org/drawingml/2006/table">
+            <a:tbl>
+              <a:tblPr>
+                <a:tableStyleId>{5C22544A-7EE6-4342-B048-85BDC9FD1C3A}</a:tableStyleId>
+              </a:tblPr>
+              <a:tblGrid>
+                <a:gridCol w="1920240"/>
+                <a:gridCol w="2286000"/>
+                <a:gridCol w="6885432"/>
+              </a:tblGrid>
+              <a:tr h="301752">
+                <a:tc>
+                  <a:txBody>
+                    <a:bodyPr/>
+                    <a:lstStyle/>
+                    <a:p>
+                      <a:pPr>
+                        <a:defRPr sz="1100" b="1">
+                          <a:solidFill>
+                            <a:srgbClr val="64748B"/>
+                          </a:solidFill>
+                          <a:latin typeface="Avenir Next"/>
+                        </a:defRPr>
+                      </a:pPr>
+                      <a:r>
+                        <a:t>Package</a:t>
+                      </a:r>
+                    </a:p>
+                  </a:txBody>
+                  <a:tcPr marL="109728" marR="73152" marT="13716" marB="13716" anchor="ctr">
+                    <a:solidFill>
+                      <a:srgbClr val="FFFFFF"/>
+                    </a:solidFill>
+                  </a:tcPr>
+                </a:tc>
+                <a:tc>
+                  <a:txBody>
+                    <a:bodyPr/>
+                    <a:lstStyle/>
+                    <a:p>
+                      <a:pPr>
+                        <a:defRPr sz="1100" b="1">
+                          <a:solidFill>
+                            <a:srgbClr val="64748B"/>
+                          </a:solidFill>
+                          <a:latin typeface="Avenir Next"/>
+                        </a:defRPr>
+                      </a:pPr>
+                      <a:r>
+                        <a:t>Versions</a:t>
+                      </a:r>
+                    </a:p>
+                  </a:txBody>
+                  <a:tcPr marL="109728" marR="73152" marT="13716" marB="13716" anchor="ctr">
+                    <a:solidFill>
+                      <a:srgbClr val="FFFFFF"/>
+                    </a:solidFill>
+                  </a:tcPr>
+                </a:tc>
+                <a:tc>
+                  <a:txBody>
+                    <a:bodyPr/>
+                    <a:lstStyle/>
+                    <a:p>
+                      <a:pPr>
+                        <a:defRPr sz="1100" b="1">
+                          <a:solidFill>
+                            <a:srgbClr val="64748B"/>
+                          </a:solidFill>
+                          <a:latin typeface="Avenir Next"/>
+                        </a:defRPr>
+                      </a:pPr>
+                      <a:r>
+                        <a:t>Built as · pairing</a:t>
+                      </a:r>
+                    </a:p>
+                  </a:txBody>
+                  <a:tcPr marL="109728" marR="73152" marT="13716" marB="13716" anchor="ctr">
+                    <a:solidFill>
+                      <a:srgbClr val="FFFFFF"/>
+                    </a:solidFill>
+                  </a:tcPr>
+                </a:tc>
+              </a:tr>
+              <a:tr h="301752">
+                <a:tc gridSpan="3">
+                  <a:txBody>
+                    <a:bodyPr/>
+                    <a:lstStyle/>
+                    <a:p>
+                      <a:pPr>
+                        <a:defRPr sz="1150" b="1">
+                          <a:solidFill>
+                            <a:srgbClr val="FFFFFF"/>
+                          </a:solidFill>
+                          <a:latin typeface="Avenir Next"/>
+                        </a:defRPr>
+                      </a:pPr>
+                      <a:r>
+                        <a:t>Foundation — ambient in the lane view, never a module</a:t>
+                      </a:r>
+                    </a:p>
+                  </a:txBody>
+                  <a:tcPr marL="109728" marR="73152" marT="13716" marB="13716" anchor="ctr">
+                    <a:solidFill>
+                      <a:srgbClr val="475569"/>
+                    </a:solidFill>
+                  </a:tcPr>
+                </a:tc>
+                <a:tc hMerge="1">
+                  <a:txBody>
+                    <a:bodyPr/>
+                    <a:lstStyle/>
+                    <a:p/>
+                  </a:txBody>
+                  <a:tcPr/>
+                </a:tc>
+                <a:tc hMerge="1">
+                  <a:txBody>
+                    <a:bodyPr/>
+                    <a:lstStyle/>
+                    <a:p/>
+                  </a:txBody>
+                  <a:tcPr/>
+                </a:tc>
+              </a:tr>
+              <a:tr h="301752">
+                <a:tc>
+                  <a:txBody>
+                    <a:bodyPr/>
+                    <a:lstStyle/>
+                    <a:p>
+                      <a:pPr>
+                        <a:defRPr sz="1100" b="1">
+                          <a:solidFill>
+                            <a:srgbClr val="0F172A"/>
+                          </a:solidFill>
+                          <a:latin typeface="Avenir Next"/>
+                        </a:defRPr>
+                      </a:pPr>
+                      <a:r>
+                        <a:t>zlib</a:t>
+                      </a:r>
+                    </a:p>
+                  </a:txBody>
+                  <a:tcPr marL="109728" marR="73152" marT="13716" marB="13716" anchor="ctr">
+                    <a:solidFill>
+                      <a:srgbClr val="FFFFFF"/>
+                    </a:solidFill>
+                  </a:tcPr>
+                </a:tc>
+                <a:tc>
+                  <a:txBody>
+                    <a:bodyPr/>
+                    <a:lstStyle/>
+                    <a:p>
+                      <a:pPr>
+                        <a:defRPr sz="1100" b="0">
+                          <a:solidFill>
+                            <a:srgbClr val="334155"/>
+                          </a:solidFill>
+                          <a:latin typeface="Avenir Next"/>
+                        </a:defRPr>
+                      </a:pPr>
+                      <a:r>
+                        <a:t>1.3.1</a:t>
+                      </a:r>
+                    </a:p>
+                  </a:txBody>
+                  <a:tcPr marL="109728" marR="73152" marT="13716" marB="13716" anchor="ctr">
+                    <a:solidFill>
+                      <a:srgbClr val="FFFFFF"/>
+                    </a:solidFill>
+                  </a:tcPr>
+                </a:tc>
+                <a:tc>
+                  <a:txBody>
+                    <a:bodyPr/>
+                    <a:lstStyle/>
+                    <a:p>
+                      <a:pPr>
+                        <a:defRPr sz="1050" b="0">
+                          <a:solidFill>
+                            <a:srgbClr val="64748B"/>
+                          </a:solidFill>
+                          <a:latin typeface="Avenir Next"/>
+                        </a:defRPr>
+                      </a:pPr>
+                      <a:r>
+                        <a:t>single pinned version (require: pin)</a:t>
+                      </a:r>
+                    </a:p>
+                  </a:txBody>
+                  <a:tcPr marL="109728" marR="73152" marT="13716" marB="13716" anchor="ctr">
+                    <a:solidFill>
+                      <a:srgbClr val="FFFFFF"/>
+                    </a:solidFill>
+                  </a:tcPr>
+                </a:tc>
+              </a:tr>
+              <a:tr h="301752">
+                <a:tc>
+                  <a:txBody>
+                    <a:bodyPr/>
+                    <a:lstStyle/>
+                    <a:p>
+                      <a:pPr>
+                        <a:defRPr sz="1100" b="1">
+                          <a:solidFill>
+                            <a:srgbClr val="0F172A"/>
+                          </a:solidFill>
+                          <a:latin typeface="Avenir Next"/>
+                        </a:defRPr>
+                      </a:pPr>
+                      <a:r>
+                        <a:t>xz</a:t>
+                      </a:r>
+                    </a:p>
+                  </a:txBody>
+                  <a:tcPr marL="109728" marR="73152" marT="13716" marB="13716" anchor="ctr">
+                    <a:solidFill>
+                      <a:srgbClr val="FFFFFF"/>
+                    </a:solidFill>
+                  </a:tcPr>
+                </a:tc>
+                <a:tc>
+                  <a:txBody>
+                    <a:bodyPr/>
+                    <a:lstStyle/>
+                    <a:p>
+                      <a:pPr>
+                        <a:defRPr sz="1100" b="0">
+                          <a:solidFill>
+                            <a:srgbClr val="334155"/>
+                          </a:solidFill>
+                          <a:latin typeface="Avenir Next"/>
+                        </a:defRPr>
+                      </a:pPr>
+                      <a:r>
+                        <a:t>5.4.6</a:t>
+                      </a:r>
+                    </a:p>
+                  </a:txBody>
+                  <a:tcPr marL="109728" marR="73152" marT="13716" marB="13716" anchor="ctr">
+                    <a:solidFill>
+                      <a:srgbClr val="FFFFFF"/>
+                    </a:solidFill>
+                  </a:tcPr>
+                </a:tc>
+                <a:tc>
+                  <a:txBody>
+                    <a:bodyPr/>
+                    <a:lstStyle/>
+                    <a:p>
+                      <a:pPr>
+                        <a:defRPr sz="1050" b="0">
+                          <a:solidFill>
+                            <a:srgbClr val="64748B"/>
+                          </a:solidFill>
+                          <a:latin typeface="Avenir Next"/>
+                        </a:defRPr>
+                      </a:pPr>
+                      <a:r>
+                        <a:t>single pinned version</a:t>
+                      </a:r>
+                    </a:p>
+                  </a:txBody>
+                  <a:tcPr marL="109728" marR="73152" marT="13716" marB="13716" anchor="ctr">
+                    <a:solidFill>
+                      <a:srgbClr val="FFFFFF"/>
+                    </a:solidFill>
+                  </a:tcPr>
+                </a:tc>
+              </a:tr>
+              <a:tr h="301752">
+                <a:tc>
+                  <a:txBody>
+                    <a:bodyPr/>
+                    <a:lstStyle/>
+                    <a:p>
+                      <a:pPr>
+                        <a:defRPr sz="1100" b="1">
+                          <a:solidFill>
+                            <a:srgbClr val="0F172A"/>
+                          </a:solidFill>
+                          <a:latin typeface="Avenir Next"/>
+                        </a:defRPr>
+                      </a:pPr>
+                      <a:r>
+                        <a:t>zstd</a:t>
+                      </a:r>
+                    </a:p>
+                  </a:txBody>
+                  <a:tcPr marL="109728" marR="73152" marT="13716" marB="13716" anchor="ctr">
+                    <a:solidFill>
+                      <a:srgbClr val="FFFFFF"/>
+                    </a:solidFill>
+                  </a:tcPr>
+                </a:tc>
+                <a:tc>
+                  <a:txBody>
+                    <a:bodyPr/>
+                    <a:lstStyle/>
+                    <a:p>
+                      <a:pPr>
+                        <a:defRPr sz="1100" b="0">
+                          <a:solidFill>
+                            <a:srgbClr val="334155"/>
+                          </a:solidFill>
+                          <a:latin typeface="Avenir Next"/>
+                        </a:defRPr>
+                      </a:pPr>
+                      <a:r>
+                        <a:t>1.5.6</a:t>
+                      </a:r>
+                    </a:p>
+                  </a:txBody>
+                  <a:tcPr marL="109728" marR="73152" marT="13716" marB="13716" anchor="ctr">
+                    <a:solidFill>
+                      <a:srgbClr val="FFFFFF"/>
+                    </a:solidFill>
+                  </a:tcPr>
+                </a:tc>
+                <a:tc>
+                  <a:txBody>
+                    <a:bodyPr/>
+                    <a:lstStyle/>
+                    <a:p>
+                      <a:pPr>
+                        <a:defRPr sz="1050" b="0">
+                          <a:solidFill>
+                            <a:srgbClr val="64748B"/>
+                          </a:solidFill>
+                          <a:latin typeface="Avenir Next"/>
+                        </a:defRPr>
+                      </a:pPr>
+                      <a:r>
+                        <a:t>single pinned version</a:t>
+                      </a:r>
+                    </a:p>
+                  </a:txBody>
+                  <a:tcPr marL="109728" marR="73152" marT="13716" marB="13716" anchor="ctr">
+                    <a:solidFill>
+                      <a:srgbClr val="FFFFFF"/>
+                    </a:solidFill>
+                  </a:tcPr>
+                </a:tc>
+              </a:tr>
+              <a:tr h="301752">
+                <a:tc gridSpan="3">
+                  <a:txBody>
+                    <a:bodyPr/>
+                    <a:lstStyle/>
+                    <a:p>
+                      <a:pPr>
+                        <a:defRPr sz="1150" b="1">
+                          <a:solidFill>
+                            <a:srgbClr val="FFFFFF"/>
+                          </a:solidFill>
+                          <a:latin typeface="Avenir Next"/>
+                        </a:defRPr>
+                      </a:pPr>
+                      <a:r>
+                        <a:t>Core tools — user-loadable, compiler-agnostic</a:t>
+                      </a:r>
+                    </a:p>
+                  </a:txBody>
+                  <a:tcPr marL="109728" marR="73152" marT="13716" marB="13716" anchor="ctr">
+                    <a:solidFill>
+                      <a:srgbClr val="0D9488"/>
+                    </a:solidFill>
+                  </a:tcPr>
+                </a:tc>
+                <a:tc hMerge="1">
+                  <a:txBody>
+                    <a:bodyPr/>
+                    <a:lstStyle/>
+                    <a:p/>
+                  </a:txBody>
+                  <a:tcPr/>
+                </a:tc>
+                <a:tc hMerge="1">
+                  <a:txBody>
+                    <a:bodyPr/>
+                    <a:lstStyle/>
+                    <a:p/>
+                  </a:txBody>
+                  <a:tcPr/>
+                </a:tc>
+              </a:tr>
+              <a:tr h="301752">
+                <a:tc>
+                  <a:txBody>
+                    <a:bodyPr/>
+                    <a:lstStyle/>
+                    <a:p>
+                      <a:pPr>
+                        <a:defRPr sz="1100" b="1">
+                          <a:solidFill>
+                            <a:srgbClr val="0F172A"/>
+                          </a:solidFill>
+                          <a:latin typeface="Avenir Next"/>
+                        </a:defRPr>
+                      </a:pPr>
+                      <a:r>
+                        <a:t>cmake</a:t>
+                      </a:r>
+                    </a:p>
+                  </a:txBody>
+                  <a:tcPr marL="109728" marR="73152" marT="13716" marB="13716" anchor="ctr">
+                    <a:solidFill>
+                      <a:srgbClr val="FFFFFF"/>
+                    </a:solidFill>
+                  </a:tcPr>
+                </a:tc>
+                <a:tc>
+                  <a:txBody>
+                    <a:bodyPr/>
+                    <a:lstStyle/>
+                    <a:p>
+                      <a:pPr>
+                        <a:defRPr sz="1100" b="0">
+                          <a:solidFill>
+                            <a:srgbClr val="334155"/>
+                          </a:solidFill>
+                          <a:latin typeface="Avenir Next"/>
+                        </a:defRPr>
+                      </a:pPr>
+                      <a:r>
+                        <a:t>4.3.3 · 4.2.3</a:t>
+                      </a:r>
+                    </a:p>
+                  </a:txBody>
+                  <a:tcPr marL="109728" marR="73152" marT="13716" marB="13716" anchor="ctr">
+                    <a:solidFill>
+                      <a:srgbClr val="FFFFFF"/>
+                    </a:solidFill>
+                  </a:tcPr>
+                </a:tc>
+                <a:tc>
+                  <a:txBody>
+                    <a:bodyPr/>
+                    <a:lstStyle/>
+                    <a:p>
+                      <a:pPr>
+                        <a:defRPr sz="1050" b="0">
+                          <a:solidFill>
+                            <a:srgbClr val="64748B"/>
+                          </a:solidFill>
+                          <a:latin typeface="Avenir Next"/>
+                        </a:defRPr>
+                      </a:pPr>
+                    </a:p>
+                  </a:txBody>
+                  <a:tcPr marL="109728" marR="73152" marT="13716" marB="13716" anchor="ctr">
+                    <a:solidFill>
+                      <a:srgbClr val="FFFFFF"/>
+                    </a:solidFill>
+                  </a:tcPr>
+                </a:tc>
+              </a:tr>
+              <a:tr h="301752">
+                <a:tc>
+                  <a:txBody>
+                    <a:bodyPr/>
+                    <a:lstStyle/>
+                    <a:p>
+                      <a:pPr>
+                        <a:defRPr sz="1100" b="1">
+                          <a:solidFill>
+                            <a:srgbClr val="0F172A"/>
+                          </a:solidFill>
+                          <a:latin typeface="Avenir Next"/>
+                        </a:defRPr>
+                      </a:pPr>
+                      <a:r>
+                        <a:t>ninja · pkgconf · git</a:t>
+                      </a:r>
+                    </a:p>
+                  </a:txBody>
+                  <a:tcPr marL="109728" marR="73152" marT="13716" marB="13716" anchor="ctr">
+                    <a:solidFill>
+                      <a:srgbClr val="FFFFFF"/>
+                    </a:solidFill>
+                  </a:tcPr>
+                </a:tc>
+                <a:tc>
+                  <a:txBody>
+                    <a:bodyPr/>
+                    <a:lstStyle/>
+                    <a:p>
+                      <a:pPr>
+                        <a:defRPr sz="1100" b="0">
+                          <a:solidFill>
+                            <a:srgbClr val="334155"/>
+                          </a:solidFill>
+                          <a:latin typeface="Avenir Next"/>
+                        </a:defRPr>
+                      </a:pPr>
+                      <a:r>
+                        <a:t>newest</a:t>
+                      </a:r>
+                    </a:p>
+                  </a:txBody>
+                  <a:tcPr marL="109728" marR="73152" marT="13716" marB="13716" anchor="ctr">
+                    <a:solidFill>
+                      <a:srgbClr val="FFFFFF"/>
+                    </a:solidFill>
+                  </a:tcPr>
+                </a:tc>
+                <a:tc>
+                  <a:txBody>
+                    <a:bodyPr/>
+                    <a:lstStyle/>
+                    <a:p>
+                      <a:pPr>
+                        <a:defRPr sz="1050" b="0">
+                          <a:solidFill>
+                            <a:srgbClr val="64748B"/>
+                          </a:solidFill>
+                          <a:latin typeface="Avenir Next"/>
+                        </a:defRPr>
+                      </a:pPr>
+                      <a:r>
+                        <a:t>unpinned — newest from the recipe generation</a:t>
+                      </a:r>
+                    </a:p>
+                  </a:txBody>
+                  <a:tcPr marL="109728" marR="73152" marT="13716" marB="13716" anchor="ctr">
+                    <a:solidFill>
+                      <a:srgbClr val="FFFFFF"/>
+                    </a:solidFill>
+                  </a:tcPr>
+                </a:tc>
+              </a:tr>
+              <a:tr h="301752">
+                <a:tc>
+                  <a:txBody>
+                    <a:bodyPr/>
+                    <a:lstStyle/>
+                    <a:p>
+                      <a:pPr>
+                        <a:defRPr sz="1100" b="1">
+                          <a:solidFill>
+                            <a:srgbClr val="0F172A"/>
+                          </a:solidFill>
+                          <a:latin typeface="Avenir Next"/>
+                        </a:defRPr>
+                      </a:pPr>
+                      <a:r>
+                        <a:t>python</a:t>
+                      </a:r>
+                    </a:p>
+                  </a:txBody>
+                  <a:tcPr marL="109728" marR="73152" marT="13716" marB="13716" anchor="ctr">
+                    <a:solidFill>
+                      <a:srgbClr val="FFFFFF"/>
+                    </a:solidFill>
+                  </a:tcPr>
+                </a:tc>
+                <a:tc>
+                  <a:txBody>
+                    <a:bodyPr/>
+                    <a:lstStyle/>
+                    <a:p>
+                      <a:pPr>
+                        <a:defRPr sz="1100" b="0">
+                          <a:solidFill>
+                            <a:srgbClr val="334155"/>
+                          </a:solidFill>
+                          <a:latin typeface="Avenir Next"/>
+                        </a:defRPr>
+                      </a:pPr>
+                      <a:r>
+                        <a:t>3.14.5 · 3.13.13</a:t>
+                      </a:r>
+                    </a:p>
+                  </a:txBody>
+                  <a:tcPr marL="109728" marR="73152" marT="13716" marB="13716" anchor="ctr">
+                    <a:solidFill>
+                      <a:srgbClr val="FFFFFF"/>
+                    </a:solidFill>
+                  </a:tcPr>
+                </a:tc>
+                <a:tc>
+                  <a:txBody>
+                    <a:bodyPr/>
+                    <a:lstStyle/>
+                    <a:p>
+                      <a:pPr>
+                        <a:defRPr sz="1050" b="0">
+                          <a:solidFill>
+                            <a:srgbClr val="64748B"/>
+                          </a:solidFill>
+                          <a:latin typeface="Avenir Next"/>
+                        </a:defRPr>
+                      </a:pPr>
+                      <a:r>
+                        <a:t>the two newest supported minor lines</a:t>
+                      </a:r>
+                    </a:p>
+                  </a:txBody>
+                  <a:tcPr marL="109728" marR="73152" marT="13716" marB="13716" anchor="ctr">
+                    <a:solidFill>
+                      <a:srgbClr val="FFFFFF"/>
+                    </a:solidFill>
+                  </a:tcPr>
+                </a:tc>
+              </a:tr>
+              <a:tr h="301752">
+                <a:tc>
+                  <a:txBody>
+                    <a:bodyPr/>
+                    <a:lstStyle/>
+                    <a:p>
+                      <a:pPr>
+                        <a:defRPr sz="1100" b="1">
+                          <a:solidFill>
+                            <a:srgbClr val="0F172A"/>
+                          </a:solidFill>
+                          <a:latin typeface="Avenir Next"/>
+                        </a:defRPr>
+                      </a:pPr>
+                      <a:r>
+                        <a:t>py-numpy</a:t>
+                      </a:r>
+                    </a:p>
+                  </a:txBody>
+                  <a:tcPr marL="109728" marR="73152" marT="13716" marB="13716" anchor="ctr">
+                    <a:solidFill>
+                      <a:srgbClr val="FFFFFF"/>
+                    </a:solidFill>
+                  </a:tcPr>
+                </a:tc>
+                <a:tc>
+                  <a:txBody>
+                    <a:bodyPr/>
+                    <a:lstStyle/>
+                    <a:p>
+                      <a:pPr>
+                        <a:defRPr sz="1100" b="0">
+                          <a:solidFill>
+                            <a:srgbClr val="334155"/>
+                          </a:solidFill>
+                          <a:latin typeface="Avenir Next"/>
+                        </a:defRPr>
+                      </a:pPr>
+                      <a:r>
+                        <a:t>2.4.6</a:t>
+                      </a:r>
+                    </a:p>
+                  </a:txBody>
+                  <a:tcPr marL="109728" marR="73152" marT="13716" marB="13716" anchor="ctr">
+                    <a:solidFill>
+                      <a:srgbClr val="FFFFFF"/>
+                    </a:solidFill>
+                  </a:tcPr>
+                </a:tc>
+                <a:tc>
+                  <a:txBody>
+                    <a:bodyPr/>
+                    <a:lstStyle/>
+                    <a:p>
+                      <a:pPr>
+                        <a:defRPr sz="1050" b="0">
+                          <a:solidFill>
+                            <a:srgbClr val="64748B"/>
+                          </a:solidFill>
+                          <a:latin typeface="Avenir Next"/>
+                        </a:defRPr>
+                      </a:pPr>
+                      <a:r>
+                        <a:t>built against each python line (newest non-deprecated recipe)</a:t>
+                      </a:r>
+                    </a:p>
+                  </a:txBody>
+                  <a:tcPr marL="109728" marR="73152" marT="13716" marB="13716" anchor="ctr">
+                    <a:solidFill>
+                      <a:srgbClr val="FFFFFF"/>
+                    </a:solidFill>
+                  </a:tcPr>
+                </a:tc>
+              </a:tr>
+              <a:tr h="301752">
+                <a:tc>
+                  <a:txBody>
+                    <a:bodyPr/>
+                    <a:lstStyle/>
+                    <a:p>
+                      <a:pPr>
+                        <a:defRPr sz="1100" b="1">
+                          <a:solidFill>
+                            <a:srgbClr val="0F172A"/>
+                          </a:solidFill>
+                          <a:latin typeface="Avenir Next"/>
+                        </a:defRPr>
+                      </a:pPr>
+                      <a:r>
+                        <a:t>miniforge3</a:t>
+                      </a:r>
+                    </a:p>
+                  </a:txBody>
+                  <a:tcPr marL="109728" marR="73152" marT="13716" marB="13716" anchor="ctr">
+                    <a:solidFill>
+                      <a:srgbClr val="FFFFFF"/>
+                    </a:solidFill>
+                  </a:tcPr>
+                </a:tc>
+                <a:tc>
+                  <a:txBody>
+                    <a:bodyPr/>
+                    <a:lstStyle/>
+                    <a:p>
+                      <a:pPr>
+                        <a:defRPr sz="1100" b="0">
+                          <a:solidFill>
+                            <a:srgbClr val="334155"/>
+                          </a:solidFill>
+                          <a:latin typeface="Avenir Next"/>
+                        </a:defRPr>
+                      </a:pPr>
+                      <a:r>
+                        <a:t>26.1.1-3</a:t>
+                      </a:r>
+                    </a:p>
+                  </a:txBody>
+                  <a:tcPr marL="109728" marR="73152" marT="13716" marB="13716" anchor="ctr">
+                    <a:solidFill>
+                      <a:srgbClr val="FFFFFF"/>
+                    </a:solidFill>
+                  </a:tcPr>
+                </a:tc>
+                <a:tc>
+                  <a:txBody>
+                    <a:bodyPr/>
+                    <a:lstStyle/>
+                    <a:p>
+                      <a:pPr>
+                        <a:defRPr sz="1050" b="0">
+                          <a:solidFill>
+                            <a:srgbClr val="64748B"/>
+                          </a:solidFill>
+                          <a:latin typeface="Avenir Next"/>
+                        </a:defRPr>
+                      </a:pPr>
+                      <a:r>
+                        <a:t>single by nature — installer for user-managed environments</a:t>
+                      </a:r>
+                    </a:p>
+                  </a:txBody>
+                  <a:tcPr marL="109728" marR="73152" marT="13716" marB="13716" anchor="ctr">
+                    <a:solidFill>
+                      <a:srgbClr val="FFFFFF"/>
+                    </a:solidFill>
+                  </a:tcPr>
+                </a:tc>
+              </a:tr>
+              <a:tr h="301752">
+                <a:tc gridSpan="3">
+                  <a:txBody>
+                    <a:bodyPr/>
+                    <a:lstStyle/>
+                    <a:p>
+                      <a:pPr>
+                        <a:defRPr sz="1150" b="1">
+                          <a:solidFill>
+                            <a:srgbClr val="FFFFFF"/>
+                          </a:solidFill>
+                          <a:latin typeface="Avenir Next"/>
+                        </a:defRPr>
+                      </a:pPr>
+                      <a:r>
+                        <a:t>Only-serial by nature — no MPI implementation exists</a:t>
+                      </a:r>
+                    </a:p>
+                  </a:txBody>
+                  <a:tcPr marL="109728" marR="73152" marT="13716" marB="13716" anchor="ctr">
+                    <a:solidFill>
+                      <a:srgbClr val="0D9488"/>
+                    </a:solidFill>
+                  </a:tcPr>
+                </a:tc>
+                <a:tc hMerge="1">
+                  <a:txBody>
+                    <a:bodyPr/>
+                    <a:lstStyle/>
+                    <a:p/>
+                  </a:txBody>
+                  <a:tcPr/>
+                </a:tc>
+                <a:tc hMerge="1">
+                  <a:txBody>
+                    <a:bodyPr/>
+                    <a:lstStyle/>
+                    <a:p/>
+                  </a:txBody>
+                  <a:tcPr/>
+                </a:tc>
+              </a:tr>
+              <a:tr h="301752">
+                <a:tc>
+                  <a:txBody>
+                    <a:bodyPr/>
+                    <a:lstStyle/>
+                    <a:p>
+                      <a:pPr>
+                        <a:defRPr sz="1100" b="1">
+                          <a:solidFill>
+                            <a:srgbClr val="0F172A"/>
+                          </a:solidFill>
+                          <a:latin typeface="Avenir Next"/>
+                        </a:defRPr>
+                      </a:pPr>
+                      <a:r>
+                        <a:t>gsl</a:t>
+                      </a:r>
+                    </a:p>
+                  </a:txBody>
+                  <a:tcPr marL="109728" marR="73152" marT="13716" marB="13716" anchor="ctr">
+                    <a:solidFill>
+                      <a:srgbClr val="FFFFFF"/>
+                    </a:solidFill>
+                  </a:tcPr>
+                </a:tc>
+                <a:tc>
+                  <a:txBody>
+                    <a:bodyPr/>
+                    <a:lstStyle/>
+                    <a:p>
+                      <a:pPr>
+                        <a:defRPr sz="1100" b="0">
+                          <a:solidFill>
+                            <a:srgbClr val="334155"/>
+                          </a:solidFill>
+                          <a:latin typeface="Avenir Next"/>
+                        </a:defRPr>
+                      </a:pPr>
+                      <a:r>
+                        <a:t>2.8 · 2.7.1</a:t>
+                      </a:r>
+                    </a:p>
+                  </a:txBody>
+                  <a:tcPr marL="109728" marR="73152" marT="13716" marB="13716" anchor="ctr">
+                    <a:solidFill>
+                      <a:srgbClr val="FFFFFF"/>
+                    </a:solidFill>
+                  </a:tcPr>
+                </a:tc>
+                <a:tc>
+                  <a:txBody>
+                    <a:bodyPr/>
+                    <a:lstStyle/>
+                    <a:p>
+                      <a:pPr>
+                        <a:defRPr sz="1050" b="0">
+                          <a:solidFill>
+                            <a:srgbClr val="64748B"/>
+                          </a:solidFill>
+                          <a:latin typeface="Avenir Next"/>
+                        </a:defRPr>
+                      </a:pPr>
+                    </a:p>
+                  </a:txBody>
+                  <a:tcPr marL="109728" marR="73152" marT="13716" marB="13716" anchor="ctr">
+                    <a:solidFill>
+                      <a:srgbClr val="FFFFFF"/>
+                    </a:solidFill>
+                  </a:tcPr>
+                </a:tc>
+              </a:tr>
+              <a:tr h="301752">
+                <a:tc>
+                  <a:txBody>
+                    <a:bodyPr/>
+                    <a:lstStyle/>
+                    <a:p>
+                      <a:pPr>
+                        <a:defRPr sz="1100" b="1">
+                          <a:solidFill>
+                            <a:srgbClr val="0F172A"/>
+                          </a:solidFill>
+                          <a:latin typeface="Avenir Next"/>
+                        </a:defRPr>
+                      </a:pPr>
+                      <a:r>
+                        <a:t>sqlite</a:t>
+                      </a:r>
+                    </a:p>
+                  </a:txBody>
+                  <a:tcPr marL="109728" marR="73152" marT="13716" marB="13716" anchor="ctr">
+                    <a:solidFill>
+                      <a:srgbClr val="FFFFFF"/>
+                    </a:solidFill>
+                  </a:tcPr>
+                </a:tc>
+                <a:tc>
+                  <a:txBody>
+                    <a:bodyPr/>
+                    <a:lstStyle/>
+                    <a:p>
+                      <a:pPr>
+                        <a:defRPr sz="1100" b="0">
+                          <a:solidFill>
+                            <a:srgbClr val="334155"/>
+                          </a:solidFill>
+                          <a:latin typeface="Avenir Next"/>
+                        </a:defRPr>
+                      </a:pPr>
+                      <a:r>
+                        <a:t>3.53.1 · 3.51.2</a:t>
+                      </a:r>
+                    </a:p>
+                  </a:txBody>
+                  <a:tcPr marL="109728" marR="73152" marT="13716" marB="13716" anchor="ctr">
+                    <a:solidFill>
+                      <a:srgbClr val="FFFFFF"/>
+                    </a:solidFill>
+                  </a:tcPr>
+                </a:tc>
+                <a:tc>
+                  <a:txBody>
+                    <a:bodyPr/>
+                    <a:lstStyle/>
+                    <a:p>
+                      <a:pPr>
+                        <a:defRPr sz="1050" b="0">
+                          <a:solidFill>
+                            <a:srgbClr val="64748B"/>
+                          </a:solidFill>
+                          <a:latin typeface="Avenir Next"/>
+                        </a:defRPr>
+                      </a:pPr>
+                    </a:p>
+                  </a:txBody>
+                  <a:tcPr marL="109728" marR="73152" marT="13716" marB="13716" anchor="ctr">
+                    <a:solidFill>
+                      <a:srgbClr val="FFFFFF"/>
+                    </a:solidFill>
+                  </a:tcPr>
+                </a:tc>
+              </a:tr>
+            </a:tbl>
+          </a:graphicData>
+        </a:graphic>
+      </p:graphicFrame>
+      <p:sp>
+        <p:nvSpPr>
+          <p:cNvPr id="7" name="TextBox 6"/>
+          <p:cNvSpPr txBox="1"/>
+          <p:nvPr/>
+        </p:nvSpPr>
+        <p:spPr>
+          <a:xfrm>
+            <a:off x="548640" y="6583680"/>
+            <a:ext cx="11064240" cy="256032"/>
+          </a:xfrm>
+          <a:prstGeom prst="rect">
+            <a:avLst/>
+          </a:prstGeom>
+          <a:noFill/>
+        </p:spPr>
+        <p:txBody>
+          <a:bodyPr wrap="square" anchor="t">
+            <a:spAutoFit/>
+          </a:bodyPr>
+          <a:lstStyle/>
+          <a:p>
+            <a:pPr algn="l">
+              <a:defRPr sz="1050" b="0">
+                <a:solidFill>
+                  <a:srgbClr val="64748B"/>
+                </a:solidFill>
+                <a:latin typeface="Avenir Next"/>
+              </a:defRPr>
+            </a:pPr>
+            <a:r>
+              <a:t>Version policy: newest supported + immediate predecessor · pinned to spack-packages v2026.06.0 (Spack v1.1.1)</a:t>
+            </a:r>
+          </a:p>
+        </p:txBody>
+      </p:sp>
+    </p:spTree>
+  </p:cSld>
+  <p:clrMapOvr>
+    <a:masterClrMapping/>
+  </p:clrMapOvr>
+</p:sld>
+</file>
+
+<file path=ppt/slides/slide11.xml><?xml version="1.0" encoding="utf-8"?>
 <p:sld xmlns:a="http://schemas.openxmlformats.org/drawingml/2006/main" xmlns:p="http://schemas.openxmlformats.org/presentationml/2006/main" xmlns:r="http://schemas.openxmlformats.org/officeDocument/2006/relationships">
   <p:cSld>
     <p:spTree>
@@ -4642,7 +5815,7 @@
 </p:sld>
 </file>
 
-<file path=ppt/slides/slide11.xml><?xml version="1.0" encoding="utf-8"?>
+<file path=ppt/slides/slide12.xml><?xml version="1.0" encoding="utf-8"?>
 <p:sld xmlns:a="http://schemas.openxmlformats.org/drawingml/2006/main" xmlns:p="http://schemas.openxmlformats.org/presentationml/2006/main" xmlns:r="http://schemas.openxmlformats.org/officeDocument/2006/relationships">
   <p:cSld>
     <p:spTree>
@@ -9357,7 +10530,7 @@
               </a:defRPr>
             </a:pPr>
             <a:r>
-              <a:t>hdf5~mpi · fftw~mpi · boost</a:t>
+              <a:t>non-MPI hdf5 · fftw · boost, plus common BLAS/LAPACK</a:t>
             </a:r>
           </a:p>
         </p:txBody>
@@ -9461,7 +10634,7 @@
               </a:defRPr>
             </a:pPr>
             <a:r>
-              <a:t>Cray MPICH · hdf5+mpi · netcdf · tau</a:t>
+              <a:t>Cray MPICH · hdf5+mpi · fftw+mpi · tau · dakota</a:t>
             </a:r>
           </a:p>
         </p:txBody>
@@ -9565,7 +10738,7 @@
               </a:defRPr>
             </a:pPr>
             <a:r>
-              <a:t>GPU-aware MPI · rocm/cuda — arch from the probe</a:t>
+              <a:t>the MPI roster plus kokkos · rocm/cuda arch from the probe</a:t>
             </a:r>
           </a:p>
         </p:txBody>
@@ -10159,7 +11332,7 @@
               </a:defRPr>
             </a:pPr>
             <a:r>
-              <a:t>hdf5~mpi 2.1.0 / 1.14.6 · fftw · boost</a:t>
+              <a:t>non-MPI hdf5 · fftw · boost, plus openblas · gnuplot</a:t>
             </a:r>
           </a:p>
         </p:txBody>
@@ -10226,7 +11399,7 @@
               </a:defRPr>
             </a:pPr>
             <a:r>
-              <a:t>Cray MPICH · hdf5+mpi · netcdf · tau</a:t>
+              <a:t>Cray MPICH · hdf5+mpi · fftw+mpi · boost+mpi · tau</a:t>
             </a:r>
           </a:p>
         </p:txBody>
@@ -10293,7 +11466,7 @@
               </a:defRPr>
             </a:pPr>
             <a:r>
-              <a:t>GPU-aware MPI · kokkos +rocm gfx942</a:t>
+              <a:t>the MPI roster plus kokkos +rocm gfx942</a:t>
             </a:r>
           </a:p>
         </p:txBody>
@@ -10347,7 +11520,7 @@
               </a:defRPr>
             </a:pPr>
             <a:r>
-              <a:t>Only the chosen lane is visible — GPU includes its compatible MPI surface.</a:t>
+              <a:t>Only the chosen lane is visible; common packages (BLAS/LAPACK, gnuplot) are reachable from every lane.</a:t>
             </a:r>
           </a:p>
           <a:p>
@@ -10698,7 +11871,7 @@
               </a:defRPr>
             </a:pPr>
             <a:r>
-              <a:t>No MPI implementation exists for it, or it is a compiler-agnostic building block. Loads with the surface.</a:t>
+              <a:t>Compiler-agnostic building blocks and tools. They load with the surface, before any lane is chosen.</a:t>
             </a:r>
           </a:p>
         </p:txBody>
@@ -10734,7 +11907,7 @@
               </a:defRPr>
             </a:pPr>
             <a:r>
-              <a:t>gsl · python · miniforge · cmake</a:t>
+              <a:t>cmake · python · miniforge · gsl · sqlite</a:t>
             </a:r>
           </a:p>
         </p:txBody>
@@ -10894,7 +12067,7 @@
               </a:defRPr>
             </a:pPr>
             <a:r>
-              <a:t>MPI-capable — deliberately built without MPI for users who want it plain.</a:t>
+              <a:t>Two classes: non-MPI builds of MPI-capable packages, and common compiler-dependent packages that every lane can load.</a:t>
             </a:r>
           </a:p>
         </p:txBody>
@@ -10930,7 +12103,7 @@
               </a:defRPr>
             </a:pPr>
             <a:r>
-              <a:t>hdf5~mpi · fftw~mpi</a:t>
+              <a:t>hdf5~mpi · fftw~mpi  |  openblas · gnuplot</a:t>
             </a:r>
           </a:p>
         </p:txBody>
@@ -11286,7 +12459,7 @@
               </a:defRPr>
             </a:pPr>
             <a:r>
-              <a:t>Complete MPI+GPU lane over a compatible compiler, MPI, and GPU toolkit. Load GPU instead of MPI, not in addition to it.</a:t>
+              <a:t>Carries the full MPI roster plus the GPU payload. Load GPU instead of MPI, not in addition to it.</a:t>
             </a:r>
           </a:p>
         </p:txBody>
@@ -12902,7 +14075,7 @@
               </a:defRPr>
             </a:pPr>
             <a:r>
-              <a:t>Kokkos</a:t>
+              <a:t>Dakota</a:t>
             </a:r>
           </a:p>
         </p:txBody>
@@ -12956,7 +14129,7 @@
               </a:defRPr>
             </a:pPr>
             <a:r>
-              <a:t>CMake</a:t>
+              <a:t>Kokkos</a:t>
             </a:r>
           </a:p>
         </p:txBody>
@@ -13010,7 +14183,7 @@
               </a:defRPr>
             </a:pPr>
             <a:r>
-              <a:t>Python</a:t>
+              <a:t>Gnuplot</a:t>
             </a:r>
           </a:p>
         </p:txBody>
@@ -13064,6 +14237,60 @@
               </a:defRPr>
             </a:pPr>
             <a:r>
+              <a:t>Python</a:t>
+            </a:r>
+          </a:p>
+        </p:txBody>
+      </p:sp>
+      <p:sp>
+        <p:nvSpPr>
+          <p:cNvPr id="36" name="Rounded Rectangle 35"/>
+          <p:cNvSpPr/>
+          <p:nvPr/>
+        </p:nvSpPr>
+        <p:spPr>
+          <a:xfrm>
+            <a:off x="10314432" y="5449824"/>
+            <a:ext cx="1481328" cy="384048"/>
+          </a:xfrm>
+          <a:prstGeom prst="roundRect">
+            <a:avLst/>
+          </a:prstGeom>
+          <a:solidFill>
+            <a:srgbClr val="E2E8F0"/>
+          </a:solidFill>
+          <a:ln>
+            <a:noFill/>
+          </a:ln>
+          <a:effectLst/>
+        </p:spPr>
+        <p:style>
+          <a:lnRef idx="1">
+            <a:schemeClr val="accent1"/>
+          </a:lnRef>
+          <a:fillRef idx="3">
+            <a:schemeClr val="accent1"/>
+          </a:fillRef>
+          <a:effectRef idx="2">
+            <a:schemeClr val="accent1"/>
+          </a:effectRef>
+          <a:fontRef idx="minor">
+            <a:schemeClr val="lt1"/>
+          </a:fontRef>
+        </p:style>
+        <p:txBody>
+          <a:bodyPr rtlCol="0" anchor="ctr" wrap="square" lIns="109728" rIns="109728"/>
+          <a:lstStyle/>
+          <a:p>
+            <a:pPr algn="ctr">
+              <a:defRPr sz="1200" b="0">
+                <a:solidFill>
+                  <a:srgbClr val="334155"/>
+                </a:solidFill>
+                <a:latin typeface="Avenir Next"/>
+              </a:defRPr>
+            </a:pPr>
+            <a:r>
               <a:t>Miniforge</a:t>
             </a:r>
           </a:p>
@@ -13071,7 +14298,7 @@
       </p:sp>
       <p:sp>
         <p:nvSpPr>
-          <p:cNvPr id="36" name="TextBox 35"/>
+          <p:cNvPr id="37" name="TextBox 36"/>
           <p:cNvSpPr txBox="1"/>
           <p:nvPr/>
         </p:nvSpPr>
@@ -13968,7 +15195,7 @@
               </a:defRPr>
             </a:pPr>
             <a:r>
-              <a:t>APPENDIX · EXACT BUILD ROOTS</a:t>
+              <a:t>APPENDIX · HOW THE LAYERS STACK</a:t>
             </a:r>
           </a:p>
         </p:txBody>
@@ -14004,7 +15231,7 @@
               </a:defRPr>
             </a:pPr>
             <a:r>
-              <a:t>Core and foundation — built once per compiler surface</a:t>
+              <a:t>What each lane exposes</a:t>
             </a:r>
           </a:p>
         </p:txBody>
@@ -14053,974 +15280,16 @@
           </a:p>
         </p:txBody>
       </p:sp>
-      <p:graphicFrame>
-        <p:nvGraphicFramePr>
-          <p:cNvPr id="6" name="Table 5"/>
-          <p:cNvGraphicFramePr>
-            <a:graphicFrameLocks noGrp="1"/>
-          </p:cNvGraphicFramePr>
-          <p:nvPr/>
-        </p:nvGraphicFramePr>
-        <p:xfrm>
-          <a:off x="548640" y="1481328"/>
-          <a:ext cx="11091672" cy="4224528"/>
-        </p:xfrm>
-        <a:graphic>
-          <a:graphicData uri="http://schemas.openxmlformats.org/drawingml/2006/table">
-            <a:tbl>
-              <a:tblPr>
-                <a:tableStyleId>{5C22544A-7EE6-4342-B048-85BDC9FD1C3A}</a:tableStyleId>
-              </a:tblPr>
-              <a:tblGrid>
-                <a:gridCol w="1920240"/>
-                <a:gridCol w="2286000"/>
-                <a:gridCol w="6885432"/>
-              </a:tblGrid>
-              <a:tr h="301752">
-                <a:tc>
-                  <a:txBody>
-                    <a:bodyPr/>
-                    <a:lstStyle/>
-                    <a:p>
-                      <a:pPr>
-                        <a:defRPr sz="1100" b="1">
-                          <a:solidFill>
-                            <a:srgbClr val="64748B"/>
-                          </a:solidFill>
-                          <a:latin typeface="Avenir Next"/>
-                        </a:defRPr>
-                      </a:pPr>
-                      <a:r>
-                        <a:t>Package</a:t>
-                      </a:r>
-                    </a:p>
-                  </a:txBody>
-                  <a:tcPr marL="109728" marR="73152" marT="13716" marB="13716" anchor="ctr">
-                    <a:solidFill>
-                      <a:srgbClr val="FFFFFF"/>
-                    </a:solidFill>
-                  </a:tcPr>
-                </a:tc>
-                <a:tc>
-                  <a:txBody>
-                    <a:bodyPr/>
-                    <a:lstStyle/>
-                    <a:p>
-                      <a:pPr>
-                        <a:defRPr sz="1100" b="1">
-                          <a:solidFill>
-                            <a:srgbClr val="64748B"/>
-                          </a:solidFill>
-                          <a:latin typeface="Avenir Next"/>
-                        </a:defRPr>
-                      </a:pPr>
-                      <a:r>
-                        <a:t>Versions</a:t>
-                      </a:r>
-                    </a:p>
-                  </a:txBody>
-                  <a:tcPr marL="109728" marR="73152" marT="13716" marB="13716" anchor="ctr">
-                    <a:solidFill>
-                      <a:srgbClr val="FFFFFF"/>
-                    </a:solidFill>
-                  </a:tcPr>
-                </a:tc>
-                <a:tc>
-                  <a:txBody>
-                    <a:bodyPr/>
-                    <a:lstStyle/>
-                    <a:p>
-                      <a:pPr>
-                        <a:defRPr sz="1100" b="1">
-                          <a:solidFill>
-                            <a:srgbClr val="64748B"/>
-                          </a:solidFill>
-                          <a:latin typeface="Avenir Next"/>
-                        </a:defRPr>
-                      </a:pPr>
-                      <a:r>
-                        <a:t>Built as · pairing</a:t>
-                      </a:r>
-                    </a:p>
-                  </a:txBody>
-                  <a:tcPr marL="109728" marR="73152" marT="13716" marB="13716" anchor="ctr">
-                    <a:solidFill>
-                      <a:srgbClr val="FFFFFF"/>
-                    </a:solidFill>
-                  </a:tcPr>
-                </a:tc>
-              </a:tr>
-              <a:tr h="301752">
-                <a:tc gridSpan="3">
-                  <a:txBody>
-                    <a:bodyPr/>
-                    <a:lstStyle/>
-                    <a:p>
-                      <a:pPr>
-                        <a:defRPr sz="1150" b="1">
-                          <a:solidFill>
-                            <a:srgbClr val="FFFFFF"/>
-                          </a:solidFill>
-                          <a:latin typeface="Avenir Next"/>
-                        </a:defRPr>
-                      </a:pPr>
-                      <a:r>
-                        <a:t>Foundation — ambient in the lane view, never a module</a:t>
-                      </a:r>
-                    </a:p>
-                  </a:txBody>
-                  <a:tcPr marL="109728" marR="73152" marT="13716" marB="13716" anchor="ctr">
-                    <a:solidFill>
-                      <a:srgbClr val="475569"/>
-                    </a:solidFill>
-                  </a:tcPr>
-                </a:tc>
-                <a:tc hMerge="1">
-                  <a:txBody>
-                    <a:bodyPr/>
-                    <a:lstStyle/>
-                    <a:p/>
-                  </a:txBody>
-                  <a:tcPr/>
-                </a:tc>
-                <a:tc hMerge="1">
-                  <a:txBody>
-                    <a:bodyPr/>
-                    <a:lstStyle/>
-                    <a:p/>
-                  </a:txBody>
-                  <a:tcPr/>
-                </a:tc>
-              </a:tr>
-              <a:tr h="301752">
-                <a:tc>
-                  <a:txBody>
-                    <a:bodyPr/>
-                    <a:lstStyle/>
-                    <a:p>
-                      <a:pPr>
-                        <a:defRPr sz="1100" b="1">
-                          <a:solidFill>
-                            <a:srgbClr val="0F172A"/>
-                          </a:solidFill>
-                          <a:latin typeface="Avenir Next"/>
-                        </a:defRPr>
-                      </a:pPr>
-                      <a:r>
-                        <a:t>zlib</a:t>
-                      </a:r>
-                    </a:p>
-                  </a:txBody>
-                  <a:tcPr marL="109728" marR="73152" marT="13716" marB="13716" anchor="ctr">
-                    <a:solidFill>
-                      <a:srgbClr val="FFFFFF"/>
-                    </a:solidFill>
-                  </a:tcPr>
-                </a:tc>
-                <a:tc>
-                  <a:txBody>
-                    <a:bodyPr/>
-                    <a:lstStyle/>
-                    <a:p>
-                      <a:pPr>
-                        <a:defRPr sz="1100" b="0">
-                          <a:solidFill>
-                            <a:srgbClr val="334155"/>
-                          </a:solidFill>
-                          <a:latin typeface="Avenir Next"/>
-                        </a:defRPr>
-                      </a:pPr>
-                      <a:r>
-                        <a:t>1.3.1</a:t>
-                      </a:r>
-                    </a:p>
-                  </a:txBody>
-                  <a:tcPr marL="109728" marR="73152" marT="13716" marB="13716" anchor="ctr">
-                    <a:solidFill>
-                      <a:srgbClr val="FFFFFF"/>
-                    </a:solidFill>
-                  </a:tcPr>
-                </a:tc>
-                <a:tc>
-                  <a:txBody>
-                    <a:bodyPr/>
-                    <a:lstStyle/>
-                    <a:p>
-                      <a:pPr>
-                        <a:defRPr sz="1050" b="0">
-                          <a:solidFill>
-                            <a:srgbClr val="64748B"/>
-                          </a:solidFill>
-                          <a:latin typeface="Avenir Next"/>
-                        </a:defRPr>
-                      </a:pPr>
-                      <a:r>
-                        <a:t>single pinned version (require: pin)</a:t>
-                      </a:r>
-                    </a:p>
-                  </a:txBody>
-                  <a:tcPr marL="109728" marR="73152" marT="13716" marB="13716" anchor="ctr">
-                    <a:solidFill>
-                      <a:srgbClr val="FFFFFF"/>
-                    </a:solidFill>
-                  </a:tcPr>
-                </a:tc>
-              </a:tr>
-              <a:tr h="301752">
-                <a:tc>
-                  <a:txBody>
-                    <a:bodyPr/>
-                    <a:lstStyle/>
-                    <a:p>
-                      <a:pPr>
-                        <a:defRPr sz="1100" b="1">
-                          <a:solidFill>
-                            <a:srgbClr val="0F172A"/>
-                          </a:solidFill>
-                          <a:latin typeface="Avenir Next"/>
-                        </a:defRPr>
-                      </a:pPr>
-                      <a:r>
-                        <a:t>xz</a:t>
-                      </a:r>
-                    </a:p>
-                  </a:txBody>
-                  <a:tcPr marL="109728" marR="73152" marT="13716" marB="13716" anchor="ctr">
-                    <a:solidFill>
-                      <a:srgbClr val="FFFFFF"/>
-                    </a:solidFill>
-                  </a:tcPr>
-                </a:tc>
-                <a:tc>
-                  <a:txBody>
-                    <a:bodyPr/>
-                    <a:lstStyle/>
-                    <a:p>
-                      <a:pPr>
-                        <a:defRPr sz="1100" b="0">
-                          <a:solidFill>
-                            <a:srgbClr val="334155"/>
-                          </a:solidFill>
-                          <a:latin typeface="Avenir Next"/>
-                        </a:defRPr>
-                      </a:pPr>
-                      <a:r>
-                        <a:t>5.4.6</a:t>
-                      </a:r>
-                    </a:p>
-                  </a:txBody>
-                  <a:tcPr marL="109728" marR="73152" marT="13716" marB="13716" anchor="ctr">
-                    <a:solidFill>
-                      <a:srgbClr val="FFFFFF"/>
-                    </a:solidFill>
-                  </a:tcPr>
-                </a:tc>
-                <a:tc>
-                  <a:txBody>
-                    <a:bodyPr/>
-                    <a:lstStyle/>
-                    <a:p>
-                      <a:pPr>
-                        <a:defRPr sz="1050" b="0">
-                          <a:solidFill>
-                            <a:srgbClr val="64748B"/>
-                          </a:solidFill>
-                          <a:latin typeface="Avenir Next"/>
-                        </a:defRPr>
-                      </a:pPr>
-                      <a:r>
-                        <a:t>single pinned version</a:t>
-                      </a:r>
-                    </a:p>
-                  </a:txBody>
-                  <a:tcPr marL="109728" marR="73152" marT="13716" marB="13716" anchor="ctr">
-                    <a:solidFill>
-                      <a:srgbClr val="FFFFFF"/>
-                    </a:solidFill>
-                  </a:tcPr>
-                </a:tc>
-              </a:tr>
-              <a:tr h="301752">
-                <a:tc>
-                  <a:txBody>
-                    <a:bodyPr/>
-                    <a:lstStyle/>
-                    <a:p>
-                      <a:pPr>
-                        <a:defRPr sz="1100" b="1">
-                          <a:solidFill>
-                            <a:srgbClr val="0F172A"/>
-                          </a:solidFill>
-                          <a:latin typeface="Avenir Next"/>
-                        </a:defRPr>
-                      </a:pPr>
-                      <a:r>
-                        <a:t>zstd</a:t>
-                      </a:r>
-                    </a:p>
-                  </a:txBody>
-                  <a:tcPr marL="109728" marR="73152" marT="13716" marB="13716" anchor="ctr">
-                    <a:solidFill>
-                      <a:srgbClr val="FFFFFF"/>
-                    </a:solidFill>
-                  </a:tcPr>
-                </a:tc>
-                <a:tc>
-                  <a:txBody>
-                    <a:bodyPr/>
-                    <a:lstStyle/>
-                    <a:p>
-                      <a:pPr>
-                        <a:defRPr sz="1100" b="0">
-                          <a:solidFill>
-                            <a:srgbClr val="334155"/>
-                          </a:solidFill>
-                          <a:latin typeface="Avenir Next"/>
-                        </a:defRPr>
-                      </a:pPr>
-                      <a:r>
-                        <a:t>1.5.6</a:t>
-                      </a:r>
-                    </a:p>
-                  </a:txBody>
-                  <a:tcPr marL="109728" marR="73152" marT="13716" marB="13716" anchor="ctr">
-                    <a:solidFill>
-                      <a:srgbClr val="FFFFFF"/>
-                    </a:solidFill>
-                  </a:tcPr>
-                </a:tc>
-                <a:tc>
-                  <a:txBody>
-                    <a:bodyPr/>
-                    <a:lstStyle/>
-                    <a:p>
-                      <a:pPr>
-                        <a:defRPr sz="1050" b="0">
-                          <a:solidFill>
-                            <a:srgbClr val="64748B"/>
-                          </a:solidFill>
-                          <a:latin typeface="Avenir Next"/>
-                        </a:defRPr>
-                      </a:pPr>
-                      <a:r>
-                        <a:t>single pinned version</a:t>
-                      </a:r>
-                    </a:p>
-                  </a:txBody>
-                  <a:tcPr marL="109728" marR="73152" marT="13716" marB="13716" anchor="ctr">
-                    <a:solidFill>
-                      <a:srgbClr val="FFFFFF"/>
-                    </a:solidFill>
-                  </a:tcPr>
-                </a:tc>
-              </a:tr>
-              <a:tr h="301752">
-                <a:tc gridSpan="3">
-                  <a:txBody>
-                    <a:bodyPr/>
-                    <a:lstStyle/>
-                    <a:p>
-                      <a:pPr>
-                        <a:defRPr sz="1150" b="1">
-                          <a:solidFill>
-                            <a:srgbClr val="FFFFFF"/>
-                          </a:solidFill>
-                          <a:latin typeface="Avenir Next"/>
-                        </a:defRPr>
-                      </a:pPr>
-                      <a:r>
-                        <a:t>Core tools — user-loadable, compiler-agnostic</a:t>
-                      </a:r>
-                    </a:p>
-                  </a:txBody>
-                  <a:tcPr marL="109728" marR="73152" marT="13716" marB="13716" anchor="ctr">
-                    <a:solidFill>
-                      <a:srgbClr val="0D9488"/>
-                    </a:solidFill>
-                  </a:tcPr>
-                </a:tc>
-                <a:tc hMerge="1">
-                  <a:txBody>
-                    <a:bodyPr/>
-                    <a:lstStyle/>
-                    <a:p/>
-                  </a:txBody>
-                  <a:tcPr/>
-                </a:tc>
-                <a:tc hMerge="1">
-                  <a:txBody>
-                    <a:bodyPr/>
-                    <a:lstStyle/>
-                    <a:p/>
-                  </a:txBody>
-                  <a:tcPr/>
-                </a:tc>
-              </a:tr>
-              <a:tr h="301752">
-                <a:tc>
-                  <a:txBody>
-                    <a:bodyPr/>
-                    <a:lstStyle/>
-                    <a:p>
-                      <a:pPr>
-                        <a:defRPr sz="1100" b="1">
-                          <a:solidFill>
-                            <a:srgbClr val="0F172A"/>
-                          </a:solidFill>
-                          <a:latin typeface="Avenir Next"/>
-                        </a:defRPr>
-                      </a:pPr>
-                      <a:r>
-                        <a:t>cmake</a:t>
-                      </a:r>
-                    </a:p>
-                  </a:txBody>
-                  <a:tcPr marL="109728" marR="73152" marT="13716" marB="13716" anchor="ctr">
-                    <a:solidFill>
-                      <a:srgbClr val="FFFFFF"/>
-                    </a:solidFill>
-                  </a:tcPr>
-                </a:tc>
-                <a:tc>
-                  <a:txBody>
-                    <a:bodyPr/>
-                    <a:lstStyle/>
-                    <a:p>
-                      <a:pPr>
-                        <a:defRPr sz="1100" b="0">
-                          <a:solidFill>
-                            <a:srgbClr val="334155"/>
-                          </a:solidFill>
-                          <a:latin typeface="Avenir Next"/>
-                        </a:defRPr>
-                      </a:pPr>
-                      <a:r>
-                        <a:t>4.3.3 · 4.2.3</a:t>
-                      </a:r>
-                    </a:p>
-                  </a:txBody>
-                  <a:tcPr marL="109728" marR="73152" marT="13716" marB="13716" anchor="ctr">
-                    <a:solidFill>
-                      <a:srgbClr val="FFFFFF"/>
-                    </a:solidFill>
-                  </a:tcPr>
-                </a:tc>
-                <a:tc>
-                  <a:txBody>
-                    <a:bodyPr/>
-                    <a:lstStyle/>
-                    <a:p>
-                      <a:pPr>
-                        <a:defRPr sz="1050" b="0">
-                          <a:solidFill>
-                            <a:srgbClr val="64748B"/>
-                          </a:solidFill>
-                          <a:latin typeface="Avenir Next"/>
-                        </a:defRPr>
-                      </a:pPr>
-                    </a:p>
-                  </a:txBody>
-                  <a:tcPr marL="109728" marR="73152" marT="13716" marB="13716" anchor="ctr">
-                    <a:solidFill>
-                      <a:srgbClr val="FFFFFF"/>
-                    </a:solidFill>
-                  </a:tcPr>
-                </a:tc>
-              </a:tr>
-              <a:tr h="301752">
-                <a:tc>
-                  <a:txBody>
-                    <a:bodyPr/>
-                    <a:lstStyle/>
-                    <a:p>
-                      <a:pPr>
-                        <a:defRPr sz="1100" b="1">
-                          <a:solidFill>
-                            <a:srgbClr val="0F172A"/>
-                          </a:solidFill>
-                          <a:latin typeface="Avenir Next"/>
-                        </a:defRPr>
-                      </a:pPr>
-                      <a:r>
-                        <a:t>ninja · pkgconf · git</a:t>
-                      </a:r>
-                    </a:p>
-                  </a:txBody>
-                  <a:tcPr marL="109728" marR="73152" marT="13716" marB="13716" anchor="ctr">
-                    <a:solidFill>
-                      <a:srgbClr val="FFFFFF"/>
-                    </a:solidFill>
-                  </a:tcPr>
-                </a:tc>
-                <a:tc>
-                  <a:txBody>
-                    <a:bodyPr/>
-                    <a:lstStyle/>
-                    <a:p>
-                      <a:pPr>
-                        <a:defRPr sz="1100" b="0">
-                          <a:solidFill>
-                            <a:srgbClr val="334155"/>
-                          </a:solidFill>
-                          <a:latin typeface="Avenir Next"/>
-                        </a:defRPr>
-                      </a:pPr>
-                      <a:r>
-                        <a:t>newest</a:t>
-                      </a:r>
-                    </a:p>
-                  </a:txBody>
-                  <a:tcPr marL="109728" marR="73152" marT="13716" marB="13716" anchor="ctr">
-                    <a:solidFill>
-                      <a:srgbClr val="FFFFFF"/>
-                    </a:solidFill>
-                  </a:tcPr>
-                </a:tc>
-                <a:tc>
-                  <a:txBody>
-                    <a:bodyPr/>
-                    <a:lstStyle/>
-                    <a:p>
-                      <a:pPr>
-                        <a:defRPr sz="1050" b="0">
-                          <a:solidFill>
-                            <a:srgbClr val="64748B"/>
-                          </a:solidFill>
-                          <a:latin typeface="Avenir Next"/>
-                        </a:defRPr>
-                      </a:pPr>
-                      <a:r>
-                        <a:t>unpinned — newest from the recipe generation</a:t>
-                      </a:r>
-                    </a:p>
-                  </a:txBody>
-                  <a:tcPr marL="109728" marR="73152" marT="13716" marB="13716" anchor="ctr">
-                    <a:solidFill>
-                      <a:srgbClr val="FFFFFF"/>
-                    </a:solidFill>
-                  </a:tcPr>
-                </a:tc>
-              </a:tr>
-              <a:tr h="301752">
-                <a:tc>
-                  <a:txBody>
-                    <a:bodyPr/>
-                    <a:lstStyle/>
-                    <a:p>
-                      <a:pPr>
-                        <a:defRPr sz="1100" b="1">
-                          <a:solidFill>
-                            <a:srgbClr val="0F172A"/>
-                          </a:solidFill>
-                          <a:latin typeface="Avenir Next"/>
-                        </a:defRPr>
-                      </a:pPr>
-                      <a:r>
-                        <a:t>python</a:t>
-                      </a:r>
-                    </a:p>
-                  </a:txBody>
-                  <a:tcPr marL="109728" marR="73152" marT="13716" marB="13716" anchor="ctr">
-                    <a:solidFill>
-                      <a:srgbClr val="FFFFFF"/>
-                    </a:solidFill>
-                  </a:tcPr>
-                </a:tc>
-                <a:tc>
-                  <a:txBody>
-                    <a:bodyPr/>
-                    <a:lstStyle/>
-                    <a:p>
-                      <a:pPr>
-                        <a:defRPr sz="1100" b="0">
-                          <a:solidFill>
-                            <a:srgbClr val="334155"/>
-                          </a:solidFill>
-                          <a:latin typeface="Avenir Next"/>
-                        </a:defRPr>
-                      </a:pPr>
-                      <a:r>
-                        <a:t>3.14.5 · 3.13.13</a:t>
-                      </a:r>
-                    </a:p>
-                  </a:txBody>
-                  <a:tcPr marL="109728" marR="73152" marT="13716" marB="13716" anchor="ctr">
-                    <a:solidFill>
-                      <a:srgbClr val="FFFFFF"/>
-                    </a:solidFill>
-                  </a:tcPr>
-                </a:tc>
-                <a:tc>
-                  <a:txBody>
-                    <a:bodyPr/>
-                    <a:lstStyle/>
-                    <a:p>
-                      <a:pPr>
-                        <a:defRPr sz="1050" b="0">
-                          <a:solidFill>
-                            <a:srgbClr val="64748B"/>
-                          </a:solidFill>
-                          <a:latin typeface="Avenir Next"/>
-                        </a:defRPr>
-                      </a:pPr>
-                      <a:r>
-                        <a:t>the two newest supported minor lines</a:t>
-                      </a:r>
-                    </a:p>
-                  </a:txBody>
-                  <a:tcPr marL="109728" marR="73152" marT="13716" marB="13716" anchor="ctr">
-                    <a:solidFill>
-                      <a:srgbClr val="FFFFFF"/>
-                    </a:solidFill>
-                  </a:tcPr>
-                </a:tc>
-              </a:tr>
-              <a:tr h="301752">
-                <a:tc>
-                  <a:txBody>
-                    <a:bodyPr/>
-                    <a:lstStyle/>
-                    <a:p>
-                      <a:pPr>
-                        <a:defRPr sz="1100" b="1">
-                          <a:solidFill>
-                            <a:srgbClr val="0F172A"/>
-                          </a:solidFill>
-                          <a:latin typeface="Avenir Next"/>
-                        </a:defRPr>
-                      </a:pPr>
-                      <a:r>
-                        <a:t>py-numpy</a:t>
-                      </a:r>
-                    </a:p>
-                  </a:txBody>
-                  <a:tcPr marL="109728" marR="73152" marT="13716" marB="13716" anchor="ctr">
-                    <a:solidFill>
-                      <a:srgbClr val="FFFFFF"/>
-                    </a:solidFill>
-                  </a:tcPr>
-                </a:tc>
-                <a:tc>
-                  <a:txBody>
-                    <a:bodyPr/>
-                    <a:lstStyle/>
-                    <a:p>
-                      <a:pPr>
-                        <a:defRPr sz="1100" b="0">
-                          <a:solidFill>
-                            <a:srgbClr val="334155"/>
-                          </a:solidFill>
-                          <a:latin typeface="Avenir Next"/>
-                        </a:defRPr>
-                      </a:pPr>
-                      <a:r>
-                        <a:t>2.4.6</a:t>
-                      </a:r>
-                    </a:p>
-                  </a:txBody>
-                  <a:tcPr marL="109728" marR="73152" marT="13716" marB="13716" anchor="ctr">
-                    <a:solidFill>
-                      <a:srgbClr val="FFFFFF"/>
-                    </a:solidFill>
-                  </a:tcPr>
-                </a:tc>
-                <a:tc>
-                  <a:txBody>
-                    <a:bodyPr/>
-                    <a:lstStyle/>
-                    <a:p>
-                      <a:pPr>
-                        <a:defRPr sz="1050" b="0">
-                          <a:solidFill>
-                            <a:srgbClr val="64748B"/>
-                          </a:solidFill>
-                          <a:latin typeface="Avenir Next"/>
-                        </a:defRPr>
-                      </a:pPr>
-                      <a:r>
-                        <a:t>built against each python line (newest non-deprecated recipe)</a:t>
-                      </a:r>
-                    </a:p>
-                  </a:txBody>
-                  <a:tcPr marL="109728" marR="73152" marT="13716" marB="13716" anchor="ctr">
-                    <a:solidFill>
-                      <a:srgbClr val="FFFFFF"/>
-                    </a:solidFill>
-                  </a:tcPr>
-                </a:tc>
-              </a:tr>
-              <a:tr h="301752">
-                <a:tc>
-                  <a:txBody>
-                    <a:bodyPr/>
-                    <a:lstStyle/>
-                    <a:p>
-                      <a:pPr>
-                        <a:defRPr sz="1100" b="1">
-                          <a:solidFill>
-                            <a:srgbClr val="0F172A"/>
-                          </a:solidFill>
-                          <a:latin typeface="Avenir Next"/>
-                        </a:defRPr>
-                      </a:pPr>
-                      <a:r>
-                        <a:t>miniforge3</a:t>
-                      </a:r>
-                    </a:p>
-                  </a:txBody>
-                  <a:tcPr marL="109728" marR="73152" marT="13716" marB="13716" anchor="ctr">
-                    <a:solidFill>
-                      <a:srgbClr val="FFFFFF"/>
-                    </a:solidFill>
-                  </a:tcPr>
-                </a:tc>
-                <a:tc>
-                  <a:txBody>
-                    <a:bodyPr/>
-                    <a:lstStyle/>
-                    <a:p>
-                      <a:pPr>
-                        <a:defRPr sz="1100" b="0">
-                          <a:solidFill>
-                            <a:srgbClr val="334155"/>
-                          </a:solidFill>
-                          <a:latin typeface="Avenir Next"/>
-                        </a:defRPr>
-                      </a:pPr>
-                      <a:r>
-                        <a:t>26.1.1-3</a:t>
-                      </a:r>
-                    </a:p>
-                  </a:txBody>
-                  <a:tcPr marL="109728" marR="73152" marT="13716" marB="13716" anchor="ctr">
-                    <a:solidFill>
-                      <a:srgbClr val="FFFFFF"/>
-                    </a:solidFill>
-                  </a:tcPr>
-                </a:tc>
-                <a:tc>
-                  <a:txBody>
-                    <a:bodyPr/>
-                    <a:lstStyle/>
-                    <a:p>
-                      <a:pPr>
-                        <a:defRPr sz="1050" b="0">
-                          <a:solidFill>
-                            <a:srgbClr val="64748B"/>
-                          </a:solidFill>
-                          <a:latin typeface="Avenir Next"/>
-                        </a:defRPr>
-                      </a:pPr>
-                      <a:r>
-                        <a:t>single by nature — installer for user-managed environments</a:t>
-                      </a:r>
-                    </a:p>
-                  </a:txBody>
-                  <a:tcPr marL="109728" marR="73152" marT="13716" marB="13716" anchor="ctr">
-                    <a:solidFill>
-                      <a:srgbClr val="FFFFFF"/>
-                    </a:solidFill>
-                  </a:tcPr>
-                </a:tc>
-              </a:tr>
-              <a:tr h="301752">
-                <a:tc gridSpan="3">
-                  <a:txBody>
-                    <a:bodyPr/>
-                    <a:lstStyle/>
-                    <a:p>
-                      <a:pPr>
-                        <a:defRPr sz="1150" b="1">
-                          <a:solidFill>
-                            <a:srgbClr val="FFFFFF"/>
-                          </a:solidFill>
-                          <a:latin typeface="Avenir Next"/>
-                        </a:defRPr>
-                      </a:pPr>
-                      <a:r>
-                        <a:t>Only-serial by nature — no MPI implementation exists</a:t>
-                      </a:r>
-                    </a:p>
-                  </a:txBody>
-                  <a:tcPr marL="109728" marR="73152" marT="13716" marB="13716" anchor="ctr">
-                    <a:solidFill>
-                      <a:srgbClr val="0D9488"/>
-                    </a:solidFill>
-                  </a:tcPr>
-                </a:tc>
-                <a:tc hMerge="1">
-                  <a:txBody>
-                    <a:bodyPr/>
-                    <a:lstStyle/>
-                    <a:p/>
-                  </a:txBody>
-                  <a:tcPr/>
-                </a:tc>
-                <a:tc hMerge="1">
-                  <a:txBody>
-                    <a:bodyPr/>
-                    <a:lstStyle/>
-                    <a:p/>
-                  </a:txBody>
-                  <a:tcPr/>
-                </a:tc>
-              </a:tr>
-              <a:tr h="301752">
-                <a:tc>
-                  <a:txBody>
-                    <a:bodyPr/>
-                    <a:lstStyle/>
-                    <a:p>
-                      <a:pPr>
-                        <a:defRPr sz="1100" b="1">
-                          <a:solidFill>
-                            <a:srgbClr val="0F172A"/>
-                          </a:solidFill>
-                          <a:latin typeface="Avenir Next"/>
-                        </a:defRPr>
-                      </a:pPr>
-                      <a:r>
-                        <a:t>gsl</a:t>
-                      </a:r>
-                    </a:p>
-                  </a:txBody>
-                  <a:tcPr marL="109728" marR="73152" marT="13716" marB="13716" anchor="ctr">
-                    <a:solidFill>
-                      <a:srgbClr val="FFFFFF"/>
-                    </a:solidFill>
-                  </a:tcPr>
-                </a:tc>
-                <a:tc>
-                  <a:txBody>
-                    <a:bodyPr/>
-                    <a:lstStyle/>
-                    <a:p>
-                      <a:pPr>
-                        <a:defRPr sz="1100" b="0">
-                          <a:solidFill>
-                            <a:srgbClr val="334155"/>
-                          </a:solidFill>
-                          <a:latin typeface="Avenir Next"/>
-                        </a:defRPr>
-                      </a:pPr>
-                      <a:r>
-                        <a:t>2.8 · 2.7.1</a:t>
-                      </a:r>
-                    </a:p>
-                  </a:txBody>
-                  <a:tcPr marL="109728" marR="73152" marT="13716" marB="13716" anchor="ctr">
-                    <a:solidFill>
-                      <a:srgbClr val="FFFFFF"/>
-                    </a:solidFill>
-                  </a:tcPr>
-                </a:tc>
-                <a:tc>
-                  <a:txBody>
-                    <a:bodyPr/>
-                    <a:lstStyle/>
-                    <a:p>
-                      <a:pPr>
-                        <a:defRPr sz="1050" b="0">
-                          <a:solidFill>
-                            <a:srgbClr val="64748B"/>
-                          </a:solidFill>
-                          <a:latin typeface="Avenir Next"/>
-                        </a:defRPr>
-                      </a:pPr>
-                    </a:p>
-                  </a:txBody>
-                  <a:tcPr marL="109728" marR="73152" marT="13716" marB="13716" anchor="ctr">
-                    <a:solidFill>
-                      <a:srgbClr val="FFFFFF"/>
-                    </a:solidFill>
-                  </a:tcPr>
-                </a:tc>
-              </a:tr>
-              <a:tr h="301752">
-                <a:tc>
-                  <a:txBody>
-                    <a:bodyPr/>
-                    <a:lstStyle/>
-                    <a:p>
-                      <a:pPr>
-                        <a:defRPr sz="1100" b="1">
-                          <a:solidFill>
-                            <a:srgbClr val="0F172A"/>
-                          </a:solidFill>
-                          <a:latin typeface="Avenir Next"/>
-                        </a:defRPr>
-                      </a:pPr>
-                      <a:r>
-                        <a:t>sqlite</a:t>
-                      </a:r>
-                    </a:p>
-                  </a:txBody>
-                  <a:tcPr marL="109728" marR="73152" marT="13716" marB="13716" anchor="ctr">
-                    <a:solidFill>
-                      <a:srgbClr val="FFFFFF"/>
-                    </a:solidFill>
-                  </a:tcPr>
-                </a:tc>
-                <a:tc>
-                  <a:txBody>
-                    <a:bodyPr/>
-                    <a:lstStyle/>
-                    <a:p>
-                      <a:pPr>
-                        <a:defRPr sz="1100" b="0">
-                          <a:solidFill>
-                            <a:srgbClr val="334155"/>
-                          </a:solidFill>
-                          <a:latin typeface="Avenir Next"/>
-                        </a:defRPr>
-                      </a:pPr>
-                      <a:r>
-                        <a:t>3.53.1 · 3.51.2</a:t>
-                      </a:r>
-                    </a:p>
-                  </a:txBody>
-                  <a:tcPr marL="109728" marR="73152" marT="13716" marB="13716" anchor="ctr">
-                    <a:solidFill>
-                      <a:srgbClr val="FFFFFF"/>
-                    </a:solidFill>
-                  </a:tcPr>
-                </a:tc>
-                <a:tc>
-                  <a:txBody>
-                    <a:bodyPr/>
-                    <a:lstStyle/>
-                    <a:p>
-                      <a:pPr>
-                        <a:defRPr sz="1050" b="0">
-                          <a:solidFill>
-                            <a:srgbClr val="64748B"/>
-                          </a:solidFill>
-                          <a:latin typeface="Avenir Next"/>
-                        </a:defRPr>
-                      </a:pPr>
-                    </a:p>
-                  </a:txBody>
-                  <a:tcPr marL="109728" marR="73152" marT="13716" marB="13716" anchor="ctr">
-                    <a:solidFill>
-                      <a:srgbClr val="FFFFFF"/>
-                    </a:solidFill>
-                  </a:tcPr>
-                </a:tc>
-              </a:tr>
-            </a:tbl>
-          </a:graphicData>
-        </a:graphic>
-      </p:graphicFrame>
-      <p:sp>
-        <p:nvSpPr>
-          <p:cNvPr id="7" name="TextBox 6"/>
+      <p:sp>
+        <p:nvSpPr>
+          <p:cNvPr id="6" name="TextBox 5"/>
           <p:cNvSpPr txBox="1"/>
           <p:nvPr/>
         </p:nvSpPr>
         <p:spPr>
           <a:xfrm>
-            <a:off x="548640" y="6583680"/>
-            <a:ext cx="11064240" cy="256032"/>
+            <a:off x="548640" y="1389888"/>
+            <a:ext cx="11064240" cy="274320"/>
           </a:xfrm>
           <a:prstGeom prst="rect">
             <a:avLst/>
@@ -15033,8 +15302,554 @@
           </a:bodyPr>
           <a:lstStyle/>
           <a:p>
+            <a:pPr algn="ctr">
+              <a:defRPr sz="1150" b="1">
+                <a:solidFill>
+                  <a:srgbClr val="64748B"/>
+                </a:solidFill>
+                <a:latin typeface="Avenir Next"/>
+              </a:defRPr>
+            </a:pPr>
+            <a:r>
+              <a:t>CHOOSE EXACTLY ONE LANE</a:t>
+            </a:r>
+          </a:p>
+        </p:txBody>
+      </p:sp>
+      <p:sp>
+        <p:nvSpPr>
+          <p:cNvPr id="7" name="Rounded Rectangle 6"/>
+          <p:cNvSpPr/>
+          <p:nvPr/>
+        </p:nvSpPr>
+        <p:spPr>
+          <a:xfrm>
+            <a:off x="548640" y="1719072"/>
+            <a:ext cx="3611880" cy="1325880"/>
+          </a:xfrm>
+          <a:prstGeom prst="roundRect">
+            <a:avLst/>
+          </a:prstGeom>
+          <a:solidFill>
+            <a:srgbClr val="D97706"/>
+          </a:solidFill>
+          <a:ln>
+            <a:noFill/>
+          </a:ln>
+          <a:effectLst/>
+        </p:spPr>
+        <p:style>
+          <a:lnRef idx="1">
+            <a:schemeClr val="accent1"/>
+          </a:lnRef>
+          <a:fillRef idx="3">
+            <a:schemeClr val="accent1"/>
+          </a:fillRef>
+          <a:effectRef idx="2">
+            <a:schemeClr val="accent1"/>
+          </a:effectRef>
+          <a:fontRef idx="minor">
+            <a:schemeClr val="lt1"/>
+          </a:fontRef>
+        </p:style>
+        <p:txBody>
+          <a:bodyPr rtlCol="0" anchor="ctr" wrap="square" lIns="109728" rIns="109728"/>
+          <a:lstStyle/>
+          <a:p>
+            <a:pPr algn="ctr">
+              <a:defRPr sz="1500" b="1">
+                <a:solidFill>
+                  <a:srgbClr val="FFFFFF"/>
+                </a:solidFill>
+                <a:latin typeface="Avenir Next"/>
+              </a:defRPr>
+            </a:pPr>
+            <a:r>
+              <a:t>Serial</a:t>
+            </a:r>
+          </a:p>
+          <a:p>
+            <a:pPr algn="ctr">
+              <a:defRPr sz="1100" b="0">
+                <a:solidFill>
+                  <a:srgbClr val="FFFFFF"/>
+                </a:solidFill>
+                <a:latin typeface="Avenir Next"/>
+              </a:defRPr>
+            </a:pPr>
+            <a:r>
+              <a:t>hdf5 · netcdf · fftw · boost</a:t>
+            </a:r>
+          </a:p>
+          <a:p>
+            <a:pPr algn="ctr">
+              <a:defRPr sz="1000" b="0">
+                <a:solidFill>
+                  <a:srgbClr val="FFFFFF"/>
+                </a:solidFill>
+                <a:latin typeface="Avenir Next"/>
+              </a:defRPr>
+            </a:pPr>
+            <a:r>
+              <a:t>the same packages, built without MPI</a:t>
+            </a:r>
+          </a:p>
+        </p:txBody>
+      </p:sp>
+      <p:sp>
+        <p:nvSpPr>
+          <p:cNvPr id="8" name="Rounded Rectangle 7"/>
+          <p:cNvSpPr/>
+          <p:nvPr/>
+        </p:nvSpPr>
+        <p:spPr>
+          <a:xfrm>
+            <a:off x="4370831" y="1719072"/>
+            <a:ext cx="3611880" cy="1325880"/>
+          </a:xfrm>
+          <a:prstGeom prst="roundRect">
+            <a:avLst/>
+          </a:prstGeom>
+          <a:solidFill>
+            <a:srgbClr val="2563EB"/>
+          </a:solidFill>
+          <a:ln>
+            <a:noFill/>
+          </a:ln>
+          <a:effectLst/>
+        </p:spPr>
+        <p:style>
+          <a:lnRef idx="1">
+            <a:schemeClr val="accent1"/>
+          </a:lnRef>
+          <a:fillRef idx="3">
+            <a:schemeClr val="accent1"/>
+          </a:fillRef>
+          <a:effectRef idx="2">
+            <a:schemeClr val="accent1"/>
+          </a:effectRef>
+          <a:fontRef idx="minor">
+            <a:schemeClr val="lt1"/>
+          </a:fontRef>
+        </p:style>
+        <p:txBody>
+          <a:bodyPr rtlCol="0" anchor="ctr" wrap="square" lIns="109728" rIns="109728"/>
+          <a:lstStyle/>
+          <a:p>
+            <a:pPr algn="ctr">
+              <a:defRPr sz="1500" b="1">
+                <a:solidFill>
+                  <a:srgbClr val="FFFFFF"/>
+                </a:solidFill>
+                <a:latin typeface="Avenir Next"/>
+              </a:defRPr>
+            </a:pPr>
+            <a:r>
+              <a:t>MPI</a:t>
+            </a:r>
+          </a:p>
+          <a:p>
+            <a:pPr algn="ctr">
+              <a:defRPr sz="1100" b="0">
+                <a:solidFill>
+                  <a:srgbClr val="FFFFFF"/>
+                </a:solidFill>
+                <a:latin typeface="Avenir Next"/>
+              </a:defRPr>
+            </a:pPr>
+            <a:r>
+              <a:t>hdf5 · netcdf · fftw · boost · tau · dakota</a:t>
+            </a:r>
+          </a:p>
+          <a:p>
+            <a:pPr algn="ctr">
+              <a:defRPr sz="1000" b="0">
+                <a:solidFill>
+                  <a:srgbClr val="FFFFFF"/>
+                </a:solidFill>
+                <a:latin typeface="Avenir Next"/>
+              </a:defRPr>
+            </a:pPr>
+            <a:r>
+              <a:t>built against the system MPI</a:t>
+            </a:r>
+          </a:p>
+        </p:txBody>
+      </p:sp>
+      <p:sp>
+        <p:nvSpPr>
+          <p:cNvPr id="9" name="Rounded Rectangle 8"/>
+          <p:cNvSpPr/>
+          <p:nvPr/>
+        </p:nvSpPr>
+        <p:spPr>
+          <a:xfrm>
+            <a:off x="8193023" y="1719072"/>
+            <a:ext cx="3611880" cy="1325880"/>
+          </a:xfrm>
+          <a:prstGeom prst="roundRect">
+            <a:avLst/>
+          </a:prstGeom>
+          <a:solidFill>
+            <a:srgbClr val="7C3AED"/>
+          </a:solidFill>
+          <a:ln>
+            <a:noFill/>
+          </a:ln>
+          <a:effectLst/>
+        </p:spPr>
+        <p:style>
+          <a:lnRef idx="1">
+            <a:schemeClr val="accent1"/>
+          </a:lnRef>
+          <a:fillRef idx="3">
+            <a:schemeClr val="accent1"/>
+          </a:fillRef>
+          <a:effectRef idx="2">
+            <a:schemeClr val="accent1"/>
+          </a:effectRef>
+          <a:fontRef idx="minor">
+            <a:schemeClr val="lt1"/>
+          </a:fontRef>
+        </p:style>
+        <p:txBody>
+          <a:bodyPr rtlCol="0" anchor="ctr" wrap="square" lIns="109728" rIns="109728"/>
+          <a:lstStyle/>
+          <a:p>
+            <a:pPr algn="ctr">
+              <a:defRPr sz="1500" b="1">
+                <a:solidFill>
+                  <a:srgbClr val="FFFFFF"/>
+                </a:solidFill>
+                <a:latin typeface="Avenir Next"/>
+              </a:defRPr>
+            </a:pPr>
+            <a:r>
+              <a:t>GPU</a:t>
+            </a:r>
+          </a:p>
+          <a:p>
+            <a:pPr algn="ctr">
+              <a:defRPr sz="1100" b="0">
+                <a:solidFill>
+                  <a:srgbClr val="FFFFFF"/>
+                </a:solidFill>
+                <a:latin typeface="Avenir Next"/>
+              </a:defRPr>
+            </a:pPr>
+            <a:r>
+              <a:t>the MPI roster, plus kokkos</a:t>
+            </a:r>
+          </a:p>
+          <a:p>
+            <a:pPr algn="ctr">
+              <a:defRPr sz="1000" b="0">
+                <a:solidFill>
+                  <a:srgbClr val="FFFFFF"/>
+                </a:solidFill>
+                <a:latin typeface="Avenir Next"/>
+              </a:defRPr>
+            </a:pPr>
+            <a:r>
+              <a:t>+rocm / +cuda, arch from the probe</a:t>
+            </a:r>
+          </a:p>
+        </p:txBody>
+      </p:sp>
+      <p:sp>
+        <p:nvSpPr>
+          <p:cNvPr id="10" name="Rounded Rectangle 9"/>
+          <p:cNvSpPr/>
+          <p:nvPr/>
+        </p:nvSpPr>
+        <p:spPr>
+          <a:xfrm>
+            <a:off x="548640" y="3200400"/>
+            <a:ext cx="11091672" cy="640080"/>
+          </a:xfrm>
+          <a:prstGeom prst="roundRect">
+            <a:avLst/>
+          </a:prstGeom>
+          <a:solidFill>
+            <a:srgbClr val="15803D"/>
+          </a:solidFill>
+          <a:ln>
+            <a:noFill/>
+          </a:ln>
+          <a:effectLst/>
+        </p:spPr>
+        <p:style>
+          <a:lnRef idx="1">
+            <a:schemeClr val="accent1"/>
+          </a:lnRef>
+          <a:fillRef idx="3">
+            <a:schemeClr val="accent1"/>
+          </a:fillRef>
+          <a:effectRef idx="2">
+            <a:schemeClr val="accent1"/>
+          </a:effectRef>
+          <a:fontRef idx="minor">
+            <a:schemeClr val="lt1"/>
+          </a:fontRef>
+        </p:style>
+        <p:txBody>
+          <a:bodyPr rtlCol="0" anchor="ctr" wrap="square" lIns="109728" rIns="109728"/>
+          <a:lstStyle/>
+          <a:p>
+            <a:pPr algn="ctr">
+              <a:defRPr sz="1250" b="1">
+                <a:solidFill>
+                  <a:srgbClr val="FFFFFF"/>
+                </a:solidFill>
+                <a:latin typeface="Avenir Next"/>
+              </a:defRPr>
+            </a:pPr>
+            <a:r>
+              <a:t>Common compiler-dependent packages — loadable from every lane</a:t>
+            </a:r>
+          </a:p>
+          <a:p>
+            <a:pPr algn="ctr">
+              <a:defRPr sz="1050" b="0">
+                <a:solidFill>
+                  <a:srgbClr val="FFFFFF"/>
+                </a:solidFill>
+                <a:latin typeface="Avenir Next"/>
+              </a:defRPr>
+            </a:pPr>
+            <a:r>
+              <a:t>openblas · netlib-lapack · gnuplot — one Serial-lane build, one install, shared module root</a:t>
+            </a:r>
+          </a:p>
+        </p:txBody>
+      </p:sp>
+      <p:sp>
+        <p:nvSpPr>
+          <p:cNvPr id="11" name="Rounded Rectangle 10"/>
+          <p:cNvSpPr/>
+          <p:nvPr/>
+        </p:nvSpPr>
+        <p:spPr>
+          <a:xfrm>
+            <a:off x="548640" y="3959352"/>
+            <a:ext cx="11091672" cy="640080"/>
+          </a:xfrm>
+          <a:prstGeom prst="roundRect">
+            <a:avLst/>
+          </a:prstGeom>
+          <a:solidFill>
+            <a:srgbClr val="0D9488"/>
+          </a:solidFill>
+          <a:ln>
+            <a:noFill/>
+          </a:ln>
+          <a:effectLst/>
+        </p:spPr>
+        <p:style>
+          <a:lnRef idx="1">
+            <a:schemeClr val="accent1"/>
+          </a:lnRef>
+          <a:fillRef idx="3">
+            <a:schemeClr val="accent1"/>
+          </a:fillRef>
+          <a:effectRef idx="2">
+            <a:schemeClr val="accent1"/>
+          </a:effectRef>
+          <a:fontRef idx="minor">
+            <a:schemeClr val="lt1"/>
+          </a:fontRef>
+        </p:style>
+        <p:txBody>
+          <a:bodyPr rtlCol="0" anchor="ctr" wrap="square" lIns="109728" rIns="109728"/>
+          <a:lstStyle/>
+          <a:p>
+            <a:pPr algn="ctr">
+              <a:defRPr sz="1250" b="1">
+                <a:solidFill>
+                  <a:srgbClr val="FFFFFF"/>
+                </a:solidFill>
+                <a:latin typeface="Avenir Next"/>
+              </a:defRPr>
+            </a:pPr>
+            <a:r>
+              <a:t>Core — loads with the compiler surface</a:t>
+            </a:r>
+          </a:p>
+          <a:p>
+            <a:pPr algn="ctr">
+              <a:defRPr sz="1050" b="0">
+                <a:solidFill>
+                  <a:srgbClr val="FFFFFF"/>
+                </a:solidFill>
+                <a:latin typeface="Avenir Next"/>
+              </a:defRPr>
+            </a:pPr>
+            <a:r>
+              <a:t>cmake · ninja · git · python · py-numpy · miniforge · gsl · sqlite</a:t>
+            </a:r>
+          </a:p>
+        </p:txBody>
+      </p:sp>
+      <p:sp>
+        <p:nvSpPr>
+          <p:cNvPr id="12" name="Rounded Rectangle 11"/>
+          <p:cNvSpPr/>
+          <p:nvPr/>
+        </p:nvSpPr>
+        <p:spPr>
+          <a:xfrm>
+            <a:off x="548640" y="4718304"/>
+            <a:ext cx="11091672" cy="640080"/>
+          </a:xfrm>
+          <a:prstGeom prst="roundRect">
+            <a:avLst/>
+          </a:prstGeom>
+          <a:solidFill>
+            <a:srgbClr val="475569"/>
+          </a:solidFill>
+          <a:ln>
+            <a:noFill/>
+          </a:ln>
+          <a:effectLst/>
+        </p:spPr>
+        <p:style>
+          <a:lnRef idx="1">
+            <a:schemeClr val="accent1"/>
+          </a:lnRef>
+          <a:fillRef idx="3">
+            <a:schemeClr val="accent1"/>
+          </a:fillRef>
+          <a:effectRef idx="2">
+            <a:schemeClr val="accent1"/>
+          </a:effectRef>
+          <a:fontRef idx="minor">
+            <a:schemeClr val="lt1"/>
+          </a:fontRef>
+        </p:style>
+        <p:txBody>
+          <a:bodyPr rtlCol="0" anchor="ctr" wrap="square" lIns="109728" rIns="109728"/>
+          <a:lstStyle/>
+          <a:p>
+            <a:pPr algn="ctr">
+              <a:defRPr sz="1250" b="1">
+                <a:solidFill>
+                  <a:srgbClr val="FFFFFF"/>
+                </a:solidFill>
+                <a:latin typeface="Avenir Next"/>
+              </a:defRPr>
+            </a:pPr>
+            <a:r>
+              <a:t>Foundation — ambient in the view, never a module</a:t>
+            </a:r>
+          </a:p>
+          <a:p>
+            <a:pPr algn="ctr">
+              <a:defRPr sz="1050" b="0">
+                <a:solidFill>
+                  <a:srgbClr val="FFFFFF"/>
+                </a:solidFill>
+                <a:latin typeface="Avenir Next"/>
+              </a:defRPr>
+            </a:pPr>
+            <a:r>
+              <a:t>zlib · xz · zstd, single pinned version</a:t>
+            </a:r>
+          </a:p>
+        </p:txBody>
+      </p:sp>
+      <p:sp>
+        <p:nvSpPr>
+          <p:cNvPr id="13" name="Rounded Rectangle 12"/>
+          <p:cNvSpPr/>
+          <p:nvPr/>
+        </p:nvSpPr>
+        <p:spPr>
+          <a:xfrm>
+            <a:off x="548640" y="5504688"/>
+            <a:ext cx="11091672" cy="548640"/>
+          </a:xfrm>
+          <a:prstGeom prst="roundRect">
+            <a:avLst/>
+          </a:prstGeom>
+          <a:solidFill>
+            <a:srgbClr val="FFFFFF"/>
+          </a:solidFill>
+          <a:ln w="15875">
+            <a:solidFill>
+              <a:srgbClr val="E2E8F0"/>
+            </a:solidFill>
+          </a:ln>
+          <a:effectLst/>
+        </p:spPr>
+        <p:style>
+          <a:lnRef idx="1">
+            <a:schemeClr val="accent1"/>
+          </a:lnRef>
+          <a:fillRef idx="3">
+            <a:schemeClr val="accent1"/>
+          </a:fillRef>
+          <a:effectRef idx="2">
+            <a:schemeClr val="accent1"/>
+          </a:effectRef>
+          <a:fontRef idx="minor">
+            <a:schemeClr val="lt1"/>
+          </a:fontRef>
+        </p:style>
+        <p:txBody>
+          <a:bodyPr rtlCol="0" anchor="ctr" wrap="square" lIns="109728" rIns="109728"/>
+          <a:lstStyle/>
+          <a:p>
+            <a:pPr algn="ctr">
+              <a:defRPr sz="1300" b="1">
+                <a:solidFill>
+                  <a:srgbClr val="0F172A"/>
+                </a:solidFill>
+                <a:latin typeface="Avenir Next"/>
+              </a:defRPr>
+            </a:pPr>
+            <a:r>
+              <a:t>cse/&lt;Compiler&gt; surface — everything above sits on one compiler</a:t>
+            </a:r>
+          </a:p>
+          <a:p>
+            <a:pPr algn="ctr">
+              <a:defRPr sz="1050" b="0">
+                <a:solidFill>
+                  <a:srgbClr val="64748B"/>
+                </a:solidFill>
+                <a:latin typeface="Avenir Next"/>
+              </a:defRPr>
+            </a:pPr>
+            <a:r>
+              <a:t>lanes never mix compilers; loading a second lane fails loudly</a:t>
+            </a:r>
+          </a:p>
+        </p:txBody>
+      </p:sp>
+      <p:sp>
+        <p:nvSpPr>
+          <p:cNvPr id="14" name="TextBox 13"/>
+          <p:cNvSpPr txBox="1"/>
+          <p:nvPr/>
+        </p:nvSpPr>
+        <p:spPr>
+          <a:xfrm>
+            <a:off x="548640" y="6199632"/>
+            <a:ext cx="11064240" cy="457200"/>
+          </a:xfrm>
+          <a:prstGeom prst="rect">
+            <a:avLst/>
+          </a:prstGeom>
+          <a:noFill/>
+        </p:spPr>
+        <p:txBody>
+          <a:bodyPr wrap="square" anchor="t">
+            <a:spAutoFit/>
+          </a:bodyPr>
+          <a:lstStyle/>
+          <a:p>
             <a:pPr algn="l">
-              <a:defRPr sz="1050" b="0">
+              <a:defRPr sz="1150" b="0">
                 <a:solidFill>
                   <a:srgbClr val="64748B"/>
                 </a:solidFill>
@@ -15042,7 +15857,7 @@
               </a:defRPr>
             </a:pPr>
             <a:r>
-              <a:t>Version policy: newest supported + immediate predecessor · pinned to spack-packages v2026.06.0 (Spack v1.1.1)</a:t>
+              <a:t>A user's view is one column: the surface, Foundation, Core, the common packages, and exactly one payload. The other payloads stay invisible until their lane is loaded.</a:t>
             </a:r>
           </a:p>
         </p:txBody>

</xml_diff>

<commit_message>
Deck: make the pipeline slide tool-neutral
The probe and render stages named internal tools (cluster-inspector,
stack-composer). The process stands on its own and can be followed by
hand; the stages now describe what happens, not which program does it.
Spack stays named — building with ordinary Spack commands is part of the
story.
</commit_message>
<xml_diff>
--- a/presentations/cse_lanes_model.pptx
+++ b/presentations/cse_lanes_model.pptx
@@ -9868,7 +9868,7 @@
               </a:defRPr>
             </a:pPr>
             <a:r>
-              <a:t>cluster-inspector</a:t>
+              <a:t>record the system's</a:t>
             </a:r>
           </a:p>
           <a:p>
@@ -9881,7 +9881,7 @@
               </a:defRPr>
             </a:pPr>
             <a:r>
-              <a:t>reads the system</a:t>
+              <a:t>facts, once</a:t>
             </a:r>
           </a:p>
         </p:txBody>
@@ -10106,7 +10106,7 @@
               </a:defRPr>
             </a:pPr>
             <a:r>
-              <a:t>stack-composer</a:t>
+              <a:t>derive every lane's</a:t>
             </a:r>
           </a:p>
           <a:p>
@@ -10119,7 +10119,7 @@
               </a:defRPr>
             </a:pPr>
             <a:r>
-              <a:t>emits every lane</a:t>
+              <a:t>build input</a:t>
             </a:r>
           </a:p>
         </p:txBody>

</xml_diff>

<commit_message>
Deck: replace em dashes throughout the slide text
Title separators become colons, note fragments use semicolons, commas,
or the existing middle-dot separator. No slide text carries an em dash;
verified against the generated pptx.
</commit_message>
<xml_diff>
--- a/presentations/cse_lanes_model.pptx
+++ b/presentations/cse_lanes_model.pptx
@@ -3298,7 +3298,7 @@
               </a:defRPr>
             </a:pPr>
             <a:r>
-              <a:t>One clean build surface per compiler, MPI, and GPU — the lanes model</a:t>
+              <a:t>One clean build surface per compiler, MPI, and GPU: the lanes model</a:t>
             </a:r>
           </a:p>
           <a:p>
@@ -3657,7 +3657,7 @@
               </a:defRPr>
             </a:pPr>
             <a:r>
-              <a:t>Core and foundation — built once per compiler surface</a:t>
+              <a:t>Core and foundation: built once per compiler surface</a:t>
             </a:r>
           </a:p>
         </p:txBody>
@@ -3818,7 +3818,7 @@
                         </a:defRPr>
                       </a:pPr>
                       <a:r>
-                        <a:t>Foundation — ambient in the lane view, never a module</a:t>
+                        <a:t>Foundation: ambient in the lane view, never a module</a:t>
                       </a:r>
                     </a:p>
                   </a:txBody>
@@ -4082,7 +4082,7 @@
                         </a:defRPr>
                       </a:pPr>
                       <a:r>
-                        <a:t>Core tools — user-loadable, compiler-agnostic</a:t>
+                        <a:t>Core tools: user-loadable, compiler-agnostic</a:t>
                       </a:r>
                     </a:p>
                   </a:txBody>
@@ -4243,7 +4243,7 @@
                         </a:defRPr>
                       </a:pPr>
                       <a:r>
-                        <a:t>unpinned — newest from the recipe generation</a:t>
+                        <a:t>unpinned; newest from the recipe generation</a:t>
                       </a:r>
                     </a:p>
                   </a:txBody>
@@ -4465,7 +4465,7 @@
                         </a:defRPr>
                       </a:pPr>
                       <a:r>
-                        <a:t>single by nature — installer for user-managed environments</a:t>
+                        <a:t>single by nature; installer for user-managed environments</a:t>
                       </a:r>
                     </a:p>
                   </a:txBody>
@@ -4491,7 +4491,7 @@
                         </a:defRPr>
                       </a:pPr>
                       <a:r>
-                        <a:t>Only-serial by nature — no MPI implementation exists</a:t>
+                        <a:t>Only-serial by nature: no MPI implementation exists</a:t>
                       </a:r>
                     </a:p>
                   </a:txBody>
@@ -4829,7 +4829,7 @@
               </a:defRPr>
             </a:pPr>
             <a:r>
-              <a:t>Serial lane — MPI-capable, deliberately built without MPI</a:t>
+              <a:t>Serial lane: MPI-capable, deliberately built without MPI</a:t>
             </a:r>
           </a:p>
         </p:txBody>
@@ -4990,7 +4990,7 @@
                         </a:defRPr>
                       </a:pPr>
                       <a:r>
-                        <a:t>Serial data chains — each netcdf rides one named hdf5</a:t>
+                        <a:t>Serial data chains: each netcdf rides one named hdf5</a:t>
                       </a:r>
                     </a:p>
                   </a:txBody>
@@ -5154,7 +5154,7 @@
                         </a:defRPr>
                       </a:pPr>
                       <a:r>
-                        <a:t>~mpi — paired to hdf5 2.1.0 / 1.14.6</a:t>
+                        <a:t>~mpi, paired to hdf5 2.1.0 / 1.14.6</a:t>
                       </a:r>
                     </a:p>
                   </a:txBody>
@@ -5302,7 +5302,7 @@
                         </a:defRPr>
                       </a:pPr>
                       <a:r>
-                        <a:t>single recipe version — newest chain only</a:t>
+                        <a:t>single recipe version; newest chain only</a:t>
                       </a:r>
                     </a:p>
                   </a:txBody>
@@ -5518,7 +5518,7 @@
                         </a:defRPr>
                       </a:pPr>
                       <a:r>
-                        <a:t>Common compiler-dependent — built here once, available in every lane</a:t>
+                        <a:t>Common compiler-dependent: built here once, available in every lane</a:t>
                       </a:r>
                     </a:p>
                   </a:txBody>
@@ -5936,7 +5936,7 @@
               </a:defRPr>
             </a:pPr>
             <a:r>
-              <a:t>MPI and GPU lanes — built against the system MPI</a:t>
+              <a:t>MPI and GPU lanes: built against the system MPI</a:t>
             </a:r>
           </a:p>
         </p:txBody>
@@ -6097,7 +6097,7 @@
                         </a:defRPr>
                       </a:pPr>
                       <a:r>
-                        <a:t>MPI data chains — same pairing rule as serial</a:t>
+                        <a:t>MPI data chains: same pairing rule as serial</a:t>
                       </a:r>
                     </a:p>
                   </a:txBody>
@@ -6261,7 +6261,7 @@
                         </a:defRPr>
                       </a:pPr>
                       <a:r>
-                        <a:t>+mpi +parallel-netcdf — paired to hdf5 2.1.0 / 1.14.6</a:t>
+                        <a:t>+mpi +parallel-netcdf, paired to hdf5 2.1.0 / 1.14.6</a:t>
                       </a:r>
                     </a:p>
                   </a:txBody>
@@ -6409,7 +6409,7 @@
                         </a:defRPr>
                       </a:pPr>
                       <a:r>
-                        <a:t>single recipe version — newest chain only</a:t>
+                        <a:t>single recipe version; newest chain only</a:t>
                       </a:r>
                     </a:p>
                   </a:txBody>
@@ -6747,7 +6747,7 @@
                         </a:defRPr>
                       </a:pPr>
                       <a:r>
-                        <a:t>+mpi — heaviest build in the roster</a:t>
+                        <a:t>+mpi; heaviest build in the roster</a:t>
                       </a:r>
                     </a:p>
                   </a:txBody>
@@ -6773,7 +6773,7 @@
                         </a:defRPr>
                       </a:pPr>
                       <a:r>
-                        <a:t>GPU lane — selects the full MPI roster above, plus the GPU payload</a:t>
+                        <a:t>GPU lane: selects the full MPI roster above, plus the GPU payload</a:t>
                       </a:r>
                     </a:p>
                   </a:txBody>
@@ -6889,7 +6889,7 @@
                         </a:defRPr>
                       </a:pPr>
                       <a:r>
-                        <a:t>Common compiler-dependent — the Serial-lane build, available here too</a:t>
+                        <a:t>Common compiler-dependent: the Serial-lane build, available here too</a:t>
                       </a:r>
                     </a:p>
                   </a:txBody>
@@ -7005,7 +7005,7 @@
                         </a:defRPr>
                       </a:pPr>
                       <a:r>
-                        <a:t>Externals — used from the system, never built</a:t>
+                        <a:t>Externals: used from the system, never built</a:t>
                       </a:r>
                     </a:p>
                   </a:txBody>
@@ -7399,7 +7399,7 @@
               </a:defRPr>
             </a:pPr>
             <a:r>
-              <a:t>Today — CSEinit</a:t>
+              <a:t>Today: CSEinit</a:t>
             </a:r>
           </a:p>
         </p:txBody>
@@ -8145,7 +8145,7 @@
               </a:defRPr>
             </a:pPr>
             <a:r>
-              <a:t>hand-curated per system — upgrades mean rebuilding everything</a:t>
+              <a:t>hand-curated per system; upgrades mean rebuilding everything</a:t>
             </a:r>
           </a:p>
         </p:txBody>
@@ -8372,7 +8372,7 @@
               </a:defRPr>
             </a:pPr>
             <a:r>
-              <a:t>Core — automatic</a:t>
+              <a:t>Core (automatic)</a:t>
             </a:r>
           </a:p>
         </p:txBody>
@@ -8426,7 +8426,7 @@
               </a:defRPr>
             </a:pPr>
             <a:r>
-              <a:t>Foundation — in view</a:t>
+              <a:t>Foundation (in view)</a:t>
             </a:r>
           </a:p>
         </p:txBody>
@@ -9110,7 +9110,7 @@
               </a:defRPr>
             </a:pPr>
             <a:r>
-              <a:t>compiler_mixing: false — lanes stay isolated</a:t>
+              <a:t>compiler_mixing: false keeps lanes isolated</a:t>
             </a:r>
           </a:p>
           <a:p>
@@ -10413,7 +10413,7 @@
               </a:defRPr>
             </a:pPr>
             <a:r>
-              <a:t>Core + Foundation — built once per compiler surface, portable target</a:t>
+              <a:t>Core + Foundation: built once per compiler surface, portable target</a:t>
             </a:r>
           </a:p>
           <a:p>
@@ -10774,7 +10774,7 @@
               </a:defRPr>
             </a:pPr>
             <a:r>
-              <a:t>A new system is a probe + a render — not months of curation.</a:t>
+              <a:t>A new system is a probe and a render, not months of curation.</a:t>
             </a:r>
           </a:p>
           <a:p>
@@ -11112,7 +11112,7 @@
               </a:defRPr>
             </a:pPr>
             <a:r>
-              <a:t>Core — loads automatically</a:t>
+              <a:t>Core: loads automatically</a:t>
             </a:r>
           </a:p>
           <a:p>
@@ -11179,7 +11179,7 @@
               </a:defRPr>
             </a:pPr>
             <a:r>
-              <a:t>Foundation — ambient in the view</a:t>
+              <a:t>Foundation: ambient in the view</a:t>
             </a:r>
           </a:p>
           <a:p>
@@ -11192,7 +11192,7 @@
               </a:defRPr>
             </a:pPr>
             <a:r>
-              <a:t>zlib · xz · zstd — one pinned version</a:t>
+              <a:t>zlib · xz · zstd · one pinned version</a:t>
             </a:r>
           </a:p>
         </p:txBody>
@@ -12549,7 +12549,7 @@
               </a:defRPr>
             </a:pPr>
             <a:r>
-              <a:t>Modules: cse/&lt;Compiler&gt;/&lt;Lane&gt; — short names for users; dependency compatibility is enforced by module metadata.</a:t>
+              <a:t>Modules: cse/&lt;Compiler&gt;/&lt;Lane&gt;. Short names for users; dependency compatibility is enforced by module metadata.</a:t>
             </a:r>
           </a:p>
         </p:txBody>
@@ -13535,7 +13535,7 @@
               </a:defRPr>
             </a:pPr>
             <a:r>
-              <a:t>Representative roster — newest two supported releases</a:t>
+              <a:t>Representative roster: newest two supported releases</a:t>
             </a:r>
           </a:p>
         </p:txBody>
@@ -15605,7 +15605,7 @@
               </a:defRPr>
             </a:pPr>
             <a:r>
-              <a:t>Common compiler-dependent packages — loadable from every lane</a:t>
+              <a:t>Common compiler-dependent packages: loadable from every lane</a:t>
             </a:r>
           </a:p>
           <a:p>
@@ -15618,7 +15618,7 @@
               </a:defRPr>
             </a:pPr>
             <a:r>
-              <a:t>openblas · netlib-lapack · gnuplot — one Serial-lane build, one install, shared module root</a:t>
+              <a:t>openblas · netlib-lapack · gnuplot · one Serial-lane build, one install, shared module root</a:t>
             </a:r>
           </a:p>
         </p:txBody>
@@ -15672,7 +15672,7 @@
               </a:defRPr>
             </a:pPr>
             <a:r>
-              <a:t>Core — loads with the compiler surface</a:t>
+              <a:t>Core: loads with the compiler surface</a:t>
             </a:r>
           </a:p>
           <a:p>
@@ -15739,7 +15739,7 @@
               </a:defRPr>
             </a:pPr>
             <a:r>
-              <a:t>Foundation — ambient in the view, never a module</a:t>
+              <a:t>Foundation: ambient in the view, never a module</a:t>
             </a:r>
           </a:p>
           <a:p>
@@ -15808,7 +15808,7 @@
               </a:defRPr>
             </a:pPr>
             <a:r>
-              <a:t>cse/&lt;Compiler&gt; surface — everything above sits on one compiler</a:t>
+              <a:t>cse/&lt;Compiler&gt; surface: everything above sits on one compiler</a:t>
             </a:r>
           </a:p>
           <a:p>

</xml_diff>

<commit_message>
Say what Foundation does in plain words
"Ambient in the view" is insider shorthand. The SOP now says what
actually happens: loading the compiler surface puts the view's bin,
include, and lib directories on the search paths, so foundation
libraries are found automatically at compile and run time, with no
module to load. Deck bands and boxes updated to "on your paths
automatically, nothing to load".
</commit_message>
<xml_diff>
--- a/presentations/cse_lanes_model.pptx
+++ b/presentations/cse_lanes_model.pptx
@@ -3818,7 +3818,7 @@
                         </a:defRPr>
                       </a:pPr>
                       <a:r>
-                        <a:t>Foundation: ambient in the lane view, never a module</a:t>
+                        <a:t>Foundation: on your paths automatically, never a loadable module</a:t>
                       </a:r>
                     </a:p>
                   </a:txBody>
@@ -8426,7 +8426,7 @@
               </a:defRPr>
             </a:pPr>
             <a:r>
-              <a:t>Foundation (in view)</a:t>
+              <a:t>Foundation (on the path)</a:t>
             </a:r>
           </a:p>
         </p:txBody>
@@ -11179,7 +11179,7 @@
               </a:defRPr>
             </a:pPr>
             <a:r>
-              <a:t>Foundation: ambient in the view</a:t>
+              <a:t>Foundation: on your paths automatically</a:t>
             </a:r>
           </a:p>
           <a:p>
@@ -15739,7 +15739,7 @@
               </a:defRPr>
             </a:pPr>
             <a:r>
-              <a:t>Foundation: ambient in the view, never a module</a:t>
+              <a:t>Foundation: on your paths automatically, nothing to load</a:t>
             </a:r>
           </a:p>
           <a:p>

</xml_diff>

<commit_message>
Define View in the SOP vocabulary; record the docs split; deck chip wording
View gets a plain-words vocabulary entry (one merged directory tree, like
one virtual install prefix; the surface puts its directories on the
search paths). Section 10 records that a user guide and a developer guide
are planned separately and the SOP stays at process level. The pilot
scope slide's Foundation chip says "on the path" instead of "view".
</commit_message>
<xml_diff>
--- a/presentations/cse_lanes_model.pptx
+++ b/presentations/cse_lanes_model.pptx
@@ -12951,7 +12951,7 @@
               </a:defRPr>
             </a:pPr>
             <a:r>
-              <a:t>Foundation (view)</a:t>
+              <a:t>Foundation (on the path)</a:t>
             </a:r>
           </a:p>
         </p:txBody>
@@ -13337,7 +13337,7 @@
               </a:defRPr>
             </a:pPr>
             <a:r>
-              <a:t>Foundation (view)</a:t>
+              <a:t>Foundation (on the path)</a:t>
             </a:r>
           </a:p>
         </p:txBody>

</xml_diff>

<commit_message>
Pilot systems slide: correct hardware, focus on the accelerated nodes
The pilot targets each system's accelerated node type, so the cards now
name that node's CPU and accelerator rather than the standard-node CPU
and the visualization GPUs. Blueback AI/ML nodes are MI300A APUs (96
cores), not Genoa 9654 with an L40; Raider and Wheat MLA nodes carry
A100s, not the A40 visualization cards; Fran carries H200s, not the
L40S quoted in the public upcoming blurb. Operating systems added:
SLES, RHEL 9, RHEL 8, RHEL 8. Coverage line now leads with the OS
spread.
</commit_message>
<xml_diff>
--- a/presentations/cse_lanes_model.pptx
+++ b/presentations/cse_lanes_model.pptx
@@ -17,6 +17,7 @@
     <p:sldId id="265" r:id="rId16"/>
     <p:sldId id="266" r:id="rId17"/>
     <p:sldId id="267" r:id="rId18"/>
+    <p:sldId id="268" r:id="rId19"/>
   </p:sldIdLst>
   <p:sldSz cx="12191695" cy="6858000" type="screen4x3"/>
   <p:notesSz cx="6858000" cy="9144000"/>
@@ -3537,6 +3538,766 @@
 </file>
 
 <file path=ppt/slides/slide10.xml><?xml version="1.0" encoding="utf-8"?>
+<p:sld xmlns:a="http://schemas.openxmlformats.org/drawingml/2006/main" xmlns:p="http://schemas.openxmlformats.org/presentationml/2006/main" xmlns:r="http://schemas.openxmlformats.org/officeDocument/2006/relationships">
+  <p:cSld>
+    <p:spTree>
+      <p:nvGrpSpPr>
+        <p:cNvPr id="1" name=""/>
+        <p:cNvGrpSpPr/>
+        <p:nvPr/>
+      </p:nvGrpSpPr>
+      <p:grpSpPr/>
+      <p:sp>
+        <p:nvSpPr>
+          <p:cNvPr id="2" name="Rectangle 1"/>
+          <p:cNvSpPr/>
+          <p:nvPr/>
+        </p:nvSpPr>
+        <p:spPr>
+          <a:xfrm>
+            <a:off x="0" y="0"/>
+            <a:ext cx="12191695" cy="6858000"/>
+          </a:xfrm>
+          <a:prstGeom prst="rect">
+            <a:avLst/>
+          </a:prstGeom>
+          <a:solidFill>
+            <a:srgbClr val="FFFFFF"/>
+          </a:solidFill>
+          <a:ln>
+            <a:noFill/>
+          </a:ln>
+          <a:effectLst/>
+        </p:spPr>
+        <p:style>
+          <a:lnRef idx="1">
+            <a:schemeClr val="accent1"/>
+          </a:lnRef>
+          <a:fillRef idx="3">
+            <a:schemeClr val="accent1"/>
+          </a:fillRef>
+          <a:effectRef idx="2">
+            <a:schemeClr val="accent1"/>
+          </a:effectRef>
+          <a:fontRef idx="minor">
+            <a:schemeClr val="lt1"/>
+          </a:fontRef>
+        </p:style>
+        <p:txBody>
+          <a:bodyPr rtlCol="0" anchor="ctr"/>
+          <a:lstStyle/>
+          <a:p>
+            <a:pPr algn="ctr"/>
+          </a:p>
+        </p:txBody>
+      </p:sp>
+      <p:sp>
+        <p:nvSpPr>
+          <p:cNvPr id="3" name="TextBox 2"/>
+          <p:cNvSpPr txBox="1"/>
+          <p:nvPr/>
+        </p:nvSpPr>
+        <p:spPr>
+          <a:xfrm>
+            <a:off x="548640" y="256032"/>
+            <a:ext cx="10972800" cy="365760"/>
+          </a:xfrm>
+          <a:prstGeom prst="rect">
+            <a:avLst/>
+          </a:prstGeom>
+          <a:noFill/>
+        </p:spPr>
+        <p:txBody>
+          <a:bodyPr wrap="square" anchor="t">
+            <a:spAutoFit/>
+          </a:bodyPr>
+          <a:lstStyle/>
+          <a:p>
+            <a:pPr algn="l">
+              <a:defRPr sz="1300" b="1">
+                <a:solidFill>
+                  <a:srgbClr val="0D9488"/>
+                </a:solidFill>
+                <a:latin typeface="Avenir Next"/>
+              </a:defRPr>
+            </a:pPr>
+            <a:r>
+              <a:t>APPENDIX · HOW THE LAYERS STACK</a:t>
+            </a:r>
+          </a:p>
+        </p:txBody>
+      </p:sp>
+      <p:sp>
+        <p:nvSpPr>
+          <p:cNvPr id="4" name="TextBox 3"/>
+          <p:cNvSpPr txBox="1"/>
+          <p:nvPr/>
+        </p:nvSpPr>
+        <p:spPr>
+          <a:xfrm>
+            <a:off x="548640" y="566928"/>
+            <a:ext cx="11064240" cy="731520"/>
+          </a:xfrm>
+          <a:prstGeom prst="rect">
+            <a:avLst/>
+          </a:prstGeom>
+          <a:noFill/>
+        </p:spPr>
+        <p:txBody>
+          <a:bodyPr wrap="square" anchor="t">
+            <a:spAutoFit/>
+          </a:bodyPr>
+          <a:lstStyle/>
+          <a:p>
+            <a:pPr algn="l">
+              <a:defRPr sz="3000" b="1">
+                <a:solidFill>
+                  <a:srgbClr val="0F172A"/>
+                </a:solidFill>
+                <a:latin typeface="Avenir Next"/>
+              </a:defRPr>
+            </a:pPr>
+            <a:r>
+              <a:t>What each lane exposes</a:t>
+            </a:r>
+          </a:p>
+        </p:txBody>
+      </p:sp>
+      <p:sp>
+        <p:nvSpPr>
+          <p:cNvPr id="5" name="Rectangle 4"/>
+          <p:cNvSpPr/>
+          <p:nvPr/>
+        </p:nvSpPr>
+        <p:spPr>
+          <a:xfrm>
+            <a:off x="566928" y="1298448"/>
+            <a:ext cx="1463040" cy="41148"/>
+          </a:xfrm>
+          <a:prstGeom prst="rect">
+            <a:avLst/>
+          </a:prstGeom>
+          <a:solidFill>
+            <a:srgbClr val="0D9488"/>
+          </a:solidFill>
+          <a:ln>
+            <a:noFill/>
+          </a:ln>
+          <a:effectLst/>
+        </p:spPr>
+        <p:style>
+          <a:lnRef idx="1">
+            <a:schemeClr val="accent1"/>
+          </a:lnRef>
+          <a:fillRef idx="3">
+            <a:schemeClr val="accent1"/>
+          </a:fillRef>
+          <a:effectRef idx="2">
+            <a:schemeClr val="accent1"/>
+          </a:effectRef>
+          <a:fontRef idx="minor">
+            <a:schemeClr val="lt1"/>
+          </a:fontRef>
+        </p:style>
+        <p:txBody>
+          <a:bodyPr rtlCol="0" anchor="ctr"/>
+          <a:lstStyle/>
+          <a:p>
+            <a:pPr algn="ctr"/>
+          </a:p>
+        </p:txBody>
+      </p:sp>
+      <p:sp>
+        <p:nvSpPr>
+          <p:cNvPr id="6" name="TextBox 5"/>
+          <p:cNvSpPr txBox="1"/>
+          <p:nvPr/>
+        </p:nvSpPr>
+        <p:spPr>
+          <a:xfrm>
+            <a:off x="548640" y="1389888"/>
+            <a:ext cx="11064240" cy="274320"/>
+          </a:xfrm>
+          <a:prstGeom prst="rect">
+            <a:avLst/>
+          </a:prstGeom>
+          <a:noFill/>
+        </p:spPr>
+        <p:txBody>
+          <a:bodyPr wrap="square" anchor="t">
+            <a:spAutoFit/>
+          </a:bodyPr>
+          <a:lstStyle/>
+          <a:p>
+            <a:pPr algn="ctr">
+              <a:defRPr sz="1150" b="1">
+                <a:solidFill>
+                  <a:srgbClr val="64748B"/>
+                </a:solidFill>
+                <a:latin typeface="Avenir Next"/>
+              </a:defRPr>
+            </a:pPr>
+            <a:r>
+              <a:t>CHOOSE EXACTLY ONE LANE</a:t>
+            </a:r>
+          </a:p>
+        </p:txBody>
+      </p:sp>
+      <p:sp>
+        <p:nvSpPr>
+          <p:cNvPr id="7" name="Rounded Rectangle 6"/>
+          <p:cNvSpPr/>
+          <p:nvPr/>
+        </p:nvSpPr>
+        <p:spPr>
+          <a:xfrm>
+            <a:off x="548640" y="1719072"/>
+            <a:ext cx="3611880" cy="1325880"/>
+          </a:xfrm>
+          <a:prstGeom prst="roundRect">
+            <a:avLst/>
+          </a:prstGeom>
+          <a:solidFill>
+            <a:srgbClr val="D97706"/>
+          </a:solidFill>
+          <a:ln>
+            <a:noFill/>
+          </a:ln>
+          <a:effectLst/>
+        </p:spPr>
+        <p:style>
+          <a:lnRef idx="1">
+            <a:schemeClr val="accent1"/>
+          </a:lnRef>
+          <a:fillRef idx="3">
+            <a:schemeClr val="accent1"/>
+          </a:fillRef>
+          <a:effectRef idx="2">
+            <a:schemeClr val="accent1"/>
+          </a:effectRef>
+          <a:fontRef idx="minor">
+            <a:schemeClr val="lt1"/>
+          </a:fontRef>
+        </p:style>
+        <p:txBody>
+          <a:bodyPr rtlCol="0" anchor="ctr" wrap="square" lIns="109728" rIns="109728"/>
+          <a:lstStyle/>
+          <a:p>
+            <a:pPr algn="ctr">
+              <a:defRPr sz="1500" b="1">
+                <a:solidFill>
+                  <a:srgbClr val="FFFFFF"/>
+                </a:solidFill>
+                <a:latin typeface="Avenir Next"/>
+              </a:defRPr>
+            </a:pPr>
+            <a:r>
+              <a:t>Serial</a:t>
+            </a:r>
+          </a:p>
+          <a:p>
+            <a:pPr algn="ctr">
+              <a:defRPr sz="1100" b="0">
+                <a:solidFill>
+                  <a:srgbClr val="FFFFFF"/>
+                </a:solidFill>
+                <a:latin typeface="Avenir Next"/>
+              </a:defRPr>
+            </a:pPr>
+            <a:r>
+              <a:t>hdf5 · netcdf · fftw · boost</a:t>
+            </a:r>
+          </a:p>
+          <a:p>
+            <a:pPr algn="ctr">
+              <a:defRPr sz="1000" b="0">
+                <a:solidFill>
+                  <a:srgbClr val="FFFFFF"/>
+                </a:solidFill>
+                <a:latin typeface="Avenir Next"/>
+              </a:defRPr>
+            </a:pPr>
+            <a:r>
+              <a:t>the same packages, built without MPI</a:t>
+            </a:r>
+          </a:p>
+        </p:txBody>
+      </p:sp>
+      <p:sp>
+        <p:nvSpPr>
+          <p:cNvPr id="8" name="Rounded Rectangle 7"/>
+          <p:cNvSpPr/>
+          <p:nvPr/>
+        </p:nvSpPr>
+        <p:spPr>
+          <a:xfrm>
+            <a:off x="4370831" y="1719072"/>
+            <a:ext cx="3611880" cy="1325880"/>
+          </a:xfrm>
+          <a:prstGeom prst="roundRect">
+            <a:avLst/>
+          </a:prstGeom>
+          <a:solidFill>
+            <a:srgbClr val="2563EB"/>
+          </a:solidFill>
+          <a:ln>
+            <a:noFill/>
+          </a:ln>
+          <a:effectLst/>
+        </p:spPr>
+        <p:style>
+          <a:lnRef idx="1">
+            <a:schemeClr val="accent1"/>
+          </a:lnRef>
+          <a:fillRef idx="3">
+            <a:schemeClr val="accent1"/>
+          </a:fillRef>
+          <a:effectRef idx="2">
+            <a:schemeClr val="accent1"/>
+          </a:effectRef>
+          <a:fontRef idx="minor">
+            <a:schemeClr val="lt1"/>
+          </a:fontRef>
+        </p:style>
+        <p:txBody>
+          <a:bodyPr rtlCol="0" anchor="ctr" wrap="square" lIns="109728" rIns="109728"/>
+          <a:lstStyle/>
+          <a:p>
+            <a:pPr algn="ctr">
+              <a:defRPr sz="1500" b="1">
+                <a:solidFill>
+                  <a:srgbClr val="FFFFFF"/>
+                </a:solidFill>
+                <a:latin typeface="Avenir Next"/>
+              </a:defRPr>
+            </a:pPr>
+            <a:r>
+              <a:t>MPI</a:t>
+            </a:r>
+          </a:p>
+          <a:p>
+            <a:pPr algn="ctr">
+              <a:defRPr sz="1100" b="0">
+                <a:solidFill>
+                  <a:srgbClr val="FFFFFF"/>
+                </a:solidFill>
+                <a:latin typeface="Avenir Next"/>
+              </a:defRPr>
+            </a:pPr>
+            <a:r>
+              <a:t>hdf5 · netcdf · fftw · boost · tau · dakota</a:t>
+            </a:r>
+          </a:p>
+          <a:p>
+            <a:pPr algn="ctr">
+              <a:defRPr sz="1000" b="0">
+                <a:solidFill>
+                  <a:srgbClr val="FFFFFF"/>
+                </a:solidFill>
+                <a:latin typeface="Avenir Next"/>
+              </a:defRPr>
+            </a:pPr>
+            <a:r>
+              <a:t>built against the system MPI</a:t>
+            </a:r>
+          </a:p>
+        </p:txBody>
+      </p:sp>
+      <p:sp>
+        <p:nvSpPr>
+          <p:cNvPr id="9" name="Rounded Rectangle 8"/>
+          <p:cNvSpPr/>
+          <p:nvPr/>
+        </p:nvSpPr>
+        <p:spPr>
+          <a:xfrm>
+            <a:off x="8193023" y="1719072"/>
+            <a:ext cx="3611880" cy="1325880"/>
+          </a:xfrm>
+          <a:prstGeom prst="roundRect">
+            <a:avLst/>
+          </a:prstGeom>
+          <a:solidFill>
+            <a:srgbClr val="7C3AED"/>
+          </a:solidFill>
+          <a:ln>
+            <a:noFill/>
+          </a:ln>
+          <a:effectLst/>
+        </p:spPr>
+        <p:style>
+          <a:lnRef idx="1">
+            <a:schemeClr val="accent1"/>
+          </a:lnRef>
+          <a:fillRef idx="3">
+            <a:schemeClr val="accent1"/>
+          </a:fillRef>
+          <a:effectRef idx="2">
+            <a:schemeClr val="accent1"/>
+          </a:effectRef>
+          <a:fontRef idx="minor">
+            <a:schemeClr val="lt1"/>
+          </a:fontRef>
+        </p:style>
+        <p:txBody>
+          <a:bodyPr rtlCol="0" anchor="ctr" wrap="square" lIns="109728" rIns="109728"/>
+          <a:lstStyle/>
+          <a:p>
+            <a:pPr algn="ctr">
+              <a:defRPr sz="1500" b="1">
+                <a:solidFill>
+                  <a:srgbClr val="FFFFFF"/>
+                </a:solidFill>
+                <a:latin typeface="Avenir Next"/>
+              </a:defRPr>
+            </a:pPr>
+            <a:r>
+              <a:t>GPU</a:t>
+            </a:r>
+          </a:p>
+          <a:p>
+            <a:pPr algn="ctr">
+              <a:defRPr sz="1100" b="0">
+                <a:solidFill>
+                  <a:srgbClr val="FFFFFF"/>
+                </a:solidFill>
+                <a:latin typeface="Avenir Next"/>
+              </a:defRPr>
+            </a:pPr>
+            <a:r>
+              <a:t>the MPI roster, plus kokkos</a:t>
+            </a:r>
+          </a:p>
+          <a:p>
+            <a:pPr algn="ctr">
+              <a:defRPr sz="1000" b="0">
+                <a:solidFill>
+                  <a:srgbClr val="FFFFFF"/>
+                </a:solidFill>
+                <a:latin typeface="Avenir Next"/>
+              </a:defRPr>
+            </a:pPr>
+            <a:r>
+              <a:t>+rocm / +cuda, arch from the probe</a:t>
+            </a:r>
+          </a:p>
+        </p:txBody>
+      </p:sp>
+      <p:sp>
+        <p:nvSpPr>
+          <p:cNvPr id="10" name="Rounded Rectangle 9"/>
+          <p:cNvSpPr/>
+          <p:nvPr/>
+        </p:nvSpPr>
+        <p:spPr>
+          <a:xfrm>
+            <a:off x="548640" y="3200400"/>
+            <a:ext cx="11091672" cy="640080"/>
+          </a:xfrm>
+          <a:prstGeom prst="roundRect">
+            <a:avLst/>
+          </a:prstGeom>
+          <a:solidFill>
+            <a:srgbClr val="15803D"/>
+          </a:solidFill>
+          <a:ln>
+            <a:noFill/>
+          </a:ln>
+          <a:effectLst/>
+        </p:spPr>
+        <p:style>
+          <a:lnRef idx="1">
+            <a:schemeClr val="accent1"/>
+          </a:lnRef>
+          <a:fillRef idx="3">
+            <a:schemeClr val="accent1"/>
+          </a:fillRef>
+          <a:effectRef idx="2">
+            <a:schemeClr val="accent1"/>
+          </a:effectRef>
+          <a:fontRef idx="minor">
+            <a:schemeClr val="lt1"/>
+          </a:fontRef>
+        </p:style>
+        <p:txBody>
+          <a:bodyPr rtlCol="0" anchor="ctr" wrap="square" lIns="109728" rIns="109728"/>
+          <a:lstStyle/>
+          <a:p>
+            <a:pPr algn="ctr">
+              <a:defRPr sz="1250" b="1">
+                <a:solidFill>
+                  <a:srgbClr val="FFFFFF"/>
+                </a:solidFill>
+                <a:latin typeface="Avenir Next"/>
+              </a:defRPr>
+            </a:pPr>
+            <a:r>
+              <a:t>Common compiler-dependent packages: loadable from every lane</a:t>
+            </a:r>
+          </a:p>
+          <a:p>
+            <a:pPr algn="ctr">
+              <a:defRPr sz="1050" b="0">
+                <a:solidFill>
+                  <a:srgbClr val="FFFFFF"/>
+                </a:solidFill>
+                <a:latin typeface="Avenir Next"/>
+              </a:defRPr>
+            </a:pPr>
+            <a:r>
+              <a:t>openblas · netlib-lapack · gnuplot · one Serial-lane build, one install, shared module root</a:t>
+            </a:r>
+          </a:p>
+        </p:txBody>
+      </p:sp>
+      <p:sp>
+        <p:nvSpPr>
+          <p:cNvPr id="11" name="Rounded Rectangle 10"/>
+          <p:cNvSpPr/>
+          <p:nvPr/>
+        </p:nvSpPr>
+        <p:spPr>
+          <a:xfrm>
+            <a:off x="548640" y="3959352"/>
+            <a:ext cx="11091672" cy="640080"/>
+          </a:xfrm>
+          <a:prstGeom prst="roundRect">
+            <a:avLst/>
+          </a:prstGeom>
+          <a:solidFill>
+            <a:srgbClr val="0D9488"/>
+          </a:solidFill>
+          <a:ln>
+            <a:noFill/>
+          </a:ln>
+          <a:effectLst/>
+        </p:spPr>
+        <p:style>
+          <a:lnRef idx="1">
+            <a:schemeClr val="accent1"/>
+          </a:lnRef>
+          <a:fillRef idx="3">
+            <a:schemeClr val="accent1"/>
+          </a:fillRef>
+          <a:effectRef idx="2">
+            <a:schemeClr val="accent1"/>
+          </a:effectRef>
+          <a:fontRef idx="minor">
+            <a:schemeClr val="lt1"/>
+          </a:fontRef>
+        </p:style>
+        <p:txBody>
+          <a:bodyPr rtlCol="0" anchor="ctr" wrap="square" lIns="109728" rIns="109728"/>
+          <a:lstStyle/>
+          <a:p>
+            <a:pPr algn="ctr">
+              <a:defRPr sz="1250" b="1">
+                <a:solidFill>
+                  <a:srgbClr val="FFFFFF"/>
+                </a:solidFill>
+                <a:latin typeface="Avenir Next"/>
+              </a:defRPr>
+            </a:pPr>
+            <a:r>
+              <a:t>Core: loads with the compiler surface</a:t>
+            </a:r>
+          </a:p>
+          <a:p>
+            <a:pPr algn="ctr">
+              <a:defRPr sz="1050" b="0">
+                <a:solidFill>
+                  <a:srgbClr val="FFFFFF"/>
+                </a:solidFill>
+                <a:latin typeface="Avenir Next"/>
+              </a:defRPr>
+            </a:pPr>
+            <a:r>
+              <a:t>cmake · ninja · git · python · py-numpy · miniforge · gsl · sqlite</a:t>
+            </a:r>
+          </a:p>
+        </p:txBody>
+      </p:sp>
+      <p:sp>
+        <p:nvSpPr>
+          <p:cNvPr id="12" name="Rounded Rectangle 11"/>
+          <p:cNvSpPr/>
+          <p:nvPr/>
+        </p:nvSpPr>
+        <p:spPr>
+          <a:xfrm>
+            <a:off x="548640" y="4718304"/>
+            <a:ext cx="11091672" cy="640080"/>
+          </a:xfrm>
+          <a:prstGeom prst="roundRect">
+            <a:avLst/>
+          </a:prstGeom>
+          <a:solidFill>
+            <a:srgbClr val="475569"/>
+          </a:solidFill>
+          <a:ln>
+            <a:noFill/>
+          </a:ln>
+          <a:effectLst/>
+        </p:spPr>
+        <p:style>
+          <a:lnRef idx="1">
+            <a:schemeClr val="accent1"/>
+          </a:lnRef>
+          <a:fillRef idx="3">
+            <a:schemeClr val="accent1"/>
+          </a:fillRef>
+          <a:effectRef idx="2">
+            <a:schemeClr val="accent1"/>
+          </a:effectRef>
+          <a:fontRef idx="minor">
+            <a:schemeClr val="lt1"/>
+          </a:fontRef>
+        </p:style>
+        <p:txBody>
+          <a:bodyPr rtlCol="0" anchor="ctr" wrap="square" lIns="109728" rIns="109728"/>
+          <a:lstStyle/>
+          <a:p>
+            <a:pPr algn="ctr">
+              <a:defRPr sz="1250" b="1">
+                <a:solidFill>
+                  <a:srgbClr val="FFFFFF"/>
+                </a:solidFill>
+                <a:latin typeface="Avenir Next"/>
+              </a:defRPr>
+            </a:pPr>
+            <a:r>
+              <a:t>Foundation: on your paths automatically, nothing to load</a:t>
+            </a:r>
+          </a:p>
+          <a:p>
+            <a:pPr algn="ctr">
+              <a:defRPr sz="1050" b="0">
+                <a:solidFill>
+                  <a:srgbClr val="FFFFFF"/>
+                </a:solidFill>
+                <a:latin typeface="Avenir Next"/>
+              </a:defRPr>
+            </a:pPr>
+            <a:r>
+              <a:t>zlib · xz · zstd, single pinned version</a:t>
+            </a:r>
+          </a:p>
+        </p:txBody>
+      </p:sp>
+      <p:sp>
+        <p:nvSpPr>
+          <p:cNvPr id="13" name="Rounded Rectangle 12"/>
+          <p:cNvSpPr/>
+          <p:nvPr/>
+        </p:nvSpPr>
+        <p:spPr>
+          <a:xfrm>
+            <a:off x="548640" y="5504688"/>
+            <a:ext cx="11091672" cy="548640"/>
+          </a:xfrm>
+          <a:prstGeom prst="roundRect">
+            <a:avLst/>
+          </a:prstGeom>
+          <a:solidFill>
+            <a:srgbClr val="FFFFFF"/>
+          </a:solidFill>
+          <a:ln w="15875">
+            <a:solidFill>
+              <a:srgbClr val="E2E8F0"/>
+            </a:solidFill>
+          </a:ln>
+          <a:effectLst/>
+        </p:spPr>
+        <p:style>
+          <a:lnRef idx="1">
+            <a:schemeClr val="accent1"/>
+          </a:lnRef>
+          <a:fillRef idx="3">
+            <a:schemeClr val="accent1"/>
+          </a:fillRef>
+          <a:effectRef idx="2">
+            <a:schemeClr val="accent1"/>
+          </a:effectRef>
+          <a:fontRef idx="minor">
+            <a:schemeClr val="lt1"/>
+          </a:fontRef>
+        </p:style>
+        <p:txBody>
+          <a:bodyPr rtlCol="0" anchor="ctr" wrap="square" lIns="109728" rIns="109728"/>
+          <a:lstStyle/>
+          <a:p>
+            <a:pPr algn="ctr">
+              <a:defRPr sz="1300" b="1">
+                <a:solidFill>
+                  <a:srgbClr val="0F172A"/>
+                </a:solidFill>
+                <a:latin typeface="Avenir Next"/>
+              </a:defRPr>
+            </a:pPr>
+            <a:r>
+              <a:t>cse/&lt;Compiler&gt; surface: everything above sits on one compiler</a:t>
+            </a:r>
+          </a:p>
+          <a:p>
+            <a:pPr algn="ctr">
+              <a:defRPr sz="1050" b="0">
+                <a:solidFill>
+                  <a:srgbClr val="64748B"/>
+                </a:solidFill>
+                <a:latin typeface="Avenir Next"/>
+              </a:defRPr>
+            </a:pPr>
+            <a:r>
+              <a:t>lanes never mix compilers; loading a second lane fails loudly</a:t>
+            </a:r>
+          </a:p>
+        </p:txBody>
+      </p:sp>
+      <p:sp>
+        <p:nvSpPr>
+          <p:cNvPr id="14" name="TextBox 13"/>
+          <p:cNvSpPr txBox="1"/>
+          <p:nvPr/>
+        </p:nvSpPr>
+        <p:spPr>
+          <a:xfrm>
+            <a:off x="548640" y="6199632"/>
+            <a:ext cx="11064240" cy="457200"/>
+          </a:xfrm>
+          <a:prstGeom prst="rect">
+            <a:avLst/>
+          </a:prstGeom>
+          <a:noFill/>
+        </p:spPr>
+        <p:txBody>
+          <a:bodyPr wrap="square" anchor="t">
+            <a:spAutoFit/>
+          </a:bodyPr>
+          <a:lstStyle/>
+          <a:p>
+            <a:pPr algn="l">
+              <a:defRPr sz="1150" b="0">
+                <a:solidFill>
+                  <a:srgbClr val="64748B"/>
+                </a:solidFill>
+                <a:latin typeface="Avenir Next"/>
+              </a:defRPr>
+            </a:pPr>
+            <a:r>
+              <a:t>A user's view is one column: the surface, Foundation, Core, the common packages, and exactly one payload. The other payloads stay invisible until their lane is loaded.</a:t>
+            </a:r>
+          </a:p>
+        </p:txBody>
+      </p:sp>
+    </p:spTree>
+  </p:cSld>
+  <p:clrMapOvr>
+    <a:masterClrMapping/>
+  </p:clrMapOvr>
+</p:sld>
+</file>
+
+<file path=ppt/slides/slide11.xml><?xml version="1.0" encoding="utf-8"?>
 <p:sld xmlns:a="http://schemas.openxmlformats.org/drawingml/2006/main" xmlns:p="http://schemas.openxmlformats.org/presentationml/2006/main" xmlns:r="http://schemas.openxmlformats.org/officeDocument/2006/relationships">
   <p:cSld>
     <p:spTree>
@@ -4708,7 +5469,7 @@
 </p:sld>
 </file>
 
-<file path=ppt/slides/slide11.xml><?xml version="1.0" encoding="utf-8"?>
+<file path=ppt/slides/slide12.xml><?xml version="1.0" encoding="utf-8"?>
 <p:sld xmlns:a="http://schemas.openxmlformats.org/drawingml/2006/main" xmlns:p="http://schemas.openxmlformats.org/presentationml/2006/main" xmlns:r="http://schemas.openxmlformats.org/officeDocument/2006/relationships">
   <p:cSld>
     <p:spTree>
@@ -5815,7 +6576,7 @@
 </p:sld>
 </file>
 
-<file path=ppt/slides/slide12.xml><?xml version="1.0" encoding="utf-8"?>
+<file path=ppt/slides/slide13.xml><?xml version="1.0" encoding="utf-8"?>
 <p:sld xmlns:a="http://schemas.openxmlformats.org/drawingml/2006/main" xmlns:p="http://schemas.openxmlformats.org/presentationml/2006/main" xmlns:r="http://schemas.openxmlformats.org/officeDocument/2006/relationships">
   <p:cSld>
     <p:spTree>
@@ -12647,7 +13408,7 @@
               </a:defRPr>
             </a:pPr>
             <a:r>
-              <a:t>TWO COMPILER SURFACES · ONE CRAY SYSTEM FIRST</a:t>
+              <a:t>TWO COMPILER SURFACES · FOUR-SYSTEM VALIDATION</a:t>
             </a:r>
           </a:p>
         </p:txBody>
@@ -14425,7 +15186,7 @@
               </a:defRPr>
             </a:pPr>
             <a:r>
-              <a:t>WHERE THE PIPELINE IS TODAY</a:t>
+              <a:t>TEST MATRIX · BREADTH BY DESIGN</a:t>
             </a:r>
           </a:p>
         </p:txBody>
@@ -14461,7 +15222,7 @@
               </a:defRPr>
             </a:pPr>
             <a:r>
-              <a:t>Status and next steps</a:t>
+              <a:t>Four systems will prove the pilot</a:t>
             </a:r>
           </a:p>
         </p:txBody>
@@ -14518,8 +15279,8 @@
         </p:nvSpPr>
         <p:spPr>
           <a:xfrm>
-            <a:off x="548640" y="1645920"/>
-            <a:ext cx="5440680" cy="4480560"/>
+            <a:off x="548640" y="1627632"/>
+            <a:ext cx="5394960" cy="1783080"/>
           </a:xfrm>
           <a:prstGeom prst="roundRect">
             <a:avLst/>
@@ -14556,14 +15317,58 @@
       </p:sp>
       <p:sp>
         <p:nvSpPr>
-          <p:cNvPr id="7" name="TextBox 6"/>
+          <p:cNvPr id="7" name="Rectangle 6"/>
+          <p:cNvSpPr/>
+          <p:nvPr/>
+        </p:nvSpPr>
+        <p:spPr>
+          <a:xfrm>
+            <a:off x="548640" y="1627632"/>
+            <a:ext cx="109728" cy="1783080"/>
+          </a:xfrm>
+          <a:prstGeom prst="rect">
+            <a:avLst/>
+          </a:prstGeom>
+          <a:solidFill>
+            <a:srgbClr val="7C3AED"/>
+          </a:solidFill>
+          <a:ln>
+            <a:noFill/>
+          </a:ln>
+          <a:effectLst/>
+        </p:spPr>
+        <p:style>
+          <a:lnRef idx="1">
+            <a:schemeClr val="accent1"/>
+          </a:lnRef>
+          <a:fillRef idx="3">
+            <a:schemeClr val="accent1"/>
+          </a:fillRef>
+          <a:effectRef idx="2">
+            <a:schemeClr val="accent1"/>
+          </a:effectRef>
+          <a:fontRef idx="minor">
+            <a:schemeClr val="lt1"/>
+          </a:fontRef>
+        </p:style>
+        <p:txBody>
+          <a:bodyPr rtlCol="0" anchor="ctr"/>
+          <a:lstStyle/>
+          <a:p>
+            <a:pPr algn="ctr"/>
+          </a:p>
+        </p:txBody>
+      </p:sp>
+      <p:sp>
+        <p:nvSpPr>
+          <p:cNvPr id="8" name="TextBox 7"/>
           <p:cNvSpPr txBox="1"/>
           <p:nvPr/>
         </p:nvSpPr>
         <p:spPr>
           <a:xfrm>
-            <a:off x="822960" y="1828800"/>
-            <a:ext cx="4937760" cy="457200"/>
+            <a:off x="822959" y="1773936"/>
+            <a:ext cx="1920240" cy="365760"/>
           </a:xfrm>
           <a:prstGeom prst="rect">
             <a:avLst/>
@@ -14579,27 +15384,27 @@
             <a:pPr algn="l">
               <a:defRPr sz="1700" b="1">
                 <a:solidFill>
-                  <a:srgbClr val="15803D"/>
-                </a:solidFill>
-                <a:latin typeface="Avenir Next"/>
-              </a:defRPr>
-            </a:pPr>
-            <a:r>
-              <a:t>Done</a:t>
-            </a:r>
-          </a:p>
-        </p:txBody>
-      </p:sp>
-      <p:sp>
-        <p:nvSpPr>
-          <p:cNvPr id="8" name="TextBox 7"/>
+                  <a:srgbClr val="0F172A"/>
+                </a:solidFill>
+                <a:latin typeface="Avenir Next"/>
+              </a:defRPr>
+            </a:pPr>
+            <a:r>
+              <a:t>Blueback</a:t>
+            </a:r>
+          </a:p>
+        </p:txBody>
+      </p:sp>
+      <p:sp>
+        <p:nvSpPr>
+          <p:cNvPr id="9" name="TextBox 8"/>
           <p:cNvSpPr txBox="1"/>
           <p:nvPr/>
         </p:nvSpPr>
         <p:spPr>
           <a:xfrm>
-            <a:off x="822960" y="2377440"/>
-            <a:ext cx="365760" cy="457200"/>
+            <a:off x="2697480" y="1801368"/>
+            <a:ext cx="2971800" cy="320040"/>
           </a:xfrm>
           <a:prstGeom prst="rect">
             <a:avLst/>
@@ -14612,30 +15417,30 @@
           </a:bodyPr>
           <a:lstStyle/>
           <a:p>
-            <a:pPr algn="l">
-              <a:defRPr sz="1600" b="1">
-                <a:solidFill>
-                  <a:srgbClr val="15803D"/>
-                </a:solidFill>
-                <a:latin typeface="Avenir Next"/>
-              </a:defRPr>
-            </a:pPr>
-            <a:r>
-              <a:t>✓</a:t>
-            </a:r>
-          </a:p>
-        </p:txBody>
-      </p:sp>
-      <p:sp>
-        <p:nvSpPr>
-          <p:cNvPr id="9" name="TextBox 8"/>
+            <a:pPr algn="r">
+              <a:defRPr sz="1150" b="1">
+                <a:solidFill>
+                  <a:srgbClr val="7C3AED"/>
+                </a:solidFill>
+                <a:latin typeface="Avenir Next"/>
+              </a:defRPr>
+            </a:pPr>
+            <a:r>
+              <a:t>CRAY PE · AMD APU</a:t>
+            </a:r>
+          </a:p>
+        </p:txBody>
+      </p:sp>
+      <p:sp>
+        <p:nvSpPr>
+          <p:cNvPr id="10" name="TextBox 9"/>
           <p:cNvSpPr txBox="1"/>
           <p:nvPr/>
         </p:nvSpPr>
         <p:spPr>
           <a:xfrm>
-            <a:off x="1234440" y="2377440"/>
-            <a:ext cx="4526280" cy="1005840"/>
+            <a:off x="822959" y="2221992"/>
+            <a:ext cx="4846320" cy="292608"/>
           </a:xfrm>
           <a:prstGeom prst="rect">
             <a:avLst/>
@@ -14649,7 +15454,7 @@
           <a:lstStyle/>
           <a:p>
             <a:pPr algn="l">
-              <a:defRPr sz="1300" b="0">
+              <a:defRPr sz="1250" b="1">
                 <a:solidFill>
                   <a:srgbClr val="334155"/>
                 </a:solidFill>
@@ -14657,21 +15462,21 @@
               </a:defRPr>
             </a:pPr>
             <a:r>
-              <a:t>End-to-end Cray smoke: probe → render → concretize → build (PrgEnv-gnu · cray-mpich · ROCm)</a:t>
-            </a:r>
-          </a:p>
-        </p:txBody>
-      </p:sp>
-      <p:sp>
-        <p:nvSpPr>
-          <p:cNvPr id="10" name="TextBox 9"/>
+              <a:t>NAVY · HPE Cray EX4000</a:t>
+            </a:r>
+          </a:p>
+        </p:txBody>
+      </p:sp>
+      <p:sp>
+        <p:nvSpPr>
+          <p:cNvPr id="11" name="TextBox 10"/>
           <p:cNvSpPr txBox="1"/>
           <p:nvPr/>
         </p:nvSpPr>
         <p:spPr>
           <a:xfrm>
-            <a:off x="822960" y="3429000"/>
-            <a:ext cx="365760" cy="457200"/>
+            <a:off x="822959" y="2578608"/>
+            <a:ext cx="4846320" cy="274320"/>
           </a:xfrm>
           <a:prstGeom prst="rect">
             <a:avLst/>
@@ -14685,29 +15490,29 @@
           <a:lstStyle/>
           <a:p>
             <a:pPr algn="l">
-              <a:defRPr sz="1600" b="1">
-                <a:solidFill>
-                  <a:srgbClr val="15803D"/>
-                </a:solidFill>
-                <a:latin typeface="Avenir Next"/>
-              </a:defRPr>
-            </a:pPr>
-            <a:r>
-              <a:t>✓</a:t>
-            </a:r>
-          </a:p>
-        </p:txBody>
-      </p:sp>
-      <p:sp>
-        <p:nvSpPr>
-          <p:cNvPr id="11" name="TextBox 10"/>
+              <a:defRPr sz="1200" b="0">
+                <a:solidFill>
+                  <a:srgbClr val="64748B"/>
+                </a:solidFill>
+                <a:latin typeface="Avenir Next"/>
+              </a:defRPr>
+            </a:pPr>
+            <a:r>
+              <a:t>SLES · AMD Instinct MI300A APU · 96 cores</a:t>
+            </a:r>
+          </a:p>
+        </p:txBody>
+      </p:sp>
+      <p:sp>
+        <p:nvSpPr>
+          <p:cNvPr id="12" name="TextBox 11"/>
           <p:cNvSpPr txBox="1"/>
           <p:nvPr/>
         </p:nvSpPr>
         <p:spPr>
           <a:xfrm>
-            <a:off x="1234440" y="3429000"/>
-            <a:ext cx="4526280" cy="1005840"/>
+            <a:off x="822959" y="2907791"/>
+            <a:ext cx="4846320" cy="274320"/>
           </a:xfrm>
           <a:prstGeom prst="rect">
             <a:avLst/>
@@ -14721,101 +15526,29 @@
           <a:lstStyle/>
           <a:p>
             <a:pPr algn="l">
-              <a:defRPr sz="1300" b="0">
-                <a:solidFill>
-                  <a:srgbClr val="334155"/>
-                </a:solidFill>
-                <a:latin typeface="Avenir Next"/>
-              </a:defRPr>
-            </a:pPr>
-            <a:r>
-              <a:t>Second system validated the generic-Linux path and hardened the prober</a:t>
-            </a:r>
-          </a:p>
-        </p:txBody>
-      </p:sp>
-      <p:sp>
-        <p:nvSpPr>
-          <p:cNvPr id="12" name="TextBox 11"/>
-          <p:cNvSpPr txBox="1"/>
-          <p:nvPr/>
-        </p:nvSpPr>
-        <p:spPr>
-          <a:xfrm>
-            <a:off x="822960" y="4480560"/>
-            <a:ext cx="365760" cy="457200"/>
-          </a:xfrm>
-          <a:prstGeom prst="rect">
-            <a:avLst/>
-          </a:prstGeom>
-          <a:noFill/>
-        </p:spPr>
-        <p:txBody>
-          <a:bodyPr wrap="square" anchor="t">
-            <a:spAutoFit/>
-          </a:bodyPr>
-          <a:lstStyle/>
-          <a:p>
-            <a:pPr algn="l">
-              <a:defRPr sz="1600" b="1">
-                <a:solidFill>
-                  <a:srgbClr val="15803D"/>
-                </a:solidFill>
-                <a:latin typeface="Avenir Next"/>
-              </a:defRPr>
-            </a:pPr>
-            <a:r>
-              <a:t>✓</a:t>
-            </a:r>
-          </a:p>
-        </p:txBody>
-      </p:sp>
-      <p:sp>
-        <p:nvSpPr>
-          <p:cNvPr id="13" name="TextBox 12"/>
-          <p:cNvSpPr txBox="1"/>
-          <p:nvPr/>
-        </p:nvSpPr>
-        <p:spPr>
-          <a:xfrm>
-            <a:off x="1234440" y="4480560"/>
-            <a:ext cx="4526280" cy="1005840"/>
-          </a:xfrm>
-          <a:prstGeom prst="rect">
-            <a:avLst/>
-          </a:prstGeom>
-          <a:noFill/>
-        </p:spPr>
-        <p:txBody>
-          <a:bodyPr wrap="square" anchor="t">
-            <a:spAutoFit/>
-          </a:bodyPr>
-          <a:lstStyle/>
-          <a:p>
-            <a:pPr algn="l">
-              <a:defRPr sz="1300" b="0">
-                <a:solidFill>
-                  <a:srgbClr val="334155"/>
-                </a:solidFill>
-                <a:latin typeface="Avenir Next"/>
-              </a:defRPr>
-            </a:pPr>
-            <a:r>
-              <a:t>Science stack renders clean today: four lanes, two-version roster</a:t>
-            </a:r>
-          </a:p>
-        </p:txBody>
-      </p:sp>
-      <p:sp>
-        <p:nvSpPr>
-          <p:cNvPr id="14" name="Rounded Rectangle 13"/>
+              <a:defRPr sz="1200" b="0">
+                <a:solidFill>
+                  <a:srgbClr val="64748B"/>
+                </a:solidFill>
+                <a:latin typeface="Avenir Next"/>
+              </a:defRPr>
+            </a:pPr>
+            <a:r>
+              <a:t>AI/ML nodes: 4 × AMD MI300A (gfx942)</a:t>
+            </a:r>
+          </a:p>
+        </p:txBody>
+      </p:sp>
+      <p:sp>
+        <p:nvSpPr>
+          <p:cNvPr id="13" name="Rounded Rectangle 12"/>
           <p:cNvSpPr/>
           <p:nvPr/>
         </p:nvSpPr>
         <p:spPr>
           <a:xfrm>
-            <a:off x="6263640" y="1645920"/>
-            <a:ext cx="5349240" cy="4480560"/>
+            <a:off x="6263640" y="1627632"/>
+            <a:ext cx="5394960" cy="1783080"/>
           </a:xfrm>
           <a:prstGeom prst="roundRect">
             <a:avLst/>
@@ -14852,14 +15585,58 @@
       </p:sp>
       <p:sp>
         <p:nvSpPr>
+          <p:cNvPr id="14" name="Rectangle 13"/>
+          <p:cNvSpPr/>
+          <p:nvPr/>
+        </p:nvSpPr>
+        <p:spPr>
+          <a:xfrm>
+            <a:off x="6263640" y="1627632"/>
+            <a:ext cx="109728" cy="1783080"/>
+          </a:xfrm>
+          <a:prstGeom prst="rect">
+            <a:avLst/>
+          </a:prstGeom>
+          <a:solidFill>
+            <a:srgbClr val="2563EB"/>
+          </a:solidFill>
+          <a:ln>
+            <a:noFill/>
+          </a:ln>
+          <a:effectLst/>
+        </p:spPr>
+        <p:style>
+          <a:lnRef idx="1">
+            <a:schemeClr val="accent1"/>
+          </a:lnRef>
+          <a:fillRef idx="3">
+            <a:schemeClr val="accent1"/>
+          </a:fillRef>
+          <a:effectRef idx="2">
+            <a:schemeClr val="accent1"/>
+          </a:effectRef>
+          <a:fontRef idx="minor">
+            <a:schemeClr val="lt1"/>
+          </a:fontRef>
+        </p:style>
+        <p:txBody>
+          <a:bodyPr rtlCol="0" anchor="ctr"/>
+          <a:lstStyle/>
+          <a:p>
+            <a:pPr algn="ctr"/>
+          </a:p>
+        </p:txBody>
+      </p:sp>
+      <p:sp>
+        <p:nvSpPr>
           <p:cNvPr id="15" name="TextBox 14"/>
           <p:cNvSpPr txBox="1"/>
           <p:nvPr/>
         </p:nvSpPr>
         <p:spPr>
           <a:xfrm>
-            <a:off x="6537960" y="1828800"/>
-            <a:ext cx="4846320" cy="457200"/>
+            <a:off x="6537959" y="1773936"/>
+            <a:ext cx="1920240" cy="365760"/>
           </a:xfrm>
           <a:prstGeom prst="rect">
             <a:avLst/>
@@ -14875,13 +15652,13 @@
             <a:pPr algn="l">
               <a:defRPr sz="1700" b="1">
                 <a:solidFill>
-                  <a:srgbClr val="D97706"/>
-                </a:solidFill>
-                <a:latin typeface="Avenir Next"/>
-              </a:defRPr>
-            </a:pPr>
-            <a:r>
-              <a:t>Next</a:t>
+                  <a:srgbClr val="0F172A"/>
+                </a:solidFill>
+                <a:latin typeface="Avenir Next"/>
+              </a:defRPr>
+            </a:pPr>
+            <a:r>
+              <a:t>Fran</a:t>
             </a:r>
           </a:p>
         </p:txBody>
@@ -14894,8 +15671,8 @@
         </p:nvSpPr>
         <p:spPr>
           <a:xfrm>
-            <a:off x="6537960" y="2377440"/>
-            <a:ext cx="365760" cy="457200"/>
+            <a:off x="8412480" y="1801368"/>
+            <a:ext cx="2971800" cy="320040"/>
           </a:xfrm>
           <a:prstGeom prst="rect">
             <a:avLst/>
@@ -14908,16 +15685,16 @@
           </a:bodyPr>
           <a:lstStyle/>
           <a:p>
-            <a:pPr algn="l">
-              <a:defRPr sz="1600" b="1">
-                <a:solidFill>
-                  <a:srgbClr val="D97706"/>
-                </a:solidFill>
-                <a:latin typeface="Avenir Next"/>
-              </a:defRPr>
-            </a:pPr>
-            <a:r>
-              <a:t>→</a:t>
+            <a:pPr algn="r">
+              <a:defRPr sz="1150" b="1">
+                <a:solidFill>
+                  <a:srgbClr val="2563EB"/>
+                </a:solidFill>
+                <a:latin typeface="Avenir Next"/>
+              </a:defRPr>
+            </a:pPr>
+            <a:r>
+              <a:t>SECOND CRAY SITE · NEWEST NVIDIA</a:t>
             </a:r>
           </a:p>
         </p:txBody>
@@ -14930,8 +15707,8 @@
         </p:nvSpPr>
         <p:spPr>
           <a:xfrm>
-            <a:off x="6949440" y="2377440"/>
-            <a:ext cx="4434840" cy="1005840"/>
+            <a:off x="6537959" y="2221992"/>
+            <a:ext cx="4846320" cy="292608"/>
           </a:xfrm>
           <a:prstGeom prst="rect">
             <a:avLst/>
@@ -14945,7 +15722,7 @@
           <a:lstStyle/>
           <a:p>
             <a:pPr algn="l">
-              <a:defRPr sz="1300" b="0">
+              <a:defRPr sz="1250" b="1">
                 <a:solidFill>
                   <a:srgbClr val="334155"/>
                 </a:solidFill>
@@ -14953,7 +15730,7 @@
               </a:defRPr>
             </a:pPr>
             <a:r>
-              <a:t>Build the science lanes on the Cray and Linux systems; verify the module/view front door</a:t>
+              <a:t>ARL · HPE Cray EX4000</a:t>
             </a:r>
           </a:p>
         </p:txBody>
@@ -14966,8 +15743,8 @@
         </p:nvSpPr>
         <p:spPr>
           <a:xfrm>
-            <a:off x="6537960" y="3429000"/>
-            <a:ext cx="365760" cy="457200"/>
+            <a:off x="6537959" y="2578608"/>
+            <a:ext cx="4846320" cy="274320"/>
           </a:xfrm>
           <a:prstGeom prst="rect">
             <a:avLst/>
@@ -14981,15 +15758,15 @@
           <a:lstStyle/>
           <a:p>
             <a:pPr algn="l">
-              <a:defRPr sz="1600" b="1">
-                <a:solidFill>
-                  <a:srgbClr val="D97706"/>
-                </a:solidFill>
-                <a:latin typeface="Avenir Next"/>
-              </a:defRPr>
-            </a:pPr>
-            <a:r>
-              <a:t>→</a:t>
+              <a:defRPr sz="1200" b="0">
+                <a:solidFill>
+                  <a:srgbClr val="64748B"/>
+                </a:solidFill>
+                <a:latin typeface="Avenir Next"/>
+              </a:defRPr>
+            </a:pPr>
+            <a:r>
+              <a:t>RHEL 9 · AMD EPYC Genoa · Slingshot-11</a:t>
             </a:r>
           </a:p>
         </p:txBody>
@@ -15002,8 +15779,8 @@
         </p:nvSpPr>
         <p:spPr>
           <a:xfrm>
-            <a:off x="6949440" y="3429000"/>
-            <a:ext cx="4434840" cy="1005840"/>
+            <a:off x="6537959" y="2907791"/>
+            <a:ext cx="4846320" cy="274320"/>
           </a:xfrm>
           <a:prstGeom prst="rect">
             <a:avLst/>
@@ -15017,29 +15794,117 @@
           <a:lstStyle/>
           <a:p>
             <a:pPr algn="l">
-              <a:defRPr sz="1300" b="0">
-                <a:solidFill>
-                  <a:srgbClr val="334155"/>
-                </a:solidFill>
-                <a:latin typeface="Avenir Next"/>
-              </a:defRPr>
-            </a:pPr>
-            <a:r>
-              <a:t>Encode module compatibility checks for multi-version package chains</a:t>
-            </a:r>
-          </a:p>
-        </p:txBody>
-      </p:sp>
-      <p:sp>
-        <p:nvSpPr>
-          <p:cNvPr id="20" name="TextBox 19"/>
+              <a:defRPr sz="1200" b="0">
+                <a:solidFill>
+                  <a:srgbClr val="64748B"/>
+                </a:solidFill>
+                <a:latin typeface="Avenir Next"/>
+              </a:defRPr>
+            </a:pPr>
+            <a:r>
+              <a:t>AI/ML nodes: NVIDIA H200</a:t>
+            </a:r>
+          </a:p>
+        </p:txBody>
+      </p:sp>
+      <p:sp>
+        <p:nvSpPr>
+          <p:cNvPr id="20" name="Rounded Rectangle 19"/>
+          <p:cNvSpPr/>
+          <p:nvPr/>
+        </p:nvSpPr>
+        <p:spPr>
+          <a:xfrm>
+            <a:off x="548640" y="3685032"/>
+            <a:ext cx="5394960" cy="1783080"/>
+          </a:xfrm>
+          <a:prstGeom prst="roundRect">
+            <a:avLst/>
+          </a:prstGeom>
+          <a:solidFill>
+            <a:srgbClr val="F1F5F9"/>
+          </a:solidFill>
+          <a:ln>
+            <a:noFill/>
+          </a:ln>
+          <a:effectLst/>
+        </p:spPr>
+        <p:style>
+          <a:lnRef idx="1">
+            <a:schemeClr val="accent1"/>
+          </a:lnRef>
+          <a:fillRef idx="3">
+            <a:schemeClr val="accent1"/>
+          </a:fillRef>
+          <a:effectRef idx="2">
+            <a:schemeClr val="accent1"/>
+          </a:effectRef>
+          <a:fontRef idx="minor">
+            <a:schemeClr val="lt1"/>
+          </a:fontRef>
+        </p:style>
+        <p:txBody>
+          <a:bodyPr rtlCol="0" anchor="ctr"/>
+          <a:lstStyle/>
+          <a:p>
+            <a:pPr algn="ctr"/>
+          </a:p>
+        </p:txBody>
+      </p:sp>
+      <p:sp>
+        <p:nvSpPr>
+          <p:cNvPr id="21" name="Rectangle 20"/>
+          <p:cNvSpPr/>
+          <p:nvPr/>
+        </p:nvSpPr>
+        <p:spPr>
+          <a:xfrm>
+            <a:off x="548640" y="3685032"/>
+            <a:ext cx="109728" cy="1783080"/>
+          </a:xfrm>
+          <a:prstGeom prst="rect">
+            <a:avLst/>
+          </a:prstGeom>
+          <a:solidFill>
+            <a:srgbClr val="0D9488"/>
+          </a:solidFill>
+          <a:ln>
+            <a:noFill/>
+          </a:ln>
+          <a:effectLst/>
+        </p:spPr>
+        <p:style>
+          <a:lnRef idx="1">
+            <a:schemeClr val="accent1"/>
+          </a:lnRef>
+          <a:fillRef idx="3">
+            <a:schemeClr val="accent1"/>
+          </a:fillRef>
+          <a:effectRef idx="2">
+            <a:schemeClr val="accent1"/>
+          </a:effectRef>
+          <a:fontRef idx="minor">
+            <a:schemeClr val="lt1"/>
+          </a:fontRef>
+        </p:style>
+        <p:txBody>
+          <a:bodyPr rtlCol="0" anchor="ctr"/>
+          <a:lstStyle/>
+          <a:p>
+            <a:pPr algn="ctr"/>
+          </a:p>
+        </p:txBody>
+      </p:sp>
+      <p:sp>
+        <p:nvSpPr>
+          <p:cNvPr id="22" name="TextBox 21"/>
           <p:cNvSpPr txBox="1"/>
           <p:nvPr/>
         </p:nvSpPr>
         <p:spPr>
           <a:xfrm>
-            <a:off x="6537960" y="4480560"/>
-            <a:ext cx="365760" cy="457200"/>
+            <a:off x="822959" y="3831336"/>
+            <a:ext cx="1920240" cy="365760"/>
           </a:xfrm>
           <a:prstGeom prst="rect">
             <a:avLst/>
@@ -15053,29 +15918,29 @@
           <a:lstStyle/>
           <a:p>
             <a:pPr algn="l">
-              <a:defRPr sz="1600" b="1">
-                <a:solidFill>
-                  <a:srgbClr val="D97706"/>
-                </a:solidFill>
-                <a:latin typeface="Avenir Next"/>
-              </a:defRPr>
-            </a:pPr>
-            <a:r>
-              <a:t>→</a:t>
-            </a:r>
-          </a:p>
-        </p:txBody>
-      </p:sp>
-      <p:sp>
-        <p:nvSpPr>
-          <p:cNvPr id="21" name="TextBox 20"/>
+              <a:defRPr sz="1700" b="1">
+                <a:solidFill>
+                  <a:srgbClr val="0F172A"/>
+                </a:solidFill>
+                <a:latin typeface="Avenir Next"/>
+              </a:defRPr>
+            </a:pPr>
+            <a:r>
+              <a:t>Raider</a:t>
+            </a:r>
+          </a:p>
+        </p:txBody>
+      </p:sp>
+      <p:sp>
+        <p:nvSpPr>
+          <p:cNvPr id="23" name="TextBox 22"/>
           <p:cNvSpPr txBox="1"/>
           <p:nvPr/>
         </p:nvSpPr>
         <p:spPr>
           <a:xfrm>
-            <a:off x="6949440" y="4480560"/>
-            <a:ext cx="4434840" cy="1005840"/>
+            <a:off x="2697480" y="3858768"/>
+            <a:ext cx="2971800" cy="320040"/>
           </a:xfrm>
           <a:prstGeom prst="rect">
             <a:avLst/>
@@ -15088,8 +15953,44 @@
           </a:bodyPr>
           <a:lstStyle/>
           <a:p>
+            <a:pPr algn="r">
+              <a:defRPr sz="1150" b="1">
+                <a:solidFill>
+                  <a:srgbClr val="0D9488"/>
+                </a:solidFill>
+                <a:latin typeface="Avenir Next"/>
+              </a:defRPr>
+            </a:pPr>
+            <a:r>
+              <a:t>GENERIC LINUX · CUDA</a:t>
+            </a:r>
+          </a:p>
+        </p:txBody>
+      </p:sp>
+      <p:sp>
+        <p:nvSpPr>
+          <p:cNvPr id="24" name="TextBox 23"/>
+          <p:cNvSpPr txBox="1"/>
+          <p:nvPr/>
+        </p:nvSpPr>
+        <p:spPr>
+          <a:xfrm>
+            <a:off x="822959" y="4279392"/>
+            <a:ext cx="4846320" cy="292608"/>
+          </a:xfrm>
+          <a:prstGeom prst="rect">
+            <a:avLst/>
+          </a:prstGeom>
+          <a:noFill/>
+        </p:spPr>
+        <p:txBody>
+          <a:bodyPr wrap="square" anchor="t">
+            <a:spAutoFit/>
+          </a:bodyPr>
+          <a:lstStyle/>
+          <a:p>
             <a:pPr algn="l">
-              <a:defRPr sz="1300" b="0">
+              <a:defRPr sz="1250" b="1">
                 <a:solidFill>
                   <a:srgbClr val="334155"/>
                 </a:solidFill>
@@ -15097,7 +15998,437 @@
               </a:defRPr>
             </a:pPr>
             <a:r>
-              <a:t>Release process: build caches, lockfiles, release manifest</a:t>
+              <a:t>AFRL · Penguin TrueHPC</a:t>
+            </a:r>
+          </a:p>
+        </p:txBody>
+      </p:sp>
+      <p:sp>
+        <p:nvSpPr>
+          <p:cNvPr id="25" name="TextBox 24"/>
+          <p:cNvSpPr txBox="1"/>
+          <p:nvPr/>
+        </p:nvSpPr>
+        <p:spPr>
+          <a:xfrm>
+            <a:off x="822959" y="4636008"/>
+            <a:ext cx="4846320" cy="274320"/>
+          </a:xfrm>
+          <a:prstGeom prst="rect">
+            <a:avLst/>
+          </a:prstGeom>
+          <a:noFill/>
+        </p:spPr>
+        <p:txBody>
+          <a:bodyPr wrap="square" anchor="t">
+            <a:spAutoFit/>
+          </a:bodyPr>
+          <a:lstStyle/>
+          <a:p>
+            <a:pPr algn="l">
+              <a:defRPr sz="1200" b="0">
+                <a:solidFill>
+                  <a:srgbClr val="64748B"/>
+                </a:solidFill>
+                <a:latin typeface="Avenir Next"/>
+              </a:defRPr>
+            </a:pPr>
+            <a:r>
+              <a:t>RHEL 8 · AMD EPYC 7713 Milan · 128 cores</a:t>
+            </a:r>
+          </a:p>
+        </p:txBody>
+      </p:sp>
+      <p:sp>
+        <p:nvSpPr>
+          <p:cNvPr id="26" name="TextBox 25"/>
+          <p:cNvSpPr txBox="1"/>
+          <p:nvPr/>
+        </p:nvSpPr>
+        <p:spPr>
+          <a:xfrm>
+            <a:off x="822959" y="4965192"/>
+            <a:ext cx="4846320" cy="274320"/>
+          </a:xfrm>
+          <a:prstGeom prst="rect">
+            <a:avLst/>
+          </a:prstGeom>
+          <a:noFill/>
+        </p:spPr>
+        <p:txBody>
+          <a:bodyPr wrap="square" anchor="t">
+            <a:spAutoFit/>
+          </a:bodyPr>
+          <a:lstStyle/>
+          <a:p>
+            <a:pPr algn="l">
+              <a:defRPr sz="1200" b="0">
+                <a:solidFill>
+                  <a:srgbClr val="64748B"/>
+                </a:solidFill>
+                <a:latin typeface="Avenir Next"/>
+              </a:defRPr>
+            </a:pPr>
+            <a:r>
+              <a:t>MLA nodes: 4 × NVIDIA A100 SXM4</a:t>
+            </a:r>
+          </a:p>
+        </p:txBody>
+      </p:sp>
+      <p:sp>
+        <p:nvSpPr>
+          <p:cNvPr id="27" name="Rounded Rectangle 26"/>
+          <p:cNvSpPr/>
+          <p:nvPr/>
+        </p:nvSpPr>
+        <p:spPr>
+          <a:xfrm>
+            <a:off x="6263640" y="3685032"/>
+            <a:ext cx="5394960" cy="1783080"/>
+          </a:xfrm>
+          <a:prstGeom prst="roundRect">
+            <a:avLst/>
+          </a:prstGeom>
+          <a:solidFill>
+            <a:srgbClr val="F1F5F9"/>
+          </a:solidFill>
+          <a:ln>
+            <a:noFill/>
+          </a:ln>
+          <a:effectLst/>
+        </p:spPr>
+        <p:style>
+          <a:lnRef idx="1">
+            <a:schemeClr val="accent1"/>
+          </a:lnRef>
+          <a:fillRef idx="3">
+            <a:schemeClr val="accent1"/>
+          </a:fillRef>
+          <a:effectRef idx="2">
+            <a:schemeClr val="accent1"/>
+          </a:effectRef>
+          <a:fontRef idx="minor">
+            <a:schemeClr val="lt1"/>
+          </a:fontRef>
+        </p:style>
+        <p:txBody>
+          <a:bodyPr rtlCol="0" anchor="ctr"/>
+          <a:lstStyle/>
+          <a:p>
+            <a:pPr algn="ctr"/>
+          </a:p>
+        </p:txBody>
+      </p:sp>
+      <p:sp>
+        <p:nvSpPr>
+          <p:cNvPr id="28" name="Rectangle 27"/>
+          <p:cNvSpPr/>
+          <p:nvPr/>
+        </p:nvSpPr>
+        <p:spPr>
+          <a:xfrm>
+            <a:off x="6263640" y="3685032"/>
+            <a:ext cx="109728" cy="1783080"/>
+          </a:xfrm>
+          <a:prstGeom prst="rect">
+            <a:avLst/>
+          </a:prstGeom>
+          <a:solidFill>
+            <a:srgbClr val="D97706"/>
+          </a:solidFill>
+          <a:ln>
+            <a:noFill/>
+          </a:ln>
+          <a:effectLst/>
+        </p:spPr>
+        <p:style>
+          <a:lnRef idx="1">
+            <a:schemeClr val="accent1"/>
+          </a:lnRef>
+          <a:fillRef idx="3">
+            <a:schemeClr val="accent1"/>
+          </a:fillRef>
+          <a:effectRef idx="2">
+            <a:schemeClr val="accent1"/>
+          </a:effectRef>
+          <a:fontRef idx="minor">
+            <a:schemeClr val="lt1"/>
+          </a:fontRef>
+        </p:style>
+        <p:txBody>
+          <a:bodyPr rtlCol="0" anchor="ctr"/>
+          <a:lstStyle/>
+          <a:p>
+            <a:pPr algn="ctr"/>
+          </a:p>
+        </p:txBody>
+      </p:sp>
+      <p:sp>
+        <p:nvSpPr>
+          <p:cNvPr id="29" name="TextBox 28"/>
+          <p:cNvSpPr txBox="1"/>
+          <p:nvPr/>
+        </p:nvSpPr>
+        <p:spPr>
+          <a:xfrm>
+            <a:off x="6537959" y="3831336"/>
+            <a:ext cx="1920240" cy="365760"/>
+          </a:xfrm>
+          <a:prstGeom prst="rect">
+            <a:avLst/>
+          </a:prstGeom>
+          <a:noFill/>
+        </p:spPr>
+        <p:txBody>
+          <a:bodyPr wrap="square" anchor="t">
+            <a:spAutoFit/>
+          </a:bodyPr>
+          <a:lstStyle/>
+          <a:p>
+            <a:pPr algn="l">
+              <a:defRPr sz="1700" b="1">
+                <a:solidFill>
+                  <a:srgbClr val="0F172A"/>
+                </a:solidFill>
+                <a:latin typeface="Avenir Next"/>
+              </a:defRPr>
+            </a:pPr>
+            <a:r>
+              <a:t>Wheat</a:t>
+            </a:r>
+          </a:p>
+        </p:txBody>
+      </p:sp>
+      <p:sp>
+        <p:nvSpPr>
+          <p:cNvPr id="30" name="TextBox 29"/>
+          <p:cNvSpPr txBox="1"/>
+          <p:nvPr/>
+        </p:nvSpPr>
+        <p:spPr>
+          <a:xfrm>
+            <a:off x="8412480" y="3858768"/>
+            <a:ext cx="2971800" cy="320040"/>
+          </a:xfrm>
+          <a:prstGeom prst="rect">
+            <a:avLst/>
+          </a:prstGeom>
+          <a:noFill/>
+        </p:spPr>
+        <p:txBody>
+          <a:bodyPr wrap="square" anchor="t">
+            <a:spAutoFit/>
+          </a:bodyPr>
+          <a:lstStyle/>
+          <a:p>
+            <a:pPr algn="r">
+              <a:defRPr sz="1150" b="1">
+                <a:solidFill>
+                  <a:srgbClr val="D97706"/>
+                </a:solidFill>
+                <a:latin typeface="Avenir Next"/>
+              </a:defRPr>
+            </a:pPr>
+            <a:r>
+              <a:t>INTEL CPU · COMPOSABLE GPU</a:t>
+            </a:r>
+          </a:p>
+        </p:txBody>
+      </p:sp>
+      <p:sp>
+        <p:nvSpPr>
+          <p:cNvPr id="31" name="TextBox 30"/>
+          <p:cNvSpPr txBox="1"/>
+          <p:nvPr/>
+        </p:nvSpPr>
+        <p:spPr>
+          <a:xfrm>
+            <a:off x="6537959" y="4279392"/>
+            <a:ext cx="4846320" cy="292608"/>
+          </a:xfrm>
+          <a:prstGeom prst="rect">
+            <a:avLst/>
+          </a:prstGeom>
+          <a:noFill/>
+        </p:spPr>
+        <p:txBody>
+          <a:bodyPr wrap="square" anchor="t">
+            <a:spAutoFit/>
+          </a:bodyPr>
+          <a:lstStyle/>
+          <a:p>
+            <a:pPr algn="l">
+              <a:defRPr sz="1250" b="1">
+                <a:solidFill>
+                  <a:srgbClr val="334155"/>
+                </a:solidFill>
+                <a:latin typeface="Avenir Next"/>
+              </a:defRPr>
+            </a:pPr>
+            <a:r>
+              <a:t>ERDC · Liqid composable</a:t>
+            </a:r>
+          </a:p>
+        </p:txBody>
+      </p:sp>
+      <p:sp>
+        <p:nvSpPr>
+          <p:cNvPr id="32" name="TextBox 31"/>
+          <p:cNvSpPr txBox="1"/>
+          <p:nvPr/>
+        </p:nvSpPr>
+        <p:spPr>
+          <a:xfrm>
+            <a:off x="6537959" y="4636008"/>
+            <a:ext cx="4846320" cy="274320"/>
+          </a:xfrm>
+          <a:prstGeom prst="rect">
+            <a:avLst/>
+          </a:prstGeom>
+          <a:noFill/>
+        </p:spPr>
+        <p:txBody>
+          <a:bodyPr wrap="square" anchor="t">
+            <a:spAutoFit/>
+          </a:bodyPr>
+          <a:lstStyle/>
+          <a:p>
+            <a:pPr algn="l">
+              <a:defRPr sz="1200" b="0">
+                <a:solidFill>
+                  <a:srgbClr val="64748B"/>
+                </a:solidFill>
+                <a:latin typeface="Avenir Next"/>
+              </a:defRPr>
+            </a:pPr>
+            <a:r>
+              <a:t>RHEL 8 · Intel Xeon 9242 Cascade Lake · 92 cores</a:t>
+            </a:r>
+          </a:p>
+        </p:txBody>
+      </p:sp>
+      <p:sp>
+        <p:nvSpPr>
+          <p:cNvPr id="33" name="TextBox 32"/>
+          <p:cNvSpPr txBox="1"/>
+          <p:nvPr/>
+        </p:nvSpPr>
+        <p:spPr>
+          <a:xfrm>
+            <a:off x="6537959" y="4965192"/>
+            <a:ext cx="4846320" cy="274320"/>
+          </a:xfrm>
+          <a:prstGeom prst="rect">
+            <a:avLst/>
+          </a:prstGeom>
+          <a:noFill/>
+        </p:spPr>
+        <p:txBody>
+          <a:bodyPr wrap="square" anchor="t">
+            <a:spAutoFit/>
+          </a:bodyPr>
+          <a:lstStyle/>
+          <a:p>
+            <a:pPr algn="l">
+              <a:defRPr sz="1200" b="0">
+                <a:solidFill>
+                  <a:srgbClr val="64748B"/>
+                </a:solidFill>
+                <a:latin typeface="Avenir Next"/>
+              </a:defRPr>
+            </a:pPr>
+            <a:r>
+              <a:t>MLA nodes: 4 or 6 × NVIDIA A100</a:t>
+            </a:r>
+          </a:p>
+        </p:txBody>
+      </p:sp>
+      <p:sp>
+        <p:nvSpPr>
+          <p:cNvPr id="34" name="Rounded Rectangle 33"/>
+          <p:cNvSpPr/>
+          <p:nvPr/>
+        </p:nvSpPr>
+        <p:spPr>
+          <a:xfrm>
+            <a:off x="548640" y="5806440"/>
+            <a:ext cx="11091672" cy="530352"/>
+          </a:xfrm>
+          <a:prstGeom prst="roundRect">
+            <a:avLst/>
+          </a:prstGeom>
+          <a:solidFill>
+            <a:srgbClr val="E2E8F0"/>
+          </a:solidFill>
+          <a:ln>
+            <a:noFill/>
+          </a:ln>
+          <a:effectLst/>
+        </p:spPr>
+        <p:style>
+          <a:lnRef idx="1">
+            <a:schemeClr val="accent1"/>
+          </a:lnRef>
+          <a:fillRef idx="3">
+            <a:schemeClr val="accent1"/>
+          </a:fillRef>
+          <a:effectRef idx="2">
+            <a:schemeClr val="accent1"/>
+          </a:effectRef>
+          <a:fontRef idx="minor">
+            <a:schemeClr val="lt1"/>
+          </a:fontRef>
+        </p:style>
+        <p:txBody>
+          <a:bodyPr rtlCol="0" anchor="ctr" wrap="square" lIns="109728" rIns="109728"/>
+          <a:lstStyle/>
+          <a:p>
+            <a:pPr algn="ctr">
+              <a:defRPr sz="1300" b="1">
+                <a:solidFill>
+                  <a:srgbClr val="0F172A"/>
+                </a:solidFill>
+                <a:latin typeface="Avenir Next"/>
+              </a:defRPr>
+            </a:pPr>
+            <a:r>
+              <a:t>Coverage: SLES + RHEL 8 + RHEL 9 · AMD + Intel CPUs · AMD MI300A + NVIDIA H200 and A100</a:t>
+            </a:r>
+          </a:p>
+        </p:txBody>
+      </p:sp>
+      <p:sp>
+        <p:nvSpPr>
+          <p:cNvPr id="35" name="TextBox 34"/>
+          <p:cNvSpPr txBox="1"/>
+          <p:nvPr/>
+        </p:nvSpPr>
+        <p:spPr>
+          <a:xfrm>
+            <a:off x="548640" y="6419088"/>
+            <a:ext cx="11064240" cy="219456"/>
+          </a:xfrm>
+          <a:prstGeom prst="rect">
+            <a:avLst/>
+          </a:prstGeom>
+          <a:noFill/>
+        </p:spPr>
+        <p:txBody>
+          <a:bodyPr wrap="square" anchor="t">
+            <a:spAutoFit/>
+          </a:bodyPr>
+          <a:lstStyle/>
+          <a:p>
+            <a:pPr algn="r">
+              <a:defRPr sz="950" b="0">
+                <a:solidFill>
+                  <a:srgbClr val="64748B"/>
+                </a:solidFill>
+                <a:latin typeface="Avenir Next"/>
+              </a:defRPr>
+            </a:pPr>
+            <a:r>
+              <a:t>The accelerated (AI/ML, MLA) node types are the pilot target on each system. Source: centers.hpc.mil hardware inventory, July 2026; Fran accelerator detail from program info.</a:t>
             </a:r>
           </a:p>
         </p:txBody>
@@ -15195,7 +16526,7 @@
               </a:defRPr>
             </a:pPr>
             <a:r>
-              <a:t>APPENDIX · HOW THE LAYERS STACK</a:t>
+              <a:t>WHERE THE PIPELINE IS TODAY</a:t>
             </a:r>
           </a:p>
         </p:txBody>
@@ -15231,7 +16562,7 @@
               </a:defRPr>
             </a:pPr>
             <a:r>
-              <a:t>What each lane exposes</a:t>
+              <a:t>Status and next steps</a:t>
             </a:r>
           </a:p>
         </p:txBody>
@@ -15282,56 +16613,20 @@
       </p:sp>
       <p:sp>
         <p:nvSpPr>
-          <p:cNvPr id="6" name="TextBox 5"/>
-          <p:cNvSpPr txBox="1"/>
-          <p:nvPr/>
-        </p:nvSpPr>
-        <p:spPr>
-          <a:xfrm>
-            <a:off x="548640" y="1389888"/>
-            <a:ext cx="11064240" cy="274320"/>
-          </a:xfrm>
-          <a:prstGeom prst="rect">
-            <a:avLst/>
-          </a:prstGeom>
-          <a:noFill/>
-        </p:spPr>
-        <p:txBody>
-          <a:bodyPr wrap="square" anchor="t">
-            <a:spAutoFit/>
-          </a:bodyPr>
-          <a:lstStyle/>
-          <a:p>
-            <a:pPr algn="ctr">
-              <a:defRPr sz="1150" b="1">
-                <a:solidFill>
-                  <a:srgbClr val="64748B"/>
-                </a:solidFill>
-                <a:latin typeface="Avenir Next"/>
-              </a:defRPr>
-            </a:pPr>
-            <a:r>
-              <a:t>CHOOSE EXACTLY ONE LANE</a:t>
-            </a:r>
-          </a:p>
-        </p:txBody>
-      </p:sp>
-      <p:sp>
-        <p:nvSpPr>
-          <p:cNvPr id="7" name="Rounded Rectangle 6"/>
+          <p:cNvPr id="6" name="Rounded Rectangle 5"/>
           <p:cNvSpPr/>
           <p:nvPr/>
         </p:nvSpPr>
         <p:spPr>
           <a:xfrm>
-            <a:off x="548640" y="1719072"/>
-            <a:ext cx="3611880" cy="1325880"/>
+            <a:off x="548640" y="1645920"/>
+            <a:ext cx="5440680" cy="4480560"/>
           </a:xfrm>
           <a:prstGeom prst="roundRect">
             <a:avLst/>
           </a:prstGeom>
           <a:solidFill>
-            <a:srgbClr val="D97706"/>
+            <a:srgbClr val="F1F5F9"/>
           </a:solidFill>
           <a:ln>
             <a:noFill/>
@@ -15353,65 +16648,281 @@
           </a:fontRef>
         </p:style>
         <p:txBody>
-          <a:bodyPr rtlCol="0" anchor="ctr" wrap="square" lIns="109728" rIns="109728"/>
-          <a:lstStyle/>
-          <a:p>
-            <a:pPr algn="ctr">
-              <a:defRPr sz="1500" b="1">
-                <a:solidFill>
-                  <a:srgbClr val="FFFFFF"/>
-                </a:solidFill>
-                <a:latin typeface="Avenir Next"/>
-              </a:defRPr>
-            </a:pPr>
-            <a:r>
-              <a:t>Serial</a:t>
-            </a:r>
-          </a:p>
-          <a:p>
-            <a:pPr algn="ctr">
-              <a:defRPr sz="1100" b="0">
-                <a:solidFill>
-                  <a:srgbClr val="FFFFFF"/>
-                </a:solidFill>
-                <a:latin typeface="Avenir Next"/>
-              </a:defRPr>
-            </a:pPr>
-            <a:r>
-              <a:t>hdf5 · netcdf · fftw · boost</a:t>
-            </a:r>
-          </a:p>
-          <a:p>
-            <a:pPr algn="ctr">
-              <a:defRPr sz="1000" b="0">
-                <a:solidFill>
-                  <a:srgbClr val="FFFFFF"/>
-                </a:solidFill>
-                <a:latin typeface="Avenir Next"/>
-              </a:defRPr>
-            </a:pPr>
-            <a:r>
-              <a:t>the same packages, built without MPI</a:t>
-            </a:r>
-          </a:p>
-        </p:txBody>
-      </p:sp>
-      <p:sp>
-        <p:nvSpPr>
-          <p:cNvPr id="8" name="Rounded Rectangle 7"/>
+          <a:bodyPr rtlCol="0" anchor="ctr"/>
+          <a:lstStyle/>
+          <a:p>
+            <a:pPr algn="ctr"/>
+          </a:p>
+        </p:txBody>
+      </p:sp>
+      <p:sp>
+        <p:nvSpPr>
+          <p:cNvPr id="7" name="TextBox 6"/>
+          <p:cNvSpPr txBox="1"/>
+          <p:nvPr/>
+        </p:nvSpPr>
+        <p:spPr>
+          <a:xfrm>
+            <a:off x="822960" y="1828800"/>
+            <a:ext cx="4937760" cy="457200"/>
+          </a:xfrm>
+          <a:prstGeom prst="rect">
+            <a:avLst/>
+          </a:prstGeom>
+          <a:noFill/>
+        </p:spPr>
+        <p:txBody>
+          <a:bodyPr wrap="square" anchor="t">
+            <a:spAutoFit/>
+          </a:bodyPr>
+          <a:lstStyle/>
+          <a:p>
+            <a:pPr algn="l">
+              <a:defRPr sz="1700" b="1">
+                <a:solidFill>
+                  <a:srgbClr val="15803D"/>
+                </a:solidFill>
+                <a:latin typeface="Avenir Next"/>
+              </a:defRPr>
+            </a:pPr>
+            <a:r>
+              <a:t>Done</a:t>
+            </a:r>
+          </a:p>
+        </p:txBody>
+      </p:sp>
+      <p:sp>
+        <p:nvSpPr>
+          <p:cNvPr id="8" name="TextBox 7"/>
+          <p:cNvSpPr txBox="1"/>
+          <p:nvPr/>
+        </p:nvSpPr>
+        <p:spPr>
+          <a:xfrm>
+            <a:off x="822960" y="2377440"/>
+            <a:ext cx="365760" cy="457200"/>
+          </a:xfrm>
+          <a:prstGeom prst="rect">
+            <a:avLst/>
+          </a:prstGeom>
+          <a:noFill/>
+        </p:spPr>
+        <p:txBody>
+          <a:bodyPr wrap="square" anchor="t">
+            <a:spAutoFit/>
+          </a:bodyPr>
+          <a:lstStyle/>
+          <a:p>
+            <a:pPr algn="l">
+              <a:defRPr sz="1600" b="1">
+                <a:solidFill>
+                  <a:srgbClr val="15803D"/>
+                </a:solidFill>
+                <a:latin typeface="Avenir Next"/>
+              </a:defRPr>
+            </a:pPr>
+            <a:r>
+              <a:t>✓</a:t>
+            </a:r>
+          </a:p>
+        </p:txBody>
+      </p:sp>
+      <p:sp>
+        <p:nvSpPr>
+          <p:cNvPr id="9" name="TextBox 8"/>
+          <p:cNvSpPr txBox="1"/>
+          <p:nvPr/>
+        </p:nvSpPr>
+        <p:spPr>
+          <a:xfrm>
+            <a:off x="1234440" y="2377440"/>
+            <a:ext cx="4526280" cy="1005840"/>
+          </a:xfrm>
+          <a:prstGeom prst="rect">
+            <a:avLst/>
+          </a:prstGeom>
+          <a:noFill/>
+        </p:spPr>
+        <p:txBody>
+          <a:bodyPr wrap="square" anchor="t">
+            <a:spAutoFit/>
+          </a:bodyPr>
+          <a:lstStyle/>
+          <a:p>
+            <a:pPr algn="l">
+              <a:defRPr sz="1300" b="0">
+                <a:solidFill>
+                  <a:srgbClr val="334155"/>
+                </a:solidFill>
+                <a:latin typeface="Avenir Next"/>
+              </a:defRPr>
+            </a:pPr>
+            <a:r>
+              <a:t>End-to-end Cray smoke: probe → render → concretize → build (PrgEnv-gnu · cray-mpich · ROCm)</a:t>
+            </a:r>
+          </a:p>
+        </p:txBody>
+      </p:sp>
+      <p:sp>
+        <p:nvSpPr>
+          <p:cNvPr id="10" name="TextBox 9"/>
+          <p:cNvSpPr txBox="1"/>
+          <p:nvPr/>
+        </p:nvSpPr>
+        <p:spPr>
+          <a:xfrm>
+            <a:off x="822960" y="3429000"/>
+            <a:ext cx="365760" cy="457200"/>
+          </a:xfrm>
+          <a:prstGeom prst="rect">
+            <a:avLst/>
+          </a:prstGeom>
+          <a:noFill/>
+        </p:spPr>
+        <p:txBody>
+          <a:bodyPr wrap="square" anchor="t">
+            <a:spAutoFit/>
+          </a:bodyPr>
+          <a:lstStyle/>
+          <a:p>
+            <a:pPr algn="l">
+              <a:defRPr sz="1600" b="1">
+                <a:solidFill>
+                  <a:srgbClr val="15803D"/>
+                </a:solidFill>
+                <a:latin typeface="Avenir Next"/>
+              </a:defRPr>
+            </a:pPr>
+            <a:r>
+              <a:t>✓</a:t>
+            </a:r>
+          </a:p>
+        </p:txBody>
+      </p:sp>
+      <p:sp>
+        <p:nvSpPr>
+          <p:cNvPr id="11" name="TextBox 10"/>
+          <p:cNvSpPr txBox="1"/>
+          <p:nvPr/>
+        </p:nvSpPr>
+        <p:spPr>
+          <a:xfrm>
+            <a:off x="1234440" y="3429000"/>
+            <a:ext cx="4526280" cy="1005840"/>
+          </a:xfrm>
+          <a:prstGeom prst="rect">
+            <a:avLst/>
+          </a:prstGeom>
+          <a:noFill/>
+        </p:spPr>
+        <p:txBody>
+          <a:bodyPr wrap="square" anchor="t">
+            <a:spAutoFit/>
+          </a:bodyPr>
+          <a:lstStyle/>
+          <a:p>
+            <a:pPr algn="l">
+              <a:defRPr sz="1300" b="0">
+                <a:solidFill>
+                  <a:srgbClr val="334155"/>
+                </a:solidFill>
+                <a:latin typeface="Avenir Next"/>
+              </a:defRPr>
+            </a:pPr>
+            <a:r>
+              <a:t>Second system validated the generic-Linux path and hardened the prober</a:t>
+            </a:r>
+          </a:p>
+        </p:txBody>
+      </p:sp>
+      <p:sp>
+        <p:nvSpPr>
+          <p:cNvPr id="12" name="TextBox 11"/>
+          <p:cNvSpPr txBox="1"/>
+          <p:nvPr/>
+        </p:nvSpPr>
+        <p:spPr>
+          <a:xfrm>
+            <a:off x="822960" y="4480560"/>
+            <a:ext cx="365760" cy="457200"/>
+          </a:xfrm>
+          <a:prstGeom prst="rect">
+            <a:avLst/>
+          </a:prstGeom>
+          <a:noFill/>
+        </p:spPr>
+        <p:txBody>
+          <a:bodyPr wrap="square" anchor="t">
+            <a:spAutoFit/>
+          </a:bodyPr>
+          <a:lstStyle/>
+          <a:p>
+            <a:pPr algn="l">
+              <a:defRPr sz="1600" b="1">
+                <a:solidFill>
+                  <a:srgbClr val="15803D"/>
+                </a:solidFill>
+                <a:latin typeface="Avenir Next"/>
+              </a:defRPr>
+            </a:pPr>
+            <a:r>
+              <a:t>✓</a:t>
+            </a:r>
+          </a:p>
+        </p:txBody>
+      </p:sp>
+      <p:sp>
+        <p:nvSpPr>
+          <p:cNvPr id="13" name="TextBox 12"/>
+          <p:cNvSpPr txBox="1"/>
+          <p:nvPr/>
+        </p:nvSpPr>
+        <p:spPr>
+          <a:xfrm>
+            <a:off x="1234440" y="4480560"/>
+            <a:ext cx="4526280" cy="1005840"/>
+          </a:xfrm>
+          <a:prstGeom prst="rect">
+            <a:avLst/>
+          </a:prstGeom>
+          <a:noFill/>
+        </p:spPr>
+        <p:txBody>
+          <a:bodyPr wrap="square" anchor="t">
+            <a:spAutoFit/>
+          </a:bodyPr>
+          <a:lstStyle/>
+          <a:p>
+            <a:pPr algn="l">
+              <a:defRPr sz="1300" b="0">
+                <a:solidFill>
+                  <a:srgbClr val="334155"/>
+                </a:solidFill>
+                <a:latin typeface="Avenir Next"/>
+              </a:defRPr>
+            </a:pPr>
+            <a:r>
+              <a:t>Pilot stack renders clean today: four lanes, two-version roster</a:t>
+            </a:r>
+          </a:p>
+        </p:txBody>
+      </p:sp>
+      <p:sp>
+        <p:nvSpPr>
+          <p:cNvPr id="14" name="Rounded Rectangle 13"/>
           <p:cNvSpPr/>
           <p:nvPr/>
         </p:nvSpPr>
         <p:spPr>
           <a:xfrm>
-            <a:off x="4370831" y="1719072"/>
-            <a:ext cx="3611880" cy="1325880"/>
+            <a:off x="6263640" y="1645920"/>
+            <a:ext cx="5349240" cy="4480560"/>
           </a:xfrm>
           <a:prstGeom prst="roundRect">
             <a:avLst/>
           </a:prstGeom>
           <a:solidFill>
-            <a:srgbClr val="2563EB"/>
+            <a:srgbClr val="F1F5F9"/>
           </a:solidFill>
           <a:ln>
             <a:noFill/>
@@ -15433,409 +16944,23 @@
           </a:fontRef>
         </p:style>
         <p:txBody>
-          <a:bodyPr rtlCol="0" anchor="ctr" wrap="square" lIns="109728" rIns="109728"/>
-          <a:lstStyle/>
-          <a:p>
-            <a:pPr algn="ctr">
-              <a:defRPr sz="1500" b="1">
-                <a:solidFill>
-                  <a:srgbClr val="FFFFFF"/>
-                </a:solidFill>
-                <a:latin typeface="Avenir Next"/>
-              </a:defRPr>
-            </a:pPr>
-            <a:r>
-              <a:t>MPI</a:t>
-            </a:r>
-          </a:p>
-          <a:p>
-            <a:pPr algn="ctr">
-              <a:defRPr sz="1100" b="0">
-                <a:solidFill>
-                  <a:srgbClr val="FFFFFF"/>
-                </a:solidFill>
-                <a:latin typeface="Avenir Next"/>
-              </a:defRPr>
-            </a:pPr>
-            <a:r>
-              <a:t>hdf5 · netcdf · fftw · boost · tau · dakota</a:t>
-            </a:r>
-          </a:p>
-          <a:p>
-            <a:pPr algn="ctr">
-              <a:defRPr sz="1000" b="0">
-                <a:solidFill>
-                  <a:srgbClr val="FFFFFF"/>
-                </a:solidFill>
-                <a:latin typeface="Avenir Next"/>
-              </a:defRPr>
-            </a:pPr>
-            <a:r>
-              <a:t>built against the system MPI</a:t>
-            </a:r>
-          </a:p>
-        </p:txBody>
-      </p:sp>
-      <p:sp>
-        <p:nvSpPr>
-          <p:cNvPr id="9" name="Rounded Rectangle 8"/>
-          <p:cNvSpPr/>
-          <p:nvPr/>
-        </p:nvSpPr>
-        <p:spPr>
-          <a:xfrm>
-            <a:off x="8193023" y="1719072"/>
-            <a:ext cx="3611880" cy="1325880"/>
-          </a:xfrm>
-          <a:prstGeom prst="roundRect">
-            <a:avLst/>
-          </a:prstGeom>
-          <a:solidFill>
-            <a:srgbClr val="7C3AED"/>
-          </a:solidFill>
-          <a:ln>
-            <a:noFill/>
-          </a:ln>
-          <a:effectLst/>
-        </p:spPr>
-        <p:style>
-          <a:lnRef idx="1">
-            <a:schemeClr val="accent1"/>
-          </a:lnRef>
-          <a:fillRef idx="3">
-            <a:schemeClr val="accent1"/>
-          </a:fillRef>
-          <a:effectRef idx="2">
-            <a:schemeClr val="accent1"/>
-          </a:effectRef>
-          <a:fontRef idx="minor">
-            <a:schemeClr val="lt1"/>
-          </a:fontRef>
-        </p:style>
-        <p:txBody>
-          <a:bodyPr rtlCol="0" anchor="ctr" wrap="square" lIns="109728" rIns="109728"/>
-          <a:lstStyle/>
-          <a:p>
-            <a:pPr algn="ctr">
-              <a:defRPr sz="1500" b="1">
-                <a:solidFill>
-                  <a:srgbClr val="FFFFFF"/>
-                </a:solidFill>
-                <a:latin typeface="Avenir Next"/>
-              </a:defRPr>
-            </a:pPr>
-            <a:r>
-              <a:t>GPU</a:t>
-            </a:r>
-          </a:p>
-          <a:p>
-            <a:pPr algn="ctr">
-              <a:defRPr sz="1100" b="0">
-                <a:solidFill>
-                  <a:srgbClr val="FFFFFF"/>
-                </a:solidFill>
-                <a:latin typeface="Avenir Next"/>
-              </a:defRPr>
-            </a:pPr>
-            <a:r>
-              <a:t>the MPI roster, plus kokkos</a:t>
-            </a:r>
-          </a:p>
-          <a:p>
-            <a:pPr algn="ctr">
-              <a:defRPr sz="1000" b="0">
-                <a:solidFill>
-                  <a:srgbClr val="FFFFFF"/>
-                </a:solidFill>
-                <a:latin typeface="Avenir Next"/>
-              </a:defRPr>
-            </a:pPr>
-            <a:r>
-              <a:t>+rocm / +cuda, arch from the probe</a:t>
-            </a:r>
-          </a:p>
-        </p:txBody>
-      </p:sp>
-      <p:sp>
-        <p:nvSpPr>
-          <p:cNvPr id="10" name="Rounded Rectangle 9"/>
-          <p:cNvSpPr/>
-          <p:nvPr/>
-        </p:nvSpPr>
-        <p:spPr>
-          <a:xfrm>
-            <a:off x="548640" y="3200400"/>
-            <a:ext cx="11091672" cy="640080"/>
-          </a:xfrm>
-          <a:prstGeom prst="roundRect">
-            <a:avLst/>
-          </a:prstGeom>
-          <a:solidFill>
-            <a:srgbClr val="15803D"/>
-          </a:solidFill>
-          <a:ln>
-            <a:noFill/>
-          </a:ln>
-          <a:effectLst/>
-        </p:spPr>
-        <p:style>
-          <a:lnRef idx="1">
-            <a:schemeClr val="accent1"/>
-          </a:lnRef>
-          <a:fillRef idx="3">
-            <a:schemeClr val="accent1"/>
-          </a:fillRef>
-          <a:effectRef idx="2">
-            <a:schemeClr val="accent1"/>
-          </a:effectRef>
-          <a:fontRef idx="minor">
-            <a:schemeClr val="lt1"/>
-          </a:fontRef>
-        </p:style>
-        <p:txBody>
-          <a:bodyPr rtlCol="0" anchor="ctr" wrap="square" lIns="109728" rIns="109728"/>
-          <a:lstStyle/>
-          <a:p>
-            <a:pPr algn="ctr">
-              <a:defRPr sz="1250" b="1">
-                <a:solidFill>
-                  <a:srgbClr val="FFFFFF"/>
-                </a:solidFill>
-                <a:latin typeface="Avenir Next"/>
-              </a:defRPr>
-            </a:pPr>
-            <a:r>
-              <a:t>Common compiler-dependent packages: loadable from every lane</a:t>
-            </a:r>
-          </a:p>
-          <a:p>
-            <a:pPr algn="ctr">
-              <a:defRPr sz="1050" b="0">
-                <a:solidFill>
-                  <a:srgbClr val="FFFFFF"/>
-                </a:solidFill>
-                <a:latin typeface="Avenir Next"/>
-              </a:defRPr>
-            </a:pPr>
-            <a:r>
-              <a:t>openblas · netlib-lapack · gnuplot · one Serial-lane build, one install, shared module root</a:t>
-            </a:r>
-          </a:p>
-        </p:txBody>
-      </p:sp>
-      <p:sp>
-        <p:nvSpPr>
-          <p:cNvPr id="11" name="Rounded Rectangle 10"/>
-          <p:cNvSpPr/>
-          <p:nvPr/>
-        </p:nvSpPr>
-        <p:spPr>
-          <a:xfrm>
-            <a:off x="548640" y="3959352"/>
-            <a:ext cx="11091672" cy="640080"/>
-          </a:xfrm>
-          <a:prstGeom prst="roundRect">
-            <a:avLst/>
-          </a:prstGeom>
-          <a:solidFill>
-            <a:srgbClr val="0D9488"/>
-          </a:solidFill>
-          <a:ln>
-            <a:noFill/>
-          </a:ln>
-          <a:effectLst/>
-        </p:spPr>
-        <p:style>
-          <a:lnRef idx="1">
-            <a:schemeClr val="accent1"/>
-          </a:lnRef>
-          <a:fillRef idx="3">
-            <a:schemeClr val="accent1"/>
-          </a:fillRef>
-          <a:effectRef idx="2">
-            <a:schemeClr val="accent1"/>
-          </a:effectRef>
-          <a:fontRef idx="minor">
-            <a:schemeClr val="lt1"/>
-          </a:fontRef>
-        </p:style>
-        <p:txBody>
-          <a:bodyPr rtlCol="0" anchor="ctr" wrap="square" lIns="109728" rIns="109728"/>
-          <a:lstStyle/>
-          <a:p>
-            <a:pPr algn="ctr">
-              <a:defRPr sz="1250" b="1">
-                <a:solidFill>
-                  <a:srgbClr val="FFFFFF"/>
-                </a:solidFill>
-                <a:latin typeface="Avenir Next"/>
-              </a:defRPr>
-            </a:pPr>
-            <a:r>
-              <a:t>Core: loads with the compiler surface</a:t>
-            </a:r>
-          </a:p>
-          <a:p>
-            <a:pPr algn="ctr">
-              <a:defRPr sz="1050" b="0">
-                <a:solidFill>
-                  <a:srgbClr val="FFFFFF"/>
-                </a:solidFill>
-                <a:latin typeface="Avenir Next"/>
-              </a:defRPr>
-            </a:pPr>
-            <a:r>
-              <a:t>cmake · ninja · git · python · py-numpy · miniforge · gsl · sqlite</a:t>
-            </a:r>
-          </a:p>
-        </p:txBody>
-      </p:sp>
-      <p:sp>
-        <p:nvSpPr>
-          <p:cNvPr id="12" name="Rounded Rectangle 11"/>
-          <p:cNvSpPr/>
-          <p:nvPr/>
-        </p:nvSpPr>
-        <p:spPr>
-          <a:xfrm>
-            <a:off x="548640" y="4718304"/>
-            <a:ext cx="11091672" cy="640080"/>
-          </a:xfrm>
-          <a:prstGeom prst="roundRect">
-            <a:avLst/>
-          </a:prstGeom>
-          <a:solidFill>
-            <a:srgbClr val="475569"/>
-          </a:solidFill>
-          <a:ln>
-            <a:noFill/>
-          </a:ln>
-          <a:effectLst/>
-        </p:spPr>
-        <p:style>
-          <a:lnRef idx="1">
-            <a:schemeClr val="accent1"/>
-          </a:lnRef>
-          <a:fillRef idx="3">
-            <a:schemeClr val="accent1"/>
-          </a:fillRef>
-          <a:effectRef idx="2">
-            <a:schemeClr val="accent1"/>
-          </a:effectRef>
-          <a:fontRef idx="minor">
-            <a:schemeClr val="lt1"/>
-          </a:fontRef>
-        </p:style>
-        <p:txBody>
-          <a:bodyPr rtlCol="0" anchor="ctr" wrap="square" lIns="109728" rIns="109728"/>
-          <a:lstStyle/>
-          <a:p>
-            <a:pPr algn="ctr">
-              <a:defRPr sz="1250" b="1">
-                <a:solidFill>
-                  <a:srgbClr val="FFFFFF"/>
-                </a:solidFill>
-                <a:latin typeface="Avenir Next"/>
-              </a:defRPr>
-            </a:pPr>
-            <a:r>
-              <a:t>Foundation: on your paths automatically, nothing to load</a:t>
-            </a:r>
-          </a:p>
-          <a:p>
-            <a:pPr algn="ctr">
-              <a:defRPr sz="1050" b="0">
-                <a:solidFill>
-                  <a:srgbClr val="FFFFFF"/>
-                </a:solidFill>
-                <a:latin typeface="Avenir Next"/>
-              </a:defRPr>
-            </a:pPr>
-            <a:r>
-              <a:t>zlib · xz · zstd, single pinned version</a:t>
-            </a:r>
-          </a:p>
-        </p:txBody>
-      </p:sp>
-      <p:sp>
-        <p:nvSpPr>
-          <p:cNvPr id="13" name="Rounded Rectangle 12"/>
-          <p:cNvSpPr/>
-          <p:nvPr/>
-        </p:nvSpPr>
-        <p:spPr>
-          <a:xfrm>
-            <a:off x="548640" y="5504688"/>
-            <a:ext cx="11091672" cy="548640"/>
-          </a:xfrm>
-          <a:prstGeom prst="roundRect">
-            <a:avLst/>
-          </a:prstGeom>
-          <a:solidFill>
-            <a:srgbClr val="FFFFFF"/>
-          </a:solidFill>
-          <a:ln w="15875">
-            <a:solidFill>
-              <a:srgbClr val="E2E8F0"/>
-            </a:solidFill>
-          </a:ln>
-          <a:effectLst/>
-        </p:spPr>
-        <p:style>
-          <a:lnRef idx="1">
-            <a:schemeClr val="accent1"/>
-          </a:lnRef>
-          <a:fillRef idx="3">
-            <a:schemeClr val="accent1"/>
-          </a:fillRef>
-          <a:effectRef idx="2">
-            <a:schemeClr val="accent1"/>
-          </a:effectRef>
-          <a:fontRef idx="minor">
-            <a:schemeClr val="lt1"/>
-          </a:fontRef>
-        </p:style>
-        <p:txBody>
-          <a:bodyPr rtlCol="0" anchor="ctr" wrap="square" lIns="109728" rIns="109728"/>
-          <a:lstStyle/>
-          <a:p>
-            <a:pPr algn="ctr">
-              <a:defRPr sz="1300" b="1">
-                <a:solidFill>
-                  <a:srgbClr val="0F172A"/>
-                </a:solidFill>
-                <a:latin typeface="Avenir Next"/>
-              </a:defRPr>
-            </a:pPr>
-            <a:r>
-              <a:t>cse/&lt;Compiler&gt; surface: everything above sits on one compiler</a:t>
-            </a:r>
-          </a:p>
-          <a:p>
-            <a:pPr algn="ctr">
-              <a:defRPr sz="1050" b="0">
-                <a:solidFill>
-                  <a:srgbClr val="64748B"/>
-                </a:solidFill>
-                <a:latin typeface="Avenir Next"/>
-              </a:defRPr>
-            </a:pPr>
-            <a:r>
-              <a:t>lanes never mix compilers; loading a second lane fails loudly</a:t>
-            </a:r>
-          </a:p>
-        </p:txBody>
-      </p:sp>
-      <p:sp>
-        <p:nvSpPr>
-          <p:cNvPr id="14" name="TextBox 13"/>
+          <a:bodyPr rtlCol="0" anchor="ctr"/>
+          <a:lstStyle/>
+          <a:p>
+            <a:pPr algn="ctr"/>
+          </a:p>
+        </p:txBody>
+      </p:sp>
+      <p:sp>
+        <p:nvSpPr>
+          <p:cNvPr id="15" name="TextBox 14"/>
           <p:cNvSpPr txBox="1"/>
           <p:nvPr/>
         </p:nvSpPr>
         <p:spPr>
           <a:xfrm>
-            <a:off x="548640" y="6199632"/>
-            <a:ext cx="11064240" cy="457200"/>
+            <a:off x="6537960" y="1828800"/>
+            <a:ext cx="4846320" cy="457200"/>
           </a:xfrm>
           <a:prstGeom prst="rect">
             <a:avLst/>
@@ -15849,15 +16974,231 @@
           <a:lstStyle/>
           <a:p>
             <a:pPr algn="l">
-              <a:defRPr sz="1150" b="0">
-                <a:solidFill>
-                  <a:srgbClr val="64748B"/>
-                </a:solidFill>
-                <a:latin typeface="Avenir Next"/>
-              </a:defRPr>
-            </a:pPr>
-            <a:r>
-              <a:t>A user's view is one column: the surface, Foundation, Core, the common packages, and exactly one payload. The other payloads stay invisible until their lane is loaded.</a:t>
+              <a:defRPr sz="1700" b="1">
+                <a:solidFill>
+                  <a:srgbClr val="D97706"/>
+                </a:solidFill>
+                <a:latin typeface="Avenir Next"/>
+              </a:defRPr>
+            </a:pPr>
+            <a:r>
+              <a:t>Next</a:t>
+            </a:r>
+          </a:p>
+        </p:txBody>
+      </p:sp>
+      <p:sp>
+        <p:nvSpPr>
+          <p:cNvPr id="16" name="TextBox 15"/>
+          <p:cNvSpPr txBox="1"/>
+          <p:nvPr/>
+        </p:nvSpPr>
+        <p:spPr>
+          <a:xfrm>
+            <a:off x="6537960" y="2377440"/>
+            <a:ext cx="365760" cy="457200"/>
+          </a:xfrm>
+          <a:prstGeom prst="rect">
+            <a:avLst/>
+          </a:prstGeom>
+          <a:noFill/>
+        </p:spPr>
+        <p:txBody>
+          <a:bodyPr wrap="square" anchor="t">
+            <a:spAutoFit/>
+          </a:bodyPr>
+          <a:lstStyle/>
+          <a:p>
+            <a:pPr algn="l">
+              <a:defRPr sz="1600" b="1">
+                <a:solidFill>
+                  <a:srgbClr val="D97706"/>
+                </a:solidFill>
+                <a:latin typeface="Avenir Next"/>
+              </a:defRPr>
+            </a:pPr>
+            <a:r>
+              <a:t>→</a:t>
+            </a:r>
+          </a:p>
+        </p:txBody>
+      </p:sp>
+      <p:sp>
+        <p:nvSpPr>
+          <p:cNvPr id="17" name="TextBox 16"/>
+          <p:cNvSpPr txBox="1"/>
+          <p:nvPr/>
+        </p:nvSpPr>
+        <p:spPr>
+          <a:xfrm>
+            <a:off x="6949440" y="2377440"/>
+            <a:ext cx="4434840" cy="1005840"/>
+          </a:xfrm>
+          <a:prstGeom prst="rect">
+            <a:avLst/>
+          </a:prstGeom>
+          <a:noFill/>
+        </p:spPr>
+        <p:txBody>
+          <a:bodyPr wrap="square" anchor="t">
+            <a:spAutoFit/>
+          </a:bodyPr>
+          <a:lstStyle/>
+          <a:p>
+            <a:pPr algn="l">
+              <a:defRPr sz="1300" b="0">
+                <a:solidFill>
+                  <a:srgbClr val="334155"/>
+                </a:solidFill>
+                <a:latin typeface="Avenir Next"/>
+              </a:defRPr>
+            </a:pPr>
+            <a:r>
+              <a:t>Build the pilot stack on Fran, Wheat, Raider, and Blueback; verify the module/view front door</a:t>
+            </a:r>
+          </a:p>
+        </p:txBody>
+      </p:sp>
+      <p:sp>
+        <p:nvSpPr>
+          <p:cNvPr id="18" name="TextBox 17"/>
+          <p:cNvSpPr txBox="1"/>
+          <p:nvPr/>
+        </p:nvSpPr>
+        <p:spPr>
+          <a:xfrm>
+            <a:off x="6537960" y="3429000"/>
+            <a:ext cx="365760" cy="457200"/>
+          </a:xfrm>
+          <a:prstGeom prst="rect">
+            <a:avLst/>
+          </a:prstGeom>
+          <a:noFill/>
+        </p:spPr>
+        <p:txBody>
+          <a:bodyPr wrap="square" anchor="t">
+            <a:spAutoFit/>
+          </a:bodyPr>
+          <a:lstStyle/>
+          <a:p>
+            <a:pPr algn="l">
+              <a:defRPr sz="1600" b="1">
+                <a:solidFill>
+                  <a:srgbClr val="D97706"/>
+                </a:solidFill>
+                <a:latin typeface="Avenir Next"/>
+              </a:defRPr>
+            </a:pPr>
+            <a:r>
+              <a:t>→</a:t>
+            </a:r>
+          </a:p>
+        </p:txBody>
+      </p:sp>
+      <p:sp>
+        <p:nvSpPr>
+          <p:cNvPr id="19" name="TextBox 18"/>
+          <p:cNvSpPr txBox="1"/>
+          <p:nvPr/>
+        </p:nvSpPr>
+        <p:spPr>
+          <a:xfrm>
+            <a:off x="6949440" y="3429000"/>
+            <a:ext cx="4434840" cy="1005840"/>
+          </a:xfrm>
+          <a:prstGeom prst="rect">
+            <a:avLst/>
+          </a:prstGeom>
+          <a:noFill/>
+        </p:spPr>
+        <p:txBody>
+          <a:bodyPr wrap="square" anchor="t">
+            <a:spAutoFit/>
+          </a:bodyPr>
+          <a:lstStyle/>
+          <a:p>
+            <a:pPr algn="l">
+              <a:defRPr sz="1300" b="0">
+                <a:solidFill>
+                  <a:srgbClr val="334155"/>
+                </a:solidFill>
+                <a:latin typeface="Avenir Next"/>
+              </a:defRPr>
+            </a:pPr>
+            <a:r>
+              <a:t>Encode module compatibility checks for multi-version package chains</a:t>
+            </a:r>
+          </a:p>
+        </p:txBody>
+      </p:sp>
+      <p:sp>
+        <p:nvSpPr>
+          <p:cNvPr id="20" name="TextBox 19"/>
+          <p:cNvSpPr txBox="1"/>
+          <p:nvPr/>
+        </p:nvSpPr>
+        <p:spPr>
+          <a:xfrm>
+            <a:off x="6537960" y="4480560"/>
+            <a:ext cx="365760" cy="457200"/>
+          </a:xfrm>
+          <a:prstGeom prst="rect">
+            <a:avLst/>
+          </a:prstGeom>
+          <a:noFill/>
+        </p:spPr>
+        <p:txBody>
+          <a:bodyPr wrap="square" anchor="t">
+            <a:spAutoFit/>
+          </a:bodyPr>
+          <a:lstStyle/>
+          <a:p>
+            <a:pPr algn="l">
+              <a:defRPr sz="1600" b="1">
+                <a:solidFill>
+                  <a:srgbClr val="D97706"/>
+                </a:solidFill>
+                <a:latin typeface="Avenir Next"/>
+              </a:defRPr>
+            </a:pPr>
+            <a:r>
+              <a:t>→</a:t>
+            </a:r>
+          </a:p>
+        </p:txBody>
+      </p:sp>
+      <p:sp>
+        <p:nvSpPr>
+          <p:cNvPr id="21" name="TextBox 20"/>
+          <p:cNvSpPr txBox="1"/>
+          <p:nvPr/>
+        </p:nvSpPr>
+        <p:spPr>
+          <a:xfrm>
+            <a:off x="6949440" y="4480560"/>
+            <a:ext cx="4434840" cy="1005840"/>
+          </a:xfrm>
+          <a:prstGeom prst="rect">
+            <a:avLst/>
+          </a:prstGeom>
+          <a:noFill/>
+        </p:spPr>
+        <p:txBody>
+          <a:bodyPr wrap="square" anchor="t">
+            <a:spAutoFit/>
+          </a:bodyPr>
+          <a:lstStyle/>
+          <a:p>
+            <a:pPr algn="l">
+              <a:defRPr sz="1300" b="0">
+                <a:solidFill>
+                  <a:srgbClr val="334155"/>
+                </a:solidFill>
+                <a:latin typeface="Avenir Next"/>
+              </a:defRPr>
+            </a:pPr>
+            <a:r>
+              <a:t>Release process: build caches, lockfiles, release manifest</a:t>
             </a:r>
           </a:p>
         </p:txBody>

</xml_diff>

<commit_message>
Pilot systems slide: one shape per card, one label for accelerated nodes
Every card now reads the same way: site, vendor, and OS on one line,
then the standard compute node, then the accelerated node. Drops the
Slingshot-11 mention (no fabric shown for the other three) and the
gfx942 arch code (no equivalent shown for the NVIDIA parts). Uses AI/ML
throughout instead of mixing AI/ML and MLA; the footer records that
Raider and Wheat name that node type MLA. Fran's standard-node core
count is marked TBD rather than inferred from the other EX4000s.
</commit_message>
<xml_diff>
--- a/presentations/cse_lanes_model.pptx
+++ b/presentations/cse_lanes_model.pptx
@@ -15462,7 +15462,7 @@
               </a:defRPr>
             </a:pPr>
             <a:r>
-              <a:t>NAVY · HPE Cray EX4000</a:t>
+              <a:t>NAVY · HPE Cray EX4000 · SLES</a:t>
             </a:r>
           </a:p>
         </p:txBody>
@@ -15498,7 +15498,7 @@
               </a:defRPr>
             </a:pPr>
             <a:r>
-              <a:t>SLES · AMD Instinct MI300A APU · 96 cores</a:t>
+              <a:t>Standard: AMD EPYC 9654 Genoa, 192 cores</a:t>
             </a:r>
           </a:p>
         </p:txBody>
@@ -15534,7 +15534,7 @@
               </a:defRPr>
             </a:pPr>
             <a:r>
-              <a:t>AI/ML nodes: 4 × AMD MI300A (gfx942)</a:t>
+              <a:t>AI/ML: AMD Instinct MI300A APU, 96 cores + 4 × MI300A</a:t>
             </a:r>
           </a:p>
         </p:txBody>
@@ -15730,7 +15730,7 @@
               </a:defRPr>
             </a:pPr>
             <a:r>
-              <a:t>ARL · HPE Cray EX4000</a:t>
+              <a:t>ARL · HPE Cray EX4000 · RHEL 9</a:t>
             </a:r>
           </a:p>
         </p:txBody>
@@ -15766,7 +15766,7 @@
               </a:defRPr>
             </a:pPr>
             <a:r>
-              <a:t>RHEL 9 · AMD EPYC Genoa · Slingshot-11</a:t>
+              <a:t>Standard: AMD EPYC Genoa, cores TBD</a:t>
             </a:r>
           </a:p>
         </p:txBody>
@@ -15802,7 +15802,7 @@
               </a:defRPr>
             </a:pPr>
             <a:r>
-              <a:t>AI/ML nodes: NVIDIA H200</a:t>
+              <a:t>AI/ML: NVIDIA H200</a:t>
             </a:r>
           </a:p>
         </p:txBody>
@@ -15998,7 +15998,7 @@
               </a:defRPr>
             </a:pPr>
             <a:r>
-              <a:t>AFRL · Penguin TrueHPC</a:t>
+              <a:t>AFRL · Penguin TrueHPC · RHEL 8</a:t>
             </a:r>
           </a:p>
         </p:txBody>
@@ -16034,7 +16034,7 @@
               </a:defRPr>
             </a:pPr>
             <a:r>
-              <a:t>RHEL 8 · AMD EPYC 7713 Milan · 128 cores</a:t>
+              <a:t>Standard: AMD EPYC 7713 Milan, 128 cores</a:t>
             </a:r>
           </a:p>
         </p:txBody>
@@ -16070,7 +16070,7 @@
               </a:defRPr>
             </a:pPr>
             <a:r>
-              <a:t>MLA nodes: 4 × NVIDIA A100 SXM4</a:t>
+              <a:t>AI/ML: same CPU + 4 × NVIDIA A100 SXM4</a:t>
             </a:r>
           </a:p>
         </p:txBody>
@@ -16266,7 +16266,7 @@
               </a:defRPr>
             </a:pPr>
             <a:r>
-              <a:t>ERDC · Liqid composable</a:t>
+              <a:t>ERDC · Liqid composable · RHEL 8</a:t>
             </a:r>
           </a:p>
         </p:txBody>
@@ -16302,7 +16302,7 @@
               </a:defRPr>
             </a:pPr>
             <a:r>
-              <a:t>RHEL 8 · Intel Xeon 9242 Cascade Lake · 92 cores</a:t>
+              <a:t>Standard: Intel Xeon 9242 Cascade Lake, 92 cores</a:t>
             </a:r>
           </a:p>
         </p:txBody>
@@ -16338,7 +16338,7 @@
               </a:defRPr>
             </a:pPr>
             <a:r>
-              <a:t>MLA nodes: 4 or 6 × NVIDIA A100</a:t>
+              <a:t>AI/ML: same CPU + 4 or 6 × NVIDIA A100</a:t>
             </a:r>
           </a:p>
         </p:txBody>
@@ -16428,7 +16428,7 @@
               </a:defRPr>
             </a:pPr>
             <a:r>
-              <a:t>The accelerated (AI/ML, MLA) node types are the pilot target on each system. Source: centers.hpc.mil hardware inventory, July 2026; Fran accelerator detail from program info.</a:t>
+              <a:t>AI/ML is this deck's label for each site's accelerated node type (named MLA on Raider and Wheat). Source: centers.hpc.mil hardware inventory, July 2026; Fran accelerator detail from program info.</a:t>
             </a:r>
           </a:p>
         </p:txBody>

</xml_diff>

<commit_message>
Deck: add an open-questions slide
Five decisions the roster and pilot scope raise that the team has not
settled: which BLAS and LAPACK users get, the missing ScaLAPACK, how
many compiler surfaces per system, whether the Serial lane stays, and
when performance targeting turns on. Points at the placement map for the
per-package detail.
</commit_message>
<xml_diff>
--- a/presentations/cse_lanes_model.pptx
+++ b/presentations/cse_lanes_model.pptx
@@ -18,6 +18,7 @@
     <p:sldId id="266" r:id="rId17"/>
     <p:sldId id="267" r:id="rId18"/>
     <p:sldId id="268" r:id="rId19"/>
+    <p:sldId id="269" r:id="rId20"/>
   </p:sldIdLst>
   <p:sldSz cx="12191695" cy="6858000" type="screen4x3"/>
   <p:notesSz cx="6858000" cy="9144000"/>
@@ -3622,6 +3623,1020 @@
               </a:defRPr>
             </a:pPr>
             <a:r>
+              <a:t>DECISIONS WE NEED · NOT SETTLED YET</a:t>
+            </a:r>
+          </a:p>
+        </p:txBody>
+      </p:sp>
+      <p:sp>
+        <p:nvSpPr>
+          <p:cNvPr id="4" name="TextBox 3"/>
+          <p:cNvSpPr txBox="1"/>
+          <p:nvPr/>
+        </p:nvSpPr>
+        <p:spPr>
+          <a:xfrm>
+            <a:off x="548640" y="566928"/>
+            <a:ext cx="11064240" cy="731520"/>
+          </a:xfrm>
+          <a:prstGeom prst="rect">
+            <a:avLst/>
+          </a:prstGeom>
+          <a:noFill/>
+        </p:spPr>
+        <p:txBody>
+          <a:bodyPr wrap="square" anchor="t">
+            <a:spAutoFit/>
+          </a:bodyPr>
+          <a:lstStyle/>
+          <a:p>
+            <a:pPr algn="l">
+              <a:defRPr sz="3000" b="1">
+                <a:solidFill>
+                  <a:srgbClr val="0F172A"/>
+                </a:solidFill>
+                <a:latin typeface="Avenir Next"/>
+              </a:defRPr>
+            </a:pPr>
+            <a:r>
+              <a:t>Open questions for the team</a:t>
+            </a:r>
+          </a:p>
+        </p:txBody>
+      </p:sp>
+      <p:sp>
+        <p:nvSpPr>
+          <p:cNvPr id="5" name="Rectangle 4"/>
+          <p:cNvSpPr/>
+          <p:nvPr/>
+        </p:nvSpPr>
+        <p:spPr>
+          <a:xfrm>
+            <a:off x="566928" y="1298448"/>
+            <a:ext cx="1463040" cy="41148"/>
+          </a:xfrm>
+          <a:prstGeom prst="rect">
+            <a:avLst/>
+          </a:prstGeom>
+          <a:solidFill>
+            <a:srgbClr val="0D9488"/>
+          </a:solidFill>
+          <a:ln>
+            <a:noFill/>
+          </a:ln>
+          <a:effectLst/>
+        </p:spPr>
+        <p:style>
+          <a:lnRef idx="1">
+            <a:schemeClr val="accent1"/>
+          </a:lnRef>
+          <a:fillRef idx="3">
+            <a:schemeClr val="accent1"/>
+          </a:fillRef>
+          <a:effectRef idx="2">
+            <a:schemeClr val="accent1"/>
+          </a:effectRef>
+          <a:fontRef idx="minor">
+            <a:schemeClr val="lt1"/>
+          </a:fontRef>
+        </p:style>
+        <p:txBody>
+          <a:bodyPr rtlCol="0" anchor="ctr"/>
+          <a:lstStyle/>
+          <a:p>
+            <a:pPr algn="ctr"/>
+          </a:p>
+        </p:txBody>
+      </p:sp>
+      <p:sp>
+        <p:nvSpPr>
+          <p:cNvPr id="6" name="Rounded Rectangle 5"/>
+          <p:cNvSpPr/>
+          <p:nvPr/>
+        </p:nvSpPr>
+        <p:spPr>
+          <a:xfrm>
+            <a:off x="548640" y="1572768"/>
+            <a:ext cx="11091672" cy="804672"/>
+          </a:xfrm>
+          <a:prstGeom prst="roundRect">
+            <a:avLst/>
+          </a:prstGeom>
+          <a:solidFill>
+            <a:srgbClr val="F1F5F9"/>
+          </a:solidFill>
+          <a:ln>
+            <a:noFill/>
+          </a:ln>
+          <a:effectLst/>
+        </p:spPr>
+        <p:style>
+          <a:lnRef idx="1">
+            <a:schemeClr val="accent1"/>
+          </a:lnRef>
+          <a:fillRef idx="3">
+            <a:schemeClr val="accent1"/>
+          </a:fillRef>
+          <a:effectRef idx="2">
+            <a:schemeClr val="accent1"/>
+          </a:effectRef>
+          <a:fontRef idx="minor">
+            <a:schemeClr val="lt1"/>
+          </a:fontRef>
+        </p:style>
+        <p:txBody>
+          <a:bodyPr rtlCol="0" anchor="ctr"/>
+          <a:lstStyle/>
+          <a:p>
+            <a:pPr algn="ctr"/>
+          </a:p>
+        </p:txBody>
+      </p:sp>
+      <p:sp>
+        <p:nvSpPr>
+          <p:cNvPr id="7" name="Rectangle 6"/>
+          <p:cNvSpPr/>
+          <p:nvPr/>
+        </p:nvSpPr>
+        <p:spPr>
+          <a:xfrm>
+            <a:off x="548640" y="1572768"/>
+            <a:ext cx="91440" cy="804672"/>
+          </a:xfrm>
+          <a:prstGeom prst="rect">
+            <a:avLst/>
+          </a:prstGeom>
+          <a:solidFill>
+            <a:srgbClr val="15803D"/>
+          </a:solidFill>
+          <a:ln>
+            <a:noFill/>
+          </a:ln>
+          <a:effectLst/>
+        </p:spPr>
+        <p:style>
+          <a:lnRef idx="1">
+            <a:schemeClr val="accent1"/>
+          </a:lnRef>
+          <a:fillRef idx="3">
+            <a:schemeClr val="accent1"/>
+          </a:fillRef>
+          <a:effectRef idx="2">
+            <a:schemeClr val="accent1"/>
+          </a:effectRef>
+          <a:fontRef idx="minor">
+            <a:schemeClr val="lt1"/>
+          </a:fontRef>
+        </p:style>
+        <p:txBody>
+          <a:bodyPr rtlCol="0" anchor="ctr"/>
+          <a:lstStyle/>
+          <a:p>
+            <a:pPr algn="ctr"/>
+          </a:p>
+        </p:txBody>
+      </p:sp>
+      <p:sp>
+        <p:nvSpPr>
+          <p:cNvPr id="8" name="TextBox 7"/>
+          <p:cNvSpPr txBox="1"/>
+          <p:nvPr/>
+        </p:nvSpPr>
+        <p:spPr>
+          <a:xfrm>
+            <a:off x="868680" y="1664208"/>
+            <a:ext cx="10515600" cy="274320"/>
+          </a:xfrm>
+          <a:prstGeom prst="rect">
+            <a:avLst/>
+          </a:prstGeom>
+          <a:noFill/>
+        </p:spPr>
+        <p:txBody>
+          <a:bodyPr wrap="square" anchor="t">
+            <a:spAutoFit/>
+          </a:bodyPr>
+          <a:lstStyle/>
+          <a:p>
+            <a:pPr algn="l">
+              <a:defRPr sz="1350" b="1">
+                <a:solidFill>
+                  <a:srgbClr val="0F172A"/>
+                </a:solidFill>
+                <a:latin typeface="Avenir Next"/>
+              </a:defRPr>
+            </a:pPr>
+            <a:r>
+              <a:t>Which BLAS and LAPACK do users get?</a:t>
+            </a:r>
+          </a:p>
+        </p:txBody>
+      </p:sp>
+      <p:sp>
+        <p:nvSpPr>
+          <p:cNvPr id="9" name="TextBox 8"/>
+          <p:cNvSpPr txBox="1"/>
+          <p:nvPr/>
+        </p:nvSpPr>
+        <p:spPr>
+          <a:xfrm>
+            <a:off x="868680" y="1956816"/>
+            <a:ext cx="10515600" cy="384048"/>
+          </a:xfrm>
+          <a:prstGeom prst="rect">
+            <a:avLst/>
+          </a:prstGeom>
+          <a:noFill/>
+        </p:spPr>
+        <p:txBody>
+          <a:bodyPr wrap="square" anchor="t">
+            <a:spAutoFit/>
+          </a:bodyPr>
+          <a:lstStyle/>
+          <a:p>
+            <a:pPr algn="l">
+              <a:defRPr sz="1100" b="0">
+                <a:solidFill>
+                  <a:srgbClr val="64748B"/>
+                </a:solidFill>
+                <a:latin typeface="Avenir Next"/>
+              </a:defRPr>
+            </a:pPr>
+            <a:r>
+              <a:t>Today the stack builds OpenBLAS and reference LAPACK. OpenBLAS already provides the LAPACK API, so the pair ships it twice. Cray LibSci is on the path already; Intel systems would expect MKL.</a:t>
+            </a:r>
+          </a:p>
+        </p:txBody>
+      </p:sp>
+      <p:sp>
+        <p:nvSpPr>
+          <p:cNvPr id="10" name="Rounded Rectangle 9"/>
+          <p:cNvSpPr/>
+          <p:nvPr/>
+        </p:nvSpPr>
+        <p:spPr>
+          <a:xfrm>
+            <a:off x="548640" y="2487168"/>
+            <a:ext cx="11091672" cy="804672"/>
+          </a:xfrm>
+          <a:prstGeom prst="roundRect">
+            <a:avLst/>
+          </a:prstGeom>
+          <a:solidFill>
+            <a:srgbClr val="F1F5F9"/>
+          </a:solidFill>
+          <a:ln>
+            <a:noFill/>
+          </a:ln>
+          <a:effectLst/>
+        </p:spPr>
+        <p:style>
+          <a:lnRef idx="1">
+            <a:schemeClr val="accent1"/>
+          </a:lnRef>
+          <a:fillRef idx="3">
+            <a:schemeClr val="accent1"/>
+          </a:fillRef>
+          <a:effectRef idx="2">
+            <a:schemeClr val="accent1"/>
+          </a:effectRef>
+          <a:fontRef idx="minor">
+            <a:schemeClr val="lt1"/>
+          </a:fontRef>
+        </p:style>
+        <p:txBody>
+          <a:bodyPr rtlCol="0" anchor="ctr"/>
+          <a:lstStyle/>
+          <a:p>
+            <a:pPr algn="ctr"/>
+          </a:p>
+        </p:txBody>
+      </p:sp>
+      <p:sp>
+        <p:nvSpPr>
+          <p:cNvPr id="11" name="Rectangle 10"/>
+          <p:cNvSpPr/>
+          <p:nvPr/>
+        </p:nvSpPr>
+        <p:spPr>
+          <a:xfrm>
+            <a:off x="548640" y="2487168"/>
+            <a:ext cx="91440" cy="804672"/>
+          </a:xfrm>
+          <a:prstGeom prst="rect">
+            <a:avLst/>
+          </a:prstGeom>
+          <a:solidFill>
+            <a:srgbClr val="2563EB"/>
+          </a:solidFill>
+          <a:ln>
+            <a:noFill/>
+          </a:ln>
+          <a:effectLst/>
+        </p:spPr>
+        <p:style>
+          <a:lnRef idx="1">
+            <a:schemeClr val="accent1"/>
+          </a:lnRef>
+          <a:fillRef idx="3">
+            <a:schemeClr val="accent1"/>
+          </a:fillRef>
+          <a:effectRef idx="2">
+            <a:schemeClr val="accent1"/>
+          </a:effectRef>
+          <a:fontRef idx="minor">
+            <a:schemeClr val="lt1"/>
+          </a:fontRef>
+        </p:style>
+        <p:txBody>
+          <a:bodyPr rtlCol="0" anchor="ctr"/>
+          <a:lstStyle/>
+          <a:p>
+            <a:pPr algn="ctr"/>
+          </a:p>
+        </p:txBody>
+      </p:sp>
+      <p:sp>
+        <p:nvSpPr>
+          <p:cNvPr id="12" name="TextBox 11"/>
+          <p:cNvSpPr txBox="1"/>
+          <p:nvPr/>
+        </p:nvSpPr>
+        <p:spPr>
+          <a:xfrm>
+            <a:off x="868680" y="2578608"/>
+            <a:ext cx="10515600" cy="274320"/>
+          </a:xfrm>
+          <a:prstGeom prst="rect">
+            <a:avLst/>
+          </a:prstGeom>
+          <a:noFill/>
+        </p:spPr>
+        <p:txBody>
+          <a:bodyPr wrap="square" anchor="t">
+            <a:spAutoFit/>
+          </a:bodyPr>
+          <a:lstStyle/>
+          <a:p>
+            <a:pPr algn="l">
+              <a:defRPr sz="1350" b="1">
+                <a:solidFill>
+                  <a:srgbClr val="0F172A"/>
+                </a:solidFill>
+                <a:latin typeface="Avenir Next"/>
+              </a:defRPr>
+            </a:pPr>
+            <a:r>
+              <a:t>ScaLAPACK is not in the roster.</a:t>
+            </a:r>
+          </a:p>
+        </p:txBody>
+      </p:sp>
+      <p:sp>
+        <p:nvSpPr>
+          <p:cNvPr id="13" name="TextBox 12"/>
+          <p:cNvSpPr txBox="1"/>
+          <p:nvPr/>
+        </p:nvSpPr>
+        <p:spPr>
+          <a:xfrm>
+            <a:off x="868680" y="2871215"/>
+            <a:ext cx="10515600" cy="384048"/>
+          </a:xfrm>
+          <a:prstGeom prst="rect">
+            <a:avLst/>
+          </a:prstGeom>
+          <a:noFill/>
+        </p:spPr>
+        <p:txBody>
+          <a:bodyPr wrap="square" anchor="t">
+            <a:spAutoFit/>
+          </a:bodyPr>
+          <a:lstStyle/>
+          <a:p>
+            <a:pPr algn="l">
+              <a:defRPr sz="1100" b="0">
+                <a:solidFill>
+                  <a:srgbClr val="64748B"/>
+                </a:solidFill>
+                <a:latin typeface="Avenir Next"/>
+              </a:defRPr>
+            </a:pPr>
+            <a:r>
+              <a:t>Distributed dense solvers need it, and both LibSci and MKL include it. It is MPI-only by nature, so the MPI and GPU lanes are its home if we carry it.</a:t>
+            </a:r>
+          </a:p>
+        </p:txBody>
+      </p:sp>
+      <p:sp>
+        <p:nvSpPr>
+          <p:cNvPr id="14" name="Rounded Rectangle 13"/>
+          <p:cNvSpPr/>
+          <p:nvPr/>
+        </p:nvSpPr>
+        <p:spPr>
+          <a:xfrm>
+            <a:off x="548640" y="3401568"/>
+            <a:ext cx="11091672" cy="804672"/>
+          </a:xfrm>
+          <a:prstGeom prst="roundRect">
+            <a:avLst/>
+          </a:prstGeom>
+          <a:solidFill>
+            <a:srgbClr val="F1F5F9"/>
+          </a:solidFill>
+          <a:ln>
+            <a:noFill/>
+          </a:ln>
+          <a:effectLst/>
+        </p:spPr>
+        <p:style>
+          <a:lnRef idx="1">
+            <a:schemeClr val="accent1"/>
+          </a:lnRef>
+          <a:fillRef idx="3">
+            <a:schemeClr val="accent1"/>
+          </a:fillRef>
+          <a:effectRef idx="2">
+            <a:schemeClr val="accent1"/>
+          </a:effectRef>
+          <a:fontRef idx="minor">
+            <a:schemeClr val="lt1"/>
+          </a:fontRef>
+        </p:style>
+        <p:txBody>
+          <a:bodyPr rtlCol="0" anchor="ctr"/>
+          <a:lstStyle/>
+          <a:p>
+            <a:pPr algn="ctr"/>
+          </a:p>
+        </p:txBody>
+      </p:sp>
+      <p:sp>
+        <p:nvSpPr>
+          <p:cNvPr id="15" name="Rectangle 14"/>
+          <p:cNvSpPr/>
+          <p:nvPr/>
+        </p:nvSpPr>
+        <p:spPr>
+          <a:xfrm>
+            <a:off x="548640" y="3401568"/>
+            <a:ext cx="91440" cy="804672"/>
+          </a:xfrm>
+          <a:prstGeom prst="rect">
+            <a:avLst/>
+          </a:prstGeom>
+          <a:solidFill>
+            <a:srgbClr val="0D9488"/>
+          </a:solidFill>
+          <a:ln>
+            <a:noFill/>
+          </a:ln>
+          <a:effectLst/>
+        </p:spPr>
+        <p:style>
+          <a:lnRef idx="1">
+            <a:schemeClr val="accent1"/>
+          </a:lnRef>
+          <a:fillRef idx="3">
+            <a:schemeClr val="accent1"/>
+          </a:fillRef>
+          <a:effectRef idx="2">
+            <a:schemeClr val="accent1"/>
+          </a:effectRef>
+          <a:fontRef idx="minor">
+            <a:schemeClr val="lt1"/>
+          </a:fontRef>
+        </p:style>
+        <p:txBody>
+          <a:bodyPr rtlCol="0" anchor="ctr"/>
+          <a:lstStyle/>
+          <a:p>
+            <a:pPr algn="ctr"/>
+          </a:p>
+        </p:txBody>
+      </p:sp>
+      <p:sp>
+        <p:nvSpPr>
+          <p:cNvPr id="16" name="TextBox 15"/>
+          <p:cNvSpPr txBox="1"/>
+          <p:nvPr/>
+        </p:nvSpPr>
+        <p:spPr>
+          <a:xfrm>
+            <a:off x="868680" y="3493008"/>
+            <a:ext cx="10515600" cy="274320"/>
+          </a:xfrm>
+          <a:prstGeom prst="rect">
+            <a:avLst/>
+          </a:prstGeom>
+          <a:noFill/>
+        </p:spPr>
+        <p:txBody>
+          <a:bodyPr wrap="square" anchor="t">
+            <a:spAutoFit/>
+          </a:bodyPr>
+          <a:lstStyle/>
+          <a:p>
+            <a:pPr algn="l">
+              <a:defRPr sz="1350" b="1">
+                <a:solidFill>
+                  <a:srgbClr val="0F172A"/>
+                </a:solidFill>
+                <a:latin typeface="Avenir Next"/>
+              </a:defRPr>
+            </a:pPr>
+            <a:r>
+              <a:t>How many compiler surfaces per system?</a:t>
+            </a:r>
+          </a:p>
+        </p:txBody>
+      </p:sp>
+      <p:sp>
+        <p:nvSpPr>
+          <p:cNvPr id="17" name="TextBox 16"/>
+          <p:cNvSpPr txBox="1"/>
+          <p:nvPr/>
+        </p:nvSpPr>
+        <p:spPr>
+          <a:xfrm>
+            <a:off x="868680" y="3785615"/>
+            <a:ext cx="10515600" cy="384048"/>
+          </a:xfrm>
+          <a:prstGeom prst="rect">
+            <a:avLst/>
+          </a:prstGeom>
+          <a:noFill/>
+        </p:spPr>
+        <p:txBody>
+          <a:bodyPr wrap="square" anchor="t">
+            <a:spAutoFit/>
+          </a:bodyPr>
+          <a:lstStyle/>
+          <a:p>
+            <a:pPr algn="l">
+              <a:defRPr sz="1100" b="0">
+                <a:solidFill>
+                  <a:srgbClr val="64748B"/>
+                </a:solidFill>
+                <a:latin typeface="Avenir Next"/>
+              </a:defRPr>
+            </a:pPr>
+            <a:r>
+              <a:t>CSEinit offers GCC and Intel today. The pilot input builds the system baseline only. Adding a surface is a one-line policy change, not a redesign, but it is a decision.</a:t>
+            </a:r>
+          </a:p>
+        </p:txBody>
+      </p:sp>
+      <p:sp>
+        <p:nvSpPr>
+          <p:cNvPr id="18" name="Rounded Rectangle 17"/>
+          <p:cNvSpPr/>
+          <p:nvPr/>
+        </p:nvSpPr>
+        <p:spPr>
+          <a:xfrm>
+            <a:off x="548640" y="4315968"/>
+            <a:ext cx="11091672" cy="804672"/>
+          </a:xfrm>
+          <a:prstGeom prst="roundRect">
+            <a:avLst/>
+          </a:prstGeom>
+          <a:solidFill>
+            <a:srgbClr val="F1F5F9"/>
+          </a:solidFill>
+          <a:ln>
+            <a:noFill/>
+          </a:ln>
+          <a:effectLst/>
+        </p:spPr>
+        <p:style>
+          <a:lnRef idx="1">
+            <a:schemeClr val="accent1"/>
+          </a:lnRef>
+          <a:fillRef idx="3">
+            <a:schemeClr val="accent1"/>
+          </a:fillRef>
+          <a:effectRef idx="2">
+            <a:schemeClr val="accent1"/>
+          </a:effectRef>
+          <a:fontRef idx="minor">
+            <a:schemeClr val="lt1"/>
+          </a:fontRef>
+        </p:style>
+        <p:txBody>
+          <a:bodyPr rtlCol="0" anchor="ctr"/>
+          <a:lstStyle/>
+          <a:p>
+            <a:pPr algn="ctr"/>
+          </a:p>
+        </p:txBody>
+      </p:sp>
+      <p:sp>
+        <p:nvSpPr>
+          <p:cNvPr id="19" name="Rectangle 18"/>
+          <p:cNvSpPr/>
+          <p:nvPr/>
+        </p:nvSpPr>
+        <p:spPr>
+          <a:xfrm>
+            <a:off x="548640" y="4315968"/>
+            <a:ext cx="91440" cy="804672"/>
+          </a:xfrm>
+          <a:prstGeom prst="rect">
+            <a:avLst/>
+          </a:prstGeom>
+          <a:solidFill>
+            <a:srgbClr val="D97706"/>
+          </a:solidFill>
+          <a:ln>
+            <a:noFill/>
+          </a:ln>
+          <a:effectLst/>
+        </p:spPr>
+        <p:style>
+          <a:lnRef idx="1">
+            <a:schemeClr val="accent1"/>
+          </a:lnRef>
+          <a:fillRef idx="3">
+            <a:schemeClr val="accent1"/>
+          </a:fillRef>
+          <a:effectRef idx="2">
+            <a:schemeClr val="accent1"/>
+          </a:effectRef>
+          <a:fontRef idx="minor">
+            <a:schemeClr val="lt1"/>
+          </a:fontRef>
+        </p:style>
+        <p:txBody>
+          <a:bodyPr rtlCol="0" anchor="ctr"/>
+          <a:lstStyle/>
+          <a:p>
+            <a:pPr algn="ctr"/>
+          </a:p>
+        </p:txBody>
+      </p:sp>
+      <p:sp>
+        <p:nvSpPr>
+          <p:cNvPr id="20" name="TextBox 19"/>
+          <p:cNvSpPr txBox="1"/>
+          <p:nvPr/>
+        </p:nvSpPr>
+        <p:spPr>
+          <a:xfrm>
+            <a:off x="868680" y="4407407"/>
+            <a:ext cx="10515600" cy="274320"/>
+          </a:xfrm>
+          <a:prstGeom prst="rect">
+            <a:avLst/>
+          </a:prstGeom>
+          <a:noFill/>
+        </p:spPr>
+        <p:txBody>
+          <a:bodyPr wrap="square" anchor="t">
+            <a:spAutoFit/>
+          </a:bodyPr>
+          <a:lstStyle/>
+          <a:p>
+            <a:pPr algn="l">
+              <a:defRPr sz="1350" b="1">
+                <a:solidFill>
+                  <a:srgbClr val="0F172A"/>
+                </a:solidFill>
+                <a:latin typeface="Avenir Next"/>
+              </a:defRPr>
+            </a:pPr>
+            <a:r>
+              <a:t>Does the Serial lane stay?</a:t>
+            </a:r>
+          </a:p>
+        </p:txBody>
+      </p:sp>
+      <p:sp>
+        <p:nvSpPr>
+          <p:cNvPr id="21" name="TextBox 20"/>
+          <p:cNvSpPr txBox="1"/>
+          <p:nvPr/>
+        </p:nvSpPr>
+        <p:spPr>
+          <a:xfrm>
+            <a:off x="868680" y="4700016"/>
+            <a:ext cx="10515600" cy="384048"/>
+          </a:xfrm>
+          <a:prstGeom prst="rect">
+            <a:avLst/>
+          </a:prstGeom>
+          <a:noFill/>
+        </p:spPr>
+        <p:txBody>
+          <a:bodyPr wrap="square" anchor="t">
+            <a:spAutoFit/>
+          </a:bodyPr>
+          <a:lstStyle/>
+          <a:p>
+            <a:pPr algn="l">
+              <a:defRPr sz="1100" b="0">
+                <a:solidFill>
+                  <a:srgbClr val="64748B"/>
+                </a:solidFill>
+                <a:latin typeface="Avenir Next"/>
+              </a:defRPr>
+            </a:pPr>
+            <a:r>
+              <a:t>An MPI build run on one rank does a serial job. We keep Serial because users ask for plain builds, but it is a deliberate cost: a second build of every MPI-capable package.</a:t>
+            </a:r>
+          </a:p>
+        </p:txBody>
+      </p:sp>
+      <p:sp>
+        <p:nvSpPr>
+          <p:cNvPr id="22" name="Rounded Rectangle 21"/>
+          <p:cNvSpPr/>
+          <p:nvPr/>
+        </p:nvSpPr>
+        <p:spPr>
+          <a:xfrm>
+            <a:off x="548640" y="5230368"/>
+            <a:ext cx="11091672" cy="804672"/>
+          </a:xfrm>
+          <a:prstGeom prst="roundRect">
+            <a:avLst/>
+          </a:prstGeom>
+          <a:solidFill>
+            <a:srgbClr val="F1F5F9"/>
+          </a:solidFill>
+          <a:ln>
+            <a:noFill/>
+          </a:ln>
+          <a:effectLst/>
+        </p:spPr>
+        <p:style>
+          <a:lnRef idx="1">
+            <a:schemeClr val="accent1"/>
+          </a:lnRef>
+          <a:fillRef idx="3">
+            <a:schemeClr val="accent1"/>
+          </a:fillRef>
+          <a:effectRef idx="2">
+            <a:schemeClr val="accent1"/>
+          </a:effectRef>
+          <a:fontRef idx="minor">
+            <a:schemeClr val="lt1"/>
+          </a:fontRef>
+        </p:style>
+        <p:txBody>
+          <a:bodyPr rtlCol="0" anchor="ctr"/>
+          <a:lstStyle/>
+          <a:p>
+            <a:pPr algn="ctr"/>
+          </a:p>
+        </p:txBody>
+      </p:sp>
+      <p:sp>
+        <p:nvSpPr>
+          <p:cNvPr id="23" name="Rectangle 22"/>
+          <p:cNvSpPr/>
+          <p:nvPr/>
+        </p:nvSpPr>
+        <p:spPr>
+          <a:xfrm>
+            <a:off x="548640" y="5230368"/>
+            <a:ext cx="91440" cy="804672"/>
+          </a:xfrm>
+          <a:prstGeom prst="rect">
+            <a:avLst/>
+          </a:prstGeom>
+          <a:solidFill>
+            <a:srgbClr val="7C3AED"/>
+          </a:solidFill>
+          <a:ln>
+            <a:noFill/>
+          </a:ln>
+          <a:effectLst/>
+        </p:spPr>
+        <p:style>
+          <a:lnRef idx="1">
+            <a:schemeClr val="accent1"/>
+          </a:lnRef>
+          <a:fillRef idx="3">
+            <a:schemeClr val="accent1"/>
+          </a:fillRef>
+          <a:effectRef idx="2">
+            <a:schemeClr val="accent1"/>
+          </a:effectRef>
+          <a:fontRef idx="minor">
+            <a:schemeClr val="lt1"/>
+          </a:fontRef>
+        </p:style>
+        <p:txBody>
+          <a:bodyPr rtlCol="0" anchor="ctr"/>
+          <a:lstStyle/>
+          <a:p>
+            <a:pPr algn="ctr"/>
+          </a:p>
+        </p:txBody>
+      </p:sp>
+      <p:sp>
+        <p:nvSpPr>
+          <p:cNvPr id="24" name="TextBox 23"/>
+          <p:cNvSpPr txBox="1"/>
+          <p:nvPr/>
+        </p:nvSpPr>
+        <p:spPr>
+          <a:xfrm>
+            <a:off x="868680" y="5321807"/>
+            <a:ext cx="10515600" cy="274320"/>
+          </a:xfrm>
+          <a:prstGeom prst="rect">
+            <a:avLst/>
+          </a:prstGeom>
+          <a:noFill/>
+        </p:spPr>
+        <p:txBody>
+          <a:bodyPr wrap="square" anchor="t">
+            <a:spAutoFit/>
+          </a:bodyPr>
+          <a:lstStyle/>
+          <a:p>
+            <a:pPr algn="l">
+              <a:defRPr sz="1350" b="1">
+                <a:solidFill>
+                  <a:srgbClr val="0F172A"/>
+                </a:solidFill>
+                <a:latin typeface="Avenir Next"/>
+              </a:defRPr>
+            </a:pPr>
+            <a:r>
+              <a:t>When do we turn on performance targeting?</a:t>
+            </a:r>
+          </a:p>
+        </p:txBody>
+      </p:sp>
+      <p:sp>
+        <p:nvSpPr>
+          <p:cNvPr id="25" name="TextBox 24"/>
+          <p:cNvSpPr txBox="1"/>
+          <p:nvPr/>
+        </p:nvSpPr>
+        <p:spPr>
+          <a:xfrm>
+            <a:off x="868680" y="5614416"/>
+            <a:ext cx="10515600" cy="384048"/>
+          </a:xfrm>
+          <a:prstGeom prst="rect">
+            <a:avLst/>
+          </a:prstGeom>
+          <a:noFill/>
+        </p:spPr>
+        <p:txBody>
+          <a:bodyPr wrap="square" anchor="t">
+            <a:spAutoFit/>
+          </a:bodyPr>
+          <a:lstStyle/>
+          <a:p>
+            <a:pPr algn="l">
+              <a:defRPr sz="1100" b="0">
+                <a:solidFill>
+                  <a:srgbClr val="64748B"/>
+                </a:solidFill>
+                <a:latin typeface="Avenir Next"/>
+              </a:defRPr>
+            </a:pPr>
+            <a:r>
+              <a:t>Everything builds at the portable baseline today. Tuning for Genoa, Milan, or Cascade Lake is a per-lane flag plus a full rebuild, so it is a scheduling question, not a design one.</a:t>
+            </a:r>
+          </a:p>
+        </p:txBody>
+      </p:sp>
+      <p:sp>
+        <p:nvSpPr>
+          <p:cNvPr id="26" name="TextBox 25"/>
+          <p:cNvSpPr txBox="1"/>
+          <p:nvPr/>
+        </p:nvSpPr>
+        <p:spPr>
+          <a:xfrm>
+            <a:off x="548640" y="6263640"/>
+            <a:ext cx="11064240" cy="365760"/>
+          </a:xfrm>
+          <a:prstGeom prst="rect">
+            <a:avLst/>
+          </a:prstGeom>
+          <a:noFill/>
+        </p:spPr>
+        <p:txBody>
+          <a:bodyPr wrap="square" anchor="t">
+            <a:spAutoFit/>
+          </a:bodyPr>
+          <a:lstStyle/>
+          <a:p>
+            <a:pPr algn="l">
+              <a:defRPr sz="1100" b="0">
+                <a:solidFill>
+                  <a:srgbClr val="64748B"/>
+                </a:solidFill>
+                <a:latin typeface="Avenir Next"/>
+              </a:defRPr>
+            </a:pPr>
+            <a:r>
+              <a:t>Per-package placement and the full reasoning: docs/package_placement_map_v1.html</a:t>
+            </a:r>
+          </a:p>
+        </p:txBody>
+      </p:sp>
+    </p:spTree>
+  </p:cSld>
+  <p:clrMapOvr>
+    <a:masterClrMapping/>
+  </p:clrMapOvr>
+</p:sld>
+</file>
+
+<file path=ppt/slides/slide11.xml><?xml version="1.0" encoding="utf-8"?>
+<p:sld xmlns:a="http://schemas.openxmlformats.org/drawingml/2006/main" xmlns:p="http://schemas.openxmlformats.org/presentationml/2006/main" xmlns:r="http://schemas.openxmlformats.org/officeDocument/2006/relationships">
+  <p:cSld>
+    <p:spTree>
+      <p:nvGrpSpPr>
+        <p:cNvPr id="1" name=""/>
+        <p:cNvGrpSpPr/>
+        <p:nvPr/>
+      </p:nvGrpSpPr>
+      <p:grpSpPr/>
+      <p:sp>
+        <p:nvSpPr>
+          <p:cNvPr id="2" name="Rectangle 1"/>
+          <p:cNvSpPr/>
+          <p:nvPr/>
+        </p:nvSpPr>
+        <p:spPr>
+          <a:xfrm>
+            <a:off x="0" y="0"/>
+            <a:ext cx="12191695" cy="6858000"/>
+          </a:xfrm>
+          <a:prstGeom prst="rect">
+            <a:avLst/>
+          </a:prstGeom>
+          <a:solidFill>
+            <a:srgbClr val="FFFFFF"/>
+          </a:solidFill>
+          <a:ln>
+            <a:noFill/>
+          </a:ln>
+          <a:effectLst/>
+        </p:spPr>
+        <p:style>
+          <a:lnRef idx="1">
+            <a:schemeClr val="accent1"/>
+          </a:lnRef>
+          <a:fillRef idx="3">
+            <a:schemeClr val="accent1"/>
+          </a:fillRef>
+          <a:effectRef idx="2">
+            <a:schemeClr val="accent1"/>
+          </a:effectRef>
+          <a:fontRef idx="minor">
+            <a:schemeClr val="lt1"/>
+          </a:fontRef>
+        </p:style>
+        <p:txBody>
+          <a:bodyPr rtlCol="0" anchor="ctr"/>
+          <a:lstStyle/>
+          <a:p>
+            <a:pPr algn="ctr"/>
+          </a:p>
+        </p:txBody>
+      </p:sp>
+      <p:sp>
+        <p:nvSpPr>
+          <p:cNvPr id="3" name="TextBox 2"/>
+          <p:cNvSpPr txBox="1"/>
+          <p:nvPr/>
+        </p:nvSpPr>
+        <p:spPr>
+          <a:xfrm>
+            <a:off x="548640" y="256032"/>
+            <a:ext cx="10972800" cy="365760"/>
+          </a:xfrm>
+          <a:prstGeom prst="rect">
+            <a:avLst/>
+          </a:prstGeom>
+          <a:noFill/>
+        </p:spPr>
+        <p:txBody>
+          <a:bodyPr wrap="square" anchor="t">
+            <a:spAutoFit/>
+          </a:bodyPr>
+          <a:lstStyle/>
+          <a:p>
+            <a:pPr algn="l">
+              <a:defRPr sz="1300" b="1">
+                <a:solidFill>
+                  <a:srgbClr val="0D9488"/>
+                </a:solidFill>
+                <a:latin typeface="Avenir Next"/>
+              </a:defRPr>
+            </a:pPr>
+            <a:r>
               <a:t>APPENDIX · HOW THE LAYERS STACK</a:t>
             </a:r>
           </a:p>
@@ -4297,7 +5312,7 @@
 </p:sld>
 </file>
 
-<file path=ppt/slides/slide11.xml><?xml version="1.0" encoding="utf-8"?>
+<file path=ppt/slides/slide12.xml><?xml version="1.0" encoding="utf-8"?>
 <p:sld xmlns:a="http://schemas.openxmlformats.org/drawingml/2006/main" xmlns:p="http://schemas.openxmlformats.org/presentationml/2006/main" xmlns:r="http://schemas.openxmlformats.org/officeDocument/2006/relationships">
   <p:cSld>
     <p:spTree>
@@ -5469,7 +6484,7 @@
 </p:sld>
 </file>
 
-<file path=ppt/slides/slide12.xml><?xml version="1.0" encoding="utf-8"?>
+<file path=ppt/slides/slide13.xml><?xml version="1.0" encoding="utf-8"?>
 <p:sld xmlns:a="http://schemas.openxmlformats.org/drawingml/2006/main" xmlns:p="http://schemas.openxmlformats.org/presentationml/2006/main" xmlns:r="http://schemas.openxmlformats.org/officeDocument/2006/relationships">
   <p:cSld>
     <p:spTree>
@@ -6576,7 +7591,7 @@
 </p:sld>
 </file>
 
-<file path=ppt/slides/slide13.xml><?xml version="1.0" encoding="utf-8"?>
+<file path=ppt/slides/slide14.xml><?xml version="1.0" encoding="utf-8"?>
 <p:sld xmlns:a="http://schemas.openxmlformats.org/drawingml/2006/main" xmlns:p="http://schemas.openxmlformats.org/presentationml/2006/main" xmlns:r="http://schemas.openxmlformats.org/officeDocument/2006/relationships">
   <p:cSld>
     <p:spTree>

</xml_diff>

<commit_message>
Record the OpenBLAS, ScaLAPACK, and TAU decisions
Rationale doc: netlib-lapack dropped (resolving the review it carried),
netlib-scalapack placed in the MPI lane, tau at one version with its own
GPU-lane build. Schema describes both GPU placeholders. Placement map
and deck appendix follow the roster; the open-questions slide loses the
two items now decided and reframes BLAS as the vendor-library question.
</commit_message>
<xml_diff>
--- a/presentations/cse_lanes_model.pptx
+++ b/presentations/cse_lanes_model.pptx
@@ -3716,8 +3716,8 @@
         </p:nvSpPr>
         <p:spPr>
           <a:xfrm>
-            <a:off x="548640" y="1572768"/>
-            <a:ext cx="11091672" cy="804672"/>
+            <a:off x="548640" y="1600200"/>
+            <a:ext cx="11091672" cy="914400"/>
           </a:xfrm>
           <a:prstGeom prst="roundRect">
             <a:avLst/>
@@ -3760,8 +3760,8 @@
         </p:nvSpPr>
         <p:spPr>
           <a:xfrm>
-            <a:off x="548640" y="1572768"/>
-            <a:ext cx="91440" cy="804672"/>
+            <a:off x="548640" y="1600200"/>
+            <a:ext cx="91440" cy="914400"/>
           </a:xfrm>
           <a:prstGeom prst="rect">
             <a:avLst/>
@@ -3804,7 +3804,7 @@
         </p:nvSpPr>
         <p:spPr>
           <a:xfrm>
-            <a:off x="868680" y="1664208"/>
+            <a:off x="868680" y="1728216"/>
             <a:ext cx="10515600" cy="274320"/>
           </a:xfrm>
           <a:prstGeom prst="rect">
@@ -3827,7 +3827,7 @@
               </a:defRPr>
             </a:pPr>
             <a:r>
-              <a:t>Which BLAS and LAPACK do users get?</a:t>
+              <a:t>Do we offer the vendor's math libraries as well as OpenBLAS?</a:t>
             </a:r>
           </a:p>
         </p:txBody>
@@ -3840,8 +3840,8 @@
         </p:nvSpPr>
         <p:spPr>
           <a:xfrm>
-            <a:off x="868680" y="1956816"/>
-            <a:ext cx="10515600" cy="384048"/>
+            <a:off x="868680" y="2029967"/>
+            <a:ext cx="10515600" cy="420624"/>
           </a:xfrm>
           <a:prstGeom prst="rect">
             <a:avLst/>
@@ -3863,7 +3863,7 @@
               </a:defRPr>
             </a:pPr>
             <a:r>
-              <a:t>Today the stack builds OpenBLAS and reference LAPACK. OpenBLAS already provides the LAPACK API, so the pair ships it twice. Cray LibSci is on the path already; Intel systems would expect MKL.</a:t>
+              <a:t>OpenBLAS is now the one BLAS and LAPACK, so users get the same library on every system. Cray LibSci is already on the path on Blueback and Fran, and Intel systems would expect MKL. Both are registered rather than built, so this is policy per system, not build cost.</a:t>
             </a:r>
           </a:p>
         </p:txBody>
@@ -3876,8 +3876,8 @@
         </p:nvSpPr>
         <p:spPr>
           <a:xfrm>
-            <a:off x="548640" y="2487168"/>
-            <a:ext cx="11091672" cy="804672"/>
+            <a:off x="548640" y="2679191"/>
+            <a:ext cx="11091672" cy="914400"/>
           </a:xfrm>
           <a:prstGeom prst="roundRect">
             <a:avLst/>
@@ -3920,14 +3920,14 @@
         </p:nvSpPr>
         <p:spPr>
           <a:xfrm>
-            <a:off x="548640" y="2487168"/>
-            <a:ext cx="91440" cy="804672"/>
+            <a:off x="548640" y="2679191"/>
+            <a:ext cx="91440" cy="914400"/>
           </a:xfrm>
           <a:prstGeom prst="rect">
             <a:avLst/>
           </a:prstGeom>
           <a:solidFill>
-            <a:srgbClr val="2563EB"/>
+            <a:srgbClr val="0D9488"/>
           </a:solidFill>
           <a:ln>
             <a:noFill/>
@@ -3964,7 +3964,7 @@
         </p:nvSpPr>
         <p:spPr>
           <a:xfrm>
-            <a:off x="868680" y="2578608"/>
+            <a:off x="868680" y="2807208"/>
             <a:ext cx="10515600" cy="274320"/>
           </a:xfrm>
           <a:prstGeom prst="rect">
@@ -3987,7 +3987,7 @@
               </a:defRPr>
             </a:pPr>
             <a:r>
-              <a:t>ScaLAPACK is not in the roster.</a:t>
+              <a:t>How many compiler surfaces per system?</a:t>
             </a:r>
           </a:p>
         </p:txBody>
@@ -4000,8 +4000,8 @@
         </p:nvSpPr>
         <p:spPr>
           <a:xfrm>
-            <a:off x="868680" y="2871215"/>
-            <a:ext cx="10515600" cy="384048"/>
+            <a:off x="868680" y="3108959"/>
+            <a:ext cx="10515600" cy="420624"/>
           </a:xfrm>
           <a:prstGeom prst="rect">
             <a:avLst/>
@@ -4023,7 +4023,7 @@
               </a:defRPr>
             </a:pPr>
             <a:r>
-              <a:t>Distributed dense solvers need it, and both LibSci and MKL include it. It is MPI-only by nature, so the MPI and GPU lanes are its home if we carry it.</a:t>
+              <a:t>CSEinit offers GCC and Intel today. The pilot input builds the system baseline only. Adding a surface is a one-line policy change, not a redesign, but it is a decision.</a:t>
             </a:r>
           </a:p>
         </p:txBody>
@@ -4036,8 +4036,8 @@
         </p:nvSpPr>
         <p:spPr>
           <a:xfrm>
-            <a:off x="548640" y="3401568"/>
-            <a:ext cx="11091672" cy="804672"/>
+            <a:off x="548640" y="3758183"/>
+            <a:ext cx="11091672" cy="914400"/>
           </a:xfrm>
           <a:prstGeom prst="roundRect">
             <a:avLst/>
@@ -4080,14 +4080,14 @@
         </p:nvSpPr>
         <p:spPr>
           <a:xfrm>
-            <a:off x="548640" y="3401568"/>
-            <a:ext cx="91440" cy="804672"/>
+            <a:off x="548640" y="3758183"/>
+            <a:ext cx="91440" cy="914400"/>
           </a:xfrm>
           <a:prstGeom prst="rect">
             <a:avLst/>
           </a:prstGeom>
           <a:solidFill>
-            <a:srgbClr val="0D9488"/>
+            <a:srgbClr val="D97706"/>
           </a:solidFill>
           <a:ln>
             <a:noFill/>
@@ -4124,7 +4124,7 @@
         </p:nvSpPr>
         <p:spPr>
           <a:xfrm>
-            <a:off x="868680" y="3493008"/>
+            <a:off x="868680" y="3886199"/>
             <a:ext cx="10515600" cy="274320"/>
           </a:xfrm>
           <a:prstGeom prst="rect">
@@ -4147,7 +4147,7 @@
               </a:defRPr>
             </a:pPr>
             <a:r>
-              <a:t>How many compiler surfaces per system?</a:t>
+              <a:t>Does the Serial lane stay?</a:t>
             </a:r>
           </a:p>
         </p:txBody>
@@ -4160,8 +4160,8 @@
         </p:nvSpPr>
         <p:spPr>
           <a:xfrm>
-            <a:off x="868680" y="3785615"/>
-            <a:ext cx="10515600" cy="384048"/>
+            <a:off x="868680" y="4187951"/>
+            <a:ext cx="10515600" cy="420624"/>
           </a:xfrm>
           <a:prstGeom prst="rect">
             <a:avLst/>
@@ -4183,7 +4183,7 @@
               </a:defRPr>
             </a:pPr>
             <a:r>
-              <a:t>CSEinit offers GCC and Intel today. The pilot input builds the system baseline only. Adding a surface is a one-line policy change, not a redesign, but it is a decision.</a:t>
+              <a:t>An MPI build run on one rank does a serial job. We keep Serial because users ask for plain builds, but it is a deliberate cost: a second build of every MPI-capable package.</a:t>
             </a:r>
           </a:p>
         </p:txBody>
@@ -4196,8 +4196,8 @@
         </p:nvSpPr>
         <p:spPr>
           <a:xfrm>
-            <a:off x="548640" y="4315968"/>
-            <a:ext cx="11091672" cy="804672"/>
+            <a:off x="548640" y="4837176"/>
+            <a:ext cx="11091672" cy="914400"/>
           </a:xfrm>
           <a:prstGeom prst="roundRect">
             <a:avLst/>
@@ -4240,168 +4240,8 @@
         </p:nvSpPr>
         <p:spPr>
           <a:xfrm>
-            <a:off x="548640" y="4315968"/>
-            <a:ext cx="91440" cy="804672"/>
-          </a:xfrm>
-          <a:prstGeom prst="rect">
-            <a:avLst/>
-          </a:prstGeom>
-          <a:solidFill>
-            <a:srgbClr val="D97706"/>
-          </a:solidFill>
-          <a:ln>
-            <a:noFill/>
-          </a:ln>
-          <a:effectLst/>
-        </p:spPr>
-        <p:style>
-          <a:lnRef idx="1">
-            <a:schemeClr val="accent1"/>
-          </a:lnRef>
-          <a:fillRef idx="3">
-            <a:schemeClr val="accent1"/>
-          </a:fillRef>
-          <a:effectRef idx="2">
-            <a:schemeClr val="accent1"/>
-          </a:effectRef>
-          <a:fontRef idx="minor">
-            <a:schemeClr val="lt1"/>
-          </a:fontRef>
-        </p:style>
-        <p:txBody>
-          <a:bodyPr rtlCol="0" anchor="ctr"/>
-          <a:lstStyle/>
-          <a:p>
-            <a:pPr algn="ctr"/>
-          </a:p>
-        </p:txBody>
-      </p:sp>
-      <p:sp>
-        <p:nvSpPr>
-          <p:cNvPr id="20" name="TextBox 19"/>
-          <p:cNvSpPr txBox="1"/>
-          <p:nvPr/>
-        </p:nvSpPr>
-        <p:spPr>
-          <a:xfrm>
-            <a:off x="868680" y="4407407"/>
-            <a:ext cx="10515600" cy="274320"/>
-          </a:xfrm>
-          <a:prstGeom prst="rect">
-            <a:avLst/>
-          </a:prstGeom>
-          <a:noFill/>
-        </p:spPr>
-        <p:txBody>
-          <a:bodyPr wrap="square" anchor="t">
-            <a:spAutoFit/>
-          </a:bodyPr>
-          <a:lstStyle/>
-          <a:p>
-            <a:pPr algn="l">
-              <a:defRPr sz="1350" b="1">
-                <a:solidFill>
-                  <a:srgbClr val="0F172A"/>
-                </a:solidFill>
-                <a:latin typeface="Avenir Next"/>
-              </a:defRPr>
-            </a:pPr>
-            <a:r>
-              <a:t>Does the Serial lane stay?</a:t>
-            </a:r>
-          </a:p>
-        </p:txBody>
-      </p:sp>
-      <p:sp>
-        <p:nvSpPr>
-          <p:cNvPr id="21" name="TextBox 20"/>
-          <p:cNvSpPr txBox="1"/>
-          <p:nvPr/>
-        </p:nvSpPr>
-        <p:spPr>
-          <a:xfrm>
-            <a:off x="868680" y="4700016"/>
-            <a:ext cx="10515600" cy="384048"/>
-          </a:xfrm>
-          <a:prstGeom prst="rect">
-            <a:avLst/>
-          </a:prstGeom>
-          <a:noFill/>
-        </p:spPr>
-        <p:txBody>
-          <a:bodyPr wrap="square" anchor="t">
-            <a:spAutoFit/>
-          </a:bodyPr>
-          <a:lstStyle/>
-          <a:p>
-            <a:pPr algn="l">
-              <a:defRPr sz="1100" b="0">
-                <a:solidFill>
-                  <a:srgbClr val="64748B"/>
-                </a:solidFill>
-                <a:latin typeface="Avenir Next"/>
-              </a:defRPr>
-            </a:pPr>
-            <a:r>
-              <a:t>An MPI build run on one rank does a serial job. We keep Serial because users ask for plain builds, but it is a deliberate cost: a second build of every MPI-capable package.</a:t>
-            </a:r>
-          </a:p>
-        </p:txBody>
-      </p:sp>
-      <p:sp>
-        <p:nvSpPr>
-          <p:cNvPr id="22" name="Rounded Rectangle 21"/>
-          <p:cNvSpPr/>
-          <p:nvPr/>
-        </p:nvSpPr>
-        <p:spPr>
-          <a:xfrm>
-            <a:off x="548640" y="5230368"/>
-            <a:ext cx="11091672" cy="804672"/>
-          </a:xfrm>
-          <a:prstGeom prst="roundRect">
-            <a:avLst/>
-          </a:prstGeom>
-          <a:solidFill>
-            <a:srgbClr val="F1F5F9"/>
-          </a:solidFill>
-          <a:ln>
-            <a:noFill/>
-          </a:ln>
-          <a:effectLst/>
-        </p:spPr>
-        <p:style>
-          <a:lnRef idx="1">
-            <a:schemeClr val="accent1"/>
-          </a:lnRef>
-          <a:fillRef idx="3">
-            <a:schemeClr val="accent1"/>
-          </a:fillRef>
-          <a:effectRef idx="2">
-            <a:schemeClr val="accent1"/>
-          </a:effectRef>
-          <a:fontRef idx="minor">
-            <a:schemeClr val="lt1"/>
-          </a:fontRef>
-        </p:style>
-        <p:txBody>
-          <a:bodyPr rtlCol="0" anchor="ctr"/>
-          <a:lstStyle/>
-          <a:p>
-            <a:pPr algn="ctr"/>
-          </a:p>
-        </p:txBody>
-      </p:sp>
-      <p:sp>
-        <p:nvSpPr>
-          <p:cNvPr id="23" name="Rectangle 22"/>
-          <p:cNvSpPr/>
-          <p:nvPr/>
-        </p:nvSpPr>
-        <p:spPr>
-          <a:xfrm>
-            <a:off x="548640" y="5230368"/>
-            <a:ext cx="91440" cy="804672"/>
+            <a:off x="548640" y="4837176"/>
+            <a:ext cx="91440" cy="914400"/>
           </a:xfrm>
           <a:prstGeom prst="rect">
             <a:avLst/>
@@ -4438,13 +4278,13 @@
       </p:sp>
       <p:sp>
         <p:nvSpPr>
-          <p:cNvPr id="24" name="TextBox 23"/>
+          <p:cNvPr id="20" name="TextBox 19"/>
           <p:cNvSpPr txBox="1"/>
           <p:nvPr/>
         </p:nvSpPr>
         <p:spPr>
           <a:xfrm>
-            <a:off x="868680" y="5321807"/>
+            <a:off x="868680" y="4965192"/>
             <a:ext cx="10515600" cy="274320"/>
           </a:xfrm>
           <a:prstGeom prst="rect">
@@ -4474,14 +4314,14 @@
       </p:sp>
       <p:sp>
         <p:nvSpPr>
-          <p:cNvPr id="25" name="TextBox 24"/>
+          <p:cNvPr id="21" name="TextBox 20"/>
           <p:cNvSpPr txBox="1"/>
           <p:nvPr/>
         </p:nvSpPr>
         <p:spPr>
           <a:xfrm>
-            <a:off x="868680" y="5614416"/>
-            <a:ext cx="10515600" cy="384048"/>
+            <a:off x="868680" y="5266944"/>
+            <a:ext cx="10515600" cy="420624"/>
           </a:xfrm>
           <a:prstGeom prst="rect">
             <a:avLst/>
@@ -4510,7 +4350,7 @@
       </p:sp>
       <p:sp>
         <p:nvSpPr>
-          <p:cNvPr id="26" name="TextBox 25"/>
+          <p:cNvPr id="22" name="TextBox 21"/>
           <p:cNvSpPr txBox="1"/>
           <p:nvPr/>
         </p:nvSpPr>
@@ -5060,7 +4900,7 @@
               </a:defRPr>
             </a:pPr>
             <a:r>
-              <a:t>openblas · netlib-lapack · gnuplot · one Serial-lane build, one install, shared module root</a:t>
+              <a:t>openblas · gnuplot · one Serial-lane build, one install, shared module root</a:t>
             </a:r>
           </a:p>
         </p:txBody>
@@ -6664,7 +6504,7 @@
         </p:nvGraphicFramePr>
         <p:xfrm>
           <a:off x="548640" y="1481328"/>
-          <a:ext cx="11091672" cy="3922776"/>
+          <a:ext cx="11091672" cy="3621024"/>
         </p:xfrm>
         <a:graphic>
           <a:graphicData uri="http://schemas.openxmlformats.org/drawingml/2006/table">
@@ -7384,81 +7224,7 @@
                         </a:defRPr>
                       </a:pPr>
                       <a:r>
-                        <a:t>performance-sensitive, so payload rather than core; the BLAS every lane links</a:t>
-                      </a:r>
-                    </a:p>
-                  </a:txBody>
-                  <a:tcPr marL="109728" marR="73152" marT="13716" marB="13716" anchor="ctr">
-                    <a:solidFill>
-                      <a:srgbClr val="FFFFFF"/>
-                    </a:solidFill>
-                  </a:tcPr>
-                </a:tc>
-              </a:tr>
-              <a:tr h="301752">
-                <a:tc>
-                  <a:txBody>
-                    <a:bodyPr/>
-                    <a:lstStyle/>
-                    <a:p>
-                      <a:pPr>
-                        <a:defRPr sz="1100" b="1">
-                          <a:solidFill>
-                            <a:srgbClr val="0F172A"/>
-                          </a:solidFill>
-                          <a:latin typeface="Avenir Next"/>
-                        </a:defRPr>
-                      </a:pPr>
-                      <a:r>
-                        <a:t>netlib-lapack</a:t>
-                      </a:r>
-                    </a:p>
-                  </a:txBody>
-                  <a:tcPr marL="109728" marR="73152" marT="13716" marB="13716" anchor="ctr">
-                    <a:solidFill>
-                      <a:srgbClr val="FFFFFF"/>
-                    </a:solidFill>
-                  </a:tcPr>
-                </a:tc>
-                <a:tc>
-                  <a:txBody>
-                    <a:bodyPr/>
-                    <a:lstStyle/>
-                    <a:p>
-                      <a:pPr>
-                        <a:defRPr sz="1100" b="0">
-                          <a:solidFill>
-                            <a:srgbClr val="334155"/>
-                          </a:solidFill>
-                          <a:latin typeface="Avenir Next"/>
-                        </a:defRPr>
-                      </a:pPr>
-                      <a:r>
-                        <a:t>3.12.1 · 3.12.0</a:t>
-                      </a:r>
-                    </a:p>
-                  </a:txBody>
-                  <a:tcPr marL="109728" marR="73152" marT="13716" marB="13716" anchor="ctr">
-                    <a:solidFill>
-                      <a:srgbClr val="FFFFFF"/>
-                    </a:solidFill>
-                  </a:tcPr>
-                </a:tc>
-                <a:tc>
-                  <a:txBody>
-                    <a:bodyPr/>
-                    <a:lstStyle/>
-                    <a:p>
-                      <a:pPr>
-                        <a:defRPr sz="1050" b="0">
-                          <a:solidFill>
-                            <a:srgbClr val="64748B"/>
-                          </a:solidFill>
-                          <a:latin typeface="Avenir Next"/>
-                        </a:defRPr>
-                      </a:pPr>
-                      <a:r>
-                        <a:t>reference LAPACK alongside openblas (flagged for team review)</a:t>
+                        <a:t>the one BLAS and LAPACK: openblas provides both APIs. Payload rather than core: performance-sensitive</a:t>
                       </a:r>
                     </a:p>
                   </a:txBody>
@@ -7771,7 +7537,7 @@
         </p:nvGraphicFramePr>
         <p:xfrm>
           <a:off x="548640" y="1481328"/>
-          <a:ext cx="11091672" cy="5129784"/>
+          <a:ext cx="11091672" cy="5125212"/>
         </p:xfrm>
         <a:graphic>
           <a:graphicData uri="http://schemas.openxmlformats.org/drawingml/2006/table">
@@ -7784,7 +7550,7 @@
                 <a:gridCol w="2286000"/>
                 <a:gridCol w="6885432"/>
               </a:tblGrid>
-              <a:tr h="301752">
+              <a:tr h="269748">
                 <a:tc>
                   <a:txBody>
                     <a:bodyPr/>
@@ -7858,7 +7624,7 @@
                   </a:tcPr>
                 </a:tc>
               </a:tr>
-              <a:tr h="301752">
+              <a:tr h="269748">
                 <a:tc gridSpan="3">
                   <a:txBody>
                     <a:bodyPr/>
@@ -7900,7 +7666,7 @@
                   <a:tcPr/>
                 </a:tc>
               </a:tr>
-              <a:tr h="301752">
+              <a:tr h="269748">
                 <a:tc>
                   <a:txBody>
                     <a:bodyPr/>
@@ -7974,7 +7740,7 @@
                   </a:tcPr>
                 </a:tc>
               </a:tr>
-              <a:tr h="301752">
+              <a:tr h="269748">
                 <a:tc>
                   <a:txBody>
                     <a:bodyPr/>
@@ -8048,7 +7814,7 @@
                   </a:tcPr>
                 </a:tc>
               </a:tr>
-              <a:tr h="301752">
+              <a:tr h="269748">
                 <a:tc>
                   <a:txBody>
                     <a:bodyPr/>
@@ -8122,7 +7888,7 @@
                   </a:tcPr>
                 </a:tc>
               </a:tr>
-              <a:tr h="301752">
+              <a:tr h="269748">
                 <a:tc>
                   <a:txBody>
                     <a:bodyPr/>
@@ -8196,7 +7962,7 @@
                   </a:tcPr>
                 </a:tc>
               </a:tr>
-              <a:tr h="301752">
+              <a:tr h="269748">
                 <a:tc gridSpan="3">
                   <a:txBody>
                     <a:bodyPr/>
@@ -8238,7 +8004,7 @@
                   <a:tcPr/>
                 </a:tc>
               </a:tr>
-              <a:tr h="301752">
+              <a:tr h="269748">
                 <a:tc>
                   <a:txBody>
                     <a:bodyPr/>
@@ -8312,7 +8078,7 @@
                   </a:tcPr>
                 </a:tc>
               </a:tr>
-              <a:tr h="301752">
+              <a:tr h="269748">
                 <a:tc>
                   <a:txBody>
                     <a:bodyPr/>
@@ -8386,7 +8152,81 @@
                   </a:tcPr>
                 </a:tc>
               </a:tr>
-              <a:tr h="301752">
+              <a:tr h="269748">
+                <a:tc>
+                  <a:txBody>
+                    <a:bodyPr/>
+                    <a:lstStyle/>
+                    <a:p>
+                      <a:pPr>
+                        <a:defRPr sz="1100" b="1">
+                          <a:solidFill>
+                            <a:srgbClr val="0F172A"/>
+                          </a:solidFill>
+                          <a:latin typeface="Avenir Next"/>
+                        </a:defRPr>
+                      </a:pPr>
+                      <a:r>
+                        <a:t>netlib-scalapack</a:t>
+                      </a:r>
+                    </a:p>
+                  </a:txBody>
+                  <a:tcPr marL="109728" marR="73152" marT="13716" marB="13716" anchor="ctr">
+                    <a:solidFill>
+                      <a:srgbClr val="FFFFFF"/>
+                    </a:solidFill>
+                  </a:tcPr>
+                </a:tc>
+                <a:tc>
+                  <a:txBody>
+                    <a:bodyPr/>
+                    <a:lstStyle/>
+                    <a:p>
+                      <a:pPr>
+                        <a:defRPr sz="1100" b="0">
+                          <a:solidFill>
+                            <a:srgbClr val="334155"/>
+                          </a:solidFill>
+                          <a:latin typeface="Avenir Next"/>
+                        </a:defRPr>
+                      </a:pPr>
+                      <a:r>
+                        <a:t>2.2.3 · 2.2.2</a:t>
+                      </a:r>
+                    </a:p>
+                  </a:txBody>
+                  <a:tcPr marL="109728" marR="73152" marT="13716" marB="13716" anchor="ctr">
+                    <a:solidFill>
+                      <a:srgbClr val="FFFFFF"/>
+                    </a:solidFill>
+                  </a:tcPr>
+                </a:tc>
+                <a:tc>
+                  <a:txBody>
+                    <a:bodyPr/>
+                    <a:lstStyle/>
+                    <a:p>
+                      <a:pPr>
+                        <a:defRPr sz="1050" b="0">
+                          <a:solidFill>
+                            <a:srgbClr val="64748B"/>
+                          </a:solidFill>
+                          <a:latin typeface="Avenir Next"/>
+                        </a:defRPr>
+                      </a:pPr>
+                      <a:r>
+                        <a:t>distributed dense solvers; MPI by nature, no serial form</a:t>
+                      </a:r>
+                    </a:p>
+                  </a:txBody>
+                  <a:tcPr marL="109728" marR="73152" marT="13716" marB="13716" anchor="ctr">
+                    <a:solidFill>
+                      <a:srgbClr val="FFFFFF"/>
+                    </a:solidFill>
+                  </a:tcPr>
+                </a:tc>
+              </a:tr>
+              <a:tr h="269748">
                 <a:tc>
                   <a:txBody>
                     <a:bodyPr/>
@@ -8425,7 +8265,7 @@
                         </a:defRPr>
                       </a:pPr>
                       <a:r>
-                        <a:t>2.35.1 · 2.35</a:t>
+                        <a:t>2.35.1</a:t>
                       </a:r>
                     </a:p>
                   </a:txBody>
@@ -8449,7 +8289,7 @@
                         </a:defRPr>
                       </a:pPr>
                       <a:r>
-                        <a:t>+mpi</a:t>
+                        <a:t>+mpi; one version, a tool users run</a:t>
                       </a:r>
                     </a:p>
                   </a:txBody>
@@ -8460,7 +8300,7 @@
                   </a:tcPr>
                 </a:tc>
               </a:tr>
-              <a:tr h="301752">
+              <a:tr h="269748">
                 <a:tc>
                   <a:txBody>
                     <a:bodyPr/>
@@ -8534,7 +8374,7 @@
                   </a:tcPr>
                 </a:tc>
               </a:tr>
-              <a:tr h="301752">
+              <a:tr h="269748">
                 <a:tc gridSpan="3">
                   <a:txBody>
                     <a:bodyPr/>
@@ -8576,7 +8416,81 @@
                   <a:tcPr/>
                 </a:tc>
               </a:tr>
-              <a:tr h="301752">
+              <a:tr h="269748">
+                <a:tc>
+                  <a:txBody>
+                    <a:bodyPr/>
+                    <a:lstStyle/>
+                    <a:p>
+                      <a:pPr>
+                        <a:defRPr sz="1100" b="1">
+                          <a:solidFill>
+                            <a:srgbClr val="0F172A"/>
+                          </a:solidFill>
+                          <a:latin typeface="Avenir Next"/>
+                        </a:defRPr>
+                      </a:pPr>
+                      <a:r>
+                        <a:t>tau</a:t>
+                      </a:r>
+                    </a:p>
+                  </a:txBody>
+                  <a:tcPr marL="109728" marR="73152" marT="13716" marB="13716" anchor="ctr">
+                    <a:solidFill>
+                      <a:srgbClr val="FFFFFF"/>
+                    </a:solidFill>
+                  </a:tcPr>
+                </a:tc>
+                <a:tc>
+                  <a:txBody>
+                    <a:bodyPr/>
+                    <a:lstStyle/>
+                    <a:p>
+                      <a:pPr>
+                        <a:defRPr sz="1100" b="0">
+                          <a:solidFill>
+                            <a:srgbClr val="334155"/>
+                          </a:solidFill>
+                          <a:latin typeface="Avenir Next"/>
+                        </a:defRPr>
+                      </a:pPr>
+                      <a:r>
+                        <a:t>2.35.1</a:t>
+                      </a:r>
+                    </a:p>
+                  </a:txBody>
+                  <a:tcPr marL="109728" marR="73152" marT="13716" marB="13716" anchor="ctr">
+                    <a:solidFill>
+                      <a:srgbClr val="FFFFFF"/>
+                    </a:solidFill>
+                  </a:tcPr>
+                </a:tc>
+                <a:tc>
+                  <a:txBody>
+                    <a:bodyPr/>
+                    <a:lstStyle/>
+                    <a:p>
+                      <a:pPr>
+                        <a:defRPr sz="1050" b="0">
+                          <a:solidFill>
+                            <a:srgbClr val="64748B"/>
+                          </a:solidFill>
+                          <a:latin typeface="Avenir Next"/>
+                        </a:defRPr>
+                      </a:pPr>
+                      <a:r>
+                        <a:t>+mpi +gpu_runtime: its own build, so it can see kernels as well as MPI</a:t>
+                      </a:r>
+                    </a:p>
+                  </a:txBody>
+                  <a:tcPr marL="109728" marR="73152" marT="13716" marB="13716" anchor="ctr">
+                    <a:solidFill>
+                      <a:srgbClr val="FFFFFF"/>
+                    </a:solidFill>
+                  </a:tcPr>
+                </a:tc>
+              </a:tr>
+              <a:tr h="269748">
                 <a:tc>
                   <a:txBody>
                     <a:bodyPr/>
@@ -8650,7 +8564,7 @@
                   </a:tcPr>
                 </a:tc>
               </a:tr>
-              <a:tr h="301752">
+              <a:tr h="269748">
                 <a:tc gridSpan="3">
                   <a:txBody>
                     <a:bodyPr/>
@@ -8692,7 +8606,7 @@
                   <a:tcPr/>
                 </a:tc>
               </a:tr>
-              <a:tr h="301752">
+              <a:tr h="269748">
                 <a:tc>
                   <a:txBody>
                     <a:bodyPr/>
@@ -8755,7 +8669,7 @@
                         </a:defRPr>
                       </a:pPr>
                       <a:r>
-                        <a:t>openblas · netlib-lapack · gnuplot: the same modules through the shared root, nothing rebuilt</a:t>
+                        <a:t>openblas · gnuplot: the same modules through the shared root, nothing rebuilt</a:t>
                       </a:r>
                     </a:p>
                   </a:txBody>
@@ -8766,7 +8680,7 @@
                   </a:tcPr>
                 </a:tc>
               </a:tr>
-              <a:tr h="301752">
+              <a:tr h="269748">
                 <a:tc gridSpan="3">
                   <a:txBody>
                     <a:bodyPr/>
@@ -8808,7 +8722,7 @@
                   <a:tcPr/>
                 </a:tc>
               </a:tr>
-              <a:tr h="301752">
+              <a:tr h="269748">
                 <a:tc>
                   <a:txBody>
                     <a:bodyPr/>

</xml_diff>

<commit_message>
Sharpen the open questions; expand why the Serial tier exists
The compiler-surface item said the pilot builds the baseline only. That
described a local test input rather than the plan: the pilot carries two
surfaces per system, and the open part is whether Intel is one of them
where the machine has it.

Performance targeting is a plan, not a question. It now reads as one:
baseline everywhere first, per-lane tuning after, with the timing open.

The Serial item said only that users ask for plain builds. The lane model
now records the actual argument: an MPI-enabled library brings the MPI
runtime with it, and on a Cray the whole platform chain behind it, which
a login-node analysis job or a small tool has no use for. The counter is
stated too, since dropping the tier would halve the build matrix for
every MPI-capable package at the cost of putting the MPI runtime on
everyone.
</commit_message>
<xml_diff>
--- a/presentations/cse_lanes_model.pptx
+++ b/presentations/cse_lanes_model.pptx
@@ -3717,7 +3717,7 @@
         <p:spPr>
           <a:xfrm>
             <a:off x="548640" y="1600200"/>
-            <a:ext cx="11091672" cy="914400"/>
+            <a:ext cx="11091672" cy="987552"/>
           </a:xfrm>
           <a:prstGeom prst="roundRect">
             <a:avLst/>
@@ -3761,7 +3761,7 @@
         <p:spPr>
           <a:xfrm>
             <a:off x="548640" y="1600200"/>
-            <a:ext cx="91440" cy="914400"/>
+            <a:ext cx="91440" cy="987552"/>
           </a:xfrm>
           <a:prstGeom prst="rect">
             <a:avLst/>
@@ -3840,8 +3840,8 @@
         </p:nvSpPr>
         <p:spPr>
           <a:xfrm>
-            <a:off x="868680" y="2029967"/>
-            <a:ext cx="10515600" cy="420624"/>
+            <a:off x="868680" y="2011680"/>
+            <a:ext cx="10515600" cy="530352"/>
           </a:xfrm>
           <a:prstGeom prst="rect">
             <a:avLst/>
@@ -3877,7 +3877,7 @@
         <p:spPr>
           <a:xfrm>
             <a:off x="548640" y="2679191"/>
-            <a:ext cx="11091672" cy="914400"/>
+            <a:ext cx="11091672" cy="987552"/>
           </a:xfrm>
           <a:prstGeom prst="roundRect">
             <a:avLst/>
@@ -3921,7 +3921,7 @@
         <p:spPr>
           <a:xfrm>
             <a:off x="548640" y="2679191"/>
-            <a:ext cx="91440" cy="914400"/>
+            <a:ext cx="91440" cy="987552"/>
           </a:xfrm>
           <a:prstGeom prst="rect">
             <a:avLst/>
@@ -3987,7 +3987,7 @@
               </a:defRPr>
             </a:pPr>
             <a:r>
-              <a:t>How many compiler surfaces per system?</a:t>
+              <a:t>Which compiler surfaces does the pilot carry?</a:t>
             </a:r>
           </a:p>
         </p:txBody>
@@ -4000,8 +4000,8 @@
         </p:nvSpPr>
         <p:spPr>
           <a:xfrm>
-            <a:off x="868680" y="3108959"/>
-            <a:ext cx="10515600" cy="420624"/>
+            <a:off x="868680" y="3090672"/>
+            <a:ext cx="10515600" cy="530352"/>
           </a:xfrm>
           <a:prstGeom prst="rect">
             <a:avLst/>
@@ -4023,7 +4023,7 @@
               </a:defRPr>
             </a:pPr>
             <a:r>
-              <a:t>CSEinit offers GCC and Intel today. The pilot input builds the system baseline only. Adding a surface is a one-line policy change, not a redesign, but it is a decision.</a:t>
+              <a:t>The pilot carries two per system: the one the machine blesses as its baseline, plus GCC as the portable reference. CSEinit offers GCC and Intel today, so whether Intel is one of the two on the systems that have it is the open part.</a:t>
             </a:r>
           </a:p>
         </p:txBody>
@@ -4037,7 +4037,7 @@
         <p:spPr>
           <a:xfrm>
             <a:off x="548640" y="3758183"/>
-            <a:ext cx="11091672" cy="914400"/>
+            <a:ext cx="11091672" cy="987552"/>
           </a:xfrm>
           <a:prstGeom prst="roundRect">
             <a:avLst/>
@@ -4081,7 +4081,7 @@
         <p:spPr>
           <a:xfrm>
             <a:off x="548640" y="3758183"/>
-            <a:ext cx="91440" cy="914400"/>
+            <a:ext cx="91440" cy="987552"/>
           </a:xfrm>
           <a:prstGeom prst="rect">
             <a:avLst/>
@@ -4160,8 +4160,8 @@
         </p:nvSpPr>
         <p:spPr>
           <a:xfrm>
-            <a:off x="868680" y="4187951"/>
-            <a:ext cx="10515600" cy="420624"/>
+            <a:off x="868680" y="4169663"/>
+            <a:ext cx="10515600" cy="530352"/>
           </a:xfrm>
           <a:prstGeom prst="rect">
             <a:avLst/>
@@ -4183,7 +4183,7 @@
               </a:defRPr>
             </a:pPr>
             <a:r>
-              <a:t>An MPI build run on one rank does a serial job. We keep Serial because users ask for plain builds, but it is a deliberate cost: a second build of every MPI-capable package.</a:t>
+              <a:t>Serial exists so users who are not running parallel do not carry the MPI runtime: analysis and post-processing on a login node, small tools, anything linking HDF5 or NetCDF without wanting libmpi behind it. An MPI build on one rank does the same work, so dropping Serial would halve the build matrix and push the MPI runtime onto everyone.</a:t>
             </a:r>
           </a:p>
         </p:txBody>
@@ -4197,7 +4197,7 @@
         <p:spPr>
           <a:xfrm>
             <a:off x="548640" y="4837176"/>
-            <a:ext cx="11091672" cy="914400"/>
+            <a:ext cx="11091672" cy="987552"/>
           </a:xfrm>
           <a:prstGeom prst="roundRect">
             <a:avLst/>
@@ -4241,7 +4241,7 @@
         <p:spPr>
           <a:xfrm>
             <a:off x="548640" y="4837176"/>
-            <a:ext cx="91440" cy="914400"/>
+            <a:ext cx="91440" cy="987552"/>
           </a:xfrm>
           <a:prstGeom prst="rect">
             <a:avLst/>
@@ -4307,7 +4307,7 @@
               </a:defRPr>
             </a:pPr>
             <a:r>
-              <a:t>When do we turn on performance targeting?</a:t>
+              <a:t>Performance targeting: baseline first, tuning after.</a:t>
             </a:r>
           </a:p>
         </p:txBody>
@@ -4320,8 +4320,8 @@
         </p:nvSpPr>
         <p:spPr>
           <a:xfrm>
-            <a:off x="868680" y="5266944"/>
-            <a:ext cx="10515600" cy="420624"/>
+            <a:off x="868680" y="5248656"/>
+            <a:ext cx="10515600" cy="530352"/>
           </a:xfrm>
           <a:prstGeom prst="rect">
             <a:avLst/>
@@ -4343,7 +4343,7 @@
               </a:defRPr>
             </a:pPr>
             <a:r>
-              <a:t>Everything builds at the portable baseline today. Tuning for Genoa, Milan, or Cascade Lake is a per-lane flag plus a full rebuild, so it is a scheduling question, not a design one.</a:t>
+              <a:t>The plan is to build every lane at the portable baseline, prove the model, then turn on per-lane tuning for Genoa, Milan, or Cascade Lake. Each target is a flag plus a full rebuild, so the open part is when, not whether.</a:t>
             </a:r>
           </a:p>
         </p:txBody>

</xml_diff>

<commit_message>
Deck: replace the status slide with the plan; trim conversational footnotes
The status slide spent half its space on work already done, which the
audience does not need itemised. It is now four numbered steps: build the
pilot stack, prove the module contract, stand up the release process,
settle the open decisions. It sits after the systems slide, so the deck
reads model, systems, plan, questions.

The systems footnote explained our AI/ML versus MLA labelling and where
Fran's accelerator detail came from. Both were artefacts of working out
the slide rather than anything the audience needs; a plain source line
replaces them.
</commit_message>
<xml_diff>
--- a/presentations/cse_lanes_model.pptx
+++ b/presentations/cse_lanes_model.pptx
@@ -17357,7 +17357,7 @@
               </a:defRPr>
             </a:pPr>
             <a:r>
-              <a:t>AI/ML is this deck's label for each site's accelerated node type (named MLA on Raider and Wheat). Source: centers.hpc.mil hardware inventory, July 2026; Fran accelerator detail from program info.</a:t>
+              <a:t>Source: HPC Centers hardware inventory, July 2026</a:t>
             </a:r>
           </a:p>
         </p:txBody>
@@ -17455,7 +17455,7 @@
               </a:defRPr>
             </a:pPr>
             <a:r>
-              <a:t>WHERE THE PIPELINE IS TODAY</a:t>
+              <a:t>THE PLAN FROM HERE</a:t>
             </a:r>
           </a:p>
         </p:txBody>
@@ -17491,7 +17491,7 @@
               </a:defRPr>
             </a:pPr>
             <a:r>
-              <a:t>Status and next steps</a:t>
+              <a:t>What happens next</a:t>
             </a:r>
           </a:p>
         </p:txBody>
@@ -17549,7 +17549,7 @@
         <p:spPr>
           <a:xfrm>
             <a:off x="548640" y="1645920"/>
-            <a:ext cx="5440680" cy="4480560"/>
+            <a:ext cx="11091672" cy="1051560"/>
           </a:xfrm>
           <a:prstGeom prst="roundRect">
             <a:avLst/>
@@ -17586,14 +17586,68 @@
       </p:sp>
       <p:sp>
         <p:nvSpPr>
-          <p:cNvPr id="7" name="TextBox 6"/>
+          <p:cNvPr id="7" name="Rounded Rectangle 6"/>
+          <p:cNvSpPr/>
+          <p:nvPr/>
+        </p:nvSpPr>
+        <p:spPr>
+          <a:xfrm>
+            <a:off x="548640" y="1645920"/>
+            <a:ext cx="566928" cy="1051560"/>
+          </a:xfrm>
+          <a:prstGeom prst="roundRect">
+            <a:avLst/>
+          </a:prstGeom>
+          <a:solidFill>
+            <a:srgbClr val="0D9488"/>
+          </a:solidFill>
+          <a:ln>
+            <a:noFill/>
+          </a:ln>
+          <a:effectLst/>
+        </p:spPr>
+        <p:style>
+          <a:lnRef idx="1">
+            <a:schemeClr val="accent1"/>
+          </a:lnRef>
+          <a:fillRef idx="3">
+            <a:schemeClr val="accent1"/>
+          </a:fillRef>
+          <a:effectRef idx="2">
+            <a:schemeClr val="accent1"/>
+          </a:effectRef>
+          <a:fontRef idx="minor">
+            <a:schemeClr val="lt1"/>
+          </a:fontRef>
+        </p:style>
+        <p:txBody>
+          <a:bodyPr rtlCol="0" anchor="ctr" wrap="square" lIns="109728" rIns="109728"/>
+          <a:lstStyle/>
+          <a:p>
+            <a:pPr algn="ctr">
+              <a:defRPr sz="1900" b="1">
+                <a:solidFill>
+                  <a:srgbClr val="FFFFFF"/>
+                </a:solidFill>
+                <a:latin typeface="Avenir Next"/>
+              </a:defRPr>
+            </a:pPr>
+            <a:r>
+              <a:t>1</a:t>
+            </a:r>
+          </a:p>
+        </p:txBody>
+      </p:sp>
+      <p:sp>
+        <p:nvSpPr>
+          <p:cNvPr id="8" name="TextBox 7"/>
           <p:cNvSpPr txBox="1"/>
           <p:nvPr/>
         </p:nvSpPr>
         <p:spPr>
           <a:xfrm>
-            <a:off x="822960" y="1828800"/>
-            <a:ext cx="4937760" cy="457200"/>
+            <a:off x="1325880" y="1810512"/>
+            <a:ext cx="10058400" cy="310896"/>
           </a:xfrm>
           <a:prstGeom prst="rect">
             <a:avLst/>
@@ -17607,29 +17661,29 @@
           <a:lstStyle/>
           <a:p>
             <a:pPr algn="l">
-              <a:defRPr sz="1700" b="1">
-                <a:solidFill>
-                  <a:srgbClr val="15803D"/>
-                </a:solidFill>
-                <a:latin typeface="Avenir Next"/>
-              </a:defRPr>
-            </a:pPr>
-            <a:r>
-              <a:t>Done</a:t>
-            </a:r>
-          </a:p>
-        </p:txBody>
-      </p:sp>
-      <p:sp>
-        <p:nvSpPr>
-          <p:cNvPr id="8" name="TextBox 7"/>
+              <a:defRPr sz="1550" b="1">
+                <a:solidFill>
+                  <a:srgbClr val="0F172A"/>
+                </a:solidFill>
+                <a:latin typeface="Avenir Next"/>
+              </a:defRPr>
+            </a:pPr>
+            <a:r>
+              <a:t>Build the pilot stack on the four systems</a:t>
+            </a:r>
+          </a:p>
+        </p:txBody>
+      </p:sp>
+      <p:sp>
+        <p:nvSpPr>
+          <p:cNvPr id="9" name="TextBox 8"/>
           <p:cNvSpPr txBox="1"/>
           <p:nvPr/>
         </p:nvSpPr>
         <p:spPr>
           <a:xfrm>
-            <a:off x="822960" y="2377440"/>
-            <a:ext cx="365760" cy="457200"/>
+            <a:off x="1325880" y="2176272"/>
+            <a:ext cx="10058400" cy="420624"/>
           </a:xfrm>
           <a:prstGeom prst="rect">
             <a:avLst/>
@@ -17643,209 +17697,29 @@
           <a:lstStyle/>
           <a:p>
             <a:pPr algn="l">
-              <a:defRPr sz="1600" b="1">
-                <a:solidFill>
-                  <a:srgbClr val="15803D"/>
-                </a:solidFill>
-                <a:latin typeface="Avenir Next"/>
-              </a:defRPr>
-            </a:pPr>
-            <a:r>
-              <a:t>✓</a:t>
-            </a:r>
-          </a:p>
-        </p:txBody>
-      </p:sp>
-      <p:sp>
-        <p:nvSpPr>
-          <p:cNvPr id="9" name="TextBox 8"/>
-          <p:cNvSpPr txBox="1"/>
-          <p:nvPr/>
-        </p:nvSpPr>
-        <p:spPr>
-          <a:xfrm>
-            <a:off x="1234440" y="2377440"/>
-            <a:ext cx="4526280" cy="1005840"/>
-          </a:xfrm>
-          <a:prstGeom prst="rect">
-            <a:avLst/>
-          </a:prstGeom>
-          <a:noFill/>
-        </p:spPr>
-        <p:txBody>
-          <a:bodyPr wrap="square" anchor="t">
-            <a:spAutoFit/>
-          </a:bodyPr>
-          <a:lstStyle/>
-          <a:p>
-            <a:pPr algn="l">
-              <a:defRPr sz="1300" b="0">
-                <a:solidFill>
-                  <a:srgbClr val="334155"/>
-                </a:solidFill>
-                <a:latin typeface="Avenir Next"/>
-              </a:defRPr>
-            </a:pPr>
-            <a:r>
-              <a:t>End-to-end Cray smoke: probe → render → concretize → build (PrgEnv-gnu · cray-mpich · ROCm)</a:t>
-            </a:r>
-          </a:p>
-        </p:txBody>
-      </p:sp>
-      <p:sp>
-        <p:nvSpPr>
-          <p:cNvPr id="10" name="TextBox 9"/>
-          <p:cNvSpPr txBox="1"/>
-          <p:nvPr/>
-        </p:nvSpPr>
-        <p:spPr>
-          <a:xfrm>
-            <a:off x="822960" y="3429000"/>
-            <a:ext cx="365760" cy="457200"/>
-          </a:xfrm>
-          <a:prstGeom prst="rect">
-            <a:avLst/>
-          </a:prstGeom>
-          <a:noFill/>
-        </p:spPr>
-        <p:txBody>
-          <a:bodyPr wrap="square" anchor="t">
-            <a:spAutoFit/>
-          </a:bodyPr>
-          <a:lstStyle/>
-          <a:p>
-            <a:pPr algn="l">
-              <a:defRPr sz="1600" b="1">
-                <a:solidFill>
-                  <a:srgbClr val="15803D"/>
-                </a:solidFill>
-                <a:latin typeface="Avenir Next"/>
-              </a:defRPr>
-            </a:pPr>
-            <a:r>
-              <a:t>✓</a:t>
-            </a:r>
-          </a:p>
-        </p:txBody>
-      </p:sp>
-      <p:sp>
-        <p:nvSpPr>
-          <p:cNvPr id="11" name="TextBox 10"/>
-          <p:cNvSpPr txBox="1"/>
-          <p:nvPr/>
-        </p:nvSpPr>
-        <p:spPr>
-          <a:xfrm>
-            <a:off x="1234440" y="3429000"/>
-            <a:ext cx="4526280" cy="1005840"/>
-          </a:xfrm>
-          <a:prstGeom prst="rect">
-            <a:avLst/>
-          </a:prstGeom>
-          <a:noFill/>
-        </p:spPr>
-        <p:txBody>
-          <a:bodyPr wrap="square" anchor="t">
-            <a:spAutoFit/>
-          </a:bodyPr>
-          <a:lstStyle/>
-          <a:p>
-            <a:pPr algn="l">
-              <a:defRPr sz="1300" b="0">
-                <a:solidFill>
-                  <a:srgbClr val="334155"/>
-                </a:solidFill>
-                <a:latin typeface="Avenir Next"/>
-              </a:defRPr>
-            </a:pPr>
-            <a:r>
-              <a:t>Second system validated the generic-Linux path and hardened the prober</a:t>
-            </a:r>
-          </a:p>
-        </p:txBody>
-      </p:sp>
-      <p:sp>
-        <p:nvSpPr>
-          <p:cNvPr id="12" name="TextBox 11"/>
-          <p:cNvSpPr txBox="1"/>
-          <p:nvPr/>
-        </p:nvSpPr>
-        <p:spPr>
-          <a:xfrm>
-            <a:off x="822960" y="4480560"/>
-            <a:ext cx="365760" cy="457200"/>
-          </a:xfrm>
-          <a:prstGeom prst="rect">
-            <a:avLst/>
-          </a:prstGeom>
-          <a:noFill/>
-        </p:spPr>
-        <p:txBody>
-          <a:bodyPr wrap="square" anchor="t">
-            <a:spAutoFit/>
-          </a:bodyPr>
-          <a:lstStyle/>
-          <a:p>
-            <a:pPr algn="l">
-              <a:defRPr sz="1600" b="1">
-                <a:solidFill>
-                  <a:srgbClr val="15803D"/>
-                </a:solidFill>
-                <a:latin typeface="Avenir Next"/>
-              </a:defRPr>
-            </a:pPr>
-            <a:r>
-              <a:t>✓</a:t>
-            </a:r>
-          </a:p>
-        </p:txBody>
-      </p:sp>
-      <p:sp>
-        <p:nvSpPr>
-          <p:cNvPr id="13" name="TextBox 12"/>
-          <p:cNvSpPr txBox="1"/>
-          <p:nvPr/>
-        </p:nvSpPr>
-        <p:spPr>
-          <a:xfrm>
-            <a:off x="1234440" y="4480560"/>
-            <a:ext cx="4526280" cy="1005840"/>
-          </a:xfrm>
-          <a:prstGeom prst="rect">
-            <a:avLst/>
-          </a:prstGeom>
-          <a:noFill/>
-        </p:spPr>
-        <p:txBody>
-          <a:bodyPr wrap="square" anchor="t">
-            <a:spAutoFit/>
-          </a:bodyPr>
-          <a:lstStyle/>
-          <a:p>
-            <a:pPr algn="l">
-              <a:defRPr sz="1300" b="0">
-                <a:solidFill>
-                  <a:srgbClr val="334155"/>
-                </a:solidFill>
-                <a:latin typeface="Avenir Next"/>
-              </a:defRPr>
-            </a:pPr>
-            <a:r>
-              <a:t>Pilot stack renders clean today: four lanes, two-version roster</a:t>
-            </a:r>
-          </a:p>
-        </p:txBody>
-      </p:sp>
-      <p:sp>
-        <p:nvSpPr>
-          <p:cNvPr id="14" name="Rounded Rectangle 13"/>
+              <a:defRPr sz="1150" b="0">
+                <a:solidFill>
+                  <a:srgbClr val="64748B"/>
+                </a:solidFill>
+                <a:latin typeface="Avenir Next"/>
+              </a:defRPr>
+            </a:pPr>
+            <a:r>
+              <a:t>Probe each machine, render its lanes, concretize, install. The front door is the first real test of the naming: one compiler surface, then one lane, then a package.</a:t>
+            </a:r>
+          </a:p>
+        </p:txBody>
+      </p:sp>
+      <p:sp>
+        <p:nvSpPr>
+          <p:cNvPr id="10" name="Rounded Rectangle 9"/>
           <p:cNvSpPr/>
           <p:nvPr/>
         </p:nvSpPr>
         <p:spPr>
           <a:xfrm>
-            <a:off x="6263640" y="1645920"/>
-            <a:ext cx="5349240" cy="4480560"/>
+            <a:off x="548640" y="2852928"/>
+            <a:ext cx="11091672" cy="1051560"/>
           </a:xfrm>
           <a:prstGeom prst="roundRect">
             <a:avLst/>
@@ -17882,14 +17756,68 @@
       </p:sp>
       <p:sp>
         <p:nvSpPr>
-          <p:cNvPr id="15" name="TextBox 14"/>
+          <p:cNvPr id="11" name="Rounded Rectangle 10"/>
+          <p:cNvSpPr/>
+          <p:nvPr/>
+        </p:nvSpPr>
+        <p:spPr>
+          <a:xfrm>
+            <a:off x="548640" y="2852928"/>
+            <a:ext cx="566928" cy="1051560"/>
+          </a:xfrm>
+          <a:prstGeom prst="roundRect">
+            <a:avLst/>
+          </a:prstGeom>
+          <a:solidFill>
+            <a:srgbClr val="2563EB"/>
+          </a:solidFill>
+          <a:ln>
+            <a:noFill/>
+          </a:ln>
+          <a:effectLst/>
+        </p:spPr>
+        <p:style>
+          <a:lnRef idx="1">
+            <a:schemeClr val="accent1"/>
+          </a:lnRef>
+          <a:fillRef idx="3">
+            <a:schemeClr val="accent1"/>
+          </a:fillRef>
+          <a:effectRef idx="2">
+            <a:schemeClr val="accent1"/>
+          </a:effectRef>
+          <a:fontRef idx="minor">
+            <a:schemeClr val="lt1"/>
+          </a:fontRef>
+        </p:style>
+        <p:txBody>
+          <a:bodyPr rtlCol="0" anchor="ctr" wrap="square" lIns="109728" rIns="109728"/>
+          <a:lstStyle/>
+          <a:p>
+            <a:pPr algn="ctr">
+              <a:defRPr sz="1900" b="1">
+                <a:solidFill>
+                  <a:srgbClr val="FFFFFF"/>
+                </a:solidFill>
+                <a:latin typeface="Avenir Next"/>
+              </a:defRPr>
+            </a:pPr>
+            <a:r>
+              <a:t>2</a:t>
+            </a:r>
+          </a:p>
+        </p:txBody>
+      </p:sp>
+      <p:sp>
+        <p:nvSpPr>
+          <p:cNvPr id="12" name="TextBox 11"/>
           <p:cNvSpPr txBox="1"/>
           <p:nvPr/>
         </p:nvSpPr>
         <p:spPr>
           <a:xfrm>
-            <a:off x="6537960" y="1828800"/>
-            <a:ext cx="4846320" cy="457200"/>
+            <a:off x="1325880" y="3017520"/>
+            <a:ext cx="10058400" cy="310896"/>
           </a:xfrm>
           <a:prstGeom prst="rect">
             <a:avLst/>
@@ -17903,29 +17831,29 @@
           <a:lstStyle/>
           <a:p>
             <a:pPr algn="l">
-              <a:defRPr sz="1700" b="1">
-                <a:solidFill>
-                  <a:srgbClr val="D97706"/>
-                </a:solidFill>
-                <a:latin typeface="Avenir Next"/>
-              </a:defRPr>
-            </a:pPr>
-            <a:r>
-              <a:t>Next</a:t>
-            </a:r>
-          </a:p>
-        </p:txBody>
-      </p:sp>
-      <p:sp>
-        <p:nvSpPr>
-          <p:cNvPr id="16" name="TextBox 15"/>
+              <a:defRPr sz="1550" b="1">
+                <a:solidFill>
+                  <a:srgbClr val="0F172A"/>
+                </a:solidFill>
+                <a:latin typeface="Avenir Next"/>
+              </a:defRPr>
+            </a:pPr>
+            <a:r>
+              <a:t>Prove the module contract</a:t>
+            </a:r>
+          </a:p>
+        </p:txBody>
+      </p:sp>
+      <p:sp>
+        <p:nvSpPr>
+          <p:cNvPr id="13" name="TextBox 12"/>
           <p:cNvSpPr txBox="1"/>
           <p:nvPr/>
         </p:nvSpPr>
         <p:spPr>
           <a:xfrm>
-            <a:off x="6537960" y="2377440"/>
-            <a:ext cx="365760" cy="457200"/>
+            <a:off x="1325880" y="3383280"/>
+            <a:ext cx="10058400" cy="420624"/>
           </a:xfrm>
           <a:prstGeom prst="rect">
             <a:avLst/>
@@ -17939,29 +17867,127 @@
           <a:lstStyle/>
           <a:p>
             <a:pPr algn="l">
-              <a:defRPr sz="1600" b="1">
-                <a:solidFill>
-                  <a:srgbClr val="D97706"/>
-                </a:solidFill>
-                <a:latin typeface="Avenir Next"/>
-              </a:defRPr>
-            </a:pPr>
-            <a:r>
-              <a:t>→</a:t>
-            </a:r>
-          </a:p>
-        </p:txBody>
-      </p:sp>
-      <p:sp>
-        <p:nvSpPr>
-          <p:cNvPr id="17" name="TextBox 16"/>
+              <a:defRPr sz="1150" b="0">
+                <a:solidFill>
+                  <a:srgbClr val="64748B"/>
+                </a:solidFill>
+                <a:latin typeface="Avenir Next"/>
+              </a:defRPr>
+            </a:pPr>
+            <a:r>
+              <a:t>Compatible chains load and incompatible mixes fail. Lane purity and version pairing are checked in the concretized lockfile, never assumed from the render.</a:t>
+            </a:r>
+          </a:p>
+        </p:txBody>
+      </p:sp>
+      <p:sp>
+        <p:nvSpPr>
+          <p:cNvPr id="14" name="Rounded Rectangle 13"/>
+          <p:cNvSpPr/>
+          <p:nvPr/>
+        </p:nvSpPr>
+        <p:spPr>
+          <a:xfrm>
+            <a:off x="548640" y="4059936"/>
+            <a:ext cx="11091672" cy="1051560"/>
+          </a:xfrm>
+          <a:prstGeom prst="roundRect">
+            <a:avLst/>
+          </a:prstGeom>
+          <a:solidFill>
+            <a:srgbClr val="F1F5F9"/>
+          </a:solidFill>
+          <a:ln>
+            <a:noFill/>
+          </a:ln>
+          <a:effectLst/>
+        </p:spPr>
+        <p:style>
+          <a:lnRef idx="1">
+            <a:schemeClr val="accent1"/>
+          </a:lnRef>
+          <a:fillRef idx="3">
+            <a:schemeClr val="accent1"/>
+          </a:fillRef>
+          <a:effectRef idx="2">
+            <a:schemeClr val="accent1"/>
+          </a:effectRef>
+          <a:fontRef idx="minor">
+            <a:schemeClr val="lt1"/>
+          </a:fontRef>
+        </p:style>
+        <p:txBody>
+          <a:bodyPr rtlCol="0" anchor="ctr"/>
+          <a:lstStyle/>
+          <a:p>
+            <a:pPr algn="ctr"/>
+          </a:p>
+        </p:txBody>
+      </p:sp>
+      <p:sp>
+        <p:nvSpPr>
+          <p:cNvPr id="15" name="Rounded Rectangle 14"/>
+          <p:cNvSpPr/>
+          <p:nvPr/>
+        </p:nvSpPr>
+        <p:spPr>
+          <a:xfrm>
+            <a:off x="548640" y="4059936"/>
+            <a:ext cx="566928" cy="1051560"/>
+          </a:xfrm>
+          <a:prstGeom prst="roundRect">
+            <a:avLst/>
+          </a:prstGeom>
+          <a:solidFill>
+            <a:srgbClr val="7C3AED"/>
+          </a:solidFill>
+          <a:ln>
+            <a:noFill/>
+          </a:ln>
+          <a:effectLst/>
+        </p:spPr>
+        <p:style>
+          <a:lnRef idx="1">
+            <a:schemeClr val="accent1"/>
+          </a:lnRef>
+          <a:fillRef idx="3">
+            <a:schemeClr val="accent1"/>
+          </a:fillRef>
+          <a:effectRef idx="2">
+            <a:schemeClr val="accent1"/>
+          </a:effectRef>
+          <a:fontRef idx="minor">
+            <a:schemeClr val="lt1"/>
+          </a:fontRef>
+        </p:style>
+        <p:txBody>
+          <a:bodyPr rtlCol="0" anchor="ctr" wrap="square" lIns="109728" rIns="109728"/>
+          <a:lstStyle/>
+          <a:p>
+            <a:pPr algn="ctr">
+              <a:defRPr sz="1900" b="1">
+                <a:solidFill>
+                  <a:srgbClr val="FFFFFF"/>
+                </a:solidFill>
+                <a:latin typeface="Avenir Next"/>
+              </a:defRPr>
+            </a:pPr>
+            <a:r>
+              <a:t>3</a:t>
+            </a:r>
+          </a:p>
+        </p:txBody>
+      </p:sp>
+      <p:sp>
+        <p:nvSpPr>
+          <p:cNvPr id="16" name="TextBox 15"/>
           <p:cNvSpPr txBox="1"/>
           <p:nvPr/>
         </p:nvSpPr>
         <p:spPr>
           <a:xfrm>
-            <a:off x="6949440" y="2377440"/>
-            <a:ext cx="4434840" cy="1005840"/>
+            <a:off x="1325880" y="4224528"/>
+            <a:ext cx="10058400" cy="310896"/>
           </a:xfrm>
           <a:prstGeom prst="rect">
             <a:avLst/>
@@ -17975,29 +18001,29 @@
           <a:lstStyle/>
           <a:p>
             <a:pPr algn="l">
-              <a:defRPr sz="1300" b="0">
-                <a:solidFill>
-                  <a:srgbClr val="334155"/>
-                </a:solidFill>
-                <a:latin typeface="Avenir Next"/>
-              </a:defRPr>
-            </a:pPr>
-            <a:r>
-              <a:t>Build the pilot stack on Fran, Wheat, Raider, and Blueback; verify the module/view front door</a:t>
-            </a:r>
-          </a:p>
-        </p:txBody>
-      </p:sp>
-      <p:sp>
-        <p:nvSpPr>
-          <p:cNvPr id="18" name="TextBox 17"/>
+              <a:defRPr sz="1550" b="1">
+                <a:solidFill>
+                  <a:srgbClr val="0F172A"/>
+                </a:solidFill>
+                <a:latin typeface="Avenir Next"/>
+              </a:defRPr>
+            </a:pPr>
+            <a:r>
+              <a:t>Stand up the release process</a:t>
+            </a:r>
+          </a:p>
+        </p:txBody>
+      </p:sp>
+      <p:sp>
+        <p:nvSpPr>
+          <p:cNvPr id="17" name="TextBox 16"/>
           <p:cNvSpPr txBox="1"/>
           <p:nvPr/>
         </p:nvSpPr>
         <p:spPr>
           <a:xfrm>
-            <a:off x="6537960" y="3429000"/>
-            <a:ext cx="365760" cy="457200"/>
+            <a:off x="1325880" y="4590288"/>
+            <a:ext cx="10058400" cy="420624"/>
           </a:xfrm>
           <a:prstGeom prst="rect">
             <a:avLst/>
@@ -18011,29 +18037,127 @@
           <a:lstStyle/>
           <a:p>
             <a:pPr algn="l">
-              <a:defRPr sz="1600" b="1">
-                <a:solidFill>
-                  <a:srgbClr val="D97706"/>
-                </a:solidFill>
-                <a:latin typeface="Avenir Next"/>
-              </a:defRPr>
-            </a:pPr>
-            <a:r>
-              <a:t>→</a:t>
-            </a:r>
-          </a:p>
-        </p:txBody>
-      </p:sp>
-      <p:sp>
-        <p:nvSpPr>
-          <p:cNvPr id="19" name="TextBox 18"/>
+              <a:defRPr sz="1150" b="0">
+                <a:solidFill>
+                  <a:srgbClr val="64748B"/>
+                </a:solidFill>
+                <a:latin typeface="Avenir Next"/>
+              </a:defRPr>
+            </a:pPr>
+            <a:r>
+              <a:t>Build caches, a lockfile per lane, and a release manifest, so a release can be rebuilt exactly, promoted deliberately, and rolled back by moving a pointer.</a:t>
+            </a:r>
+          </a:p>
+        </p:txBody>
+      </p:sp>
+      <p:sp>
+        <p:nvSpPr>
+          <p:cNvPr id="18" name="Rounded Rectangle 17"/>
+          <p:cNvSpPr/>
+          <p:nvPr/>
+        </p:nvSpPr>
+        <p:spPr>
+          <a:xfrm>
+            <a:off x="548640" y="5266944"/>
+            <a:ext cx="11091672" cy="1051560"/>
+          </a:xfrm>
+          <a:prstGeom prst="roundRect">
+            <a:avLst/>
+          </a:prstGeom>
+          <a:solidFill>
+            <a:srgbClr val="F1F5F9"/>
+          </a:solidFill>
+          <a:ln>
+            <a:noFill/>
+          </a:ln>
+          <a:effectLst/>
+        </p:spPr>
+        <p:style>
+          <a:lnRef idx="1">
+            <a:schemeClr val="accent1"/>
+          </a:lnRef>
+          <a:fillRef idx="3">
+            <a:schemeClr val="accent1"/>
+          </a:fillRef>
+          <a:effectRef idx="2">
+            <a:schemeClr val="accent1"/>
+          </a:effectRef>
+          <a:fontRef idx="minor">
+            <a:schemeClr val="lt1"/>
+          </a:fontRef>
+        </p:style>
+        <p:txBody>
+          <a:bodyPr rtlCol="0" anchor="ctr"/>
+          <a:lstStyle/>
+          <a:p>
+            <a:pPr algn="ctr"/>
+          </a:p>
+        </p:txBody>
+      </p:sp>
+      <p:sp>
+        <p:nvSpPr>
+          <p:cNvPr id="19" name="Rounded Rectangle 18"/>
+          <p:cNvSpPr/>
+          <p:nvPr/>
+        </p:nvSpPr>
+        <p:spPr>
+          <a:xfrm>
+            <a:off x="548640" y="5266944"/>
+            <a:ext cx="566928" cy="1051560"/>
+          </a:xfrm>
+          <a:prstGeom prst="roundRect">
+            <a:avLst/>
+          </a:prstGeom>
+          <a:solidFill>
+            <a:srgbClr val="D97706"/>
+          </a:solidFill>
+          <a:ln>
+            <a:noFill/>
+          </a:ln>
+          <a:effectLst/>
+        </p:spPr>
+        <p:style>
+          <a:lnRef idx="1">
+            <a:schemeClr val="accent1"/>
+          </a:lnRef>
+          <a:fillRef idx="3">
+            <a:schemeClr val="accent1"/>
+          </a:fillRef>
+          <a:effectRef idx="2">
+            <a:schemeClr val="accent1"/>
+          </a:effectRef>
+          <a:fontRef idx="minor">
+            <a:schemeClr val="lt1"/>
+          </a:fontRef>
+        </p:style>
+        <p:txBody>
+          <a:bodyPr rtlCol="0" anchor="ctr" wrap="square" lIns="109728" rIns="109728"/>
+          <a:lstStyle/>
+          <a:p>
+            <a:pPr algn="ctr">
+              <a:defRPr sz="1900" b="1">
+                <a:solidFill>
+                  <a:srgbClr val="FFFFFF"/>
+                </a:solidFill>
+                <a:latin typeface="Avenir Next"/>
+              </a:defRPr>
+            </a:pPr>
+            <a:r>
+              <a:t>4</a:t>
+            </a:r>
+          </a:p>
+        </p:txBody>
+      </p:sp>
+      <p:sp>
+        <p:nvSpPr>
+          <p:cNvPr id="20" name="TextBox 19"/>
           <p:cNvSpPr txBox="1"/>
           <p:nvPr/>
         </p:nvSpPr>
         <p:spPr>
           <a:xfrm>
-            <a:off x="6949440" y="3429000"/>
-            <a:ext cx="4434840" cy="1005840"/>
+            <a:off x="1325880" y="5431536"/>
+            <a:ext cx="10058400" cy="310896"/>
           </a:xfrm>
           <a:prstGeom prst="rect">
             <a:avLst/>
@@ -18047,29 +18171,29 @@
           <a:lstStyle/>
           <a:p>
             <a:pPr algn="l">
-              <a:defRPr sz="1300" b="0">
-                <a:solidFill>
-                  <a:srgbClr val="334155"/>
-                </a:solidFill>
-                <a:latin typeface="Avenir Next"/>
-              </a:defRPr>
-            </a:pPr>
-            <a:r>
-              <a:t>Encode module compatibility checks for multi-version package chains</a:t>
-            </a:r>
-          </a:p>
-        </p:txBody>
-      </p:sp>
-      <p:sp>
-        <p:nvSpPr>
-          <p:cNvPr id="20" name="TextBox 19"/>
+              <a:defRPr sz="1550" b="1">
+                <a:solidFill>
+                  <a:srgbClr val="0F172A"/>
+                </a:solidFill>
+                <a:latin typeface="Avenir Next"/>
+              </a:defRPr>
+            </a:pPr>
+            <a:r>
+              <a:t>Settle the open decisions</a:t>
+            </a:r>
+          </a:p>
+        </p:txBody>
+      </p:sp>
+      <p:sp>
+        <p:nvSpPr>
+          <p:cNvPr id="21" name="TextBox 20"/>
           <p:cNvSpPr txBox="1"/>
           <p:nvPr/>
         </p:nvSpPr>
         <p:spPr>
           <a:xfrm>
-            <a:off x="6537960" y="4480560"/>
-            <a:ext cx="365760" cy="457200"/>
+            <a:off x="1325880" y="5797296"/>
+            <a:ext cx="10058400" cy="420624"/>
           </a:xfrm>
           <a:prstGeom prst="rect">
             <a:avLst/>
@@ -18083,51 +18207,15 @@
           <a:lstStyle/>
           <a:p>
             <a:pPr algn="l">
-              <a:defRPr sz="1600" b="1">
-                <a:solidFill>
-                  <a:srgbClr val="D97706"/>
-                </a:solidFill>
-                <a:latin typeface="Avenir Next"/>
-              </a:defRPr>
-            </a:pPr>
-            <a:r>
-              <a:t>→</a:t>
-            </a:r>
-          </a:p>
-        </p:txBody>
-      </p:sp>
-      <p:sp>
-        <p:nvSpPr>
-          <p:cNvPr id="21" name="TextBox 20"/>
-          <p:cNvSpPr txBox="1"/>
-          <p:nvPr/>
-        </p:nvSpPr>
-        <p:spPr>
-          <a:xfrm>
-            <a:off x="6949440" y="4480560"/>
-            <a:ext cx="4434840" cy="1005840"/>
-          </a:xfrm>
-          <a:prstGeom prst="rect">
-            <a:avLst/>
-          </a:prstGeom>
-          <a:noFill/>
-        </p:spPr>
-        <p:txBody>
-          <a:bodyPr wrap="square" anchor="t">
-            <a:spAutoFit/>
-          </a:bodyPr>
-          <a:lstStyle/>
-          <a:p>
-            <a:pPr algn="l">
-              <a:defRPr sz="1300" b="0">
-                <a:solidFill>
-                  <a:srgbClr val="334155"/>
-                </a:solidFill>
-                <a:latin typeface="Avenir Next"/>
-              </a:defRPr>
-            </a:pPr>
-            <a:r>
-              <a:t>Release process: build caches, lockfiles, release manifest</a:t>
+              <a:defRPr sz="1150" b="0">
+                <a:solidFill>
+                  <a:srgbClr val="64748B"/>
+                </a:solidFill>
+                <a:latin typeface="Avenir Next"/>
+              </a:defRPr>
+            </a:pPr>
+            <a:r>
+              <a:t>Vendor math libraries, compiler surfaces, the Serial tier, and when performance targeting turns on. These shape the roster before it is fixed for v1.</a:t>
             </a:r>
           </a:p>
         </p:txBody>

</xml_diff>

<commit_message>
Keep our process bookkeeping out of the audience-facing material
The deck and the map both carried notes that only made sense to whoever
built them: a pointer to an internal doc path, the recipe-generation pin,
the file names the roster is copied from, an instruction about updating
them together, and our own placeholder syntax for GPU specs. None of it
means anything to a reader who has not seen the repos, and the deck is
meant to present the process at an overview before any of the tooling
language is introduced. The version policy stays; how we pin it does not.
TAU's GPU build is now described by what it is, MPI plus the lane's GPU
backend, rather than by the token we render it from.
</commit_message>
<xml_diff>
--- a/presentations/cse_lanes_model.pptx
+++ b/presentations/cse_lanes_model.pptx
@@ -4344,42 +4344,6 @@
             </a:pPr>
             <a:r>
               <a:t>The plan is to build every lane at the portable baseline, prove the model, then turn on per-lane tuning for Genoa, Milan, or Cascade Lake. Each target is a flag plus a full rebuild, so the open part is when, not whether.</a:t>
-            </a:r>
-          </a:p>
-        </p:txBody>
-      </p:sp>
-      <p:sp>
-        <p:nvSpPr>
-          <p:cNvPr id="22" name="TextBox 21"/>
-          <p:cNvSpPr txBox="1"/>
-          <p:nvPr/>
-        </p:nvSpPr>
-        <p:spPr>
-          <a:xfrm>
-            <a:off x="548640" y="6263640"/>
-            <a:ext cx="11064240" cy="365760"/>
-          </a:xfrm>
-          <a:prstGeom prst="rect">
-            <a:avLst/>
-          </a:prstGeom>
-          <a:noFill/>
-        </p:spPr>
-        <p:txBody>
-          <a:bodyPr wrap="square" anchor="t">
-            <a:spAutoFit/>
-          </a:bodyPr>
-          <a:lstStyle/>
-          <a:p>
-            <a:pPr algn="l">
-              <a:defRPr sz="1100" b="0">
-                <a:solidFill>
-                  <a:srgbClr val="64748B"/>
-                </a:solidFill>
-                <a:latin typeface="Avenir Next"/>
-              </a:defRPr>
-            </a:pPr>
-            <a:r>
-              <a:t>Per-package placement and the full reasoning: docs/package_placement_map_v1.html</a:t>
             </a:r>
           </a:p>
         </p:txBody>
@@ -6311,7 +6275,7 @@
               </a:defRPr>
             </a:pPr>
             <a:r>
-              <a:t>Version policy: newest supported + immediate predecessor · pinned to spack-packages v2026.06.0 (Spack v1.1.1)</a:t>
+              <a:t>Version policy: the newest supported release and its immediate predecessor</a:t>
             </a:r>
           </a:p>
         </p:txBody>
@@ -7344,7 +7308,7 @@
               </a:defRPr>
             </a:pPr>
             <a:r>
-              <a:t>Version policy: newest supported + immediate predecessor · pinned to spack-packages v2026.06.0 (Spack v1.1.1)</a:t>
+              <a:t>Version policy: the newest supported release and its immediate predecessor</a:t>
             </a:r>
           </a:p>
         </p:txBody>
@@ -8831,7 +8795,7 @@
               </a:defRPr>
             </a:pPr>
             <a:r>
-              <a:t>Version policy: newest supported + immediate predecessor · pinned to spack-packages v2026.06.0 (Spack v1.1.1)</a:t>
+              <a:t>Version policy: the newest supported release and its immediate predecessor</a:t>
             </a:r>
           </a:p>
         </p:txBody>

</xml_diff>

<commit_message>
Record why Kokkos stays GPU-only, and drop the last placeholder syntax
Kokkos invites the opposite conclusion, so the reasoning is worth having
written down. It does not link MPI: no mpi variant, no depends_on. What
it has is a host backend and an optional device backend, and the recipe
requires a host backend in every case, so the GPU build already runs on
the CPU today. A CPU build could therefore sit in the serial and MPI
lanes under one name, extending the dual-build rule from the MPI
boundary to the GPU boundary. Not this pass: Kokkos is here to prove the
GPU toolchain rather than to answer a request, and the reason to hand
CPU users a portability layer is performance, which everything-at-the-
baseline does not chase. Revisit with target optimization.

The GPU appendix rows still carried our own +gpu and +gpu_runtime
placeholder tokens, which are renderer authoring syntax rather than
anything a reader could type. Both now describe the build instead.
</commit_message>
<xml_diff>
--- a/presentations/cse_lanes_model.pptx
+++ b/presentations/cse_lanes_model.pptx
@@ -7501,7 +7501,7 @@
         </p:nvGraphicFramePr>
         <p:xfrm>
           <a:off x="548640" y="1481328"/>
-          <a:ext cx="11091672" cy="5125212"/>
+          <a:ext cx="11091672" cy="4829860"/>
         </p:xfrm>
         <a:graphic>
           <a:graphicData uri="http://schemas.openxmlformats.org/drawingml/2006/table">
@@ -7514,7 +7514,7 @@
                 <a:gridCol w="2286000"/>
                 <a:gridCol w="6885432"/>
               </a:tblGrid>
-              <a:tr h="269748">
+              <a:tr h="254203">
                 <a:tc>
                   <a:txBody>
                     <a:bodyPr/>
@@ -7588,7 +7588,7 @@
                   </a:tcPr>
                 </a:tc>
               </a:tr>
-              <a:tr h="269748">
+              <a:tr h="254203">
                 <a:tc gridSpan="3">
                   <a:txBody>
                     <a:bodyPr/>
@@ -7630,7 +7630,7 @@
                   <a:tcPr/>
                 </a:tc>
               </a:tr>
-              <a:tr h="269748">
+              <a:tr h="254203">
                 <a:tc>
                   <a:txBody>
                     <a:bodyPr/>
@@ -7704,7 +7704,7 @@
                   </a:tcPr>
                 </a:tc>
               </a:tr>
-              <a:tr h="269748">
+              <a:tr h="254203">
                 <a:tc>
                   <a:txBody>
                     <a:bodyPr/>
@@ -7778,7 +7778,7 @@
                   </a:tcPr>
                 </a:tc>
               </a:tr>
-              <a:tr h="269748">
+              <a:tr h="254203">
                 <a:tc>
                   <a:txBody>
                     <a:bodyPr/>
@@ -7852,7 +7852,7 @@
                   </a:tcPr>
                 </a:tc>
               </a:tr>
-              <a:tr h="269748">
+              <a:tr h="254203">
                 <a:tc>
                   <a:txBody>
                     <a:bodyPr/>
@@ -7926,7 +7926,7 @@
                   </a:tcPr>
                 </a:tc>
               </a:tr>
-              <a:tr h="269748">
+              <a:tr h="254203">
                 <a:tc gridSpan="3">
                   <a:txBody>
                     <a:bodyPr/>
@@ -7968,7 +7968,7 @@
                   <a:tcPr/>
                 </a:tc>
               </a:tr>
-              <a:tr h="269748">
+              <a:tr h="254203">
                 <a:tc>
                   <a:txBody>
                     <a:bodyPr/>
@@ -8042,7 +8042,7 @@
                   </a:tcPr>
                 </a:tc>
               </a:tr>
-              <a:tr h="269748">
+              <a:tr h="254203">
                 <a:tc>
                   <a:txBody>
                     <a:bodyPr/>
@@ -8116,7 +8116,7 @@
                   </a:tcPr>
                 </a:tc>
               </a:tr>
-              <a:tr h="269748">
+              <a:tr h="254203">
                 <a:tc>
                   <a:txBody>
                     <a:bodyPr/>
@@ -8190,7 +8190,7 @@
                   </a:tcPr>
                 </a:tc>
               </a:tr>
-              <a:tr h="269748">
+              <a:tr h="254203">
                 <a:tc>
                   <a:txBody>
                     <a:bodyPr/>
@@ -8264,7 +8264,7 @@
                   </a:tcPr>
                 </a:tc>
               </a:tr>
-              <a:tr h="269748">
+              <a:tr h="254203">
                 <a:tc>
                   <a:txBody>
                     <a:bodyPr/>
@@ -8338,7 +8338,7 @@
                   </a:tcPr>
                 </a:tc>
               </a:tr>
-              <a:tr h="269748">
+              <a:tr h="254203">
                 <a:tc gridSpan="3">
                   <a:txBody>
                     <a:bodyPr/>
@@ -8380,7 +8380,7 @@
                   <a:tcPr/>
                 </a:tc>
               </a:tr>
-              <a:tr h="269748">
+              <a:tr h="254203">
                 <a:tc>
                   <a:txBody>
                     <a:bodyPr/>
@@ -8443,7 +8443,7 @@
                         </a:defRPr>
                       </a:pPr>
                       <a:r>
-                        <a:t>+mpi +gpu_runtime: its own build, so it can see kernels as well as MPI</a:t>
+                        <a:t>built with MPI and the lane's GPU backend, so it sees kernels as well as MPI</a:t>
                       </a:r>
                     </a:p>
                   </a:txBody>
@@ -8454,7 +8454,7 @@
                   </a:tcPr>
                 </a:tc>
               </a:tr>
-              <a:tr h="269748">
+              <a:tr h="254203">
                 <a:tc>
                   <a:txBody>
                     <a:bodyPr/>
@@ -8517,7 +8517,7 @@
                         </a:defRPr>
                       </a:pPr>
                       <a:r>
-                        <a:t>+gpu → expands per lane: +rocm amdgpu_target=&lt;arch&gt; or +cuda cuda_arch=&lt;n&gt;</a:t>
+                        <a:t>built for the lane's GPU architecture from the probe; new here, it proves the GPU path</a:t>
                       </a:r>
                     </a:p>
                   </a:txBody>
@@ -8528,7 +8528,7 @@
                   </a:tcPr>
                 </a:tc>
               </a:tr>
-              <a:tr h="269748">
+              <a:tr h="254203">
                 <a:tc gridSpan="3">
                   <a:txBody>
                     <a:bodyPr/>
@@ -8570,7 +8570,7 @@
                   <a:tcPr/>
                 </a:tc>
               </a:tr>
-              <a:tr h="269748">
+              <a:tr h="254203">
                 <a:tc>
                   <a:txBody>
                     <a:bodyPr/>
@@ -8644,7 +8644,7 @@
                   </a:tcPr>
                 </a:tc>
               </a:tr>
-              <a:tr h="269748">
+              <a:tr h="254203">
                 <a:tc gridSpan="3">
                   <a:txBody>
                     <a:bodyPr/>
@@ -8686,7 +8686,7 @@
                   <a:tcPr/>
                 </a:tc>
               </a:tr>
-              <a:tr h="269748">
+              <a:tr h="254206">
                 <a:tc>
                   <a:txBody>
                     <a:bodyPr/>

</xml_diff>

<commit_message>
Docs and deck catch up with the implemented common kind
The lane model's implementation-trails note flips to implemented: common
is a build kind with its own environment and module root, and the surface
prepends that root beside Core's, so its modules are loadable before any
lane. The SOP, rationale, placement map, deck layer band, and appendix
now say so; the compiler-common appendix section moves from the Serial
slide to the Core slide, since it is a surface group, not lane content.
</commit_message>
<xml_diff>
--- a/presentations/cse_lanes_model.pptx
+++ b/presentations/cse_lanes_model.pptx
@@ -4864,7 +4864,7 @@
               </a:defRPr>
             </a:pPr>
             <a:r>
-              <a:t>openblas · gnuplot · load them from Serial, MPI, or GPU alike; one build, one install</a:t>
+              <a:t>openblas · gnuplot · loadable as soon as the surface loads, before any lane; one build, one install</a:t>
             </a:r>
           </a:p>
         </p:txBody>
@@ -5296,7 +5296,7 @@
         </p:nvGraphicFramePr>
         <p:xfrm>
           <a:off x="548640" y="1481328"/>
-          <a:ext cx="11091672" cy="4224528"/>
+          <a:ext cx="11091672" cy="5129784"/>
         </p:xfrm>
         <a:graphic>
           <a:graphicData uri="http://schemas.openxmlformats.org/drawingml/2006/table">
@@ -6240,6 +6240,196 @@
                   </a:tcPr>
                 </a:tc>
               </a:tr>
+              <a:tr h="301752">
+                <a:tc gridSpan="3">
+                  <a:txBody>
+                    <a:bodyPr/>
+                    <a:lstStyle/>
+                    <a:p>
+                      <a:pPr>
+                        <a:defRPr sz="1150" b="1">
+                          <a:solidFill>
+                            <a:srgbClr val="FFFFFF"/>
+                          </a:solidFill>
+                          <a:latin typeface="Avenir Next"/>
+                        </a:defRPr>
+                      </a:pPr>
+                      <a:r>
+                        <a:t>Compiler-common: its own group, loadable before any lane</a:t>
+                      </a:r>
+                    </a:p>
+                  </a:txBody>
+                  <a:tcPr marL="109728" marR="73152" marT="13716" marB="13716" anchor="ctr">
+                    <a:solidFill>
+                      <a:srgbClr val="15803D"/>
+                    </a:solidFill>
+                  </a:tcPr>
+                </a:tc>
+                <a:tc hMerge="1">
+                  <a:txBody>
+                    <a:bodyPr/>
+                    <a:lstStyle/>
+                    <a:p/>
+                  </a:txBody>
+                  <a:tcPr/>
+                </a:tc>
+                <a:tc hMerge="1">
+                  <a:txBody>
+                    <a:bodyPr/>
+                    <a:lstStyle/>
+                    <a:p/>
+                  </a:txBody>
+                  <a:tcPr/>
+                </a:tc>
+              </a:tr>
+              <a:tr h="301752">
+                <a:tc>
+                  <a:txBody>
+                    <a:bodyPr/>
+                    <a:lstStyle/>
+                    <a:p>
+                      <a:pPr>
+                        <a:defRPr sz="1100" b="1">
+                          <a:solidFill>
+                            <a:srgbClr val="0F172A"/>
+                          </a:solidFill>
+                          <a:latin typeface="Avenir Next"/>
+                        </a:defRPr>
+                      </a:pPr>
+                      <a:r>
+                        <a:t>openblas</a:t>
+                      </a:r>
+                    </a:p>
+                  </a:txBody>
+                  <a:tcPr marL="109728" marR="73152" marT="13716" marB="13716" anchor="ctr">
+                    <a:solidFill>
+                      <a:srgbClr val="FFFFFF"/>
+                    </a:solidFill>
+                  </a:tcPr>
+                </a:tc>
+                <a:tc>
+                  <a:txBody>
+                    <a:bodyPr/>
+                    <a:lstStyle/>
+                    <a:p>
+                      <a:pPr>
+                        <a:defRPr sz="1100" b="0">
+                          <a:solidFill>
+                            <a:srgbClr val="334155"/>
+                          </a:solidFill>
+                          <a:latin typeface="Avenir Next"/>
+                        </a:defRPr>
+                      </a:pPr>
+                      <a:r>
+                        <a:t>0.3.33 · 0.3.32</a:t>
+                      </a:r>
+                    </a:p>
+                  </a:txBody>
+                  <a:tcPr marL="109728" marR="73152" marT="13716" marB="13716" anchor="ctr">
+                    <a:solidFill>
+                      <a:srgbClr val="FFFFFF"/>
+                    </a:solidFill>
+                  </a:tcPr>
+                </a:tc>
+                <a:tc>
+                  <a:txBody>
+                    <a:bodyPr/>
+                    <a:lstStyle/>
+                    <a:p>
+                      <a:pPr>
+                        <a:defRPr sz="1050" b="0">
+                          <a:solidFill>
+                            <a:srgbClr val="64748B"/>
+                          </a:solidFill>
+                          <a:latin typeface="Avenir Next"/>
+                        </a:defRPr>
+                      </a:pPr>
+                      <a:r>
+                        <a:t>the one BLAS and LAPACK: openblas provides both APIs</a:t>
+                      </a:r>
+                    </a:p>
+                  </a:txBody>
+                  <a:tcPr marL="109728" marR="73152" marT="13716" marB="13716" anchor="ctr">
+                    <a:solidFill>
+                      <a:srgbClr val="FFFFFF"/>
+                    </a:solidFill>
+                  </a:tcPr>
+                </a:tc>
+              </a:tr>
+              <a:tr h="301752">
+                <a:tc>
+                  <a:txBody>
+                    <a:bodyPr/>
+                    <a:lstStyle/>
+                    <a:p>
+                      <a:pPr>
+                        <a:defRPr sz="1100" b="1">
+                          <a:solidFill>
+                            <a:srgbClr val="0F172A"/>
+                          </a:solidFill>
+                          <a:latin typeface="Avenir Next"/>
+                        </a:defRPr>
+                      </a:pPr>
+                      <a:r>
+                        <a:t>gnuplot</a:t>
+                      </a:r>
+                    </a:p>
+                  </a:txBody>
+                  <a:tcPr marL="109728" marR="73152" marT="13716" marB="13716" anchor="ctr">
+                    <a:solidFill>
+                      <a:srgbClr val="FFFFFF"/>
+                    </a:solidFill>
+                  </a:tcPr>
+                </a:tc>
+                <a:tc>
+                  <a:txBody>
+                    <a:bodyPr/>
+                    <a:lstStyle/>
+                    <a:p>
+                      <a:pPr>
+                        <a:defRPr sz="1100" b="0">
+                          <a:solidFill>
+                            <a:srgbClr val="334155"/>
+                          </a:solidFill>
+                          <a:latin typeface="Avenir Next"/>
+                        </a:defRPr>
+                      </a:pPr>
+                      <a:r>
+                        <a:t>6.0.0 · 5.4.10</a:t>
+                      </a:r>
+                    </a:p>
+                  </a:txBody>
+                  <a:tcPr marL="109728" marR="73152" marT="13716" marB="13716" anchor="ctr">
+                    <a:solidFill>
+                      <a:srgbClr val="FFFFFF"/>
+                    </a:solidFill>
+                  </a:tcPr>
+                </a:tc>
+                <a:tc>
+                  <a:txBody>
+                    <a:bodyPr/>
+                    <a:lstStyle/>
+                    <a:p>
+                      <a:pPr>
+                        <a:defRPr sz="1050" b="0">
+                          <a:solidFill>
+                            <a:srgbClr val="64748B"/>
+                          </a:solidFill>
+                          <a:latin typeface="Avenir Next"/>
+                        </a:defRPr>
+                      </a:pPr>
+                      <a:r>
+                        <a:t>needs the surface's compiler, so not Core</a:t>
+                      </a:r>
+                    </a:p>
+                  </a:txBody>
+                  <a:tcPr marL="109728" marR="73152" marT="13716" marB="13716" anchor="ctr">
+                    <a:solidFill>
+                      <a:srgbClr val="FFFFFF"/>
+                    </a:solidFill>
+                  </a:tcPr>
+                </a:tc>
+              </a:tr>
             </a:tbl>
           </a:graphicData>
         </a:graphic>
@@ -6468,7 +6658,7 @@
         </p:nvGraphicFramePr>
         <p:xfrm>
           <a:off x="548640" y="1481328"/>
-          <a:ext cx="11091672" cy="3621024"/>
+          <a:ext cx="11091672" cy="2715768"/>
         </p:xfrm>
         <a:graphic>
           <a:graphicData uri="http://schemas.openxmlformats.org/drawingml/2006/table">
@@ -7073,196 +7263,6 @@
                       </a:pPr>
                       <a:r>
                         <a:t>~mpi here; the MPI lane carries its own +mpi build</a:t>
-                      </a:r>
-                    </a:p>
-                  </a:txBody>
-                  <a:tcPr marL="109728" marR="73152" marT="13716" marB="13716" anchor="ctr">
-                    <a:solidFill>
-                      <a:srgbClr val="FFFFFF"/>
-                    </a:solidFill>
-                  </a:tcPr>
-                </a:tc>
-              </a:tr>
-              <a:tr h="301752">
-                <a:tc gridSpan="3">
-                  <a:txBody>
-                    <a:bodyPr/>
-                    <a:lstStyle/>
-                    <a:p>
-                      <a:pPr>
-                        <a:defRPr sz="1150" b="1">
-                          <a:solidFill>
-                            <a:srgbClr val="FFFFFF"/>
-                          </a:solidFill>
-                          <a:latin typeface="Avenir Next"/>
-                        </a:defRPr>
-                      </a:pPr>
-                      <a:r>
-                        <a:t>Compiler-common: built for this compiler, loadable from any lane</a:t>
-                      </a:r>
-                    </a:p>
-                  </a:txBody>
-                  <a:tcPr marL="109728" marR="73152" marT="13716" marB="13716" anchor="ctr">
-                    <a:solidFill>
-                      <a:srgbClr val="15803D"/>
-                    </a:solidFill>
-                  </a:tcPr>
-                </a:tc>
-                <a:tc hMerge="1">
-                  <a:txBody>
-                    <a:bodyPr/>
-                    <a:lstStyle/>
-                    <a:p/>
-                  </a:txBody>
-                  <a:tcPr/>
-                </a:tc>
-                <a:tc hMerge="1">
-                  <a:txBody>
-                    <a:bodyPr/>
-                    <a:lstStyle/>
-                    <a:p/>
-                  </a:txBody>
-                  <a:tcPr/>
-                </a:tc>
-              </a:tr>
-              <a:tr h="301752">
-                <a:tc>
-                  <a:txBody>
-                    <a:bodyPr/>
-                    <a:lstStyle/>
-                    <a:p>
-                      <a:pPr>
-                        <a:defRPr sz="1100" b="1">
-                          <a:solidFill>
-                            <a:srgbClr val="0F172A"/>
-                          </a:solidFill>
-                          <a:latin typeface="Avenir Next"/>
-                        </a:defRPr>
-                      </a:pPr>
-                      <a:r>
-                        <a:t>openblas</a:t>
-                      </a:r>
-                    </a:p>
-                  </a:txBody>
-                  <a:tcPr marL="109728" marR="73152" marT="13716" marB="13716" anchor="ctr">
-                    <a:solidFill>
-                      <a:srgbClr val="FFFFFF"/>
-                    </a:solidFill>
-                  </a:tcPr>
-                </a:tc>
-                <a:tc>
-                  <a:txBody>
-                    <a:bodyPr/>
-                    <a:lstStyle/>
-                    <a:p>
-                      <a:pPr>
-                        <a:defRPr sz="1100" b="0">
-                          <a:solidFill>
-                            <a:srgbClr val="334155"/>
-                          </a:solidFill>
-                          <a:latin typeface="Avenir Next"/>
-                        </a:defRPr>
-                      </a:pPr>
-                      <a:r>
-                        <a:t>0.3.33 · 0.3.32</a:t>
-                      </a:r>
-                    </a:p>
-                  </a:txBody>
-                  <a:tcPr marL="109728" marR="73152" marT="13716" marB="13716" anchor="ctr">
-                    <a:solidFill>
-                      <a:srgbClr val="FFFFFF"/>
-                    </a:solidFill>
-                  </a:tcPr>
-                </a:tc>
-                <a:tc>
-                  <a:txBody>
-                    <a:bodyPr/>
-                    <a:lstStyle/>
-                    <a:p>
-                      <a:pPr>
-                        <a:defRPr sz="1050" b="0">
-                          <a:solidFill>
-                            <a:srgbClr val="64748B"/>
-                          </a:solidFill>
-                          <a:latin typeface="Avenir Next"/>
-                        </a:defRPr>
-                      </a:pPr>
-                      <a:r>
-                        <a:t>the one BLAS and LAPACK: openblas provides both APIs. Payload rather than core: performance-sensitive</a:t>
-                      </a:r>
-                    </a:p>
-                  </a:txBody>
-                  <a:tcPr marL="109728" marR="73152" marT="13716" marB="13716" anchor="ctr">
-                    <a:solidFill>
-                      <a:srgbClr val="FFFFFF"/>
-                    </a:solidFill>
-                  </a:tcPr>
-                </a:tc>
-              </a:tr>
-              <a:tr h="301752">
-                <a:tc>
-                  <a:txBody>
-                    <a:bodyPr/>
-                    <a:lstStyle/>
-                    <a:p>
-                      <a:pPr>
-                        <a:defRPr sz="1100" b="1">
-                          <a:solidFill>
-                            <a:srgbClr val="0F172A"/>
-                          </a:solidFill>
-                          <a:latin typeface="Avenir Next"/>
-                        </a:defRPr>
-                      </a:pPr>
-                      <a:r>
-                        <a:t>gnuplot</a:t>
-                      </a:r>
-                    </a:p>
-                  </a:txBody>
-                  <a:tcPr marL="109728" marR="73152" marT="13716" marB="13716" anchor="ctr">
-                    <a:solidFill>
-                      <a:srgbClr val="FFFFFF"/>
-                    </a:solidFill>
-                  </a:tcPr>
-                </a:tc>
-                <a:tc>
-                  <a:txBody>
-                    <a:bodyPr/>
-                    <a:lstStyle/>
-                    <a:p>
-                      <a:pPr>
-                        <a:defRPr sz="1100" b="0">
-                          <a:solidFill>
-                            <a:srgbClr val="334155"/>
-                          </a:solidFill>
-                          <a:latin typeface="Avenir Next"/>
-                        </a:defRPr>
-                      </a:pPr>
-                      <a:r>
-                        <a:t>6.0.0 · 5.4.10</a:t>
-                      </a:r>
-                    </a:p>
-                  </a:txBody>
-                  <a:tcPr marL="109728" marR="73152" marT="13716" marB="13716" anchor="ctr">
-                    <a:solidFill>
-                      <a:srgbClr val="FFFFFF"/>
-                    </a:solidFill>
-                  </a:tcPr>
-                </a:tc>
-                <a:tc>
-                  <a:txBody>
-                    <a:bodyPr/>
-                    <a:lstStyle/>
-                    <a:p>
-                      <a:pPr>
-                        <a:defRPr sz="1050" b="0">
-                          <a:solidFill>
-                            <a:srgbClr val="64748B"/>
-                          </a:solidFill>
-                          <a:latin typeface="Avenir Next"/>
-                        </a:defRPr>
-                      </a:pPr>
-                      <a:r>
-                        <a:t>needs the surface's compiler, so payload rather than core</a:t>
                       </a:r>
                     </a:p>
                   </a:txBody>
@@ -8543,7 +8543,7 @@
                         </a:defRPr>
                       </a:pPr>
                       <a:r>
-                        <a:t>Compiler-common: independent of the lane, loadable from any of them</a:t>
+                        <a:t>Compiler-common: loadable here too, from the surface</a:t>
                       </a:r>
                     </a:p>
                   </a:txBody>
@@ -8609,7 +8609,7 @@
                         </a:defRPr>
                       </a:pPr>
                       <a:r>
-                        <a:t>see below</a:t>
+                        <a:t>see Core slide</a:t>
                       </a:r>
                     </a:p>
                   </a:txBody>
@@ -8633,7 +8633,7 @@
                         </a:defRPr>
                       </a:pPr>
                       <a:r>
-                        <a:t>openblas · gnuplot: its own group, loadable from any lane of this compiler</a:t>
+                        <a:t>openblas · gnuplot: available before and regardless of the lane choice</a:t>
                       </a:r>
                     </a:p>
                   </a:txBody>
@@ -13174,7 +13174,7 @@
               </a:defRPr>
             </a:pPr>
             <a:r>
-              <a:t>Only the chosen lane is visible; common packages (BLAS/LAPACK, gnuplot) are reachable from every lane.</a:t>
+              <a:t>Only the chosen lane is visible; common packages (BLAS/LAPACK, gnuplot) load from the surface itself.</a:t>
             </a:r>
           </a:p>
           <a:p>

</xml_diff>

<commit_message>
Deck: Common appears wherever Core does, from the first model slide
The group was only visible in the appendix; the slides that introduce
the model showed Core and Foundation alone. Slide 2's lanes panel, the
front-door schematic, the vocabulary cards (now five), and the pilot
scope surface chips all show Core, Common, and Foundation as siblings.
The Serial box on the front-door slide stops listing openblas and
gnuplot, which belong to Common.
</commit_message>
<xml_diff>
--- a/presentations/cse_lanes_model.pptx
+++ b/presentations/cse_lanes_model.pptx
@@ -9986,7 +9986,7 @@
         <p:spPr>
           <a:xfrm>
             <a:off x="6766560" y="3063240"/>
-            <a:ext cx="2103120" cy="566928"/>
+            <a:ext cx="1371600" cy="566928"/>
           </a:xfrm>
           <a:prstGeom prst="roundRect">
             <a:avLst/>
@@ -10018,7 +10018,7 @@
           <a:lstStyle/>
           <a:p>
             <a:pPr algn="ctr">
-              <a:defRPr sz="1250" b="1">
+              <a:defRPr sz="1150" b="1">
                 <a:solidFill>
                   <a:srgbClr val="FFFFFF"/>
                 </a:solidFill>
@@ -10026,7 +10026,20 @@
               </a:defRPr>
             </a:pPr>
             <a:r>
-              <a:t>Core (automatic)</a:t>
+              <a:t>Core</a:t>
+            </a:r>
+          </a:p>
+          <a:p>
+            <a:pPr algn="ctr">
+              <a:defRPr sz="950" b="0">
+                <a:solidFill>
+                  <a:srgbClr val="FFFFFF"/>
+                </a:solidFill>
+                <a:latin typeface="Avenir Next"/>
+              </a:defRPr>
+            </a:pPr>
+            <a:r>
+              <a:t>modules</a:t>
             </a:r>
           </a:p>
         </p:txBody>
@@ -10039,8 +10052,75 @@
         </p:nvSpPr>
         <p:spPr>
           <a:xfrm>
-            <a:off x="9006840" y="3063240"/>
-            <a:ext cx="2103120" cy="566928"/>
+            <a:off x="8229600" y="3063240"/>
+            <a:ext cx="1371600" cy="566928"/>
+          </a:xfrm>
+          <a:prstGeom prst="roundRect">
+            <a:avLst/>
+          </a:prstGeom>
+          <a:solidFill>
+            <a:srgbClr val="15803D"/>
+          </a:solidFill>
+          <a:ln>
+            <a:noFill/>
+          </a:ln>
+          <a:effectLst/>
+        </p:spPr>
+        <p:style>
+          <a:lnRef idx="1">
+            <a:schemeClr val="accent1"/>
+          </a:lnRef>
+          <a:fillRef idx="3">
+            <a:schemeClr val="accent1"/>
+          </a:fillRef>
+          <a:effectRef idx="2">
+            <a:schemeClr val="accent1"/>
+          </a:effectRef>
+          <a:fontRef idx="minor">
+            <a:schemeClr val="lt1"/>
+          </a:fontRef>
+        </p:style>
+        <p:txBody>
+          <a:bodyPr rtlCol="0" anchor="ctr" wrap="square" lIns="109728" rIns="109728"/>
+          <a:lstStyle/>
+          <a:p>
+            <a:pPr algn="ctr">
+              <a:defRPr sz="1150" b="1">
+                <a:solidFill>
+                  <a:srgbClr val="FFFFFF"/>
+                </a:solidFill>
+                <a:latin typeface="Avenir Next"/>
+              </a:defRPr>
+            </a:pPr>
+            <a:r>
+              <a:t>Common</a:t>
+            </a:r>
+          </a:p>
+          <a:p>
+            <a:pPr algn="ctr">
+              <a:defRPr sz="950" b="0">
+                <a:solidFill>
+                  <a:srgbClr val="FFFFFF"/>
+                </a:solidFill>
+                <a:latin typeface="Avenir Next"/>
+              </a:defRPr>
+            </a:pPr>
+            <a:r>
+              <a:t>modules</a:t>
+            </a:r>
+          </a:p>
+        </p:txBody>
+      </p:sp>
+      <p:sp>
+        <p:nvSpPr>
+          <p:cNvPr id="28" name="Rounded Rectangle 27"/>
+          <p:cNvSpPr/>
+          <p:nvPr/>
+        </p:nvSpPr>
+        <p:spPr>
+          <a:xfrm>
+            <a:off x="9692640" y="3063240"/>
+            <a:ext cx="1417320" cy="566928"/>
           </a:xfrm>
           <a:prstGeom prst="roundRect">
             <a:avLst/>
@@ -10072,7 +10152,7 @@
           <a:lstStyle/>
           <a:p>
             <a:pPr algn="ctr">
-              <a:defRPr sz="1250" b="1">
+              <a:defRPr sz="1150" b="1">
                 <a:solidFill>
                   <a:srgbClr val="FFFFFF"/>
                 </a:solidFill>
@@ -10080,14 +10160,27 @@
               </a:defRPr>
             </a:pPr>
             <a:r>
-              <a:t>Foundation (on the path)</a:t>
+              <a:t>Foundation</a:t>
+            </a:r>
+          </a:p>
+          <a:p>
+            <a:pPr algn="ctr">
+              <a:defRPr sz="950" b="0">
+                <a:solidFill>
+                  <a:srgbClr val="FFFFFF"/>
+                </a:solidFill>
+                <a:latin typeface="Avenir Next"/>
+              </a:defRPr>
+            </a:pPr>
+            <a:r>
+              <a:t>on the path</a:t>
             </a:r>
           </a:p>
         </p:txBody>
       </p:sp>
       <p:cxnSp>
         <p:nvCxnSpPr>
-          <p:cNvPr id="28" name="Connector 27"/>
+          <p:cNvPr id="29" name="Connector 28"/>
           <p:cNvCxnSpPr/>
           <p:nvPr/>
         </p:nvCxnSpPr>
@@ -10124,7 +10217,7 @@
       </p:cxnSp>
       <p:sp>
         <p:nvSpPr>
-          <p:cNvPr id="29" name="TextBox 28"/>
+          <p:cNvPr id="30" name="TextBox 29"/>
           <p:cNvSpPr txBox="1"/>
           <p:nvPr/>
         </p:nvSpPr>
@@ -10160,7 +10253,7 @@
       </p:sp>
       <p:sp>
         <p:nvSpPr>
-          <p:cNvPr id="30" name="Rounded Rectangle 29"/>
+          <p:cNvPr id="31" name="Rounded Rectangle 30"/>
           <p:cNvSpPr/>
           <p:nvPr/>
         </p:nvSpPr>
@@ -10214,7 +10307,7 @@
       </p:sp>
       <p:sp>
         <p:nvSpPr>
-          <p:cNvPr id="31" name="Rounded Rectangle 30"/>
+          <p:cNvPr id="32" name="Rounded Rectangle 31"/>
           <p:cNvSpPr/>
           <p:nvPr/>
         </p:nvSpPr>
@@ -10268,7 +10361,7 @@
       </p:sp>
       <p:sp>
         <p:nvSpPr>
-          <p:cNvPr id="32" name="Rounded Rectangle 31"/>
+          <p:cNvPr id="33" name="Rounded Rectangle 32"/>
           <p:cNvSpPr/>
           <p:nvPr/>
         </p:nvSpPr>
@@ -10322,7 +10415,7 @@
       </p:sp>
       <p:sp>
         <p:nvSpPr>
-          <p:cNvPr id="33" name="TextBox 32"/>
+          <p:cNvPr id="34" name="TextBox 33"/>
           <p:cNvSpPr txBox="1"/>
           <p:nvPr/>
         </p:nvSpPr>
@@ -12725,8 +12818,8 @@
         </p:nvSpPr>
         <p:spPr>
           <a:xfrm>
-            <a:off x="2163470" y="2578608"/>
-            <a:ext cx="3749039" cy="914400"/>
+            <a:off x="685800" y="2578608"/>
+            <a:ext cx="3474720" cy="914400"/>
           </a:xfrm>
           <a:prstGeom prst="roundRect">
             <a:avLst/>
@@ -12758,7 +12851,7 @@
           <a:lstStyle/>
           <a:p>
             <a:pPr algn="ctr">
-              <a:defRPr sz="1450" b="1">
+              <a:defRPr sz="1300" b="1">
                 <a:solidFill>
                   <a:srgbClr val="FFFFFF"/>
                 </a:solidFill>
@@ -12766,12 +12859,12 @@
               </a:defRPr>
             </a:pPr>
             <a:r>
-              <a:t>Core: loads automatically</a:t>
+              <a:t>Core: modules available</a:t>
             </a:r>
           </a:p>
           <a:p>
             <a:pPr algn="ctr">
-              <a:defRPr sz="1150" b="0">
+              <a:defRPr sz="1050" b="0">
                 <a:solidFill>
                   <a:srgbClr val="FFFFFF"/>
                 </a:solidFill>
@@ -12792,8 +12885,75 @@
         </p:nvSpPr>
         <p:spPr>
           <a:xfrm>
-            <a:off x="6278270" y="2578608"/>
-            <a:ext cx="3749039" cy="914400"/>
+            <a:off x="4361688" y="2578608"/>
+            <a:ext cx="3474720" cy="914400"/>
+          </a:xfrm>
+          <a:prstGeom prst="roundRect">
+            <a:avLst/>
+          </a:prstGeom>
+          <a:solidFill>
+            <a:srgbClr val="15803D"/>
+          </a:solidFill>
+          <a:ln>
+            <a:noFill/>
+          </a:ln>
+          <a:effectLst/>
+        </p:spPr>
+        <p:style>
+          <a:lnRef idx="1">
+            <a:schemeClr val="accent1"/>
+          </a:lnRef>
+          <a:fillRef idx="3">
+            <a:schemeClr val="accent1"/>
+          </a:fillRef>
+          <a:effectRef idx="2">
+            <a:schemeClr val="accent1"/>
+          </a:effectRef>
+          <a:fontRef idx="minor">
+            <a:schemeClr val="lt1"/>
+          </a:fontRef>
+        </p:style>
+        <p:txBody>
+          <a:bodyPr rtlCol="0" anchor="ctr" wrap="square" lIns="109728" rIns="109728"/>
+          <a:lstStyle/>
+          <a:p>
+            <a:pPr algn="ctr">
+              <a:defRPr sz="1300" b="1">
+                <a:solidFill>
+                  <a:srgbClr val="FFFFFF"/>
+                </a:solidFill>
+                <a:latin typeface="Avenir Next"/>
+              </a:defRPr>
+            </a:pPr>
+            <a:r>
+              <a:t>GCC Common: modules available</a:t>
+            </a:r>
+          </a:p>
+          <a:p>
+            <a:pPr algn="ctr">
+              <a:defRPr sz="1050" b="0">
+                <a:solidFill>
+                  <a:srgbClr val="FFFFFF"/>
+                </a:solidFill>
+                <a:latin typeface="Avenir Next"/>
+              </a:defRPr>
+            </a:pPr>
+            <a:r>
+              <a:t>openblas · gnuplot</a:t>
+            </a:r>
+          </a:p>
+        </p:txBody>
+      </p:sp>
+      <p:sp>
+        <p:nvSpPr>
+          <p:cNvPr id="10" name="Rounded Rectangle 9"/>
+          <p:cNvSpPr/>
+          <p:nvPr/>
+        </p:nvSpPr>
+        <p:spPr>
+          <a:xfrm>
+            <a:off x="8037575" y="2578608"/>
+            <a:ext cx="3474720" cy="914400"/>
           </a:xfrm>
           <a:prstGeom prst="roundRect">
             <a:avLst/>
@@ -12825,7 +12985,7 @@
           <a:lstStyle/>
           <a:p>
             <a:pPr algn="ctr">
-              <a:defRPr sz="1450" b="1">
+              <a:defRPr sz="1300" b="1">
                 <a:solidFill>
                   <a:srgbClr val="FFFFFF"/>
                 </a:solidFill>
@@ -12833,12 +12993,12 @@
               </a:defRPr>
             </a:pPr>
             <a:r>
-              <a:t>Foundation: on your paths automatically</a:t>
+              <a:t>Foundation: on your paths</a:t>
             </a:r>
           </a:p>
           <a:p>
             <a:pPr algn="ctr">
-              <a:defRPr sz="1150" b="0">
+              <a:defRPr sz="1050" b="0">
                 <a:solidFill>
                   <a:srgbClr val="FFFFFF"/>
                 </a:solidFill>
@@ -12853,7 +13013,7 @@
       </p:sp>
       <p:cxnSp>
         <p:nvCxnSpPr>
-          <p:cNvPr id="10" name="Connector 9"/>
+          <p:cNvPr id="11" name="Connector 10"/>
           <p:cNvCxnSpPr/>
           <p:nvPr/>
         </p:nvCxnSpPr>
@@ -12890,7 +13050,7 @@
       </p:cxnSp>
       <p:sp>
         <p:nvSpPr>
-          <p:cNvPr id="11" name="TextBox 10"/>
+          <p:cNvPr id="12" name="TextBox 11"/>
           <p:cNvSpPr txBox="1"/>
           <p:nvPr/>
         </p:nvSpPr>
@@ -12926,7 +13086,7 @@
       </p:sp>
       <p:sp>
         <p:nvSpPr>
-          <p:cNvPr id="12" name="Rounded Rectangle 11"/>
+          <p:cNvPr id="13" name="Rounded Rectangle 12"/>
           <p:cNvSpPr/>
           <p:nvPr/>
         </p:nvSpPr>
@@ -12986,14 +13146,14 @@
               </a:defRPr>
             </a:pPr>
             <a:r>
-              <a:t>non-MPI hdf5 · fftw · boost, plus openblas · gnuplot</a:t>
-            </a:r>
-          </a:p>
-        </p:txBody>
-      </p:sp>
-      <p:sp>
-        <p:nvSpPr>
-          <p:cNvPr id="13" name="Rounded Rectangle 12"/>
+              <a:t>non-MPI hdf5 · netcdf · fftw · boost</a:t>
+            </a:r>
+          </a:p>
+        </p:txBody>
+      </p:sp>
+      <p:sp>
+        <p:nvSpPr>
+          <p:cNvPr id="14" name="Rounded Rectangle 13"/>
           <p:cNvSpPr/>
           <p:nvPr/>
         </p:nvSpPr>
@@ -13060,7 +13220,7 @@
       </p:sp>
       <p:sp>
         <p:nvSpPr>
-          <p:cNvPr id="14" name="Rounded Rectangle 13"/>
+          <p:cNvPr id="15" name="Rounded Rectangle 14"/>
           <p:cNvSpPr/>
           <p:nvPr/>
         </p:nvSpPr>
@@ -13127,7 +13287,7 @@
       </p:sp>
       <p:sp>
         <p:nvSpPr>
-          <p:cNvPr id="15" name="Rounded Rectangle 14"/>
+          <p:cNvPr id="16" name="Rounded Rectangle 15"/>
           <p:cNvSpPr/>
           <p:nvPr/>
         </p:nvSpPr>
@@ -13379,7 +13539,7 @@
         <p:spPr>
           <a:xfrm>
             <a:off x="548640" y="1645920"/>
-            <a:ext cx="2743200" cy="3246120"/>
+            <a:ext cx="2048256" cy="3429000"/>
           </a:xfrm>
           <a:prstGeom prst="roundRect">
             <a:avLst/>
@@ -13423,7 +13583,7 @@
         <p:spPr>
           <a:xfrm>
             <a:off x="548640" y="1645920"/>
-            <a:ext cx="2743200" cy="685800"/>
+            <a:ext cx="2048256" cy="594360"/>
           </a:xfrm>
           <a:prstGeom prst="roundRect">
             <a:avLst/>
@@ -13466,8 +13626,8 @@
         </p:nvSpPr>
         <p:spPr>
           <a:xfrm>
-            <a:off x="685800" y="1755648"/>
-            <a:ext cx="2468880" cy="502920"/>
+            <a:off x="640080" y="1773936"/>
+            <a:ext cx="1865376" cy="457200"/>
           </a:xfrm>
           <a:prstGeom prst="rect">
             <a:avLst/>
@@ -13481,7 +13641,7 @@
           <a:lstStyle/>
           <a:p>
             <a:pPr algn="ctr">
-              <a:defRPr sz="1700" b="1">
+              <a:defRPr sz="1500" b="1">
                 <a:solidFill>
                   <a:srgbClr val="FFFFFF"/>
                 </a:solidFill>
@@ -13502,8 +13662,8 @@
         </p:nvSpPr>
         <p:spPr>
           <a:xfrm>
-            <a:off x="749808" y="2514600"/>
-            <a:ext cx="2377440" cy="1554480"/>
+            <a:off x="694944" y="2377440"/>
+            <a:ext cx="1783080" cy="1920240"/>
           </a:xfrm>
           <a:prstGeom prst="rect">
             <a:avLst/>
@@ -13517,7 +13677,7 @@
           <a:lstStyle/>
           <a:p>
             <a:pPr algn="l">
-              <a:defRPr sz="1250" b="0">
+              <a:defRPr sz="1100" b="0">
                 <a:solidFill>
                   <a:srgbClr val="334155"/>
                 </a:solidFill>
@@ -13525,7 +13685,7 @@
               </a:defRPr>
             </a:pPr>
             <a:r>
-              <a:t>Compiler-agnostic building blocks and tools. They load with the surface, before any lane is chosen.</a:t>
+              <a:t>Compiler-agnostic building blocks and tools. Available as soon as the surface loads.</a:t>
             </a:r>
           </a:p>
         </p:txBody>
@@ -13538,8 +13698,8 @@
         </p:nvSpPr>
         <p:spPr>
           <a:xfrm>
-            <a:off x="749808" y="4160520"/>
-            <a:ext cx="2377440" cy="640080"/>
+            <a:off x="694944" y="4343400"/>
+            <a:ext cx="1783080" cy="640080"/>
           </a:xfrm>
           <a:prstGeom prst="rect">
             <a:avLst/>
@@ -13553,7 +13713,7 @@
           <a:lstStyle/>
           <a:p>
             <a:pPr algn="l">
-              <a:defRPr sz="1150" b="0">
+              <a:defRPr sz="1000" b="0">
                 <a:solidFill>
                   <a:srgbClr val="64748B"/>
                 </a:solidFill>
@@ -13561,7 +13721,7 @@
               </a:defRPr>
             </a:pPr>
             <a:r>
-              <a:t>cmake · python · miniforge · gsl · sqlite</a:t>
+              <a:t>cmake · python · miniforge · gsl</a:t>
             </a:r>
           </a:p>
         </p:txBody>
@@ -13574,8 +13734,8 @@
         </p:nvSpPr>
         <p:spPr>
           <a:xfrm>
-            <a:off x="3493008" y="1645920"/>
-            <a:ext cx="2743200" cy="3246120"/>
+            <a:off x="2706624" y="1645920"/>
+            <a:ext cx="2048256" cy="3429000"/>
           </a:xfrm>
           <a:prstGeom prst="roundRect">
             <a:avLst/>
@@ -13618,8 +13778,204 @@
         </p:nvSpPr>
         <p:spPr>
           <a:xfrm>
-            <a:off x="3493008" y="1645920"/>
-            <a:ext cx="2743200" cy="685800"/>
+            <a:off x="2706624" y="1645920"/>
+            <a:ext cx="2048256" cy="594360"/>
+          </a:xfrm>
+          <a:prstGeom prst="roundRect">
+            <a:avLst/>
+          </a:prstGeom>
+          <a:solidFill>
+            <a:srgbClr val="15803D"/>
+          </a:solidFill>
+          <a:ln>
+            <a:noFill/>
+          </a:ln>
+          <a:effectLst/>
+        </p:spPr>
+        <p:style>
+          <a:lnRef idx="1">
+            <a:schemeClr val="accent1"/>
+          </a:lnRef>
+          <a:fillRef idx="3">
+            <a:schemeClr val="accent1"/>
+          </a:fillRef>
+          <a:effectRef idx="2">
+            <a:schemeClr val="accent1"/>
+          </a:effectRef>
+          <a:fontRef idx="minor">
+            <a:schemeClr val="lt1"/>
+          </a:fontRef>
+        </p:style>
+        <p:txBody>
+          <a:bodyPr rtlCol="0" anchor="ctr"/>
+          <a:lstStyle/>
+          <a:p>
+            <a:pPr algn="ctr"/>
+          </a:p>
+        </p:txBody>
+      </p:sp>
+      <p:sp>
+        <p:nvSpPr>
+          <p:cNvPr id="13" name="TextBox 12"/>
+          <p:cNvSpPr txBox="1"/>
+          <p:nvPr/>
+        </p:nvSpPr>
+        <p:spPr>
+          <a:xfrm>
+            <a:off x="2798064" y="1773936"/>
+            <a:ext cx="1865376" cy="457200"/>
+          </a:xfrm>
+          <a:prstGeom prst="rect">
+            <a:avLst/>
+          </a:prstGeom>
+          <a:noFill/>
+        </p:spPr>
+        <p:txBody>
+          <a:bodyPr wrap="square" anchor="t">
+            <a:spAutoFit/>
+          </a:bodyPr>
+          <a:lstStyle/>
+          <a:p>
+            <a:pPr algn="ctr">
+              <a:defRPr sz="1500" b="1">
+                <a:solidFill>
+                  <a:srgbClr val="FFFFFF"/>
+                </a:solidFill>
+                <a:latin typeface="Avenir Next"/>
+              </a:defRPr>
+            </a:pPr>
+            <a:r>
+              <a:t>Common</a:t>
+            </a:r>
+          </a:p>
+        </p:txBody>
+      </p:sp>
+      <p:sp>
+        <p:nvSpPr>
+          <p:cNvPr id="14" name="TextBox 13"/>
+          <p:cNvSpPr txBox="1"/>
+          <p:nvPr/>
+        </p:nvSpPr>
+        <p:spPr>
+          <a:xfrm>
+            <a:off x="2852928" y="2377440"/>
+            <a:ext cx="1783080" cy="1920240"/>
+          </a:xfrm>
+          <a:prstGeom prst="rect">
+            <a:avLst/>
+          </a:prstGeom>
+          <a:noFill/>
+        </p:spPr>
+        <p:txBody>
+          <a:bodyPr wrap="square" anchor="t">
+            <a:spAutoFit/>
+          </a:bodyPr>
+          <a:lstStyle/>
+          <a:p>
+            <a:pPr algn="l">
+              <a:defRPr sz="1100" b="0">
+                <a:solidFill>
+                  <a:srgbClr val="334155"/>
+                </a:solidFill>
+                <a:latin typeface="Avenir Next"/>
+              </a:defRPr>
+            </a:pPr>
+            <a:r>
+              <a:t>Built for this compiler, one build for every lane. Available with the surface, like Core.</a:t>
+            </a:r>
+          </a:p>
+        </p:txBody>
+      </p:sp>
+      <p:sp>
+        <p:nvSpPr>
+          <p:cNvPr id="15" name="TextBox 14"/>
+          <p:cNvSpPr txBox="1"/>
+          <p:nvPr/>
+        </p:nvSpPr>
+        <p:spPr>
+          <a:xfrm>
+            <a:off x="2852928" y="4343400"/>
+            <a:ext cx="1783080" cy="640080"/>
+          </a:xfrm>
+          <a:prstGeom prst="rect">
+            <a:avLst/>
+          </a:prstGeom>
+          <a:noFill/>
+        </p:spPr>
+        <p:txBody>
+          <a:bodyPr wrap="square" anchor="t">
+            <a:spAutoFit/>
+          </a:bodyPr>
+          <a:lstStyle/>
+          <a:p>
+            <a:pPr algn="l">
+              <a:defRPr sz="1000" b="0">
+                <a:solidFill>
+                  <a:srgbClr val="64748B"/>
+                </a:solidFill>
+                <a:latin typeface="Avenir Next"/>
+              </a:defRPr>
+            </a:pPr>
+            <a:r>
+              <a:t>openblas · gnuplot</a:t>
+            </a:r>
+          </a:p>
+        </p:txBody>
+      </p:sp>
+      <p:sp>
+        <p:nvSpPr>
+          <p:cNvPr id="16" name="Rounded Rectangle 15"/>
+          <p:cNvSpPr/>
+          <p:nvPr/>
+        </p:nvSpPr>
+        <p:spPr>
+          <a:xfrm>
+            <a:off x="4864607" y="1645920"/>
+            <a:ext cx="2048256" cy="3429000"/>
+          </a:xfrm>
+          <a:prstGeom prst="roundRect">
+            <a:avLst/>
+          </a:prstGeom>
+          <a:solidFill>
+            <a:srgbClr val="F1F5F9"/>
+          </a:solidFill>
+          <a:ln>
+            <a:noFill/>
+          </a:ln>
+          <a:effectLst/>
+        </p:spPr>
+        <p:style>
+          <a:lnRef idx="1">
+            <a:schemeClr val="accent1"/>
+          </a:lnRef>
+          <a:fillRef idx="3">
+            <a:schemeClr val="accent1"/>
+          </a:fillRef>
+          <a:effectRef idx="2">
+            <a:schemeClr val="accent1"/>
+          </a:effectRef>
+          <a:fontRef idx="minor">
+            <a:schemeClr val="lt1"/>
+          </a:fontRef>
+        </p:style>
+        <p:txBody>
+          <a:bodyPr rtlCol="0" anchor="ctr"/>
+          <a:lstStyle/>
+          <a:p>
+            <a:pPr algn="ctr"/>
+          </a:p>
+        </p:txBody>
+      </p:sp>
+      <p:sp>
+        <p:nvSpPr>
+          <p:cNvPr id="17" name="Rounded Rectangle 16"/>
+          <p:cNvSpPr/>
+          <p:nvPr/>
+        </p:nvSpPr>
+        <p:spPr>
+          <a:xfrm>
+            <a:off x="4864607" y="1645920"/>
+            <a:ext cx="2048256" cy="594360"/>
           </a:xfrm>
           <a:prstGeom prst="roundRect">
             <a:avLst/>
@@ -13656,14 +14012,14 @@
       </p:sp>
       <p:sp>
         <p:nvSpPr>
-          <p:cNvPr id="13" name="TextBox 12"/>
+          <p:cNvPr id="18" name="TextBox 17"/>
           <p:cNvSpPr txBox="1"/>
           <p:nvPr/>
         </p:nvSpPr>
         <p:spPr>
           <a:xfrm>
-            <a:off x="3630168" y="1755648"/>
-            <a:ext cx="2468880" cy="502920"/>
+            <a:off x="4956047" y="1773936"/>
+            <a:ext cx="1865376" cy="457200"/>
           </a:xfrm>
           <a:prstGeom prst="rect">
             <a:avLst/>
@@ -13677,7 +14033,7 @@
           <a:lstStyle/>
           <a:p>
             <a:pPr algn="ctr">
-              <a:defRPr sz="1700" b="1">
+              <a:defRPr sz="1500" b="1">
                 <a:solidFill>
                   <a:srgbClr val="FFFFFF"/>
                 </a:solidFill>
@@ -13692,14 +14048,14 @@
       </p:sp>
       <p:sp>
         <p:nvSpPr>
-          <p:cNvPr id="14" name="TextBox 13"/>
+          <p:cNvPr id="19" name="TextBox 18"/>
           <p:cNvSpPr txBox="1"/>
           <p:nvPr/>
         </p:nvSpPr>
         <p:spPr>
           <a:xfrm>
-            <a:off x="3694176" y="2514600"/>
-            <a:ext cx="2377440" cy="1554480"/>
+            <a:off x="5010912" y="2377440"/>
+            <a:ext cx="1783080" cy="1920240"/>
           </a:xfrm>
           <a:prstGeom prst="rect">
             <a:avLst/>
@@ -13713,7 +14069,7 @@
           <a:lstStyle/>
           <a:p>
             <a:pPr algn="l">
-              <a:defRPr sz="1250" b="0">
+              <a:defRPr sz="1100" b="0">
                 <a:solidFill>
                   <a:srgbClr val="334155"/>
                 </a:solidFill>
@@ -13728,14 +14084,14 @@
       </p:sp>
       <p:sp>
         <p:nvSpPr>
-          <p:cNvPr id="15" name="TextBox 14"/>
+          <p:cNvPr id="20" name="TextBox 19"/>
           <p:cNvSpPr txBox="1"/>
           <p:nvPr/>
         </p:nvSpPr>
         <p:spPr>
           <a:xfrm>
-            <a:off x="3694176" y="4160520"/>
-            <a:ext cx="2377440" cy="640080"/>
+            <a:off x="5010912" y="4343400"/>
+            <a:ext cx="1783080" cy="640080"/>
           </a:xfrm>
           <a:prstGeom prst="rect">
             <a:avLst/>
@@ -13749,7 +14105,7 @@
           <a:lstStyle/>
           <a:p>
             <a:pPr algn="l">
-              <a:defRPr sz="1150" b="0">
+              <a:defRPr sz="1000" b="0">
                 <a:solidFill>
                   <a:srgbClr val="64748B"/>
                 </a:solidFill>
@@ -13757,21 +14113,21 @@
               </a:defRPr>
             </a:pPr>
             <a:r>
-              <a:t>hdf5~mpi · netcdf~mpi · fftw~mpi · boost~mpi</a:t>
-            </a:r>
-          </a:p>
-        </p:txBody>
-      </p:sp>
-      <p:sp>
-        <p:nvSpPr>
-          <p:cNvPr id="16" name="Rounded Rectangle 15"/>
+              <a:t>hdf5~mpi · fftw~mpi · boost~mpi</a:t>
+            </a:r>
+          </a:p>
+        </p:txBody>
+      </p:sp>
+      <p:sp>
+        <p:nvSpPr>
+          <p:cNvPr id="21" name="Rounded Rectangle 20"/>
           <p:cNvSpPr/>
           <p:nvPr/>
         </p:nvSpPr>
         <p:spPr>
           <a:xfrm>
-            <a:off x="6437376" y="1645920"/>
-            <a:ext cx="2743200" cy="3246120"/>
+            <a:off x="7022592" y="1645920"/>
+            <a:ext cx="2048256" cy="3429000"/>
           </a:xfrm>
           <a:prstGeom prst="roundRect">
             <a:avLst/>
@@ -13808,14 +14164,14 @@
       </p:sp>
       <p:sp>
         <p:nvSpPr>
-          <p:cNvPr id="17" name="Rounded Rectangle 16"/>
+          <p:cNvPr id="22" name="Rounded Rectangle 21"/>
           <p:cNvSpPr/>
           <p:nvPr/>
         </p:nvSpPr>
         <p:spPr>
           <a:xfrm>
-            <a:off x="6437376" y="1645920"/>
-            <a:ext cx="2743200" cy="685800"/>
+            <a:off x="7022592" y="1645920"/>
+            <a:ext cx="2048256" cy="594360"/>
           </a:xfrm>
           <a:prstGeom prst="roundRect">
             <a:avLst/>
@@ -13852,14 +14208,14 @@
       </p:sp>
       <p:sp>
         <p:nvSpPr>
-          <p:cNvPr id="18" name="TextBox 17"/>
+          <p:cNvPr id="23" name="TextBox 22"/>
           <p:cNvSpPr txBox="1"/>
           <p:nvPr/>
         </p:nvSpPr>
         <p:spPr>
           <a:xfrm>
-            <a:off x="6574536" y="1755648"/>
-            <a:ext cx="2468880" cy="502920"/>
+            <a:off x="7114031" y="1773936"/>
+            <a:ext cx="1865376" cy="457200"/>
           </a:xfrm>
           <a:prstGeom prst="rect">
             <a:avLst/>
@@ -13873,7 +14229,7 @@
           <a:lstStyle/>
           <a:p>
             <a:pPr algn="ctr">
-              <a:defRPr sz="1700" b="1">
+              <a:defRPr sz="1500" b="1">
                 <a:solidFill>
                   <a:srgbClr val="FFFFFF"/>
                 </a:solidFill>
@@ -13888,14 +14244,14 @@
       </p:sp>
       <p:sp>
         <p:nvSpPr>
-          <p:cNvPr id="19" name="TextBox 18"/>
+          <p:cNvPr id="24" name="TextBox 23"/>
           <p:cNvSpPr txBox="1"/>
           <p:nvPr/>
         </p:nvSpPr>
         <p:spPr>
           <a:xfrm>
-            <a:off x="6638544" y="2514600"/>
-            <a:ext cx="2377440" cy="1554480"/>
+            <a:off x="7168896" y="2377440"/>
+            <a:ext cx="1783080" cy="1920240"/>
           </a:xfrm>
           <a:prstGeom prst="rect">
             <a:avLst/>
@@ -13909,7 +14265,7 @@
           <a:lstStyle/>
           <a:p>
             <a:pPr algn="l">
-              <a:defRPr sz="1250" b="0">
+              <a:defRPr sz="1100" b="0">
                 <a:solidFill>
                   <a:srgbClr val="334155"/>
                 </a:solidFill>
@@ -13924,14 +14280,14 @@
       </p:sp>
       <p:sp>
         <p:nvSpPr>
-          <p:cNvPr id="20" name="TextBox 19"/>
+          <p:cNvPr id="25" name="TextBox 24"/>
           <p:cNvSpPr txBox="1"/>
           <p:nvPr/>
         </p:nvSpPr>
         <p:spPr>
           <a:xfrm>
-            <a:off x="6638544" y="4160520"/>
-            <a:ext cx="2377440" cy="640080"/>
+            <a:off x="7168896" y="4343400"/>
+            <a:ext cx="1783080" cy="640080"/>
           </a:xfrm>
           <a:prstGeom prst="rect">
             <a:avLst/>
@@ -13945,7 +14301,7 @@
           <a:lstStyle/>
           <a:p>
             <a:pPr algn="l">
-              <a:defRPr sz="1150" b="0">
+              <a:defRPr sz="1000" b="0">
                 <a:solidFill>
                   <a:srgbClr val="64748B"/>
                 </a:solidFill>
@@ -13953,21 +14309,21 @@
               </a:defRPr>
             </a:pPr>
             <a:r>
-              <a:t>MPI  ·  or MPI-openmpi / MPI-mpich</a:t>
-            </a:r>
-          </a:p>
-        </p:txBody>
-      </p:sp>
-      <p:sp>
-        <p:nvSpPr>
-          <p:cNvPr id="21" name="Rounded Rectangle 20"/>
+              <a:t>MPI · or MPI-openmpi / MPI-mpich</a:t>
+            </a:r>
+          </a:p>
+        </p:txBody>
+      </p:sp>
+      <p:sp>
+        <p:nvSpPr>
+          <p:cNvPr id="26" name="Rounded Rectangle 25"/>
           <p:cNvSpPr/>
           <p:nvPr/>
         </p:nvSpPr>
         <p:spPr>
           <a:xfrm>
-            <a:off x="9381744" y="1645920"/>
-            <a:ext cx="2743200" cy="3246120"/>
+            <a:off x="9180576" y="1645920"/>
+            <a:ext cx="2048256" cy="3429000"/>
           </a:xfrm>
           <a:prstGeom prst="roundRect">
             <a:avLst/>
@@ -14004,14 +14360,14 @@
       </p:sp>
       <p:sp>
         <p:nvSpPr>
-          <p:cNvPr id="22" name="Rounded Rectangle 21"/>
+          <p:cNvPr id="27" name="Rounded Rectangle 26"/>
           <p:cNvSpPr/>
           <p:nvPr/>
         </p:nvSpPr>
         <p:spPr>
           <a:xfrm>
-            <a:off x="9381744" y="1645920"/>
-            <a:ext cx="2743200" cy="685800"/>
+            <a:off x="9180576" y="1645920"/>
+            <a:ext cx="2048256" cy="594360"/>
           </a:xfrm>
           <a:prstGeom prst="roundRect">
             <a:avLst/>
@@ -14048,14 +14404,14 @@
       </p:sp>
       <p:sp>
         <p:nvSpPr>
-          <p:cNvPr id="23" name="TextBox 22"/>
+          <p:cNvPr id="28" name="TextBox 27"/>
           <p:cNvSpPr txBox="1"/>
           <p:nvPr/>
         </p:nvSpPr>
         <p:spPr>
           <a:xfrm>
-            <a:off x="9518904" y="1755648"/>
-            <a:ext cx="2468880" cy="502920"/>
+            <a:off x="9272015" y="1773936"/>
+            <a:ext cx="1865376" cy="457200"/>
           </a:xfrm>
           <a:prstGeom prst="rect">
             <a:avLst/>
@@ -14069,7 +14425,7 @@
           <a:lstStyle/>
           <a:p>
             <a:pPr algn="ctr">
-              <a:defRPr sz="1700" b="1">
+              <a:defRPr sz="1500" b="1">
                 <a:solidFill>
                   <a:srgbClr val="FFFFFF"/>
                 </a:solidFill>
@@ -14084,14 +14440,14 @@
       </p:sp>
       <p:sp>
         <p:nvSpPr>
-          <p:cNvPr id="24" name="TextBox 23"/>
+          <p:cNvPr id="29" name="TextBox 28"/>
           <p:cNvSpPr txBox="1"/>
           <p:nvPr/>
         </p:nvSpPr>
         <p:spPr>
           <a:xfrm>
-            <a:off x="9582912" y="2514600"/>
-            <a:ext cx="2377440" cy="1554480"/>
+            <a:off x="9326880" y="2377440"/>
+            <a:ext cx="1783080" cy="1920240"/>
           </a:xfrm>
           <a:prstGeom prst="rect">
             <a:avLst/>
@@ -14105,7 +14461,7 @@
           <a:lstStyle/>
           <a:p>
             <a:pPr algn="l">
-              <a:defRPr sz="1250" b="0">
+              <a:defRPr sz="1100" b="0">
                 <a:solidFill>
                   <a:srgbClr val="334155"/>
                 </a:solidFill>
@@ -14113,21 +14469,21 @@
               </a:defRPr>
             </a:pPr>
             <a:r>
-              <a:t>Carries the full MPI roster plus the GPU payload. Load GPU instead of MPI, not in addition to it.</a:t>
-            </a:r>
-          </a:p>
-        </p:txBody>
-      </p:sp>
-      <p:sp>
-        <p:nvSpPr>
-          <p:cNvPr id="25" name="TextBox 24"/>
+              <a:t>The full MPI roster plus the GPU payload. Load GPU instead of MPI, not in addition.</a:t>
+            </a:r>
+          </a:p>
+        </p:txBody>
+      </p:sp>
+      <p:sp>
+        <p:nvSpPr>
+          <p:cNvPr id="30" name="TextBox 29"/>
           <p:cNvSpPr txBox="1"/>
           <p:nvPr/>
         </p:nvSpPr>
         <p:spPr>
           <a:xfrm>
-            <a:off x="9582912" y="4160520"/>
-            <a:ext cx="2377440" cy="640080"/>
+            <a:off x="9326880" y="4343400"/>
+            <a:ext cx="1783080" cy="640080"/>
           </a:xfrm>
           <a:prstGeom prst="rect">
             <a:avLst/>
@@ -14141,7 +14497,7 @@
           <a:lstStyle/>
           <a:p>
             <a:pPr algn="l">
-              <a:defRPr sz="1150" b="0">
+              <a:defRPr sz="1000" b="0">
                 <a:solidFill>
                   <a:srgbClr val="64748B"/>
                 </a:solidFill>
@@ -14149,14 +14505,14 @@
               </a:defRPr>
             </a:pPr>
             <a:r>
-              <a:t>GPU  ·  or GPU-gfx90a / GPU-gfx942</a:t>
-            </a:r>
-          </a:p>
-        </p:txBody>
-      </p:sp>
-      <p:sp>
-        <p:nvSpPr>
-          <p:cNvPr id="26" name="Rounded Rectangle 25"/>
+              <a:t>GPU · or GPU-gfx90a / GPU-gfx942</a:t>
+            </a:r>
+          </a:p>
+        </p:txBody>
+      </p:sp>
+      <p:sp>
+        <p:nvSpPr>
+          <p:cNvPr id="31" name="Rounded Rectangle 30"/>
           <p:cNvSpPr/>
           <p:nvPr/>
         </p:nvSpPr>
@@ -14511,7 +14867,7 @@
         <p:spPr>
           <a:xfrm>
             <a:off x="822959" y="2743200"/>
-            <a:ext cx="2331720" cy="502920"/>
+            <a:ext cx="1508760" cy="502920"/>
           </a:xfrm>
           <a:prstGeom prst="roundRect">
             <a:avLst/>
@@ -14543,7 +14899,7 @@
           <a:lstStyle/>
           <a:p>
             <a:pPr algn="ctr">
-              <a:defRPr sz="1200" b="1">
+              <a:defRPr sz="1100" b="1">
                 <a:solidFill>
                   <a:srgbClr val="FFFFFF"/>
                 </a:solidFill>
@@ -14551,7 +14907,7 @@
               </a:defRPr>
             </a:pPr>
             <a:r>
-              <a:t>Core (automatic)</a:t>
+              <a:t>Core</a:t>
             </a:r>
           </a:p>
         </p:txBody>
@@ -14564,8 +14920,62 @@
         </p:nvSpPr>
         <p:spPr>
           <a:xfrm>
-            <a:off x="3291840" y="2743200"/>
-            <a:ext cx="2331720" cy="502920"/>
+            <a:off x="2468880" y="2743200"/>
+            <a:ext cx="1508760" cy="502920"/>
+          </a:xfrm>
+          <a:prstGeom prst="roundRect">
+            <a:avLst/>
+          </a:prstGeom>
+          <a:solidFill>
+            <a:srgbClr val="15803D"/>
+          </a:solidFill>
+          <a:ln>
+            <a:noFill/>
+          </a:ln>
+          <a:effectLst/>
+        </p:spPr>
+        <p:style>
+          <a:lnRef idx="1">
+            <a:schemeClr val="accent1"/>
+          </a:lnRef>
+          <a:fillRef idx="3">
+            <a:schemeClr val="accent1"/>
+          </a:fillRef>
+          <a:effectRef idx="2">
+            <a:schemeClr val="accent1"/>
+          </a:effectRef>
+          <a:fontRef idx="minor">
+            <a:schemeClr val="lt1"/>
+          </a:fontRef>
+        </p:style>
+        <p:txBody>
+          <a:bodyPr rtlCol="0" anchor="ctr" wrap="square" lIns="109728" rIns="109728"/>
+          <a:lstStyle/>
+          <a:p>
+            <a:pPr algn="ctr">
+              <a:defRPr sz="1100" b="1">
+                <a:solidFill>
+                  <a:srgbClr val="FFFFFF"/>
+                </a:solidFill>
+                <a:latin typeface="Avenir Next"/>
+              </a:defRPr>
+            </a:pPr>
+            <a:r>
+              <a:t>Common</a:t>
+            </a:r>
+          </a:p>
+        </p:txBody>
+      </p:sp>
+      <p:sp>
+        <p:nvSpPr>
+          <p:cNvPr id="11" name="Rounded Rectangle 10"/>
+          <p:cNvSpPr/>
+          <p:nvPr/>
+        </p:nvSpPr>
+        <p:spPr>
+          <a:xfrm>
+            <a:off x="4114800" y="2743200"/>
+            <a:ext cx="1508760" cy="502920"/>
           </a:xfrm>
           <a:prstGeom prst="roundRect">
             <a:avLst/>
@@ -14597,7 +15007,7 @@
           <a:lstStyle/>
           <a:p>
             <a:pPr algn="ctr">
-              <a:defRPr sz="1200" b="1">
+              <a:defRPr sz="1100" b="1">
                 <a:solidFill>
                   <a:srgbClr val="FFFFFF"/>
                 </a:solidFill>
@@ -14605,14 +15015,14 @@
               </a:defRPr>
             </a:pPr>
             <a:r>
-              <a:t>Foundation (on the path)</a:t>
-            </a:r>
-          </a:p>
-        </p:txBody>
-      </p:sp>
-      <p:sp>
-        <p:nvSpPr>
-          <p:cNvPr id="11" name="Rounded Rectangle 10"/>
+              <a:t>Foundation</a:t>
+            </a:r>
+          </a:p>
+        </p:txBody>
+      </p:sp>
+      <p:sp>
+        <p:nvSpPr>
+          <p:cNvPr id="12" name="Rounded Rectangle 11"/>
           <p:cNvSpPr/>
           <p:nvPr/>
         </p:nvSpPr>
@@ -14666,7 +15076,7 @@
       </p:sp>
       <p:sp>
         <p:nvSpPr>
-          <p:cNvPr id="12" name="Rounded Rectangle 11"/>
+          <p:cNvPr id="13" name="Rounded Rectangle 12"/>
           <p:cNvSpPr/>
           <p:nvPr/>
         </p:nvSpPr>
@@ -14720,7 +15130,7 @@
       </p:sp>
       <p:sp>
         <p:nvSpPr>
-          <p:cNvPr id="13" name="Rounded Rectangle 12"/>
+          <p:cNvPr id="14" name="Rounded Rectangle 13"/>
           <p:cNvSpPr/>
           <p:nvPr/>
         </p:nvSpPr>
@@ -14774,7 +15184,7 @@
       </p:sp>
       <p:sp>
         <p:nvSpPr>
-          <p:cNvPr id="14" name="Rounded Rectangle 13"/>
+          <p:cNvPr id="15" name="Rounded Rectangle 14"/>
           <p:cNvSpPr/>
           <p:nvPr/>
         </p:nvSpPr>
@@ -14818,7 +15228,7 @@
       </p:sp>
       <p:sp>
         <p:nvSpPr>
-          <p:cNvPr id="15" name="TextBox 14"/>
+          <p:cNvPr id="16" name="TextBox 15"/>
           <p:cNvSpPr txBox="1"/>
           <p:nvPr/>
         </p:nvSpPr>
@@ -14854,7 +15264,7 @@
       </p:sp>
       <p:sp>
         <p:nvSpPr>
-          <p:cNvPr id="16" name="TextBox 15"/>
+          <p:cNvPr id="17" name="TextBox 16"/>
           <p:cNvSpPr txBox="1"/>
           <p:nvPr/>
         </p:nvSpPr>
@@ -14890,14 +15300,14 @@
       </p:sp>
       <p:sp>
         <p:nvSpPr>
-          <p:cNvPr id="17" name="Rounded Rectangle 16"/>
+          <p:cNvPr id="18" name="Rounded Rectangle 17"/>
           <p:cNvSpPr/>
           <p:nvPr/>
         </p:nvSpPr>
         <p:spPr>
           <a:xfrm>
             <a:off x="6537959" y="2743200"/>
-            <a:ext cx="2331720" cy="502920"/>
+            <a:ext cx="1508760" cy="502920"/>
           </a:xfrm>
           <a:prstGeom prst="roundRect">
             <a:avLst/>
@@ -14929,7 +15339,7 @@
           <a:lstStyle/>
           <a:p>
             <a:pPr algn="ctr">
-              <a:defRPr sz="1200" b="1">
+              <a:defRPr sz="1100" b="1">
                 <a:solidFill>
                   <a:srgbClr val="FFFFFF"/>
                 </a:solidFill>
@@ -14937,21 +15347,75 @@
               </a:defRPr>
             </a:pPr>
             <a:r>
-              <a:t>Core (automatic)</a:t>
-            </a:r>
-          </a:p>
-        </p:txBody>
-      </p:sp>
-      <p:sp>
-        <p:nvSpPr>
-          <p:cNvPr id="18" name="Rounded Rectangle 17"/>
+              <a:t>Core</a:t>
+            </a:r>
+          </a:p>
+        </p:txBody>
+      </p:sp>
+      <p:sp>
+        <p:nvSpPr>
+          <p:cNvPr id="19" name="Rounded Rectangle 18"/>
           <p:cNvSpPr/>
           <p:nvPr/>
         </p:nvSpPr>
         <p:spPr>
           <a:xfrm>
-            <a:off x="9006840" y="2743200"/>
-            <a:ext cx="2331720" cy="502920"/>
+            <a:off x="8183879" y="2743200"/>
+            <a:ext cx="1508760" cy="502920"/>
+          </a:xfrm>
+          <a:prstGeom prst="roundRect">
+            <a:avLst/>
+          </a:prstGeom>
+          <a:solidFill>
+            <a:srgbClr val="15803D"/>
+          </a:solidFill>
+          <a:ln>
+            <a:noFill/>
+          </a:ln>
+          <a:effectLst/>
+        </p:spPr>
+        <p:style>
+          <a:lnRef idx="1">
+            <a:schemeClr val="accent1"/>
+          </a:lnRef>
+          <a:fillRef idx="3">
+            <a:schemeClr val="accent1"/>
+          </a:fillRef>
+          <a:effectRef idx="2">
+            <a:schemeClr val="accent1"/>
+          </a:effectRef>
+          <a:fontRef idx="minor">
+            <a:schemeClr val="lt1"/>
+          </a:fontRef>
+        </p:style>
+        <p:txBody>
+          <a:bodyPr rtlCol="0" anchor="ctr" wrap="square" lIns="109728" rIns="109728"/>
+          <a:lstStyle/>
+          <a:p>
+            <a:pPr algn="ctr">
+              <a:defRPr sz="1100" b="1">
+                <a:solidFill>
+                  <a:srgbClr val="FFFFFF"/>
+                </a:solidFill>
+                <a:latin typeface="Avenir Next"/>
+              </a:defRPr>
+            </a:pPr>
+            <a:r>
+              <a:t>Common</a:t>
+            </a:r>
+          </a:p>
+        </p:txBody>
+      </p:sp>
+      <p:sp>
+        <p:nvSpPr>
+          <p:cNvPr id="20" name="Rounded Rectangle 19"/>
+          <p:cNvSpPr/>
+          <p:nvPr/>
+        </p:nvSpPr>
+        <p:spPr>
+          <a:xfrm>
+            <a:off x="9829800" y="2743200"/>
+            <a:ext cx="1508760" cy="502920"/>
           </a:xfrm>
           <a:prstGeom prst="roundRect">
             <a:avLst/>
@@ -14983,7 +15447,7 @@
           <a:lstStyle/>
           <a:p>
             <a:pPr algn="ctr">
-              <a:defRPr sz="1200" b="1">
+              <a:defRPr sz="1100" b="1">
                 <a:solidFill>
                   <a:srgbClr val="FFFFFF"/>
                 </a:solidFill>
@@ -14991,14 +15455,14 @@
               </a:defRPr>
             </a:pPr>
             <a:r>
-              <a:t>Foundation (on the path)</a:t>
-            </a:r>
-          </a:p>
-        </p:txBody>
-      </p:sp>
-      <p:sp>
-        <p:nvSpPr>
-          <p:cNvPr id="19" name="Rounded Rectangle 18"/>
+              <a:t>Foundation</a:t>
+            </a:r>
+          </a:p>
+        </p:txBody>
+      </p:sp>
+      <p:sp>
+        <p:nvSpPr>
+          <p:cNvPr id="21" name="Rounded Rectangle 20"/>
           <p:cNvSpPr/>
           <p:nvPr/>
         </p:nvSpPr>
@@ -15052,7 +15516,7 @@
       </p:sp>
       <p:sp>
         <p:nvSpPr>
-          <p:cNvPr id="20" name="Rounded Rectangle 19"/>
+          <p:cNvPr id="22" name="Rounded Rectangle 21"/>
           <p:cNvSpPr/>
           <p:nvPr/>
         </p:nvSpPr>
@@ -15106,7 +15570,7 @@
       </p:sp>
       <p:sp>
         <p:nvSpPr>
-          <p:cNvPr id="21" name="Rounded Rectangle 20"/>
+          <p:cNvPr id="23" name="Rounded Rectangle 22"/>
           <p:cNvSpPr/>
           <p:nvPr/>
         </p:nvSpPr>
@@ -15160,7 +15624,7 @@
       </p:sp>
       <p:sp>
         <p:nvSpPr>
-          <p:cNvPr id="22" name="TextBox 21"/>
+          <p:cNvPr id="24" name="TextBox 23"/>
           <p:cNvSpPr txBox="1"/>
           <p:nvPr/>
         </p:nvSpPr>
@@ -15196,7 +15660,7 @@
       </p:sp>
       <p:sp>
         <p:nvSpPr>
-          <p:cNvPr id="23" name="Rounded Rectangle 22"/>
+          <p:cNvPr id="25" name="Rounded Rectangle 24"/>
           <p:cNvSpPr/>
           <p:nvPr/>
         </p:nvSpPr>
@@ -15250,7 +15714,7 @@
       </p:sp>
       <p:sp>
         <p:nvSpPr>
-          <p:cNvPr id="24" name="Rounded Rectangle 23"/>
+          <p:cNvPr id="26" name="Rounded Rectangle 25"/>
           <p:cNvSpPr/>
           <p:nvPr/>
         </p:nvSpPr>
@@ -15304,7 +15768,7 @@
       </p:sp>
       <p:sp>
         <p:nvSpPr>
-          <p:cNvPr id="25" name="Rounded Rectangle 24"/>
+          <p:cNvPr id="27" name="Rounded Rectangle 26"/>
           <p:cNvSpPr/>
           <p:nvPr/>
         </p:nvSpPr>
@@ -15358,7 +15822,7 @@
       </p:sp>
       <p:sp>
         <p:nvSpPr>
-          <p:cNvPr id="26" name="Rounded Rectangle 25"/>
+          <p:cNvPr id="28" name="Rounded Rectangle 27"/>
           <p:cNvSpPr/>
           <p:nvPr/>
         </p:nvSpPr>
@@ -15412,7 +15876,7 @@
       </p:sp>
       <p:sp>
         <p:nvSpPr>
-          <p:cNvPr id="27" name="Rounded Rectangle 26"/>
+          <p:cNvPr id="29" name="Rounded Rectangle 28"/>
           <p:cNvSpPr/>
           <p:nvPr/>
         </p:nvSpPr>
@@ -15466,7 +15930,7 @@
       </p:sp>
       <p:sp>
         <p:nvSpPr>
-          <p:cNvPr id="28" name="Rounded Rectangle 27"/>
+          <p:cNvPr id="30" name="Rounded Rectangle 29"/>
           <p:cNvSpPr/>
           <p:nvPr/>
         </p:nvSpPr>
@@ -15520,7 +15984,7 @@
       </p:sp>
       <p:sp>
         <p:nvSpPr>
-          <p:cNvPr id="29" name="Rounded Rectangle 28"/>
+          <p:cNvPr id="31" name="Rounded Rectangle 30"/>
           <p:cNvSpPr/>
           <p:nvPr/>
         </p:nvSpPr>
@@ -15574,7 +16038,7 @@
       </p:sp>
       <p:sp>
         <p:nvSpPr>
-          <p:cNvPr id="30" name="Rounded Rectangle 29"/>
+          <p:cNvPr id="32" name="Rounded Rectangle 31"/>
           <p:cNvSpPr/>
           <p:nvPr/>
         </p:nvSpPr>
@@ -15628,7 +16092,7 @@
       </p:sp>
       <p:sp>
         <p:nvSpPr>
-          <p:cNvPr id="31" name="Rounded Rectangle 30"/>
+          <p:cNvPr id="33" name="Rounded Rectangle 32"/>
           <p:cNvSpPr/>
           <p:nvPr/>
         </p:nvSpPr>
@@ -15682,7 +16146,7 @@
       </p:sp>
       <p:sp>
         <p:nvSpPr>
-          <p:cNvPr id="32" name="Rounded Rectangle 31"/>
+          <p:cNvPr id="34" name="Rounded Rectangle 33"/>
           <p:cNvSpPr/>
           <p:nvPr/>
         </p:nvSpPr>
@@ -15736,7 +16200,7 @@
       </p:sp>
       <p:sp>
         <p:nvSpPr>
-          <p:cNvPr id="33" name="Rounded Rectangle 32"/>
+          <p:cNvPr id="35" name="Rounded Rectangle 34"/>
           <p:cNvSpPr/>
           <p:nvPr/>
         </p:nvSpPr>
@@ -15790,7 +16254,7 @@
       </p:sp>
       <p:sp>
         <p:nvSpPr>
-          <p:cNvPr id="34" name="Rounded Rectangle 33"/>
+          <p:cNvPr id="36" name="Rounded Rectangle 35"/>
           <p:cNvSpPr/>
           <p:nvPr/>
         </p:nvSpPr>
@@ -15844,7 +16308,7 @@
       </p:sp>
       <p:sp>
         <p:nvSpPr>
-          <p:cNvPr id="35" name="Rounded Rectangle 34"/>
+          <p:cNvPr id="37" name="Rounded Rectangle 36"/>
           <p:cNvSpPr/>
           <p:nvPr/>
         </p:nvSpPr>
@@ -15898,7 +16362,7 @@
       </p:sp>
       <p:sp>
         <p:nvSpPr>
-          <p:cNvPr id="36" name="Rounded Rectangle 35"/>
+          <p:cNvPr id="38" name="Rounded Rectangle 37"/>
           <p:cNvSpPr/>
           <p:nvPr/>
         </p:nvSpPr>
@@ -15952,7 +16416,7 @@
       </p:sp>
       <p:sp>
         <p:nvSpPr>
-          <p:cNvPr id="37" name="TextBox 36"/>
+          <p:cNvPr id="39" name="TextBox 38"/>
           <p:cNvSpPr txBox="1"/>
           <p:nvPr/>
         </p:nvSpPr>

</xml_diff>

<commit_message>
Schedulers on the systems slide; richer palette; map matches the deck
Each system card names its scheduler, since launch mechanics for MPI and
GPU jobs differ by it: Blueback, Fran, and Raider run Slurm, Wheat runs
PBS, and the coverage bar records the Slurm-plus-PBS spread. The palette
gains some saturation over the first navy/gold pass. The placement map's
stylesheet moves to the same palette, light and dark, with the gold
kicker, and ships alongside as a PDF for anyone who prefers one.
</commit_message>
<xml_diff>
--- a/presentations/cse_lanes_model.pptx
+++ b/presentations/cse_lanes_model.pptx
@@ -3325,7 +3325,7 @@
             <a:avLst/>
           </a:prstGeom>
           <a:solidFill>
-            <a:srgbClr val="1D6E6A"/>
+            <a:srgbClr val="117A72"/>
           </a:solidFill>
           <a:ln>
             <a:noFill/>
@@ -3369,7 +3369,7 @@
             <a:avLst/>
           </a:prstGeom>
           <a:solidFill>
-            <a:srgbClr val="A86A14"/>
+            <a:srgbClr val="BA740E"/>
           </a:solidFill>
           <a:ln>
             <a:noFill/>
@@ -3413,7 +3413,7 @@
             <a:avLst/>
           </a:prstGeom>
           <a:solidFill>
-            <a:srgbClr val="2C5AA0"/>
+            <a:srgbClr val="2B62B8"/>
           </a:solidFill>
           <a:ln>
             <a:noFill/>
@@ -3457,7 +3457,7 @@
             <a:avLst/>
           </a:prstGeom>
           <a:solidFill>
-            <a:srgbClr val="634A94"/>
+            <a:srgbClr val="6D4EAA"/>
           </a:solidFill>
           <a:ln>
             <a:noFill/>
@@ -3573,7 +3573,7 @@
             <a:pPr algn="l">
               <a:defRPr sz="1300" b="1">
                 <a:solidFill>
-                  <a:srgbClr val="8C6D1F"/>
+                  <a:srgbClr val="9A7614"/>
                 </a:solidFill>
                 <a:latin typeface="Avenir Next"/>
               </a:defRPr>
@@ -3689,7 +3689,7 @@
             <a:pPr algn="l">
               <a:defRPr sz="1350" b="1">
                 <a:solidFill>
-                  <a:srgbClr val="2E6B45"/>
+                  <a:srgbClr val="2C7A4B"/>
                 </a:solidFill>
                 <a:latin typeface="Avenir Next"/>
               </a:defRPr>
@@ -3805,7 +3805,7 @@
             <a:pPr algn="l">
               <a:defRPr sz="1350" b="1">
                 <a:solidFill>
-                  <a:srgbClr val="1D6E6A"/>
+                  <a:srgbClr val="117A72"/>
                 </a:solidFill>
                 <a:latin typeface="Avenir Next"/>
               </a:defRPr>
@@ -3921,7 +3921,7 @@
             <a:pPr algn="l">
               <a:defRPr sz="1350" b="1">
                 <a:solidFill>
-                  <a:srgbClr val="A86A14"/>
+                  <a:srgbClr val="BA740E"/>
                 </a:solidFill>
                 <a:latin typeface="Avenir Next"/>
               </a:defRPr>
@@ -4037,7 +4037,7 @@
             <a:pPr algn="l">
               <a:defRPr sz="1350" b="1">
                 <a:solidFill>
-                  <a:srgbClr val="634A94"/>
+                  <a:srgbClr val="6D4EAA"/>
                 </a:solidFill>
                 <a:latin typeface="Avenir Next"/>
               </a:defRPr>
@@ -4171,7 +4171,7 @@
             <a:pPr algn="l">
               <a:defRPr sz="1300" b="1">
                 <a:solidFill>
-                  <a:srgbClr val="8C6D1F"/>
+                  <a:srgbClr val="9A7614"/>
                 </a:solidFill>
                 <a:latin typeface="Avenir Next"/>
               </a:defRPr>
@@ -4269,7 +4269,7 @@
             <a:avLst/>
           </a:prstGeom>
           <a:solidFill>
-            <a:srgbClr val="A86A14"/>
+            <a:srgbClr val="BA740E"/>
           </a:solidFill>
           <a:ln>
             <a:noFill/>
@@ -4349,7 +4349,7 @@
             <a:avLst/>
           </a:prstGeom>
           <a:solidFill>
-            <a:srgbClr val="2C5AA0"/>
+            <a:srgbClr val="2B62B8"/>
           </a:solidFill>
           <a:ln>
             <a:noFill/>
@@ -4429,7 +4429,7 @@
             <a:avLst/>
           </a:prstGeom>
           <a:solidFill>
-            <a:srgbClr val="634A94"/>
+            <a:srgbClr val="6D4EAA"/>
           </a:solidFill>
           <a:ln>
             <a:noFill/>
@@ -4509,7 +4509,7 @@
             <a:avLst/>
           </a:prstGeom>
           <a:solidFill>
-            <a:srgbClr val="2E6B45"/>
+            <a:srgbClr val="2C7A4B"/>
           </a:solidFill>
           <a:ln>
             <a:noFill/>
@@ -4576,7 +4576,7 @@
             <a:avLst/>
           </a:prstGeom>
           <a:solidFill>
-            <a:srgbClr val="1D6E6A"/>
+            <a:srgbClr val="117A72"/>
           </a:solidFill>
           <a:ln>
             <a:noFill/>
@@ -4887,7 +4887,7 @@
             <a:pPr algn="l">
               <a:defRPr sz="1300" b="1">
                 <a:solidFill>
-                  <a:srgbClr val="8C6D1F"/>
+                  <a:srgbClr val="9A7614"/>
                 </a:solidFill>
                 <a:latin typeface="Avenir Next"/>
               </a:defRPr>
@@ -5316,7 +5316,7 @@
                   </a:txBody>
                   <a:tcPr marL="109728" marR="73152" marT="13716" marB="13716" anchor="ctr">
                     <a:solidFill>
-                      <a:srgbClr val="1D6E6A"/>
+                      <a:srgbClr val="117A72"/>
                     </a:solidFill>
                   </a:tcPr>
                 </a:tc>
@@ -5725,7 +5725,7 @@
                   </a:txBody>
                   <a:tcPr marL="109728" marR="73152" marT="13716" marB="13716" anchor="ctr">
                     <a:solidFill>
-                      <a:srgbClr val="1D6E6A"/>
+                      <a:srgbClr val="117A72"/>
                     </a:solidFill>
                   </a:tcPr>
                 </a:tc>
@@ -5909,7 +5909,7 @@
                   </a:txBody>
                   <a:tcPr marL="109728" marR="73152" marT="13716" marB="13716" anchor="ctr">
                     <a:solidFill>
-                      <a:srgbClr val="2E6B45"/>
+                      <a:srgbClr val="2C7A4B"/>
                     </a:solidFill>
                   </a:tcPr>
                 </a:tc>
@@ -6205,7 +6205,7 @@
             <a:pPr algn="l">
               <a:defRPr sz="1300" b="1">
                 <a:solidFill>
-                  <a:srgbClr val="8C6D1F"/>
+                  <a:srgbClr val="9A7614"/>
                 </a:solidFill>
                 <a:latin typeface="Avenir Next"/>
               </a:defRPr>
@@ -6370,7 +6370,7 @@
                   </a:txBody>
                   <a:tcPr marL="109728" marR="73152" marT="13716" marB="13716" anchor="ctr">
                     <a:solidFill>
-                      <a:srgbClr val="A86A14"/>
+                      <a:srgbClr val="BA740E"/>
                     </a:solidFill>
                   </a:tcPr>
                 </a:tc>
@@ -6708,7 +6708,7 @@
                   </a:txBody>
                   <a:tcPr marL="109728" marR="73152" marT="13716" marB="13716" anchor="ctr">
                     <a:solidFill>
-                      <a:srgbClr val="A86A14"/>
+                      <a:srgbClr val="BA740E"/>
                     </a:solidFill>
                   </a:tcPr>
                 </a:tc>
@@ -7004,7 +7004,7 @@
             <a:pPr algn="l">
               <a:defRPr sz="1300" b="1">
                 <a:solidFill>
-                  <a:srgbClr val="8C6D1F"/>
+                  <a:srgbClr val="9A7614"/>
                 </a:solidFill>
                 <a:latin typeface="Avenir Next"/>
               </a:defRPr>
@@ -7169,7 +7169,7 @@
                   </a:txBody>
                   <a:tcPr marL="109728" marR="73152" marT="13716" marB="13716" anchor="ctr">
                     <a:solidFill>
-                      <a:srgbClr val="2C5AA0"/>
+                      <a:srgbClr val="2B62B8"/>
                     </a:solidFill>
                   </a:tcPr>
                 </a:tc>
@@ -7507,7 +7507,7 @@
                   </a:txBody>
                   <a:tcPr marL="109728" marR="73152" marT="13716" marB="13716" anchor="ctr">
                     <a:solidFill>
-                      <a:srgbClr val="2C5AA0"/>
+                      <a:srgbClr val="2B62B8"/>
                     </a:solidFill>
                   </a:tcPr>
                 </a:tc>
@@ -7919,7 +7919,7 @@
                   </a:txBody>
                   <a:tcPr marL="109728" marR="73152" marT="13716" marB="13716" anchor="ctr">
                     <a:solidFill>
-                      <a:srgbClr val="634A94"/>
+                      <a:srgbClr val="6D4EAA"/>
                     </a:solidFill>
                   </a:tcPr>
                 </a:tc>
@@ -8109,7 +8109,7 @@
                   </a:txBody>
                   <a:tcPr marL="109728" marR="73152" marT="13716" marB="13716" anchor="ctr">
                     <a:solidFill>
-                      <a:srgbClr val="2E6B45"/>
+                      <a:srgbClr val="2C7A4B"/>
                     </a:solidFill>
                   </a:tcPr>
                 </a:tc>
@@ -8447,7 +8447,7 @@
             <a:pPr algn="l">
               <a:defRPr sz="1300" b="1">
                 <a:solidFill>
-                  <a:srgbClr val="8C6D1F"/>
+                  <a:srgbClr val="9A7614"/>
                 </a:solidFill>
                 <a:latin typeface="Avenir Next"/>
               </a:defRPr>
@@ -9283,7 +9283,7 @@
             <a:pPr algn="l">
               <a:defRPr sz="1350" b="1">
                 <a:solidFill>
-                  <a:srgbClr val="A86A14"/>
+                  <a:srgbClr val="BA740E"/>
                 </a:solidFill>
                 <a:latin typeface="Avenir Next"/>
               </a:defRPr>
@@ -9472,7 +9472,7 @@
           </a:prstGeom>
           <a:ln w="28575">
             <a:solidFill>
-              <a:srgbClr val="1D6E6A"/>
+              <a:srgbClr val="117A72"/>
             </a:solidFill>
             <a:tailEnd type="triangle" w="med" len="med"/>
           </a:ln>
@@ -9508,7 +9508,7 @@
             <a:avLst/>
           </a:prstGeom>
           <a:solidFill>
-            <a:srgbClr val="1D6E6A"/>
+            <a:srgbClr val="117A72"/>
           </a:solidFill>
           <a:ln>
             <a:noFill/>
@@ -9575,7 +9575,7 @@
             <a:avLst/>
           </a:prstGeom>
           <a:solidFill>
-            <a:srgbClr val="2E6B45"/>
+            <a:srgbClr val="2C7A4B"/>
           </a:solidFill>
           <a:ln>
             <a:noFill/>
@@ -9710,7 +9710,7 @@
           </a:prstGeom>
           <a:ln w="28575">
             <a:solidFill>
-              <a:srgbClr val="1D6E6A"/>
+              <a:srgbClr val="117A72"/>
             </a:solidFill>
             <a:tailEnd type="triangle" w="med" len="med"/>
           </a:ln>
@@ -9782,7 +9782,7 @@
             <a:avLst/>
           </a:prstGeom>
           <a:solidFill>
-            <a:srgbClr val="A86A14"/>
+            <a:srgbClr val="BA740E"/>
           </a:solidFill>
           <a:ln>
             <a:noFill/>
@@ -9836,7 +9836,7 @@
             <a:avLst/>
           </a:prstGeom>
           <a:solidFill>
-            <a:srgbClr val="2C5AA0"/>
+            <a:srgbClr val="2B62B8"/>
           </a:solidFill>
           <a:ln>
             <a:noFill/>
@@ -9890,7 +9890,7 @@
             <a:avLst/>
           </a:prstGeom>
           <a:solidFill>
-            <a:srgbClr val="634A94"/>
+            <a:srgbClr val="6D4EAA"/>
           </a:solidFill>
           <a:ln>
             <a:noFill/>
@@ -9954,7 +9954,7 @@
             <a:pPr algn="l">
               <a:defRPr sz="1350" b="1">
                 <a:solidFill>
-                  <a:srgbClr val="1D6E6A"/>
+                  <a:srgbClr val="117A72"/>
                 </a:solidFill>
                 <a:latin typeface="Avenir Next"/>
               </a:defRPr>
@@ -10078,7 +10078,7 @@
             <a:pPr algn="l">
               <a:defRPr sz="1300" b="1">
                 <a:solidFill>
-                  <a:srgbClr val="8C6D1F"/>
+                  <a:srgbClr val="9A7614"/>
                 </a:solidFill>
                 <a:latin typeface="Avenir Next"/>
               </a:defRPr>
@@ -10194,7 +10194,7 @@
             <a:pPr algn="l">
               <a:defRPr sz="1450" b="1">
                 <a:solidFill>
-                  <a:srgbClr val="2C5AA0"/>
+                  <a:srgbClr val="2B62B8"/>
                 </a:solidFill>
                 <a:latin typeface="Avenir Next"/>
               </a:defRPr>
@@ -10230,7 +10230,7 @@
             <a:pPr algn="l">
               <a:defRPr sz="1600" b="1">
                 <a:solidFill>
-                  <a:srgbClr val="2C5AA0"/>
+                  <a:srgbClr val="2B62B8"/>
                 </a:solidFill>
                 <a:latin typeface="Avenir Next"/>
               </a:defRPr>
@@ -10372,7 +10372,7 @@
             <a:pPr algn="l">
               <a:defRPr sz="1450" b="1">
                 <a:solidFill>
-                  <a:srgbClr val="634A94"/>
+                  <a:srgbClr val="6D4EAA"/>
                 </a:solidFill>
                 <a:latin typeface="Avenir Next"/>
               </a:defRPr>
@@ -10408,7 +10408,7 @@
             <a:pPr algn="l">
               <a:defRPr sz="1600" b="1">
                 <a:solidFill>
-                  <a:srgbClr val="634A94"/>
+                  <a:srgbClr val="6D4EAA"/>
                 </a:solidFill>
                 <a:latin typeface="Avenir Next"/>
               </a:defRPr>
@@ -10550,7 +10550,7 @@
             <a:pPr algn="l">
               <a:defRPr sz="1450" b="1">
                 <a:solidFill>
-                  <a:srgbClr val="1D6E6A"/>
+                  <a:srgbClr val="117A72"/>
                 </a:solidFill>
                 <a:latin typeface="Avenir Next"/>
               </a:defRPr>
@@ -10586,7 +10586,7 @@
             <a:pPr algn="l">
               <a:defRPr sz="1600" b="1">
                 <a:solidFill>
-                  <a:srgbClr val="1D6E6A"/>
+                  <a:srgbClr val="117A72"/>
                 </a:solidFill>
                 <a:latin typeface="Avenir Next"/>
               </a:defRPr>
@@ -10800,7 +10800,7 @@
             <a:pPr algn="l">
               <a:defRPr sz="1300" b="1">
                 <a:solidFill>
-                  <a:srgbClr val="8C6D1F"/>
+                  <a:srgbClr val="9A7614"/>
                 </a:solidFill>
                 <a:latin typeface="Avenir Next"/>
               </a:defRPr>
@@ -10945,7 +10945,7 @@
           </a:prstGeom>
           <a:ln w="28575">
             <a:solidFill>
-              <a:srgbClr val="1D6E6A"/>
+              <a:srgbClr val="117A72"/>
             </a:solidFill>
             <a:tailEnd type="triangle" w="med" len="med"/>
           </a:ln>
@@ -11064,7 +11064,7 @@
           </a:prstGeom>
           <a:ln w="28575">
             <a:solidFill>
-              <a:srgbClr val="1D6E6A"/>
+              <a:srgbClr val="117A72"/>
             </a:solidFill>
             <a:tailEnd type="triangle" w="med" len="med"/>
           </a:ln>
@@ -11183,7 +11183,7 @@
           </a:prstGeom>
           <a:ln w="28575">
             <a:solidFill>
-              <a:srgbClr val="1D6E6A"/>
+              <a:srgbClr val="117A72"/>
             </a:solidFill>
             <a:tailEnd type="triangle" w="med" len="med"/>
           </a:ln>
@@ -11302,7 +11302,7 @@
           </a:prstGeom>
           <a:ln w="28575">
             <a:solidFill>
-              <a:srgbClr val="1D6E6A"/>
+              <a:srgbClr val="117A72"/>
             </a:solidFill>
             <a:tailEnd type="triangle" w="med" len="med"/>
           </a:ln>
@@ -11424,7 +11424,7 @@
           </a:solidFill>
           <a:ln w="15875">
             <a:solidFill>
-              <a:srgbClr val="1D6E6A"/>
+              <a:srgbClr val="117A72"/>
             </a:solidFill>
           </a:ln>
           <a:effectLst/>
@@ -11490,7 +11490,7 @@
           </a:prstGeom>
           <a:ln w="28575">
             <a:solidFill>
-              <a:srgbClr val="A86A14"/>
+              <a:srgbClr val="BA740E"/>
             </a:solidFill>
             <a:tailEnd type="triangle" w="med" len="med"/>
           </a:ln>
@@ -11526,7 +11526,7 @@
             <a:avLst/>
           </a:prstGeom>
           <a:solidFill>
-            <a:srgbClr val="A86A14"/>
+            <a:srgbClr val="BA740E"/>
           </a:solidFill>
           <a:ln>
             <a:noFill/>
@@ -11594,7 +11594,7 @@
           </a:prstGeom>
           <a:ln w="28575">
             <a:solidFill>
-              <a:srgbClr val="2C5AA0"/>
+              <a:srgbClr val="2B62B8"/>
             </a:solidFill>
             <a:tailEnd type="triangle" w="med" len="med"/>
           </a:ln>
@@ -11630,7 +11630,7 @@
             <a:avLst/>
           </a:prstGeom>
           <a:solidFill>
-            <a:srgbClr val="2C5AA0"/>
+            <a:srgbClr val="2B62B8"/>
           </a:solidFill>
           <a:ln>
             <a:noFill/>
@@ -11698,7 +11698,7 @@
           </a:prstGeom>
           <a:ln w="28575">
             <a:solidFill>
-              <a:srgbClr val="634A94"/>
+              <a:srgbClr val="6D4EAA"/>
             </a:solidFill>
             <a:tailEnd type="triangle" w="med" len="med"/>
           </a:ln>
@@ -11734,7 +11734,7 @@
             <a:avLst/>
           </a:prstGeom>
           <a:solidFill>
-            <a:srgbClr val="634A94"/>
+            <a:srgbClr val="6D4EAA"/>
           </a:solidFill>
           <a:ln>
             <a:noFill/>
@@ -11811,7 +11811,7 @@
             <a:pPr algn="l">
               <a:defRPr sz="1400" b="1">
                 <a:solidFill>
-                  <a:srgbClr val="1D6E6A"/>
+                  <a:srgbClr val="117A72"/>
                 </a:solidFill>
                 <a:latin typeface="Avenir Next"/>
               </a:defRPr>
@@ -11922,7 +11922,7 @@
             <a:pPr algn="l">
               <a:defRPr sz="1300" b="1">
                 <a:solidFill>
-                  <a:srgbClr val="8C6D1F"/>
+                  <a:srgbClr val="9A7614"/>
                 </a:solidFill>
                 <a:latin typeface="Avenir Next"/>
               </a:defRPr>
@@ -12041,7 +12041,7 @@
           </a:prstGeom>
           <a:ln w="28575">
             <a:solidFill>
-              <a:srgbClr val="1D6E6A"/>
+              <a:srgbClr val="117A72"/>
             </a:solidFill>
             <a:tailEnd type="triangle" w="med" len="med"/>
           </a:ln>
@@ -12077,7 +12077,7 @@
             <a:avLst/>
           </a:prstGeom>
           <a:solidFill>
-            <a:srgbClr val="1D6E6A"/>
+            <a:srgbClr val="117A72"/>
           </a:solidFill>
           <a:ln>
             <a:noFill/>
@@ -12144,7 +12144,7 @@
             <a:avLst/>
           </a:prstGeom>
           <a:solidFill>
-            <a:srgbClr val="2E6B45"/>
+            <a:srgbClr val="2C7A4B"/>
           </a:solidFill>
           <a:ln>
             <a:noFill/>
@@ -12279,7 +12279,7 @@
           </a:prstGeom>
           <a:ln w="28575">
             <a:solidFill>
-              <a:srgbClr val="1D6E6A"/>
+              <a:srgbClr val="117A72"/>
             </a:solidFill>
             <a:tailEnd type="triangle" w="med" len="med"/>
           </a:ln>
@@ -12351,7 +12351,7 @@
             <a:avLst/>
           </a:prstGeom>
           <a:solidFill>
-            <a:srgbClr val="A86A14"/>
+            <a:srgbClr val="BA740E"/>
           </a:solidFill>
           <a:ln>
             <a:noFill/>
@@ -12418,7 +12418,7 @@
             <a:avLst/>
           </a:prstGeom>
           <a:solidFill>
-            <a:srgbClr val="2C5AA0"/>
+            <a:srgbClr val="2B62B8"/>
           </a:solidFill>
           <a:ln>
             <a:noFill/>
@@ -12485,7 +12485,7 @@
             <a:avLst/>
           </a:prstGeom>
           <a:solidFill>
-            <a:srgbClr val="634A94"/>
+            <a:srgbClr val="6D4EAA"/>
           </a:solidFill>
           <a:ln>
             <a:noFill/>
@@ -12691,7 +12691,7 @@
             <a:pPr algn="l">
               <a:defRPr sz="1300" b="1">
                 <a:solidFill>
-                  <a:srgbClr val="8C6D1F"/>
+                  <a:srgbClr val="9A7614"/>
                 </a:solidFill>
                 <a:latin typeface="Avenir Next"/>
               </a:defRPr>
@@ -12797,7 +12797,7 @@
             <a:avLst/>
           </a:prstGeom>
           <a:solidFill>
-            <a:srgbClr val="1D6E6A"/>
+            <a:srgbClr val="117A72"/>
           </a:solidFill>
           <a:ln>
             <a:noFill/>
@@ -12993,7 +12993,7 @@
             <a:avLst/>
           </a:prstGeom>
           <a:solidFill>
-            <a:srgbClr val="2E6B45"/>
+            <a:srgbClr val="2C7A4B"/>
           </a:solidFill>
           <a:ln>
             <a:noFill/>
@@ -13189,7 +13189,7 @@
             <a:avLst/>
           </a:prstGeom>
           <a:solidFill>
-            <a:srgbClr val="A86A14"/>
+            <a:srgbClr val="BA740E"/>
           </a:solidFill>
           <a:ln>
             <a:noFill/>
@@ -13385,7 +13385,7 @@
             <a:avLst/>
           </a:prstGeom>
           <a:solidFill>
-            <a:srgbClr val="2C5AA0"/>
+            <a:srgbClr val="2B62B8"/>
           </a:solidFill>
           <a:ln>
             <a:noFill/>
@@ -13581,7 +13581,7 @@
             <a:avLst/>
           </a:prstGeom>
           <a:solidFill>
-            <a:srgbClr val="634A94"/>
+            <a:srgbClr val="6D4EAA"/>
           </a:solidFill>
           <a:ln>
             <a:noFill/>
@@ -13859,7 +13859,7 @@
             <a:pPr algn="l">
               <a:defRPr sz="1300" b="1">
                 <a:solidFill>
-                  <a:srgbClr val="8C6D1F"/>
+                  <a:srgbClr val="9A7614"/>
                 </a:solidFill>
                 <a:latin typeface="Avenir Next"/>
               </a:defRPr>
@@ -14037,7 +14037,7 @@
             <a:avLst/>
           </a:prstGeom>
           <a:solidFill>
-            <a:srgbClr val="1D6E6A"/>
+            <a:srgbClr val="117A72"/>
           </a:solidFill>
           <a:ln>
             <a:noFill/>
@@ -14091,7 +14091,7 @@
             <a:avLst/>
           </a:prstGeom>
           <a:solidFill>
-            <a:srgbClr val="2E6B45"/>
+            <a:srgbClr val="2C7A4B"/>
           </a:solidFill>
           <a:ln>
             <a:noFill/>
@@ -14199,7 +14199,7 @@
             <a:avLst/>
           </a:prstGeom>
           <a:solidFill>
-            <a:srgbClr val="A86A14"/>
+            <a:srgbClr val="BA740E"/>
           </a:solidFill>
           <a:ln>
             <a:noFill/>
@@ -14253,7 +14253,7 @@
             <a:avLst/>
           </a:prstGeom>
           <a:solidFill>
-            <a:srgbClr val="2C5AA0"/>
+            <a:srgbClr val="2B62B8"/>
           </a:solidFill>
           <a:ln>
             <a:noFill/>
@@ -14307,7 +14307,7 @@
             <a:avLst/>
           </a:prstGeom>
           <a:solidFill>
-            <a:srgbClr val="634A94"/>
+            <a:srgbClr val="6D4EAA"/>
           </a:solidFill>
           <a:ln>
             <a:noFill/>
@@ -14477,7 +14477,7 @@
             <a:avLst/>
           </a:prstGeom>
           <a:solidFill>
-            <a:srgbClr val="1D6E6A"/>
+            <a:srgbClr val="117A72"/>
           </a:solidFill>
           <a:ln>
             <a:noFill/>
@@ -14531,7 +14531,7 @@
             <a:avLst/>
           </a:prstGeom>
           <a:solidFill>
-            <a:srgbClr val="2E6B45"/>
+            <a:srgbClr val="2C7A4B"/>
           </a:solidFill>
           <a:ln>
             <a:noFill/>
@@ -14639,7 +14639,7 @@
             <a:avLst/>
           </a:prstGeom>
           <a:solidFill>
-            <a:srgbClr val="A86A14"/>
+            <a:srgbClr val="BA740E"/>
           </a:solidFill>
           <a:ln>
             <a:noFill/>
@@ -14693,7 +14693,7 @@
             <a:avLst/>
           </a:prstGeom>
           <a:solidFill>
-            <a:srgbClr val="2C5AA0"/>
+            <a:srgbClr val="2B62B8"/>
           </a:solidFill>
           <a:ln>
             <a:noFill/>
@@ -14747,7 +14747,7 @@
             <a:avLst/>
           </a:prstGeom>
           <a:solidFill>
-            <a:srgbClr val="634A94"/>
+            <a:srgbClr val="6D4EAA"/>
           </a:solidFill>
           <a:ln>
             <a:noFill/>
@@ -15701,7 +15701,7 @@
             <a:pPr algn="l">
               <a:defRPr sz="1300" b="1">
                 <a:solidFill>
-                  <a:srgbClr val="8C6D1F"/>
+                  <a:srgbClr val="9A7614"/>
                 </a:solidFill>
                 <a:latin typeface="Avenir Next"/>
               </a:defRPr>
@@ -15817,7 +15817,7 @@
             <a:pPr algn="l">
               <a:defRPr sz="1700" b="1">
                 <a:solidFill>
-                  <a:srgbClr val="634A94"/>
+                  <a:srgbClr val="6D4EAA"/>
                 </a:solidFill>
                 <a:latin typeface="Avenir Next"/>
               </a:defRPr>
@@ -15853,7 +15853,7 @@
             <a:pPr algn="r">
               <a:defRPr sz="1150" b="1">
                 <a:solidFill>
-                  <a:srgbClr val="634A94"/>
+                  <a:srgbClr val="6D4EAA"/>
                 </a:solidFill>
                 <a:latin typeface="Avenir Next"/>
               </a:defRPr>
@@ -15895,7 +15895,7 @@
               </a:defRPr>
             </a:pPr>
             <a:r>
-              <a:t>NAVY · HPE Cray EX4000 · SLES</a:t>
+              <a:t>NAVY · HPE Cray EX4000 · SLES · Slurm</a:t>
             </a:r>
           </a:p>
         </p:txBody>
@@ -16041,7 +16041,7 @@
             <a:pPr algn="l">
               <a:defRPr sz="1700" b="1">
                 <a:solidFill>
-                  <a:srgbClr val="2C5AA0"/>
+                  <a:srgbClr val="2B62B8"/>
                 </a:solidFill>
                 <a:latin typeface="Avenir Next"/>
               </a:defRPr>
@@ -16077,7 +16077,7 @@
             <a:pPr algn="r">
               <a:defRPr sz="1150" b="1">
                 <a:solidFill>
-                  <a:srgbClr val="2C5AA0"/>
+                  <a:srgbClr val="2B62B8"/>
                 </a:solidFill>
                 <a:latin typeface="Avenir Next"/>
               </a:defRPr>
@@ -16119,7 +16119,7 @@
               </a:defRPr>
             </a:pPr>
             <a:r>
-              <a:t>ARL · HPE Cray EX4000 · RHEL 9</a:t>
+              <a:t>ARL · HPE Cray EX4000 · RHEL 9 · Slurm</a:t>
             </a:r>
           </a:p>
         </p:txBody>
@@ -16265,7 +16265,7 @@
             <a:pPr algn="l">
               <a:defRPr sz="1700" b="1">
                 <a:solidFill>
-                  <a:srgbClr val="1D6E6A"/>
+                  <a:srgbClr val="117A72"/>
                 </a:solidFill>
                 <a:latin typeface="Avenir Next"/>
               </a:defRPr>
@@ -16301,7 +16301,7 @@
             <a:pPr algn="r">
               <a:defRPr sz="1150" b="1">
                 <a:solidFill>
-                  <a:srgbClr val="1D6E6A"/>
+                  <a:srgbClr val="117A72"/>
                 </a:solidFill>
                 <a:latin typeface="Avenir Next"/>
               </a:defRPr>
@@ -16343,7 +16343,7 @@
               </a:defRPr>
             </a:pPr>
             <a:r>
-              <a:t>AFRL · Penguin TrueHPC · RHEL 8</a:t>
+              <a:t>AFRL · Penguin TrueHPC · RHEL 8 · Slurm</a:t>
             </a:r>
           </a:p>
         </p:txBody>
@@ -16489,7 +16489,7 @@
             <a:pPr algn="l">
               <a:defRPr sz="1700" b="1">
                 <a:solidFill>
-                  <a:srgbClr val="A86A14"/>
+                  <a:srgbClr val="BA740E"/>
                 </a:solidFill>
                 <a:latin typeface="Avenir Next"/>
               </a:defRPr>
@@ -16525,7 +16525,7 @@
             <a:pPr algn="r">
               <a:defRPr sz="1150" b="1">
                 <a:solidFill>
-                  <a:srgbClr val="A86A14"/>
+                  <a:srgbClr val="BA740E"/>
                 </a:solidFill>
                 <a:latin typeface="Avenir Next"/>
               </a:defRPr>
@@ -16567,7 +16567,7 @@
               </a:defRPr>
             </a:pPr>
             <a:r>
-              <a:t>ERDC · Liqid composable · RHEL 8</a:t>
+              <a:t>ERDC · Liqid composable · RHEL 8 · PBS</a:t>
             </a:r>
           </a:p>
         </p:txBody>
@@ -16693,7 +16693,7 @@
               </a:defRPr>
             </a:pPr>
             <a:r>
-              <a:t>Coverage: SLES + RHEL 8 + RHEL 9 · AMD + Intel CPUs · AMD MI300A + NVIDIA H200 and A100</a:t>
+              <a:t>Coverage: SLES + RHEL 8/9 · AMD + Intel CPUs · MI300A + H200 + A100 · Slurm + PBS</a:t>
             </a:r>
           </a:p>
         </p:txBody>
@@ -16821,7 +16821,7 @@
             <a:pPr algn="l">
               <a:defRPr sz="1300" b="1">
                 <a:solidFill>
-                  <a:srgbClr val="8C6D1F"/>
+                  <a:srgbClr val="9A7614"/>
                 </a:solidFill>
                 <a:latin typeface="Avenir Next"/>
               </a:defRPr>
@@ -16927,7 +16927,7 @@
             <a:avLst/>
           </a:prstGeom>
           <a:solidFill>
-            <a:srgbClr val="1D6E6A"/>
+            <a:srgbClr val="117A72"/>
           </a:solidFill>
           <a:ln>
             <a:noFill/>
@@ -17097,7 +17097,7 @@
             <a:avLst/>
           </a:prstGeom>
           <a:solidFill>
-            <a:srgbClr val="2C5AA0"/>
+            <a:srgbClr val="2B62B8"/>
           </a:solidFill>
           <a:ln>
             <a:noFill/>
@@ -17267,7 +17267,7 @@
             <a:avLst/>
           </a:prstGeom>
           <a:solidFill>
-            <a:srgbClr val="634A94"/>
+            <a:srgbClr val="6D4EAA"/>
           </a:solidFill>
           <a:ln>
             <a:noFill/>
@@ -17437,7 +17437,7 @@
             <a:avLst/>
           </a:prstGeom>
           <a:solidFill>
-            <a:srgbClr val="A86A14"/>
+            <a:srgbClr val="BA740E"/>
           </a:solidFill>
           <a:ln>
             <a:noFill/>

</xml_diff>

<commit_message>
Consistency note: what CSE promises across DSRCs
Names the tension the externals policy carries: integration with each
platform against consistency across all of them. Separates the two
promises (same interface, which the lanes already deliver, and same
binaries, which they do not), recommends building a pinned CSE GCC,
and lays out three MPI routes: the native provider per system, a stock
MPICH lane with ABI substitution through cray-mpich-abi and Spack
splicing, and our own OpenMPI over Slingshot 11. Lists what Blueback
must prove for each. The build rationale's never-built section is
reframed as pilot policy rather than doctrine, and the deck gains the
question as its fifth open item.
</commit_message>
<xml_diff>
--- a/presentations/cse_lanes_model.pptx
+++ b/presentations/cse_lanes_model.pptx
@@ -3628,8 +3628,8 @@
         </p:nvSpPr>
         <p:spPr>
           <a:xfrm>
-            <a:off x="548640" y="1600200"/>
-            <a:ext cx="11091672" cy="987552"/>
+            <a:off x="548640" y="1517904"/>
+            <a:ext cx="11091672" cy="896112"/>
           </a:xfrm>
           <a:prstGeom prst="roundRect">
             <a:avLst/>
@@ -3672,7 +3672,7 @@
         </p:nvSpPr>
         <p:spPr>
           <a:xfrm>
-            <a:off x="868680" y="1728216"/>
+            <a:off x="868680" y="1609344"/>
             <a:ext cx="10515600" cy="274320"/>
           </a:xfrm>
           <a:prstGeom prst="rect">
@@ -3687,7 +3687,7 @@
           <a:lstStyle/>
           <a:p>
             <a:pPr algn="l">
-              <a:defRPr sz="1350" b="1">
+              <a:defRPr sz="1300" b="1">
                 <a:solidFill>
                   <a:srgbClr val="2C7A4B"/>
                 </a:solidFill>
@@ -3708,8 +3708,8 @@
         </p:nvSpPr>
         <p:spPr>
           <a:xfrm>
-            <a:off x="868680" y="2011680"/>
-            <a:ext cx="10515600" cy="530352"/>
+            <a:off x="868680" y="1892807"/>
+            <a:ext cx="10515600" cy="493776"/>
           </a:xfrm>
           <a:prstGeom prst="rect">
             <a:avLst/>
@@ -3723,7 +3723,7 @@
           <a:lstStyle/>
           <a:p>
             <a:pPr algn="l">
-              <a:defRPr sz="1100" b="0">
+              <a:defRPr sz="1050" b="0">
                 <a:solidFill>
                   <a:srgbClr val="6E7B90"/>
                 </a:solidFill>
@@ -3744,8 +3744,8 @@
         </p:nvSpPr>
         <p:spPr>
           <a:xfrm>
-            <a:off x="548640" y="2679191"/>
-            <a:ext cx="11091672" cy="987552"/>
+            <a:off x="548640" y="2487168"/>
+            <a:ext cx="11091672" cy="896112"/>
           </a:xfrm>
           <a:prstGeom prst="roundRect">
             <a:avLst/>
@@ -3788,7 +3788,7 @@
         </p:nvSpPr>
         <p:spPr>
           <a:xfrm>
-            <a:off x="868680" y="2807208"/>
+            <a:off x="868680" y="2578608"/>
             <a:ext cx="10515600" cy="274320"/>
           </a:xfrm>
           <a:prstGeom prst="rect">
@@ -3803,7 +3803,7 @@
           <a:lstStyle/>
           <a:p>
             <a:pPr algn="l">
-              <a:defRPr sz="1350" b="1">
+              <a:defRPr sz="1300" b="1">
                 <a:solidFill>
                   <a:srgbClr val="117A72"/>
                 </a:solidFill>
@@ -3824,8 +3824,8 @@
         </p:nvSpPr>
         <p:spPr>
           <a:xfrm>
-            <a:off x="868680" y="3090672"/>
-            <a:ext cx="10515600" cy="530352"/>
+            <a:off x="868680" y="2862072"/>
+            <a:ext cx="10515600" cy="493776"/>
           </a:xfrm>
           <a:prstGeom prst="rect">
             <a:avLst/>
@@ -3839,7 +3839,7 @@
           <a:lstStyle/>
           <a:p>
             <a:pPr algn="l">
-              <a:defRPr sz="1100" b="0">
+              <a:defRPr sz="1050" b="0">
                 <a:solidFill>
                   <a:srgbClr val="6E7B90"/>
                 </a:solidFill>
@@ -3860,8 +3860,8 @@
         </p:nvSpPr>
         <p:spPr>
           <a:xfrm>
-            <a:off x="548640" y="3758183"/>
-            <a:ext cx="11091672" cy="987552"/>
+            <a:off x="548640" y="3456432"/>
+            <a:ext cx="11091672" cy="896112"/>
           </a:xfrm>
           <a:prstGeom prst="roundRect">
             <a:avLst/>
@@ -3904,7 +3904,7 @@
         </p:nvSpPr>
         <p:spPr>
           <a:xfrm>
-            <a:off x="868680" y="3886199"/>
+            <a:off x="868680" y="3547872"/>
             <a:ext cx="10515600" cy="274320"/>
           </a:xfrm>
           <a:prstGeom prst="rect">
@@ -3919,7 +3919,7 @@
           <a:lstStyle/>
           <a:p>
             <a:pPr algn="l">
-              <a:defRPr sz="1350" b="1">
+              <a:defRPr sz="1300" b="1">
                 <a:solidFill>
                   <a:srgbClr val="BA740E"/>
                 </a:solidFill>
@@ -3940,8 +3940,8 @@
         </p:nvSpPr>
         <p:spPr>
           <a:xfrm>
-            <a:off x="868680" y="4169663"/>
-            <a:ext cx="10515600" cy="530352"/>
+            <a:off x="868680" y="3831336"/>
+            <a:ext cx="10515600" cy="493776"/>
           </a:xfrm>
           <a:prstGeom prst="rect">
             <a:avLst/>
@@ -3955,7 +3955,7 @@
           <a:lstStyle/>
           <a:p>
             <a:pPr algn="l">
-              <a:defRPr sz="1100" b="0">
+              <a:defRPr sz="1050" b="0">
                 <a:solidFill>
                   <a:srgbClr val="6E7B90"/>
                 </a:solidFill>
@@ -3976,8 +3976,8 @@
         </p:nvSpPr>
         <p:spPr>
           <a:xfrm>
-            <a:off x="548640" y="4837176"/>
-            <a:ext cx="11091672" cy="987552"/>
+            <a:off x="548640" y="4425696"/>
+            <a:ext cx="11091672" cy="896112"/>
           </a:xfrm>
           <a:prstGeom prst="roundRect">
             <a:avLst/>
@@ -4020,7 +4020,7 @@
         </p:nvSpPr>
         <p:spPr>
           <a:xfrm>
-            <a:off x="868680" y="4965192"/>
+            <a:off x="868680" y="4517136"/>
             <a:ext cx="10515600" cy="274320"/>
           </a:xfrm>
           <a:prstGeom prst="rect">
@@ -4035,7 +4035,7 @@
           <a:lstStyle/>
           <a:p>
             <a:pPr algn="l">
-              <a:defRPr sz="1350" b="1">
+              <a:defRPr sz="1300" b="1">
                 <a:solidFill>
                   <a:srgbClr val="6D4EAA"/>
                 </a:solidFill>
@@ -4056,8 +4056,8 @@
         </p:nvSpPr>
         <p:spPr>
           <a:xfrm>
-            <a:off x="868680" y="5248656"/>
-            <a:ext cx="10515600" cy="530352"/>
+            <a:off x="868680" y="4800600"/>
+            <a:ext cx="10515600" cy="493776"/>
           </a:xfrm>
           <a:prstGeom prst="rect">
             <a:avLst/>
@@ -4071,7 +4071,7 @@
           <a:lstStyle/>
           <a:p>
             <a:pPr algn="l">
-              <a:defRPr sz="1100" b="0">
+              <a:defRPr sz="1050" b="0">
                 <a:solidFill>
                   <a:srgbClr val="6E7B90"/>
                 </a:solidFill>
@@ -4080,6 +4080,122 @@
             </a:pPr>
             <a:r>
               <a:t>The plan is to build every lane at the portable baseline, prove the model, then turn on per-lane tuning for Genoa, Milan, or Cascade Lake. Each target is a flag plus a full rebuild, so the open part is when, not whether.</a:t>
+            </a:r>
+          </a:p>
+        </p:txBody>
+      </p:sp>
+      <p:sp>
+        <p:nvSpPr>
+          <p:cNvPr id="17" name="Rounded Rectangle 16"/>
+          <p:cNvSpPr/>
+          <p:nvPr/>
+        </p:nvSpPr>
+        <p:spPr>
+          <a:xfrm>
+            <a:off x="548640" y="5394960"/>
+            <a:ext cx="11091672" cy="896112"/>
+          </a:xfrm>
+          <a:prstGeom prst="roundRect">
+            <a:avLst/>
+          </a:prstGeom>
+          <a:solidFill>
+            <a:srgbClr val="F2F4F7"/>
+          </a:solidFill>
+          <a:ln>
+            <a:noFill/>
+          </a:ln>
+          <a:effectLst/>
+        </p:spPr>
+        <p:style>
+          <a:lnRef idx="1">
+            <a:schemeClr val="accent1"/>
+          </a:lnRef>
+          <a:fillRef idx="3">
+            <a:schemeClr val="accent1"/>
+          </a:fillRef>
+          <a:effectRef idx="2">
+            <a:schemeClr val="accent1"/>
+          </a:effectRef>
+          <a:fontRef idx="minor">
+            <a:schemeClr val="lt1"/>
+          </a:fontRef>
+        </p:style>
+        <p:txBody>
+          <a:bodyPr rtlCol="0" anchor="ctr"/>
+          <a:lstStyle/>
+          <a:p>
+            <a:pPr algn="ctr"/>
+          </a:p>
+        </p:txBody>
+      </p:sp>
+      <p:sp>
+        <p:nvSpPr>
+          <p:cNvPr id="18" name="TextBox 17"/>
+          <p:cNvSpPr txBox="1"/>
+          <p:nvPr/>
+        </p:nvSpPr>
+        <p:spPr>
+          <a:xfrm>
+            <a:off x="868680" y="5486400"/>
+            <a:ext cx="10515600" cy="274320"/>
+          </a:xfrm>
+          <a:prstGeom prst="rect">
+            <a:avLst/>
+          </a:prstGeom>
+          <a:noFill/>
+        </p:spPr>
+        <p:txBody>
+          <a:bodyPr wrap="square" anchor="t">
+            <a:spAutoFit/>
+          </a:bodyPr>
+          <a:lstStyle/>
+          <a:p>
+            <a:pPr algn="l">
+              <a:defRPr sz="1300" b="1">
+                <a:solidFill>
+                  <a:srgbClr val="9A7614"/>
+                </a:solidFill>
+                <a:latin typeface="Avenir Next"/>
+              </a:defRPr>
+            </a:pPr>
+            <a:r>
+              <a:t>What is CSE promising: the same interface, or the same binaries?</a:t>
+            </a:r>
+          </a:p>
+        </p:txBody>
+      </p:sp>
+      <p:sp>
+        <p:nvSpPr>
+          <p:cNvPr id="19" name="TextBox 18"/>
+          <p:cNvSpPr txBox="1"/>
+          <p:nvPr/>
+        </p:nvSpPr>
+        <p:spPr>
+          <a:xfrm>
+            <a:off x="868680" y="5769864"/>
+            <a:ext cx="10515600" cy="493776"/>
+          </a:xfrm>
+          <a:prstGeom prst="rect">
+            <a:avLst/>
+          </a:prstGeom>
+          <a:noFill/>
+        </p:spPr>
+        <p:txBody>
+          <a:bodyPr wrap="square" anchor="t">
+            <a:spAutoFit/>
+          </a:bodyPr>
+          <a:lstStyle/>
+          <a:p>
+            <a:pPr algn="l">
+              <a:defRPr sz="1050" b="0">
+                <a:solidFill>
+                  <a:srgbClr val="6E7B90"/>
+                </a:solidFill>
+                <a:latin typeface="Avenir Next"/>
+              </a:defRPr>
+            </a:pPr>
+            <a:r>
+              <a:t>The lanes already give every DSRC the same front door, names, and rosters, with the native MPI behind them. A stock MPICH lane with ABI substitution on the Crays would add binary-level consistency, and a pinned CSE GCC would anchor the compilers.</a:t>
             </a:r>
           </a:p>
         </p:txBody>

</xml_diff>

<commit_message>
Consistency has three tiers, not two
Build consistency is its own promise between interface and binary: the
same spec and the same steps work on every system, with each machine's
compiler, MPI, and fabric resolved underneath. It is Spack's split
between the abstract spec and its concretization, the model already
delivers it, and it serves every app manager. The deck's fifth question
now names the trio.
</commit_message>
<xml_diff>
--- a/presentations/cse_lanes_model.pptx
+++ b/presentations/cse_lanes_model.pptx
@@ -4159,7 +4159,7 @@
               </a:defRPr>
             </a:pPr>
             <a:r>
-              <a:t>What is CSE promising: the same interface, or the same binaries?</a:t>
+              <a:t>What is CSE promising: same interface, same build steps, or same binaries?</a:t>
             </a:r>
           </a:p>
         </p:txBody>
@@ -4195,7 +4195,7 @@
               </a:defRPr>
             </a:pPr>
             <a:r>
-              <a:t>The lanes already give every DSRC the same front door, names, and rosters, with the native MPI behind them. A stock MPICH lane with ABI substitution on the Crays would add binary-level consistency, and a pinned CSE GCC would anchor the compilers.</a:t>
+              <a:t>The lanes give every DSRC the same front door and rosters, and the same spec plus the same steps already build on any system, with that system's MPI and compiler underneath. Same binaries is the open part: a stock MPICH lane with ABI substitution on the Crays.</a:t>
             </a:r>
           </a:p>
         </p:txBody>

</xml_diff>

<commit_message>
Consistency is functional, for end users; binaries out of scope
The lanes serve end users who build and run their own code. App managers
were never the lane audience: they have the catalog and expose their own
software as they choose. For the lane user, consistency means the same
functionality reached the same way on every system: front door, rosters,
workflow, capabilities. What sits underneath is a platform fact the
promise deliberately does not extend to.

Binary consistency leaves the table: no user need identified, so the
MPICH-ABI route demotes to a recorded mechanism, tried only if a need
appears. The proving list reorders around the functionality promise: the
pinned CSE GCC lane first, then the capability floor across the four
systems, then OpenMPI over CXI as the fallback. The deck question now
states the position and leaves the floor open.
</commit_message>
<xml_diff>
--- a/presentations/cse_lanes_model.pptx
+++ b/presentations/cse_lanes_model.pptx
@@ -4159,7 +4159,7 @@
               </a:defRPr>
             </a:pPr>
             <a:r>
-              <a:t>What is CSE promising: same interface, same build steps, or same binaries?</a:t>
+              <a:t>Consistency means the same functionality, not the same implementations.</a:t>
             </a:r>
           </a:p>
         </p:txBody>
@@ -4195,7 +4195,7 @@
               </a:defRPr>
             </a:pPr>
             <a:r>
-              <a:t>The lanes give every DSRC the same front door and rosters, and the same spec plus the same steps already build on any system, with that system's MPI and compiler underneath. Same binaries is the open part: a stock MPICH lane with ABI substitution on the Crays.</a:t>
+              <a:t>A user builds and runs the same way on every system: same front door, same rosters, same workflow, with each machine's native MPI and compiler underneath. The open part is the floor: which capabilities every system must provide, and whether one pinned CSE GCC anchors the compilers.</a:t>
             </a:r>
           </a:p>
         </p:txBody>

</xml_diff>

<commit_message>
Add build-readiness notes and a closing decide-together slide
</commit_message>
<xml_diff>
--- a/presentations/cse_lanes_model.pptx
+++ b/presentations/cse_lanes_model.pptx
@@ -19,6 +19,7 @@
     <p:sldId id="267" r:id="rId18"/>
     <p:sldId id="268" r:id="rId19"/>
     <p:sldId id="269" r:id="rId20"/>
+    <p:sldId id="270" r:id="rId21"/>
   </p:sldIdLst>
   <p:sldSz cx="12191695" cy="6858000" type="screen4x3"/>
   <p:notesSz cx="6858000" cy="9144000"/>
@@ -4293,6 +4294,1143 @@
               </a:defRPr>
             </a:pPr>
             <a:r>
+              <a:t>DISCUSSION · FROM MODEL TO FIRST INSTALLS</a:t>
+            </a:r>
+          </a:p>
+        </p:txBody>
+      </p:sp>
+      <p:sp>
+        <p:nvSpPr>
+          <p:cNvPr id="4" name="TextBox 3"/>
+          <p:cNvSpPr txBox="1"/>
+          <p:nvPr/>
+        </p:nvSpPr>
+        <p:spPr>
+          <a:xfrm>
+            <a:off x="548640" y="566928"/>
+            <a:ext cx="11064240" cy="731520"/>
+          </a:xfrm>
+          <a:prstGeom prst="rect">
+            <a:avLst/>
+          </a:prstGeom>
+          <a:noFill/>
+        </p:spPr>
+        <p:txBody>
+          <a:bodyPr wrap="square" anchor="t">
+            <a:spAutoFit/>
+          </a:bodyPr>
+          <a:lstStyle/>
+          <a:p>
+            <a:pPr algn="l">
+              <a:defRPr sz="3000" b="1">
+                <a:solidFill>
+                  <a:srgbClr val="16243D"/>
+                </a:solidFill>
+                <a:latin typeface="Avenir Next"/>
+              </a:defRPr>
+            </a:pPr>
+            <a:r>
+              <a:t>Starting the builds: what to decide together</a:t>
+            </a:r>
+          </a:p>
+        </p:txBody>
+      </p:sp>
+      <p:sp>
+        <p:nvSpPr>
+          <p:cNvPr id="5" name="TextBox 4"/>
+          <p:cNvSpPr txBox="1"/>
+          <p:nvPr/>
+        </p:nvSpPr>
+        <p:spPr>
+          <a:xfrm>
+            <a:off x="548640" y="1481328"/>
+            <a:ext cx="5394960" cy="365760"/>
+          </a:xfrm>
+          <a:prstGeom prst="rect">
+            <a:avLst/>
+          </a:prstGeom>
+          <a:noFill/>
+        </p:spPr>
+        <p:txBody>
+          <a:bodyPr wrap="square" anchor="t">
+            <a:spAutoFit/>
+          </a:bodyPr>
+          <a:lstStyle/>
+          <a:p>
+            <a:pPr algn="l">
+              <a:defRPr sz="1500" b="1">
+                <a:solidFill>
+                  <a:srgbClr val="2C7A4B"/>
+                </a:solidFill>
+                <a:latin typeface="Avenir Next"/>
+              </a:defRPr>
+            </a:pPr>
+            <a:r>
+              <a:t>What I'm bringing</a:t>
+            </a:r>
+          </a:p>
+        </p:txBody>
+      </p:sp>
+      <p:sp>
+        <p:nvSpPr>
+          <p:cNvPr id="6" name="TextBox 5"/>
+          <p:cNvSpPr txBox="1"/>
+          <p:nvPr/>
+        </p:nvSpPr>
+        <p:spPr>
+          <a:xfrm>
+            <a:off x="548640" y="1938528"/>
+            <a:ext cx="365760" cy="365760"/>
+          </a:xfrm>
+          <a:prstGeom prst="rect">
+            <a:avLst/>
+          </a:prstGeom>
+          <a:noFill/>
+        </p:spPr>
+        <p:txBody>
+          <a:bodyPr wrap="square" anchor="t">
+            <a:spAutoFit/>
+          </a:bodyPr>
+          <a:lstStyle/>
+          <a:p>
+            <a:pPr algn="l">
+              <a:defRPr sz="1500" b="1">
+                <a:solidFill>
+                  <a:srgbClr val="2C7A4B"/>
+                </a:solidFill>
+                <a:latin typeface="Avenir Next"/>
+              </a:defRPr>
+            </a:pPr>
+            <a:r>
+              <a:t>✓</a:t>
+            </a:r>
+          </a:p>
+        </p:txBody>
+      </p:sp>
+      <p:sp>
+        <p:nvSpPr>
+          <p:cNvPr id="7" name="TextBox 6"/>
+          <p:cNvSpPr txBox="1"/>
+          <p:nvPr/>
+        </p:nvSpPr>
+        <p:spPr>
+          <a:xfrm>
+            <a:off x="960120" y="1938528"/>
+            <a:ext cx="5029200" cy="292608"/>
+          </a:xfrm>
+          <a:prstGeom prst="rect">
+            <a:avLst/>
+          </a:prstGeom>
+          <a:noFill/>
+        </p:spPr>
+        <p:txBody>
+          <a:bodyPr wrap="square" anchor="t">
+            <a:spAutoFit/>
+          </a:bodyPr>
+          <a:lstStyle/>
+          <a:p>
+            <a:pPr algn="l">
+              <a:defRPr sz="1300" b="1">
+                <a:solidFill>
+                  <a:srgbClr val="16243D"/>
+                </a:solidFill>
+                <a:latin typeface="Avenir Next"/>
+              </a:defRPr>
+            </a:pPr>
+            <a:r>
+              <a:t>Pilot systems and order</a:t>
+            </a:r>
+          </a:p>
+        </p:txBody>
+      </p:sp>
+      <p:sp>
+        <p:nvSpPr>
+          <p:cNvPr id="8" name="TextBox 7"/>
+          <p:cNvSpPr txBox="1"/>
+          <p:nvPr/>
+        </p:nvSpPr>
+        <p:spPr>
+          <a:xfrm>
+            <a:off x="960120" y="2249424"/>
+            <a:ext cx="5029200" cy="566928"/>
+          </a:xfrm>
+          <a:prstGeom prst="rect">
+            <a:avLst/>
+          </a:prstGeom>
+          <a:noFill/>
+        </p:spPr>
+        <p:txBody>
+          <a:bodyPr wrap="square" anchor="t">
+            <a:spAutoFit/>
+          </a:bodyPr>
+          <a:lstStyle/>
+          <a:p>
+            <a:pPr algn="l">
+              <a:defRPr sz="1100" b="0">
+                <a:solidFill>
+                  <a:srgbClr val="6E7B90"/>
+                </a:solidFill>
+                <a:latin typeface="Avenir Next"/>
+              </a:defRPr>
+            </a:pPr>
+            <a:r>
+              <a:t>Blueback first, then Raider and Wheat; Fran when it arrives</a:t>
+            </a:r>
+          </a:p>
+        </p:txBody>
+      </p:sp>
+      <p:sp>
+        <p:nvSpPr>
+          <p:cNvPr id="9" name="TextBox 8"/>
+          <p:cNvSpPr txBox="1"/>
+          <p:nvPr/>
+        </p:nvSpPr>
+        <p:spPr>
+          <a:xfrm>
+            <a:off x="548640" y="2944368"/>
+            <a:ext cx="365760" cy="365760"/>
+          </a:xfrm>
+          <a:prstGeom prst="rect">
+            <a:avLst/>
+          </a:prstGeom>
+          <a:noFill/>
+        </p:spPr>
+        <p:txBody>
+          <a:bodyPr wrap="square" anchor="t">
+            <a:spAutoFit/>
+          </a:bodyPr>
+          <a:lstStyle/>
+          <a:p>
+            <a:pPr algn="l">
+              <a:defRPr sz="1500" b="1">
+                <a:solidFill>
+                  <a:srgbClr val="2C7A4B"/>
+                </a:solidFill>
+                <a:latin typeface="Avenir Next"/>
+              </a:defRPr>
+            </a:pPr>
+            <a:r>
+              <a:t>✓</a:t>
+            </a:r>
+          </a:p>
+        </p:txBody>
+      </p:sp>
+      <p:sp>
+        <p:nvSpPr>
+          <p:cNvPr id="10" name="TextBox 9"/>
+          <p:cNvSpPr txBox="1"/>
+          <p:nvPr/>
+        </p:nvSpPr>
+        <p:spPr>
+          <a:xfrm>
+            <a:off x="960120" y="2944368"/>
+            <a:ext cx="5029200" cy="292608"/>
+          </a:xfrm>
+          <a:prstGeom prst="rect">
+            <a:avLst/>
+          </a:prstGeom>
+          <a:noFill/>
+        </p:spPr>
+        <p:txBody>
+          <a:bodyPr wrap="square" anchor="t">
+            <a:spAutoFit/>
+          </a:bodyPr>
+          <a:lstStyle/>
+          <a:p>
+            <a:pPr algn="l">
+              <a:defRPr sz="1300" b="1">
+                <a:solidFill>
+                  <a:srgbClr val="16243D"/>
+                </a:solidFill>
+                <a:latin typeface="Avenir Next"/>
+              </a:defRPr>
+            </a:pPr>
+            <a:r>
+              <a:t>A package roster with versions</a:t>
+            </a:r>
+          </a:p>
+        </p:txBody>
+      </p:sp>
+      <p:sp>
+        <p:nvSpPr>
+          <p:cNvPr id="11" name="TextBox 10"/>
+          <p:cNvSpPr txBox="1"/>
+          <p:nvPr/>
+        </p:nvSpPr>
+        <p:spPr>
+          <a:xfrm>
+            <a:off x="960120" y="3255264"/>
+            <a:ext cx="5029200" cy="566928"/>
+          </a:xfrm>
+          <a:prstGeom prst="rect">
+            <a:avLst/>
+          </a:prstGeom>
+          <a:noFill/>
+        </p:spPr>
+        <p:txBody>
+          <a:bodyPr wrap="square" anchor="t">
+            <a:spAutoFit/>
+          </a:bodyPr>
+          <a:lstStyle/>
+          <a:p>
+            <a:pPr algn="l">
+              <a:defRPr sz="1100" b="0">
+                <a:solidFill>
+                  <a:srgbClr val="6E7B90"/>
+                </a:solidFill>
+                <a:latin typeface="Avenir Next"/>
+              </a:defRPr>
+            </a:pPr>
+            <a:r>
+              <a:t>newest supported release plus its predecessor, variants written down</a:t>
+            </a:r>
+          </a:p>
+        </p:txBody>
+      </p:sp>
+      <p:sp>
+        <p:nvSpPr>
+          <p:cNvPr id="12" name="TextBox 11"/>
+          <p:cNvSpPr txBox="1"/>
+          <p:nvPr/>
+        </p:nvSpPr>
+        <p:spPr>
+          <a:xfrm>
+            <a:off x="548640" y="3950208"/>
+            <a:ext cx="365760" cy="365760"/>
+          </a:xfrm>
+          <a:prstGeom prst="rect">
+            <a:avLst/>
+          </a:prstGeom>
+          <a:noFill/>
+        </p:spPr>
+        <p:txBody>
+          <a:bodyPr wrap="square" anchor="t">
+            <a:spAutoFit/>
+          </a:bodyPr>
+          <a:lstStyle/>
+          <a:p>
+            <a:pPr algn="l">
+              <a:defRPr sz="1500" b="1">
+                <a:solidFill>
+                  <a:srgbClr val="2C7A4B"/>
+                </a:solidFill>
+                <a:latin typeface="Avenir Next"/>
+              </a:defRPr>
+            </a:pPr>
+            <a:r>
+              <a:t>✓</a:t>
+            </a:r>
+          </a:p>
+        </p:txBody>
+      </p:sp>
+      <p:sp>
+        <p:nvSpPr>
+          <p:cNvPr id="13" name="TextBox 12"/>
+          <p:cNvSpPr txBox="1"/>
+          <p:nvPr/>
+        </p:nvSpPr>
+        <p:spPr>
+          <a:xfrm>
+            <a:off x="960120" y="3950208"/>
+            <a:ext cx="5029200" cy="292608"/>
+          </a:xfrm>
+          <a:prstGeom prst="rect">
+            <a:avLst/>
+          </a:prstGeom>
+          <a:noFill/>
+        </p:spPr>
+        <p:txBody>
+          <a:bodyPr wrap="square" anchor="t">
+            <a:spAutoFit/>
+          </a:bodyPr>
+          <a:lstStyle/>
+          <a:p>
+            <a:pPr algn="l">
+              <a:defRPr sz="1300" b="1">
+                <a:solidFill>
+                  <a:srgbClr val="16243D"/>
+                </a:solidFill>
+                <a:latin typeface="Avenir Next"/>
+              </a:defRPr>
+            </a:pPr>
+            <a:r>
+              <a:t>A baseline CPU target</a:t>
+            </a:r>
+          </a:p>
+        </p:txBody>
+      </p:sp>
+      <p:sp>
+        <p:nvSpPr>
+          <p:cNvPr id="14" name="TextBox 13"/>
+          <p:cNvSpPr txBox="1"/>
+          <p:nvPr/>
+        </p:nvSpPr>
+        <p:spPr>
+          <a:xfrm>
+            <a:off x="960120" y="4261104"/>
+            <a:ext cx="5029200" cy="566928"/>
+          </a:xfrm>
+          <a:prstGeom prst="rect">
+            <a:avLst/>
+          </a:prstGeom>
+          <a:noFill/>
+        </p:spPr>
+        <p:txBody>
+          <a:bodyPr wrap="square" anchor="t">
+            <a:spAutoFit/>
+          </a:bodyPr>
+          <a:lstStyle/>
+          <a:p>
+            <a:pPr algn="l">
+              <a:defRPr sz="1100" b="0">
+                <a:solidFill>
+                  <a:srgbClr val="6E7B90"/>
+                </a:solidFill>
+                <a:latin typeface="Avenir Next"/>
+              </a:defRPr>
+            </a:pPr>
+            <a:r>
+              <a:t>x86_64_v3 runs natively on every pilot system; tuning is a later flag</a:t>
+            </a:r>
+          </a:p>
+        </p:txBody>
+      </p:sp>
+      <p:sp>
+        <p:nvSpPr>
+          <p:cNvPr id="15" name="TextBox 14"/>
+          <p:cNvSpPr txBox="1"/>
+          <p:nvPr/>
+        </p:nvSpPr>
+        <p:spPr>
+          <a:xfrm>
+            <a:off x="548640" y="4956048"/>
+            <a:ext cx="365760" cy="365760"/>
+          </a:xfrm>
+          <a:prstGeom prst="rect">
+            <a:avLst/>
+          </a:prstGeom>
+          <a:noFill/>
+        </p:spPr>
+        <p:txBody>
+          <a:bodyPr wrap="square" anchor="t">
+            <a:spAutoFit/>
+          </a:bodyPr>
+          <a:lstStyle/>
+          <a:p>
+            <a:pPr algn="l">
+              <a:defRPr sz="1500" b="1">
+                <a:solidFill>
+                  <a:srgbClr val="2C7A4B"/>
+                </a:solidFill>
+                <a:latin typeface="Avenir Next"/>
+              </a:defRPr>
+            </a:pPr>
+            <a:r>
+              <a:t>✓</a:t>
+            </a:r>
+          </a:p>
+        </p:txBody>
+      </p:sp>
+      <p:sp>
+        <p:nvSpPr>
+          <p:cNvPr id="16" name="TextBox 15"/>
+          <p:cNvSpPr txBox="1"/>
+          <p:nvPr/>
+        </p:nvSpPr>
+        <p:spPr>
+          <a:xfrm>
+            <a:off x="960120" y="4956048"/>
+            <a:ext cx="5029200" cy="292608"/>
+          </a:xfrm>
+          <a:prstGeom prst="rect">
+            <a:avLst/>
+          </a:prstGeom>
+          <a:noFill/>
+        </p:spPr>
+        <p:txBody>
+          <a:bodyPr wrap="square" anchor="t">
+            <a:spAutoFit/>
+          </a:bodyPr>
+          <a:lstStyle/>
+          <a:p>
+            <a:pPr algn="l">
+              <a:defRPr sz="1300" b="1">
+                <a:solidFill>
+                  <a:srgbClr val="16243D"/>
+                </a:solidFill>
+                <a:latin typeface="Avenir Next"/>
+              </a:defRPr>
+            </a:pPr>
+            <a:r>
+              <a:t>A draft definition of done</a:t>
+            </a:r>
+          </a:p>
+        </p:txBody>
+      </p:sp>
+      <p:sp>
+        <p:nvSpPr>
+          <p:cNvPr id="17" name="TextBox 16"/>
+          <p:cNvSpPr txBox="1"/>
+          <p:nvPr/>
+        </p:nvSpPr>
+        <p:spPr>
+          <a:xfrm>
+            <a:off x="960120" y="5266944"/>
+            <a:ext cx="5029200" cy="566928"/>
+          </a:xfrm>
+          <a:prstGeom prst="rect">
+            <a:avLst/>
+          </a:prstGeom>
+          <a:noFill/>
+        </p:spPr>
+        <p:txBody>
+          <a:bodyPr wrap="square" anchor="t">
+            <a:spAutoFit/>
+          </a:bodyPr>
+          <a:lstStyle/>
+          <a:p>
+            <a:pPr algn="l">
+              <a:defRPr sz="1100" b="0">
+                <a:solidFill>
+                  <a:srgbClr val="6E7B90"/>
+                </a:solidFill>
+                <a:latin typeface="Avenir Next"/>
+              </a:defRPr>
+            </a:pPr>
+            <a:r>
+              <a:t>five checks, spelled out below</a:t>
+            </a:r>
+          </a:p>
+        </p:txBody>
+      </p:sp>
+      <p:sp>
+        <p:nvSpPr>
+          <p:cNvPr id="18" name="TextBox 17"/>
+          <p:cNvSpPr txBox="1"/>
+          <p:nvPr/>
+        </p:nvSpPr>
+        <p:spPr>
+          <a:xfrm>
+            <a:off x="6263640" y="1481328"/>
+            <a:ext cx="5394960" cy="365760"/>
+          </a:xfrm>
+          <a:prstGeom prst="rect">
+            <a:avLst/>
+          </a:prstGeom>
+          <a:noFill/>
+        </p:spPr>
+        <p:txBody>
+          <a:bodyPr wrap="square" anchor="t">
+            <a:spAutoFit/>
+          </a:bodyPr>
+          <a:lstStyle/>
+          <a:p>
+            <a:pPr algn="l">
+              <a:defRPr sz="1500" b="1">
+                <a:solidFill>
+                  <a:srgbClr val="9A7614"/>
+                </a:solidFill>
+                <a:latin typeface="Avenir Next"/>
+              </a:defRPr>
+            </a:pPr>
+            <a:r>
+              <a:t>What I need from you</a:t>
+            </a:r>
+          </a:p>
+        </p:txBody>
+      </p:sp>
+      <p:sp>
+        <p:nvSpPr>
+          <p:cNvPr id="19" name="TextBox 18"/>
+          <p:cNvSpPr txBox="1"/>
+          <p:nvPr/>
+        </p:nvSpPr>
+        <p:spPr>
+          <a:xfrm>
+            <a:off x="6263640" y="1938528"/>
+            <a:ext cx="365760" cy="365760"/>
+          </a:xfrm>
+          <a:prstGeom prst="rect">
+            <a:avLst/>
+          </a:prstGeom>
+          <a:noFill/>
+        </p:spPr>
+        <p:txBody>
+          <a:bodyPr wrap="square" anchor="t">
+            <a:spAutoFit/>
+          </a:bodyPr>
+          <a:lstStyle/>
+          <a:p>
+            <a:pPr algn="l">
+              <a:defRPr sz="1500" b="1">
+                <a:solidFill>
+                  <a:srgbClr val="9A7614"/>
+                </a:solidFill>
+                <a:latin typeface="Avenir Next"/>
+              </a:defRPr>
+            </a:pPr>
+            <a:r>
+              <a:t>→</a:t>
+            </a:r>
+          </a:p>
+        </p:txBody>
+      </p:sp>
+      <p:sp>
+        <p:nvSpPr>
+          <p:cNvPr id="20" name="TextBox 19"/>
+          <p:cNvSpPr txBox="1"/>
+          <p:nvPr/>
+        </p:nvSpPr>
+        <p:spPr>
+          <a:xfrm>
+            <a:off x="6675120" y="1938528"/>
+            <a:ext cx="4937760" cy="292608"/>
+          </a:xfrm>
+          <a:prstGeom prst="rect">
+            <a:avLst/>
+          </a:prstGeom>
+          <a:noFill/>
+        </p:spPr>
+        <p:txBody>
+          <a:bodyPr wrap="square" anchor="t">
+            <a:spAutoFit/>
+          </a:bodyPr>
+          <a:lstStyle/>
+          <a:p>
+            <a:pPr algn="l">
+              <a:defRPr sz="1300" b="1">
+                <a:solidFill>
+                  <a:srgbClr val="16243D"/>
+                </a:solidFill>
+                <a:latin typeface="Avenir Next"/>
+              </a:defRPr>
+            </a:pPr>
+            <a:r>
+              <a:t>Which GCC on each system</a:t>
+            </a:r>
+          </a:p>
+        </p:txBody>
+      </p:sp>
+      <p:sp>
+        <p:nvSpPr>
+          <p:cNvPr id="21" name="TextBox 20"/>
+          <p:cNvSpPr txBox="1"/>
+          <p:nvPr/>
+        </p:nvSpPr>
+        <p:spPr>
+          <a:xfrm>
+            <a:off x="6675120" y="2249424"/>
+            <a:ext cx="4937760" cy="566928"/>
+          </a:xfrm>
+          <a:prstGeom prst="rect">
+            <a:avLst/>
+          </a:prstGeom>
+          <a:noFill/>
+        </p:spPr>
+        <p:txBody>
+          <a:bodyPr wrap="square" anchor="t">
+            <a:spAutoFit/>
+          </a:bodyPr>
+          <a:lstStyle/>
+          <a:p>
+            <a:pPr algn="l">
+              <a:defRPr sz="1100" b="0">
+                <a:solidFill>
+                  <a:srgbClr val="6E7B90"/>
+                </a:solidFill>
+                <a:latin typeface="Avenir Next"/>
+              </a:defRPr>
+            </a:pPr>
+            <a:r>
+              <a:t>the system's own, or one version built everywhere; every package rests on this</a:t>
+            </a:r>
+          </a:p>
+        </p:txBody>
+      </p:sp>
+      <p:sp>
+        <p:nvSpPr>
+          <p:cNvPr id="22" name="TextBox 21"/>
+          <p:cNvSpPr txBox="1"/>
+          <p:nvPr/>
+        </p:nvSpPr>
+        <p:spPr>
+          <a:xfrm>
+            <a:off x="6263640" y="2944368"/>
+            <a:ext cx="365760" cy="365760"/>
+          </a:xfrm>
+          <a:prstGeom prst="rect">
+            <a:avLst/>
+          </a:prstGeom>
+          <a:noFill/>
+        </p:spPr>
+        <p:txBody>
+          <a:bodyPr wrap="square" anchor="t">
+            <a:spAutoFit/>
+          </a:bodyPr>
+          <a:lstStyle/>
+          <a:p>
+            <a:pPr algn="l">
+              <a:defRPr sz="1500" b="1">
+                <a:solidFill>
+                  <a:srgbClr val="9A7614"/>
+                </a:solidFill>
+                <a:latin typeface="Avenir Next"/>
+              </a:defRPr>
+            </a:pPr>
+            <a:r>
+              <a:t>→</a:t>
+            </a:r>
+          </a:p>
+        </p:txBody>
+      </p:sp>
+      <p:sp>
+        <p:nvSpPr>
+          <p:cNvPr id="23" name="TextBox 22"/>
+          <p:cNvSpPr txBox="1"/>
+          <p:nvPr/>
+        </p:nvSpPr>
+        <p:spPr>
+          <a:xfrm>
+            <a:off x="6675120" y="2944368"/>
+            <a:ext cx="4937760" cy="292608"/>
+          </a:xfrm>
+          <a:prstGeom prst="rect">
+            <a:avLst/>
+          </a:prstGeom>
+          <a:noFill/>
+        </p:spPr>
+        <p:txBody>
+          <a:bodyPr wrap="square" anchor="t">
+            <a:spAutoFit/>
+          </a:bodyPr>
+          <a:lstStyle/>
+          <a:p>
+            <a:pPr algn="l">
+              <a:defRPr sz="1300" b="1">
+                <a:solidFill>
+                  <a:srgbClr val="16243D"/>
+                </a:solidFill>
+                <a:latin typeface="Avenir Next"/>
+              </a:defRPr>
+            </a:pPr>
+            <a:r>
+              <a:t>MPI pairing on Raider and Wheat</a:t>
+            </a:r>
+          </a:p>
+        </p:txBody>
+      </p:sp>
+      <p:sp>
+        <p:nvSpPr>
+          <p:cNvPr id="24" name="TextBox 23"/>
+          <p:cNvSpPr txBox="1"/>
+          <p:nvPr/>
+        </p:nvSpPr>
+        <p:spPr>
+          <a:xfrm>
+            <a:off x="6675120" y="3255264"/>
+            <a:ext cx="4937760" cy="566928"/>
+          </a:xfrm>
+          <a:prstGeom prst="rect">
+            <a:avLst/>
+          </a:prstGeom>
+          <a:noFill/>
+        </p:spPr>
+        <p:txBody>
+          <a:bodyPr wrap="square" anchor="t">
+            <a:spAutoFit/>
+          </a:bodyPr>
+          <a:lstStyle/>
+          <a:p>
+            <a:pPr algn="l">
+              <a:defRPr sz="1100" b="0">
+                <a:solidFill>
+                  <a:srgbClr val="6E7B90"/>
+                </a:solidFill>
+                <a:latin typeface="Avenir Next"/>
+              </a:defRPr>
+            </a:pPr>
+            <a:r>
+              <a:t>the Crays point at cray-mpich; the others need the site MPI confirmed</a:t>
+            </a:r>
+          </a:p>
+        </p:txBody>
+      </p:sp>
+      <p:sp>
+        <p:nvSpPr>
+          <p:cNvPr id="25" name="TextBox 24"/>
+          <p:cNvSpPr txBox="1"/>
+          <p:nvPr/>
+        </p:nvSpPr>
+        <p:spPr>
+          <a:xfrm>
+            <a:off x="6263640" y="3950208"/>
+            <a:ext cx="365760" cy="365760"/>
+          </a:xfrm>
+          <a:prstGeom prst="rect">
+            <a:avLst/>
+          </a:prstGeom>
+          <a:noFill/>
+        </p:spPr>
+        <p:txBody>
+          <a:bodyPr wrap="square" anchor="t">
+            <a:spAutoFit/>
+          </a:bodyPr>
+          <a:lstStyle/>
+          <a:p>
+            <a:pPr algn="l">
+              <a:defRPr sz="1500" b="1">
+                <a:solidFill>
+                  <a:srgbClr val="9A7614"/>
+                </a:solidFill>
+                <a:latin typeface="Avenir Next"/>
+              </a:defRPr>
+            </a:pPr>
+            <a:r>
+              <a:t>→</a:t>
+            </a:r>
+          </a:p>
+        </p:txBody>
+      </p:sp>
+      <p:sp>
+        <p:nvSpPr>
+          <p:cNvPr id="26" name="TextBox 25"/>
+          <p:cNvSpPr txBox="1"/>
+          <p:nvPr/>
+        </p:nvSpPr>
+        <p:spPr>
+          <a:xfrm>
+            <a:off x="6675120" y="3950208"/>
+            <a:ext cx="4937760" cy="292608"/>
+          </a:xfrm>
+          <a:prstGeom prst="rect">
+            <a:avLst/>
+          </a:prstGeom>
+          <a:noFill/>
+        </p:spPr>
+        <p:txBody>
+          <a:bodyPr wrap="square" anchor="t">
+            <a:spAutoFit/>
+          </a:bodyPr>
+          <a:lstStyle/>
+          <a:p>
+            <a:pPr algn="l">
+              <a:defRPr sz="1300" b="1">
+                <a:solidFill>
+                  <a:srgbClr val="16243D"/>
+                </a:solidFill>
+                <a:latin typeface="Avenir Next"/>
+              </a:defRPr>
+            </a:pPr>
+            <a:r>
+              <a:t>System details and install paths</a:t>
+            </a:r>
+          </a:p>
+        </p:txBody>
+      </p:sp>
+      <p:sp>
+        <p:nvSpPr>
+          <p:cNvPr id="27" name="TextBox 26"/>
+          <p:cNvSpPr txBox="1"/>
+          <p:nvPr/>
+        </p:nvSpPr>
+        <p:spPr>
+          <a:xfrm>
+            <a:off x="6675120" y="4261104"/>
+            <a:ext cx="4937760" cy="566928"/>
+          </a:xfrm>
+          <a:prstGeom prst="rect">
+            <a:avLst/>
+          </a:prstGeom>
+          <a:noFill/>
+        </p:spPr>
+        <p:txBody>
+          <a:bodyPr wrap="square" anchor="t">
+            <a:spAutoFit/>
+          </a:bodyPr>
+          <a:lstStyle/>
+          <a:p>
+            <a:pPr algn="l">
+              <a:defRPr sz="1100" b="0">
+                <a:solidFill>
+                  <a:srgbClr val="6E7B90"/>
+                </a:solidFill>
+                <a:latin typeface="Avenir Next"/>
+              </a:defRPr>
+            </a:pPr>
+            <a:r>
+              <a:t>each system needs its facts confirmed and locations chosen, with an owner</a:t>
+            </a:r>
+          </a:p>
+        </p:txBody>
+      </p:sp>
+      <p:sp>
+        <p:nvSpPr>
+          <p:cNvPr id="28" name="TextBox 27"/>
+          <p:cNvSpPr txBox="1"/>
+          <p:nvPr/>
+        </p:nvSpPr>
+        <p:spPr>
+          <a:xfrm>
+            <a:off x="6263640" y="4956048"/>
+            <a:ext cx="365760" cy="365760"/>
+          </a:xfrm>
+          <a:prstGeom prst="rect">
+            <a:avLst/>
+          </a:prstGeom>
+          <a:noFill/>
+        </p:spPr>
+        <p:txBody>
+          <a:bodyPr wrap="square" anchor="t">
+            <a:spAutoFit/>
+          </a:bodyPr>
+          <a:lstStyle/>
+          <a:p>
+            <a:pPr algn="l">
+              <a:defRPr sz="1500" b="1">
+                <a:solidFill>
+                  <a:srgbClr val="9A7614"/>
+                </a:solidFill>
+                <a:latin typeface="Avenir Next"/>
+              </a:defRPr>
+            </a:pPr>
+            <a:r>
+              <a:t>→</a:t>
+            </a:r>
+          </a:p>
+        </p:txBody>
+      </p:sp>
+      <p:sp>
+        <p:nvSpPr>
+          <p:cNvPr id="29" name="TextBox 28"/>
+          <p:cNvSpPr txBox="1"/>
+          <p:nvPr/>
+        </p:nvSpPr>
+        <p:spPr>
+          <a:xfrm>
+            <a:off x="6675120" y="4956048"/>
+            <a:ext cx="4937760" cy="292608"/>
+          </a:xfrm>
+          <a:prstGeom prst="rect">
+            <a:avLst/>
+          </a:prstGeom>
+          <a:noFill/>
+        </p:spPr>
+        <p:txBody>
+          <a:bodyPr wrap="square" anchor="t">
+            <a:spAutoFit/>
+          </a:bodyPr>
+          <a:lstStyle/>
+          <a:p>
+            <a:pPr algn="l">
+              <a:defRPr sz="1300" b="1">
+                <a:solidFill>
+                  <a:srgbClr val="16243D"/>
+                </a:solidFill>
+                <a:latin typeface="Avenir Next"/>
+              </a:defRPr>
+            </a:pPr>
+            <a:r>
+              <a:t>Agreement on the definition of done</a:t>
+            </a:r>
+          </a:p>
+        </p:txBody>
+      </p:sp>
+      <p:sp>
+        <p:nvSpPr>
+          <p:cNvPr id="30" name="TextBox 29"/>
+          <p:cNvSpPr txBox="1"/>
+          <p:nvPr/>
+        </p:nvSpPr>
+        <p:spPr>
+          <a:xfrm>
+            <a:off x="6675120" y="5266944"/>
+            <a:ext cx="4937760" cy="566928"/>
+          </a:xfrm>
+          <a:prstGeom prst="rect">
+            <a:avLst/>
+          </a:prstGeom>
+          <a:noFill/>
+        </p:spPr>
+        <p:txBody>
+          <a:bodyPr wrap="square" anchor="t">
+            <a:spAutoFit/>
+          </a:bodyPr>
+          <a:lstStyle/>
+          <a:p>
+            <a:pPr algn="l">
+              <a:defRPr sz="1100" b="0">
+                <a:solidFill>
+                  <a:srgbClr val="6E7B90"/>
+                </a:solidFill>
+                <a:latin typeface="Avenir Next"/>
+              </a:defRPr>
+            </a:pPr>
+            <a:r>
+              <a:t>so the first build has a finish line</a:t>
+            </a:r>
+          </a:p>
+        </p:txBody>
+      </p:sp>
+      <p:sp>
+        <p:nvSpPr>
+          <p:cNvPr id="31" name="Rounded Rectangle 30"/>
+          <p:cNvSpPr/>
+          <p:nvPr/>
+        </p:nvSpPr>
+        <p:spPr>
+          <a:xfrm>
+            <a:off x="548640" y="5943600"/>
+            <a:ext cx="11091672" cy="713232"/>
+          </a:xfrm>
+          <a:prstGeom prst="roundRect">
+            <a:avLst/>
+          </a:prstGeom>
+          <a:solidFill>
+            <a:srgbClr val="E3E7EE"/>
+          </a:solidFill>
+          <a:ln>
+            <a:noFill/>
+          </a:ln>
+          <a:effectLst/>
+        </p:spPr>
+        <p:style>
+          <a:lnRef idx="1">
+            <a:schemeClr val="accent1"/>
+          </a:lnRef>
+          <a:fillRef idx="3">
+            <a:schemeClr val="accent1"/>
+          </a:fillRef>
+          <a:effectRef idx="2">
+            <a:schemeClr val="accent1"/>
+          </a:effectRef>
+          <a:fontRef idx="minor">
+            <a:schemeClr val="lt1"/>
+          </a:fontRef>
+        </p:style>
+        <p:txBody>
+          <a:bodyPr rtlCol="0" anchor="ctr" wrap="square" lIns="109728" rIns="109728"/>
+          <a:lstStyle/>
+          <a:p>
+            <a:pPr algn="ctr">
+              <a:defRPr sz="1250" b="1">
+                <a:solidFill>
+                  <a:srgbClr val="16243D"/>
+                </a:solidFill>
+                <a:latin typeface="Avenir Next"/>
+              </a:defRPr>
+            </a:pPr>
+            <a:r>
+              <a:t>Draft definition of done: packages build · sample C, C++, and Fortran codes compile and run ·</a:t>
+            </a:r>
+          </a:p>
+          <a:p>
+            <a:pPr algn="ctr">
+              <a:defRPr sz="1250" b="1">
+                <a:solidFill>
+                  <a:srgbClr val="16243D"/>
+                </a:solidFill>
+                <a:latin typeface="Avenir Next"/>
+              </a:defRPr>
+            </a:pPr>
+            <a:r>
+              <a:t>MPI jobs run across nodes · a rebuild reproduces the result · installs come from the build cache</a:t>
+            </a:r>
+          </a:p>
+        </p:txBody>
+      </p:sp>
+    </p:spTree>
+  </p:cSld>
+  <p:clrMapOvr>
+    <a:masterClrMapping/>
+  </p:clrMapOvr>
+</p:sld>
+</file>
+
+<file path=ppt/slides/slide12.xml><?xml version="1.0" encoding="utf-8"?>
+<p:sld xmlns:a="http://schemas.openxmlformats.org/drawingml/2006/main" xmlns:p="http://schemas.openxmlformats.org/presentationml/2006/main" xmlns:r="http://schemas.openxmlformats.org/officeDocument/2006/relationships">
+  <p:cSld>
+    <p:spTree>
+      <p:nvGrpSpPr>
+        <p:cNvPr id="1" name=""/>
+        <p:cNvGrpSpPr/>
+        <p:nvPr/>
+      </p:nvGrpSpPr>
+      <p:grpSpPr/>
+      <p:sp>
+        <p:nvSpPr>
+          <p:cNvPr id="2" name="Rectangle 1"/>
+          <p:cNvSpPr/>
+          <p:nvPr/>
+        </p:nvSpPr>
+        <p:spPr>
+          <a:xfrm>
+            <a:off x="0" y="0"/>
+            <a:ext cx="12191695" cy="6858000"/>
+          </a:xfrm>
+          <a:prstGeom prst="rect">
+            <a:avLst/>
+          </a:prstGeom>
+          <a:solidFill>
+            <a:srgbClr val="FFFFFF"/>
+          </a:solidFill>
+          <a:ln>
+            <a:noFill/>
+          </a:ln>
+          <a:effectLst/>
+        </p:spPr>
+        <p:style>
+          <a:lnRef idx="1">
+            <a:schemeClr val="accent1"/>
+          </a:lnRef>
+          <a:fillRef idx="3">
+            <a:schemeClr val="accent1"/>
+          </a:fillRef>
+          <a:effectRef idx="2">
+            <a:schemeClr val="accent1"/>
+          </a:effectRef>
+          <a:fontRef idx="minor">
+            <a:schemeClr val="lt1"/>
+          </a:fontRef>
+        </p:style>
+        <p:txBody>
+          <a:bodyPr rtlCol="0" anchor="ctr"/>
+          <a:lstStyle/>
+          <a:p>
+            <a:pPr algn="ctr"/>
+          </a:p>
+        </p:txBody>
+      </p:sp>
+      <p:sp>
+        <p:nvSpPr>
+          <p:cNvPr id="3" name="TextBox 2"/>
+          <p:cNvSpPr txBox="1"/>
+          <p:nvPr/>
+        </p:nvSpPr>
+        <p:spPr>
+          <a:xfrm>
+            <a:off x="548640" y="256032"/>
+            <a:ext cx="10972800" cy="365760"/>
+          </a:xfrm>
+          <a:prstGeom prst="rect">
+            <a:avLst/>
+          </a:prstGeom>
+          <a:noFill/>
+        </p:spPr>
+        <p:txBody>
+          <a:bodyPr wrap="square" anchor="t">
+            <a:spAutoFit/>
+          </a:bodyPr>
+          <a:lstStyle/>
+          <a:p>
+            <a:pPr algn="l">
+              <a:defRPr sz="1300" b="1">
+                <a:solidFill>
+                  <a:srgbClr val="9A7614"/>
+                </a:solidFill>
+                <a:latin typeface="Avenir Next"/>
+              </a:defRPr>
+            </a:pPr>
+            <a:r>
               <a:t>APPENDIX · HOW THE LAYERS STACK</a:t>
             </a:r>
           </a:p>
@@ -4924,7 +6062,7 @@
 </p:sld>
 </file>
 
-<file path=ppt/slides/slide12.xml><?xml version="1.0" encoding="utf-8"?>
+<file path=ppt/slides/slide13.xml><?xml version="1.0" encoding="utf-8"?>
 <p:sld xmlns:a="http://schemas.openxmlformats.org/drawingml/2006/main" xmlns:p="http://schemas.openxmlformats.org/presentationml/2006/main" xmlns:r="http://schemas.openxmlformats.org/officeDocument/2006/relationships">
   <p:cSld>
     <p:spTree>
@@ -6242,7 +7380,7 @@
 </p:sld>
 </file>
 
-<file path=ppt/slides/slide13.xml><?xml version="1.0" encoding="utf-8"?>
+<file path=ppt/slides/slide14.xml><?xml version="1.0" encoding="utf-8"?>
 <p:sld xmlns:a="http://schemas.openxmlformats.org/drawingml/2006/main" xmlns:p="http://schemas.openxmlformats.org/presentationml/2006/main" xmlns:r="http://schemas.openxmlformats.org/officeDocument/2006/relationships">
   <p:cSld>
     <p:spTree>
@@ -7041,7 +8179,7 @@
 </p:sld>
 </file>
 
-<file path=ppt/slides/slide14.xml><?xml version="1.0" encoding="utf-8"?>
+<file path=ppt/slides/slide15.xml><?xml version="1.0" encoding="utf-8"?>
 <p:sld xmlns:a="http://schemas.openxmlformats.org/drawingml/2006/main" xmlns:p="http://schemas.openxmlformats.org/presentationml/2006/main" xmlns:r="http://schemas.openxmlformats.org/officeDocument/2006/relationships">
   <p:cSld>
     <p:spTree>

</xml_diff>

<commit_message>
Closing slide asks the starter questions instead of answering them
</commit_message>
<xml_diff>
--- a/presentations/cse_lanes_model.pptx
+++ b/presentations/cse_lanes_model.pptx
@@ -4294,7 +4294,7 @@
               </a:defRPr>
             </a:pPr>
             <a:r>
-              <a:t>DISCUSSION · FROM MODEL TO FIRST INSTALLS</a:t>
+              <a:t>DISCUSSION · STARTER QUESTIONS FOR THE BUILD</a:t>
             </a:r>
           </a:p>
         </p:txBody>
@@ -4330,21 +4330,65 @@
               </a:defRPr>
             </a:pPr>
             <a:r>
-              <a:t>Starting the builds: what to decide together</a:t>
-            </a:r>
-          </a:p>
-        </p:txBody>
-      </p:sp>
-      <p:sp>
-        <p:nvSpPr>
-          <p:cNvPr id="5" name="TextBox 4"/>
+              <a:t>If we start building: what has to be decided?</a:t>
+            </a:r>
+          </a:p>
+        </p:txBody>
+      </p:sp>
+      <p:sp>
+        <p:nvSpPr>
+          <p:cNvPr id="5" name="Rounded Rectangle 4"/>
+          <p:cNvSpPr/>
+          <p:nvPr/>
+        </p:nvSpPr>
+        <p:spPr>
+          <a:xfrm>
+            <a:off x="548640" y="1517904"/>
+            <a:ext cx="11091672" cy="896112"/>
+          </a:xfrm>
+          <a:prstGeom prst="roundRect">
+            <a:avLst/>
+          </a:prstGeom>
+          <a:solidFill>
+            <a:srgbClr val="F2F4F7"/>
+          </a:solidFill>
+          <a:ln>
+            <a:noFill/>
+          </a:ln>
+          <a:effectLst/>
+        </p:spPr>
+        <p:style>
+          <a:lnRef idx="1">
+            <a:schemeClr val="accent1"/>
+          </a:lnRef>
+          <a:fillRef idx="3">
+            <a:schemeClr val="accent1"/>
+          </a:fillRef>
+          <a:effectRef idx="2">
+            <a:schemeClr val="accent1"/>
+          </a:effectRef>
+          <a:fontRef idx="minor">
+            <a:schemeClr val="lt1"/>
+          </a:fontRef>
+        </p:style>
+        <p:txBody>
+          <a:bodyPr rtlCol="0" anchor="ctr"/>
+          <a:lstStyle/>
+          <a:p>
+            <a:pPr algn="ctr"/>
+          </a:p>
+        </p:txBody>
+      </p:sp>
+      <p:sp>
+        <p:nvSpPr>
+          <p:cNvPr id="6" name="TextBox 5"/>
           <p:cNvSpPr txBox="1"/>
           <p:nvPr/>
         </p:nvSpPr>
         <p:spPr>
           <a:xfrm>
-            <a:off x="548640" y="1481328"/>
-            <a:ext cx="5394960" cy="365760"/>
+            <a:off x="868680" y="1609344"/>
+            <a:ext cx="10515600" cy="274320"/>
           </a:xfrm>
           <a:prstGeom prst="rect">
             <a:avLst/>
@@ -4358,29 +4402,29 @@
           <a:lstStyle/>
           <a:p>
             <a:pPr algn="l">
-              <a:defRPr sz="1500" b="1">
-                <a:solidFill>
-                  <a:srgbClr val="2C7A4B"/>
-                </a:solidFill>
-                <a:latin typeface="Avenir Next"/>
-              </a:defRPr>
-            </a:pPr>
-            <a:r>
-              <a:t>What I'm bringing</a:t>
-            </a:r>
-          </a:p>
-        </p:txBody>
-      </p:sp>
-      <p:sp>
-        <p:nvSpPr>
-          <p:cNvPr id="6" name="TextBox 5"/>
+              <a:defRPr sz="1300" b="1">
+                <a:solidFill>
+                  <a:srgbClr val="117A72"/>
+                </a:solidFill>
+                <a:latin typeface="Avenir Next"/>
+              </a:defRPr>
+            </a:pPr>
+            <a:r>
+              <a:t>Which compiler anchors each system's stack?</a:t>
+            </a:r>
+          </a:p>
+        </p:txBody>
+      </p:sp>
+      <p:sp>
+        <p:nvSpPr>
+          <p:cNvPr id="7" name="TextBox 6"/>
           <p:cNvSpPr txBox="1"/>
           <p:nvPr/>
         </p:nvSpPr>
         <p:spPr>
           <a:xfrm>
-            <a:off x="548640" y="1938528"/>
-            <a:ext cx="365760" cy="365760"/>
+            <a:off x="868680" y="1892807"/>
+            <a:ext cx="10515600" cy="493776"/>
           </a:xfrm>
           <a:prstGeom prst="rect">
             <a:avLst/>
@@ -4394,29 +4438,73 @@
           <a:lstStyle/>
           <a:p>
             <a:pPr algn="l">
-              <a:defRPr sz="1500" b="1">
-                <a:solidFill>
-                  <a:srgbClr val="2C7A4B"/>
-                </a:solidFill>
-                <a:latin typeface="Avenir Next"/>
-              </a:defRPr>
-            </a:pPr>
-            <a:r>
-              <a:t>✓</a:t>
-            </a:r>
-          </a:p>
-        </p:txBody>
-      </p:sp>
-      <p:sp>
-        <p:nvSpPr>
-          <p:cNvPr id="7" name="TextBox 6"/>
+              <a:defRPr sz="1050" b="0">
+                <a:solidFill>
+                  <a:srgbClr val="6E7B90"/>
+                </a:solidFill>
+                <a:latin typeface="Avenir Next"/>
+              </a:defRPr>
+            </a:pPr>
+            <a:r>
+              <a:t>Every package on a system builds against this choice, so it comes first. The system's own compiler, one common version everywhere, or something else?</a:t>
+            </a:r>
+          </a:p>
+        </p:txBody>
+      </p:sp>
+      <p:sp>
+        <p:nvSpPr>
+          <p:cNvPr id="8" name="Rounded Rectangle 7"/>
+          <p:cNvSpPr/>
+          <p:nvPr/>
+        </p:nvSpPr>
+        <p:spPr>
+          <a:xfrm>
+            <a:off x="548640" y="2487168"/>
+            <a:ext cx="11091672" cy="896112"/>
+          </a:xfrm>
+          <a:prstGeom prst="roundRect">
+            <a:avLst/>
+          </a:prstGeom>
+          <a:solidFill>
+            <a:srgbClr val="F2F4F7"/>
+          </a:solidFill>
+          <a:ln>
+            <a:noFill/>
+          </a:ln>
+          <a:effectLst/>
+        </p:spPr>
+        <p:style>
+          <a:lnRef idx="1">
+            <a:schemeClr val="accent1"/>
+          </a:lnRef>
+          <a:fillRef idx="3">
+            <a:schemeClr val="accent1"/>
+          </a:fillRef>
+          <a:effectRef idx="2">
+            <a:schemeClr val="accent1"/>
+          </a:effectRef>
+          <a:fontRef idx="minor">
+            <a:schemeClr val="lt1"/>
+          </a:fontRef>
+        </p:style>
+        <p:txBody>
+          <a:bodyPr rtlCol="0" anchor="ctr"/>
+          <a:lstStyle/>
+          <a:p>
+            <a:pPr algn="ctr"/>
+          </a:p>
+        </p:txBody>
+      </p:sp>
+      <p:sp>
+        <p:nvSpPr>
+          <p:cNvPr id="9" name="TextBox 8"/>
           <p:cNvSpPr txBox="1"/>
           <p:nvPr/>
         </p:nvSpPr>
         <p:spPr>
           <a:xfrm>
-            <a:off x="960120" y="1938528"/>
-            <a:ext cx="5029200" cy="292608"/>
+            <a:off x="868680" y="2578608"/>
+            <a:ext cx="10515600" cy="274320"/>
           </a:xfrm>
           <a:prstGeom prst="rect">
             <a:avLst/>
@@ -4432,27 +4520,27 @@
             <a:pPr algn="l">
               <a:defRPr sz="1300" b="1">
                 <a:solidFill>
-                  <a:srgbClr val="16243D"/>
-                </a:solidFill>
-                <a:latin typeface="Avenir Next"/>
-              </a:defRPr>
-            </a:pPr>
-            <a:r>
-              <a:t>Pilot systems and order</a:t>
-            </a:r>
-          </a:p>
-        </p:txBody>
-      </p:sp>
-      <p:sp>
-        <p:nvSpPr>
-          <p:cNvPr id="8" name="TextBox 7"/>
+                  <a:srgbClr val="2B62B8"/>
+                </a:solidFill>
+                <a:latin typeface="Avenir Next"/>
+              </a:defRPr>
+            </a:pPr>
+            <a:r>
+              <a:t>Which MPI pairs with it on each system?</a:t>
+            </a:r>
+          </a:p>
+        </p:txBody>
+      </p:sp>
+      <p:sp>
+        <p:nvSpPr>
+          <p:cNvPr id="10" name="TextBox 9"/>
           <p:cNvSpPr txBox="1"/>
           <p:nvPr/>
         </p:nvSpPr>
         <p:spPr>
           <a:xfrm>
-            <a:off x="960120" y="2249424"/>
-            <a:ext cx="5029200" cy="566928"/>
+            <a:off x="868680" y="2862072"/>
+            <a:ext cx="10515600" cy="493776"/>
           </a:xfrm>
           <a:prstGeom prst="rect">
             <a:avLst/>
@@ -4466,7 +4554,7 @@
           <a:lstStyle/>
           <a:p>
             <a:pPr algn="l">
-              <a:defRPr sz="1100" b="0">
+              <a:defRPr sz="1050" b="0">
                 <a:solidFill>
                   <a:srgbClr val="6E7B90"/>
                 </a:solidFill>
@@ -4474,21 +4562,65 @@
               </a:defRPr>
             </a:pPr>
             <a:r>
-              <a:t>Blueback first, then Raider and Wheat; Fran when it arrives</a:t>
-            </a:r>
-          </a:p>
-        </p:txBody>
-      </p:sp>
-      <p:sp>
-        <p:nvSpPr>
-          <p:cNvPr id="9" name="TextBox 8"/>
+              <a:t>Whatever we pick has to work with each machine's fabric and job launcher. Do we take what each site provides, and what do we do where that answer is unclear?</a:t>
+            </a:r>
+          </a:p>
+        </p:txBody>
+      </p:sp>
+      <p:sp>
+        <p:nvSpPr>
+          <p:cNvPr id="11" name="Rounded Rectangle 10"/>
+          <p:cNvSpPr/>
+          <p:nvPr/>
+        </p:nvSpPr>
+        <p:spPr>
+          <a:xfrm>
+            <a:off x="548640" y="3456432"/>
+            <a:ext cx="11091672" cy="896112"/>
+          </a:xfrm>
+          <a:prstGeom prst="roundRect">
+            <a:avLst/>
+          </a:prstGeom>
+          <a:solidFill>
+            <a:srgbClr val="F2F4F7"/>
+          </a:solidFill>
+          <a:ln>
+            <a:noFill/>
+          </a:ln>
+          <a:effectLst/>
+        </p:spPr>
+        <p:style>
+          <a:lnRef idx="1">
+            <a:schemeClr val="accent1"/>
+          </a:lnRef>
+          <a:fillRef idx="3">
+            <a:schemeClr val="accent1"/>
+          </a:fillRef>
+          <a:effectRef idx="2">
+            <a:schemeClr val="accent1"/>
+          </a:effectRef>
+          <a:fontRef idx="minor">
+            <a:schemeClr val="lt1"/>
+          </a:fontRef>
+        </p:style>
+        <p:txBody>
+          <a:bodyPr rtlCol="0" anchor="ctr"/>
+          <a:lstStyle/>
+          <a:p>
+            <a:pPr algn="ctr"/>
+          </a:p>
+        </p:txBody>
+      </p:sp>
+      <p:sp>
+        <p:nvSpPr>
+          <p:cNvPr id="12" name="TextBox 11"/>
           <p:cNvSpPr txBox="1"/>
           <p:nvPr/>
         </p:nvSpPr>
         <p:spPr>
           <a:xfrm>
-            <a:off x="548640" y="2944368"/>
-            <a:ext cx="365760" cy="365760"/>
+            <a:off x="868680" y="3547872"/>
+            <a:ext cx="10515600" cy="274320"/>
           </a:xfrm>
           <a:prstGeom prst="rect">
             <a:avLst/>
@@ -4502,29 +4634,29 @@
           <a:lstStyle/>
           <a:p>
             <a:pPr algn="l">
-              <a:defRPr sz="1500" b="1">
-                <a:solidFill>
-                  <a:srgbClr val="2C7A4B"/>
-                </a:solidFill>
-                <a:latin typeface="Avenir Next"/>
-              </a:defRPr>
-            </a:pPr>
-            <a:r>
-              <a:t>✓</a:t>
-            </a:r>
-          </a:p>
-        </p:txBody>
-      </p:sp>
-      <p:sp>
-        <p:nvSpPr>
-          <p:cNvPr id="10" name="TextBox 9"/>
+              <a:defRPr sz="1300" b="1">
+                <a:solidFill>
+                  <a:srgbClr val="BA740E"/>
+                </a:solidFill>
+                <a:latin typeface="Avenir Next"/>
+              </a:defRPr>
+            </a:pPr>
+            <a:r>
+              <a:t>What CPU baseline do we build for?</a:t>
+            </a:r>
+          </a:p>
+        </p:txBody>
+      </p:sp>
+      <p:sp>
+        <p:nvSpPr>
+          <p:cNvPr id="13" name="TextBox 12"/>
           <p:cNvSpPr txBox="1"/>
           <p:nvPr/>
         </p:nvSpPr>
         <p:spPr>
           <a:xfrm>
-            <a:off x="960120" y="2944368"/>
-            <a:ext cx="5029200" cy="292608"/>
+            <a:off x="868680" y="3831336"/>
+            <a:ext cx="10515600" cy="493776"/>
           </a:xfrm>
           <a:prstGeom prst="rect">
             <a:avLst/>
@@ -4538,29 +4670,73 @@
           <a:lstStyle/>
           <a:p>
             <a:pPr algn="l">
-              <a:defRPr sz="1300" b="1">
-                <a:solidFill>
-                  <a:srgbClr val="16243D"/>
-                </a:solidFill>
-                <a:latin typeface="Avenir Next"/>
-              </a:defRPr>
-            </a:pPr>
-            <a:r>
-              <a:t>A package roster with versions</a:t>
-            </a:r>
-          </a:p>
-        </p:txBody>
-      </p:sp>
-      <p:sp>
-        <p:nvSpPr>
-          <p:cNvPr id="11" name="TextBox 10"/>
+              <a:defRPr sz="1050" b="0">
+                <a:solidFill>
+                  <a:srgbClr val="6E7B90"/>
+                </a:solidFill>
+                <a:latin typeface="Avenir Next"/>
+              </a:defRPr>
+            </a:pPr>
+            <a:r>
+              <a:t>One portable target that runs on every pilot system, or per-system tuning from day one? This sets how many builds exist and where they can run.</a:t>
+            </a:r>
+          </a:p>
+        </p:txBody>
+      </p:sp>
+      <p:sp>
+        <p:nvSpPr>
+          <p:cNvPr id="14" name="Rounded Rectangle 13"/>
+          <p:cNvSpPr/>
+          <p:nvPr/>
+        </p:nvSpPr>
+        <p:spPr>
+          <a:xfrm>
+            <a:off x="548640" y="4425696"/>
+            <a:ext cx="11091672" cy="896112"/>
+          </a:xfrm>
+          <a:prstGeom prst="roundRect">
+            <a:avLst/>
+          </a:prstGeom>
+          <a:solidFill>
+            <a:srgbClr val="F2F4F7"/>
+          </a:solidFill>
+          <a:ln>
+            <a:noFill/>
+          </a:ln>
+          <a:effectLst/>
+        </p:spPr>
+        <p:style>
+          <a:lnRef idx="1">
+            <a:schemeClr val="accent1"/>
+          </a:lnRef>
+          <a:fillRef idx="3">
+            <a:schemeClr val="accent1"/>
+          </a:fillRef>
+          <a:effectRef idx="2">
+            <a:schemeClr val="accent1"/>
+          </a:effectRef>
+          <a:fontRef idx="minor">
+            <a:schemeClr val="lt1"/>
+          </a:fontRef>
+        </p:style>
+        <p:txBody>
+          <a:bodyPr rtlCol="0" anchor="ctr"/>
+          <a:lstStyle/>
+          <a:p>
+            <a:pPr algn="ctr"/>
+          </a:p>
+        </p:txBody>
+      </p:sp>
+      <p:sp>
+        <p:nvSpPr>
+          <p:cNvPr id="15" name="TextBox 14"/>
           <p:cNvSpPr txBox="1"/>
           <p:nvPr/>
         </p:nvSpPr>
         <p:spPr>
           <a:xfrm>
-            <a:off x="960120" y="3255264"/>
-            <a:ext cx="5029200" cy="566928"/>
+            <a:off x="868680" y="4517136"/>
+            <a:ext cx="10515600" cy="274320"/>
           </a:xfrm>
           <a:prstGeom prst="rect">
             <a:avLst/>
@@ -4574,29 +4750,29 @@
           <a:lstStyle/>
           <a:p>
             <a:pPr algn="l">
-              <a:defRPr sz="1100" b="0">
-                <a:solidFill>
-                  <a:srgbClr val="6E7B90"/>
-                </a:solidFill>
-                <a:latin typeface="Avenir Next"/>
-              </a:defRPr>
-            </a:pPr>
-            <a:r>
-              <a:t>newest supported release plus its predecessor, variants written down</a:t>
-            </a:r>
-          </a:p>
-        </p:txBody>
-      </p:sp>
-      <p:sp>
-        <p:nvSpPr>
-          <p:cNvPr id="12" name="TextBox 11"/>
+              <a:defRPr sz="1300" b="1">
+                <a:solidFill>
+                  <a:srgbClr val="6D4EAA"/>
+                </a:solidFill>
+                <a:latin typeface="Avenir Next"/>
+              </a:defRPr>
+            </a:pPr>
+            <a:r>
+              <a:t>Where does the software live on each system?</a:t>
+            </a:r>
+          </a:p>
+        </p:txBody>
+      </p:sp>
+      <p:sp>
+        <p:nvSpPr>
+          <p:cNvPr id="16" name="TextBox 15"/>
           <p:cNvSpPr txBox="1"/>
           <p:nvPr/>
         </p:nvSpPr>
         <p:spPr>
           <a:xfrm>
-            <a:off x="548640" y="3950208"/>
-            <a:ext cx="365760" cy="365760"/>
+            <a:off x="868680" y="4800600"/>
+            <a:ext cx="10515600" cy="493776"/>
           </a:xfrm>
           <a:prstGeom prst="rect">
             <a:avLst/>
@@ -4610,29 +4786,73 @@
           <a:lstStyle/>
           <a:p>
             <a:pPr algn="l">
-              <a:defRPr sz="1500" b="1">
-                <a:solidFill>
-                  <a:srgbClr val="2C7A4B"/>
-                </a:solidFill>
-                <a:latin typeface="Avenir Next"/>
-              </a:defRPr>
-            </a:pPr>
-            <a:r>
-              <a:t>✓</a:t>
-            </a:r>
-          </a:p>
-        </p:txBody>
-      </p:sp>
-      <p:sp>
-        <p:nvSpPr>
-          <p:cNvPr id="13" name="TextBox 12"/>
+              <a:defRPr sz="1050" b="0">
+                <a:solidFill>
+                  <a:srgbClr val="6E7B90"/>
+                </a:solidFill>
+                <a:latin typeface="Avenir Next"/>
+              </a:defRPr>
+            </a:pPr>
+            <a:r>
+              <a:t>Install locations, and who owns them, per system. Nothing installs until someone can answer this for their machine.</a:t>
+            </a:r>
+          </a:p>
+        </p:txBody>
+      </p:sp>
+      <p:sp>
+        <p:nvSpPr>
+          <p:cNvPr id="17" name="Rounded Rectangle 16"/>
+          <p:cNvSpPr/>
+          <p:nvPr/>
+        </p:nvSpPr>
+        <p:spPr>
+          <a:xfrm>
+            <a:off x="548640" y="5394960"/>
+            <a:ext cx="11091672" cy="896112"/>
+          </a:xfrm>
+          <a:prstGeom prst="roundRect">
+            <a:avLst/>
+          </a:prstGeom>
+          <a:solidFill>
+            <a:srgbClr val="F2F4F7"/>
+          </a:solidFill>
+          <a:ln>
+            <a:noFill/>
+          </a:ln>
+          <a:effectLst/>
+        </p:spPr>
+        <p:style>
+          <a:lnRef idx="1">
+            <a:schemeClr val="accent1"/>
+          </a:lnRef>
+          <a:fillRef idx="3">
+            <a:schemeClr val="accent1"/>
+          </a:fillRef>
+          <a:effectRef idx="2">
+            <a:schemeClr val="accent1"/>
+          </a:effectRef>
+          <a:fontRef idx="minor">
+            <a:schemeClr val="lt1"/>
+          </a:fontRef>
+        </p:style>
+        <p:txBody>
+          <a:bodyPr rtlCol="0" anchor="ctr"/>
+          <a:lstStyle/>
+          <a:p>
+            <a:pPr algn="ctr"/>
+          </a:p>
+        </p:txBody>
+      </p:sp>
+      <p:sp>
+        <p:nvSpPr>
+          <p:cNvPr id="18" name="TextBox 17"/>
           <p:cNvSpPr txBox="1"/>
           <p:nvPr/>
         </p:nvSpPr>
         <p:spPr>
           <a:xfrm>
-            <a:off x="960120" y="3950208"/>
-            <a:ext cx="5029200" cy="292608"/>
+            <a:off x="868680" y="5486400"/>
+            <a:ext cx="10515600" cy="274320"/>
           </a:xfrm>
           <a:prstGeom prst="rect">
             <a:avLst/>
@@ -4648,27 +4868,27 @@
             <a:pPr algn="l">
               <a:defRPr sz="1300" b="1">
                 <a:solidFill>
-                  <a:srgbClr val="16243D"/>
-                </a:solidFill>
-                <a:latin typeface="Avenir Next"/>
-              </a:defRPr>
-            </a:pPr>
-            <a:r>
-              <a:t>A baseline CPU target</a:t>
-            </a:r>
-          </a:p>
-        </p:txBody>
-      </p:sp>
-      <p:sp>
-        <p:nvSpPr>
-          <p:cNvPr id="14" name="TextBox 13"/>
+                  <a:srgbClr val="9A7614"/>
+                </a:solidFill>
+                <a:latin typeface="Avenir Next"/>
+              </a:defRPr>
+            </a:pPr>
+            <a:r>
+              <a:t>What has to pass before a build counts as done?</a:t>
+            </a:r>
+          </a:p>
+        </p:txBody>
+      </p:sp>
+      <p:sp>
+        <p:nvSpPr>
+          <p:cNvPr id="19" name="TextBox 18"/>
           <p:cNvSpPr txBox="1"/>
           <p:nvPr/>
         </p:nvSpPr>
         <p:spPr>
           <a:xfrm>
-            <a:off x="960120" y="4261104"/>
-            <a:ext cx="5029200" cy="566928"/>
+            <a:off x="868680" y="5769864"/>
+            <a:ext cx="10515600" cy="493776"/>
           </a:xfrm>
           <a:prstGeom prst="rect">
             <a:avLst/>
@@ -4682,7 +4902,7 @@
           <a:lstStyle/>
           <a:p>
             <a:pPr algn="l">
-              <a:defRPr sz="1100" b="0">
+              <a:defRPr sz="1050" b="0">
                 <a:solidFill>
                   <a:srgbClr val="6E7B90"/>
                 </a:solidFill>
@@ -4690,597 +4910,21 @@
               </a:defRPr>
             </a:pPr>
             <a:r>
-              <a:t>x86_64_v3 runs natively on every pilot system; tuning is a later flag</a:t>
-            </a:r>
-          </a:p>
-        </p:txBody>
-      </p:sp>
-      <p:sp>
-        <p:nvSpPr>
-          <p:cNvPr id="15" name="TextBox 14"/>
-          <p:cNvSpPr txBox="1"/>
-          <p:nvPr/>
-        </p:nvSpPr>
-        <p:spPr>
-          <a:xfrm>
-            <a:off x="548640" y="4956048"/>
-            <a:ext cx="365760" cy="365760"/>
-          </a:xfrm>
-          <a:prstGeom prst="rect">
-            <a:avLst/>
-          </a:prstGeom>
-          <a:noFill/>
-        </p:spPr>
-        <p:txBody>
-          <a:bodyPr wrap="square" anchor="t">
-            <a:spAutoFit/>
-          </a:bodyPr>
-          <a:lstStyle/>
-          <a:p>
-            <a:pPr algn="l">
-              <a:defRPr sz="1500" b="1">
-                <a:solidFill>
-                  <a:srgbClr val="2C7A4B"/>
-                </a:solidFill>
-                <a:latin typeface="Avenir Next"/>
-              </a:defRPr>
-            </a:pPr>
-            <a:r>
-              <a:t>✓</a:t>
-            </a:r>
-          </a:p>
-        </p:txBody>
-      </p:sp>
-      <p:sp>
-        <p:nvSpPr>
-          <p:cNvPr id="16" name="TextBox 15"/>
-          <p:cNvSpPr txBox="1"/>
-          <p:nvPr/>
-        </p:nvSpPr>
-        <p:spPr>
-          <a:xfrm>
-            <a:off x="960120" y="4956048"/>
-            <a:ext cx="5029200" cy="292608"/>
-          </a:xfrm>
-          <a:prstGeom prst="rect">
-            <a:avLst/>
-          </a:prstGeom>
-          <a:noFill/>
-        </p:spPr>
-        <p:txBody>
-          <a:bodyPr wrap="square" anchor="t">
-            <a:spAutoFit/>
-          </a:bodyPr>
-          <a:lstStyle/>
-          <a:p>
-            <a:pPr algn="l">
-              <a:defRPr sz="1300" b="1">
-                <a:solidFill>
-                  <a:srgbClr val="16243D"/>
-                </a:solidFill>
-                <a:latin typeface="Avenir Next"/>
-              </a:defRPr>
-            </a:pPr>
-            <a:r>
-              <a:t>A draft definition of done</a:t>
-            </a:r>
-          </a:p>
-        </p:txBody>
-      </p:sp>
-      <p:sp>
-        <p:nvSpPr>
-          <p:cNvPr id="17" name="TextBox 16"/>
-          <p:cNvSpPr txBox="1"/>
-          <p:nvPr/>
-        </p:nvSpPr>
-        <p:spPr>
-          <a:xfrm>
-            <a:off x="960120" y="5266944"/>
-            <a:ext cx="5029200" cy="566928"/>
-          </a:xfrm>
-          <a:prstGeom prst="rect">
-            <a:avLst/>
-          </a:prstGeom>
-          <a:noFill/>
-        </p:spPr>
-        <p:txBody>
-          <a:bodyPr wrap="square" anchor="t">
-            <a:spAutoFit/>
-          </a:bodyPr>
-          <a:lstStyle/>
-          <a:p>
-            <a:pPr algn="l">
-              <a:defRPr sz="1100" b="0">
-                <a:solidFill>
-                  <a:srgbClr val="6E7B90"/>
-                </a:solidFill>
-                <a:latin typeface="Avenir Next"/>
-              </a:defRPr>
-            </a:pPr>
-            <a:r>
-              <a:t>five checks, spelled out below</a:t>
-            </a:r>
-          </a:p>
-        </p:txBody>
-      </p:sp>
-      <p:sp>
-        <p:nvSpPr>
-          <p:cNvPr id="18" name="TextBox 17"/>
-          <p:cNvSpPr txBox="1"/>
-          <p:nvPr/>
-        </p:nvSpPr>
-        <p:spPr>
-          <a:xfrm>
-            <a:off x="6263640" y="1481328"/>
-            <a:ext cx="5394960" cy="365760"/>
-          </a:xfrm>
-          <a:prstGeom prst="rect">
-            <a:avLst/>
-          </a:prstGeom>
-          <a:noFill/>
-        </p:spPr>
-        <p:txBody>
-          <a:bodyPr wrap="square" anchor="t">
-            <a:spAutoFit/>
-          </a:bodyPr>
-          <a:lstStyle/>
-          <a:p>
-            <a:pPr algn="l">
-              <a:defRPr sz="1500" b="1">
-                <a:solidFill>
-                  <a:srgbClr val="9A7614"/>
-                </a:solidFill>
-                <a:latin typeface="Avenir Next"/>
-              </a:defRPr>
-            </a:pPr>
-            <a:r>
-              <a:t>What I need from you</a:t>
-            </a:r>
-          </a:p>
-        </p:txBody>
-      </p:sp>
-      <p:sp>
-        <p:nvSpPr>
-          <p:cNvPr id="19" name="TextBox 18"/>
-          <p:cNvSpPr txBox="1"/>
-          <p:nvPr/>
-        </p:nvSpPr>
-        <p:spPr>
-          <a:xfrm>
-            <a:off x="6263640" y="1938528"/>
-            <a:ext cx="365760" cy="365760"/>
-          </a:xfrm>
-          <a:prstGeom prst="rect">
-            <a:avLst/>
-          </a:prstGeom>
-          <a:noFill/>
-        </p:spPr>
-        <p:txBody>
-          <a:bodyPr wrap="square" anchor="t">
-            <a:spAutoFit/>
-          </a:bodyPr>
-          <a:lstStyle/>
-          <a:p>
-            <a:pPr algn="l">
-              <a:defRPr sz="1500" b="1">
-                <a:solidFill>
-                  <a:srgbClr val="9A7614"/>
-                </a:solidFill>
-                <a:latin typeface="Avenir Next"/>
-              </a:defRPr>
-            </a:pPr>
-            <a:r>
-              <a:t>→</a:t>
-            </a:r>
-          </a:p>
-        </p:txBody>
-      </p:sp>
-      <p:sp>
-        <p:nvSpPr>
-          <p:cNvPr id="20" name="TextBox 19"/>
-          <p:cNvSpPr txBox="1"/>
-          <p:nvPr/>
-        </p:nvSpPr>
-        <p:spPr>
-          <a:xfrm>
-            <a:off x="6675120" y="1938528"/>
-            <a:ext cx="4937760" cy="292608"/>
-          </a:xfrm>
-          <a:prstGeom prst="rect">
-            <a:avLst/>
-          </a:prstGeom>
-          <a:noFill/>
-        </p:spPr>
-        <p:txBody>
-          <a:bodyPr wrap="square" anchor="t">
-            <a:spAutoFit/>
-          </a:bodyPr>
-          <a:lstStyle/>
-          <a:p>
-            <a:pPr algn="l">
-              <a:defRPr sz="1300" b="1">
-                <a:solidFill>
-                  <a:srgbClr val="16243D"/>
-                </a:solidFill>
-                <a:latin typeface="Avenir Next"/>
-              </a:defRPr>
-            </a:pPr>
-            <a:r>
-              <a:t>Which GCC on each system</a:t>
-            </a:r>
-          </a:p>
-        </p:txBody>
-      </p:sp>
-      <p:sp>
-        <p:nvSpPr>
-          <p:cNvPr id="21" name="TextBox 20"/>
-          <p:cNvSpPr txBox="1"/>
-          <p:nvPr/>
-        </p:nvSpPr>
-        <p:spPr>
-          <a:xfrm>
-            <a:off x="6675120" y="2249424"/>
-            <a:ext cx="4937760" cy="566928"/>
-          </a:xfrm>
-          <a:prstGeom prst="rect">
-            <a:avLst/>
-          </a:prstGeom>
-          <a:noFill/>
-        </p:spPr>
-        <p:txBody>
-          <a:bodyPr wrap="square" anchor="t">
-            <a:spAutoFit/>
-          </a:bodyPr>
-          <a:lstStyle/>
-          <a:p>
-            <a:pPr algn="l">
-              <a:defRPr sz="1100" b="0">
-                <a:solidFill>
-                  <a:srgbClr val="6E7B90"/>
-                </a:solidFill>
-                <a:latin typeface="Avenir Next"/>
-              </a:defRPr>
-            </a:pPr>
-            <a:r>
-              <a:t>the system's own, or one version built everywhere; every package rests on this</a:t>
-            </a:r>
-          </a:p>
-        </p:txBody>
-      </p:sp>
-      <p:sp>
-        <p:nvSpPr>
-          <p:cNvPr id="22" name="TextBox 21"/>
-          <p:cNvSpPr txBox="1"/>
-          <p:nvPr/>
-        </p:nvSpPr>
-        <p:spPr>
-          <a:xfrm>
-            <a:off x="6263640" y="2944368"/>
-            <a:ext cx="365760" cy="365760"/>
-          </a:xfrm>
-          <a:prstGeom prst="rect">
-            <a:avLst/>
-          </a:prstGeom>
-          <a:noFill/>
-        </p:spPr>
-        <p:txBody>
-          <a:bodyPr wrap="square" anchor="t">
-            <a:spAutoFit/>
-          </a:bodyPr>
-          <a:lstStyle/>
-          <a:p>
-            <a:pPr algn="l">
-              <a:defRPr sz="1500" b="1">
-                <a:solidFill>
-                  <a:srgbClr val="9A7614"/>
-                </a:solidFill>
-                <a:latin typeface="Avenir Next"/>
-              </a:defRPr>
-            </a:pPr>
-            <a:r>
-              <a:t>→</a:t>
-            </a:r>
-          </a:p>
-        </p:txBody>
-      </p:sp>
-      <p:sp>
-        <p:nvSpPr>
-          <p:cNvPr id="23" name="TextBox 22"/>
-          <p:cNvSpPr txBox="1"/>
-          <p:nvPr/>
-        </p:nvSpPr>
-        <p:spPr>
-          <a:xfrm>
-            <a:off x="6675120" y="2944368"/>
-            <a:ext cx="4937760" cy="292608"/>
-          </a:xfrm>
-          <a:prstGeom prst="rect">
-            <a:avLst/>
-          </a:prstGeom>
-          <a:noFill/>
-        </p:spPr>
-        <p:txBody>
-          <a:bodyPr wrap="square" anchor="t">
-            <a:spAutoFit/>
-          </a:bodyPr>
-          <a:lstStyle/>
-          <a:p>
-            <a:pPr algn="l">
-              <a:defRPr sz="1300" b="1">
-                <a:solidFill>
-                  <a:srgbClr val="16243D"/>
-                </a:solidFill>
-                <a:latin typeface="Avenir Next"/>
-              </a:defRPr>
-            </a:pPr>
-            <a:r>
-              <a:t>MPI pairing on Raider and Wheat</a:t>
-            </a:r>
-          </a:p>
-        </p:txBody>
-      </p:sp>
-      <p:sp>
-        <p:nvSpPr>
-          <p:cNvPr id="24" name="TextBox 23"/>
-          <p:cNvSpPr txBox="1"/>
-          <p:nvPr/>
-        </p:nvSpPr>
-        <p:spPr>
-          <a:xfrm>
-            <a:off x="6675120" y="3255264"/>
-            <a:ext cx="4937760" cy="566928"/>
-          </a:xfrm>
-          <a:prstGeom prst="rect">
-            <a:avLst/>
-          </a:prstGeom>
-          <a:noFill/>
-        </p:spPr>
-        <p:txBody>
-          <a:bodyPr wrap="square" anchor="t">
-            <a:spAutoFit/>
-          </a:bodyPr>
-          <a:lstStyle/>
-          <a:p>
-            <a:pPr algn="l">
-              <a:defRPr sz="1100" b="0">
-                <a:solidFill>
-                  <a:srgbClr val="6E7B90"/>
-                </a:solidFill>
-                <a:latin typeface="Avenir Next"/>
-              </a:defRPr>
-            </a:pPr>
-            <a:r>
-              <a:t>the Crays point at cray-mpich; the others need the site MPI confirmed</a:t>
-            </a:r>
-          </a:p>
-        </p:txBody>
-      </p:sp>
-      <p:sp>
-        <p:nvSpPr>
-          <p:cNvPr id="25" name="TextBox 24"/>
-          <p:cNvSpPr txBox="1"/>
-          <p:nvPr/>
-        </p:nvSpPr>
-        <p:spPr>
-          <a:xfrm>
-            <a:off x="6263640" y="3950208"/>
-            <a:ext cx="365760" cy="365760"/>
-          </a:xfrm>
-          <a:prstGeom prst="rect">
-            <a:avLst/>
-          </a:prstGeom>
-          <a:noFill/>
-        </p:spPr>
-        <p:txBody>
-          <a:bodyPr wrap="square" anchor="t">
-            <a:spAutoFit/>
-          </a:bodyPr>
-          <a:lstStyle/>
-          <a:p>
-            <a:pPr algn="l">
-              <a:defRPr sz="1500" b="1">
-                <a:solidFill>
-                  <a:srgbClr val="9A7614"/>
-                </a:solidFill>
-                <a:latin typeface="Avenir Next"/>
-              </a:defRPr>
-            </a:pPr>
-            <a:r>
-              <a:t>→</a:t>
-            </a:r>
-          </a:p>
-        </p:txBody>
-      </p:sp>
-      <p:sp>
-        <p:nvSpPr>
-          <p:cNvPr id="26" name="TextBox 25"/>
-          <p:cNvSpPr txBox="1"/>
-          <p:nvPr/>
-        </p:nvSpPr>
-        <p:spPr>
-          <a:xfrm>
-            <a:off x="6675120" y="3950208"/>
-            <a:ext cx="4937760" cy="292608"/>
-          </a:xfrm>
-          <a:prstGeom prst="rect">
-            <a:avLst/>
-          </a:prstGeom>
-          <a:noFill/>
-        </p:spPr>
-        <p:txBody>
-          <a:bodyPr wrap="square" anchor="t">
-            <a:spAutoFit/>
-          </a:bodyPr>
-          <a:lstStyle/>
-          <a:p>
-            <a:pPr algn="l">
-              <a:defRPr sz="1300" b="1">
-                <a:solidFill>
-                  <a:srgbClr val="16243D"/>
-                </a:solidFill>
-                <a:latin typeface="Avenir Next"/>
-              </a:defRPr>
-            </a:pPr>
-            <a:r>
-              <a:t>System details and install paths</a:t>
-            </a:r>
-          </a:p>
-        </p:txBody>
-      </p:sp>
-      <p:sp>
-        <p:nvSpPr>
-          <p:cNvPr id="27" name="TextBox 26"/>
-          <p:cNvSpPr txBox="1"/>
-          <p:nvPr/>
-        </p:nvSpPr>
-        <p:spPr>
-          <a:xfrm>
-            <a:off x="6675120" y="4261104"/>
-            <a:ext cx="4937760" cy="566928"/>
-          </a:xfrm>
-          <a:prstGeom prst="rect">
-            <a:avLst/>
-          </a:prstGeom>
-          <a:noFill/>
-        </p:spPr>
-        <p:txBody>
-          <a:bodyPr wrap="square" anchor="t">
-            <a:spAutoFit/>
-          </a:bodyPr>
-          <a:lstStyle/>
-          <a:p>
-            <a:pPr algn="l">
-              <a:defRPr sz="1100" b="0">
-                <a:solidFill>
-                  <a:srgbClr val="6E7B90"/>
-                </a:solidFill>
-                <a:latin typeface="Avenir Next"/>
-              </a:defRPr>
-            </a:pPr>
-            <a:r>
-              <a:t>each system needs its facts confirmed and locations chosen, with an owner</a:t>
-            </a:r>
-          </a:p>
-        </p:txBody>
-      </p:sp>
-      <p:sp>
-        <p:nvSpPr>
-          <p:cNvPr id="28" name="TextBox 27"/>
-          <p:cNvSpPr txBox="1"/>
-          <p:nvPr/>
-        </p:nvSpPr>
-        <p:spPr>
-          <a:xfrm>
-            <a:off x="6263640" y="4956048"/>
-            <a:ext cx="365760" cy="365760"/>
-          </a:xfrm>
-          <a:prstGeom prst="rect">
-            <a:avLst/>
-          </a:prstGeom>
-          <a:noFill/>
-        </p:spPr>
-        <p:txBody>
-          <a:bodyPr wrap="square" anchor="t">
-            <a:spAutoFit/>
-          </a:bodyPr>
-          <a:lstStyle/>
-          <a:p>
-            <a:pPr algn="l">
-              <a:defRPr sz="1500" b="1">
-                <a:solidFill>
-                  <a:srgbClr val="9A7614"/>
-                </a:solidFill>
-                <a:latin typeface="Avenir Next"/>
-              </a:defRPr>
-            </a:pPr>
-            <a:r>
-              <a:t>→</a:t>
-            </a:r>
-          </a:p>
-        </p:txBody>
-      </p:sp>
-      <p:sp>
-        <p:nvSpPr>
-          <p:cNvPr id="29" name="TextBox 28"/>
-          <p:cNvSpPr txBox="1"/>
-          <p:nvPr/>
-        </p:nvSpPr>
-        <p:spPr>
-          <a:xfrm>
-            <a:off x="6675120" y="4956048"/>
-            <a:ext cx="4937760" cy="292608"/>
-          </a:xfrm>
-          <a:prstGeom prst="rect">
-            <a:avLst/>
-          </a:prstGeom>
-          <a:noFill/>
-        </p:spPr>
-        <p:txBody>
-          <a:bodyPr wrap="square" anchor="t">
-            <a:spAutoFit/>
-          </a:bodyPr>
-          <a:lstStyle/>
-          <a:p>
-            <a:pPr algn="l">
-              <a:defRPr sz="1300" b="1">
-                <a:solidFill>
-                  <a:srgbClr val="16243D"/>
-                </a:solidFill>
-                <a:latin typeface="Avenir Next"/>
-              </a:defRPr>
-            </a:pPr>
-            <a:r>
-              <a:t>Agreement on the definition of done</a:t>
-            </a:r>
-          </a:p>
-        </p:txBody>
-      </p:sp>
-      <p:sp>
-        <p:nvSpPr>
-          <p:cNvPr id="30" name="TextBox 29"/>
-          <p:cNvSpPr txBox="1"/>
-          <p:nvPr/>
-        </p:nvSpPr>
-        <p:spPr>
-          <a:xfrm>
-            <a:off x="6675120" y="5266944"/>
-            <a:ext cx="4937760" cy="566928"/>
-          </a:xfrm>
-          <a:prstGeom prst="rect">
-            <a:avLst/>
-          </a:prstGeom>
-          <a:noFill/>
-        </p:spPr>
-        <p:txBody>
-          <a:bodyPr wrap="square" anchor="t">
-            <a:spAutoFit/>
-          </a:bodyPr>
-          <a:lstStyle/>
-          <a:p>
-            <a:pPr algn="l">
-              <a:defRPr sz="1100" b="0">
-                <a:solidFill>
-                  <a:srgbClr val="6E7B90"/>
-                </a:solidFill>
-                <a:latin typeface="Avenir Next"/>
-              </a:defRPr>
-            </a:pPr>
-            <a:r>
-              <a:t>so the first build has a finish line</a:t>
-            </a:r>
-          </a:p>
-        </p:txBody>
-      </p:sp>
-      <p:sp>
-        <p:nvSpPr>
-          <p:cNvPr id="31" name="Rounded Rectangle 30"/>
+              <a:t>A shared finish line, agreed before the first build starts: what compiles, what runs, and what we can rebuild from scratch.</a:t>
+            </a:r>
+          </a:p>
+        </p:txBody>
+      </p:sp>
+      <p:sp>
+        <p:nvSpPr>
+          <p:cNvPr id="20" name="Rounded Rectangle 19"/>
           <p:cNvSpPr/>
           <p:nvPr/>
         </p:nvSpPr>
         <p:spPr>
           <a:xfrm>
-            <a:off x="548640" y="5943600"/>
-            <a:ext cx="11091672" cy="713232"/>
+            <a:off x="548640" y="6382512"/>
+            <a:ext cx="11091672" cy="384048"/>
           </a:xfrm>
           <a:prstGeom prst="roundRect">
             <a:avLst/>
@@ -5312,7 +4956,7 @@
           <a:lstStyle/>
           <a:p>
             <a:pPr algn="ctr">
-              <a:defRPr sz="1250" b="1">
+              <a:defRPr sz="1200" b="1">
                 <a:solidFill>
                   <a:srgbClr val="16243D"/>
                 </a:solidFill>
@@ -5320,20 +4964,7 @@
               </a:defRPr>
             </a:pPr>
             <a:r>
-              <a:t>Draft definition of done: packages build · sample C, C++, and Fortran codes compile and run ·</a:t>
-            </a:r>
-          </a:p>
-          <a:p>
-            <a:pPr algn="ctr">
-              <a:defRPr sz="1250" b="1">
-                <a:solidFill>
-                  <a:srgbClr val="16243D"/>
-                </a:solidFill>
-                <a:latin typeface="Avenir Next"/>
-              </a:defRPr>
-            </a:pPr>
-            <a:r>
-              <a:t>MPI jobs run across nodes · a rebuild reproduces the result · installs come from the build cache</a:t>
+              <a:t>And just as useful: which of these can wait until after the first builds?</a:t>
             </a:r>
           </a:p>
         </p:txBody>

</xml_diff>

<commit_message>
Reframe starter questions; add version-anchor question to open questions
</commit_message>
<xml_diff>
--- a/presentations/cse_lanes_model.pptx
+++ b/presentations/cse_lanes_model.pptx
@@ -3629,8 +3629,8 @@
         </p:nvSpPr>
         <p:spPr>
           <a:xfrm>
-            <a:off x="548640" y="1517904"/>
-            <a:ext cx="11091672" cy="896112"/>
+            <a:off x="548640" y="1463040"/>
+            <a:ext cx="11091672" cy="822960"/>
           </a:xfrm>
           <a:prstGeom prst="roundRect">
             <a:avLst/>
@@ -3673,7 +3673,7 @@
         </p:nvSpPr>
         <p:spPr>
           <a:xfrm>
-            <a:off x="868680" y="1609344"/>
+            <a:off x="868680" y="1545336"/>
             <a:ext cx="10515600" cy="274320"/>
           </a:xfrm>
           <a:prstGeom prst="rect">
@@ -3709,8 +3709,8 @@
         </p:nvSpPr>
         <p:spPr>
           <a:xfrm>
-            <a:off x="868680" y="1892807"/>
-            <a:ext cx="10515600" cy="493776"/>
+            <a:off x="868680" y="1828800"/>
+            <a:ext cx="10515600" cy="457200"/>
           </a:xfrm>
           <a:prstGeom prst="rect">
             <a:avLst/>
@@ -3724,7 +3724,7 @@
           <a:lstStyle/>
           <a:p>
             <a:pPr algn="l">
-              <a:defRPr sz="1050" b="0">
+              <a:defRPr sz="1000" b="0">
                 <a:solidFill>
                   <a:srgbClr val="6E7B90"/>
                 </a:solidFill>
@@ -3732,7 +3732,7 @@
               </a:defRPr>
             </a:pPr>
             <a:r>
-              <a:t>OpenBLAS is now the one BLAS and LAPACK, so users get the same library on every system. Cray LibSci is already on the path on Blueback and Fran, and Intel systems would expect MKL. Both are registered rather than built, so this is policy per system, not build cost.</a:t>
+              <a:t>OpenBLAS is the one BLAS and LAPACK today. Cray LibSci is already on the path on the Cray systems, and Intel systems expect MKL. Both are registered rather than built, so this is policy per system, not build cost.</a:t>
             </a:r>
           </a:p>
         </p:txBody>
@@ -3745,8 +3745,8 @@
         </p:nvSpPr>
         <p:spPr>
           <a:xfrm>
-            <a:off x="548640" y="2487168"/>
-            <a:ext cx="11091672" cy="896112"/>
+            <a:off x="548640" y="2345436"/>
+            <a:ext cx="11091672" cy="822960"/>
           </a:xfrm>
           <a:prstGeom prst="roundRect">
             <a:avLst/>
@@ -3789,7 +3789,7 @@
         </p:nvSpPr>
         <p:spPr>
           <a:xfrm>
-            <a:off x="868680" y="2578608"/>
+            <a:off x="868680" y="2427732"/>
             <a:ext cx="10515600" cy="274320"/>
           </a:xfrm>
           <a:prstGeom prst="rect">
@@ -3825,8 +3825,8 @@
         </p:nvSpPr>
         <p:spPr>
           <a:xfrm>
-            <a:off x="868680" y="2862072"/>
-            <a:ext cx="10515600" cy="493776"/>
+            <a:off x="868680" y="2711196"/>
+            <a:ext cx="10515600" cy="457200"/>
           </a:xfrm>
           <a:prstGeom prst="rect">
             <a:avLst/>
@@ -3840,7 +3840,7 @@
           <a:lstStyle/>
           <a:p>
             <a:pPr algn="l">
-              <a:defRPr sz="1050" b="0">
+              <a:defRPr sz="1000" b="0">
                 <a:solidFill>
                   <a:srgbClr val="6E7B90"/>
                 </a:solidFill>
@@ -3848,7 +3848,7 @@
               </a:defRPr>
             </a:pPr>
             <a:r>
-              <a:t>The pilot carries two per system: the one the machine blesses as its baseline, plus GCC as the portable reference. CSEinit offers GCC and Intel today, so whether Intel is one of the two on the systems that have it is the open part.</a:t>
+              <a:t>Two per system: the one the machine blesses as its baseline, plus GCC as the portable reference. CSEinit offers GCC and Intel today, so whether Intel stays one of the two on the systems that have it is the open part.</a:t>
             </a:r>
           </a:p>
         </p:txBody>
@@ -3861,8 +3861,8 @@
         </p:nvSpPr>
         <p:spPr>
           <a:xfrm>
-            <a:off x="548640" y="3456432"/>
-            <a:ext cx="11091672" cy="896112"/>
+            <a:off x="548640" y="3227832"/>
+            <a:ext cx="11091672" cy="822960"/>
           </a:xfrm>
           <a:prstGeom prst="roundRect">
             <a:avLst/>
@@ -3905,7 +3905,7 @@
         </p:nvSpPr>
         <p:spPr>
           <a:xfrm>
-            <a:off x="868680" y="3547872"/>
+            <a:off x="868680" y="3310128"/>
             <a:ext cx="10515600" cy="274320"/>
           </a:xfrm>
           <a:prstGeom prst="rect">
@@ -3922,13 +3922,13 @@
             <a:pPr algn="l">
               <a:defRPr sz="1300" b="1">
                 <a:solidFill>
-                  <a:srgbClr val="BA740E"/>
-                </a:solidFill>
-                <a:latin typeface="Avenir Next"/>
-              </a:defRPr>
-            </a:pPr>
-            <a:r>
-              <a:t>Does the Serial lane stay?</a:t>
+                  <a:srgbClr val="2B62B8"/>
+                </a:solidFill>
+                <a:latin typeface="Avenir Next"/>
+              </a:defRPr>
+            </a:pPr>
+            <a:r>
+              <a:t>Do we anchor the older version to what the systems run today?</a:t>
             </a:r>
           </a:p>
         </p:txBody>
@@ -3941,8 +3941,8 @@
         </p:nvSpPr>
         <p:spPr>
           <a:xfrm>
-            <a:off x="868680" y="3831336"/>
-            <a:ext cx="10515600" cy="493776"/>
+            <a:off x="868680" y="3593592"/>
+            <a:ext cx="10515600" cy="457200"/>
           </a:xfrm>
           <a:prstGeom prst="rect">
             <a:avLst/>
@@ -3956,7 +3956,7 @@
           <a:lstStyle/>
           <a:p>
             <a:pPr algn="l">
-              <a:defRPr sz="1050" b="0">
+              <a:defRPr sz="1000" b="0">
                 <a:solidFill>
                   <a:srgbClr val="6E7B90"/>
                 </a:solidFill>
@@ -3964,7 +3964,7 @@
               </a:defRPr>
             </a:pPr>
             <a:r>
-              <a:t>Serial exists so users who are not running parallel do not carry the MPI runtime: analysis and post-processing on a login node, small tools, anything linking HDF5 or NetCDF without wanting libmpi behind it. An MPI build on one rank does the same work, so dropping Serial would halve the build matrix and push the MPI runtime onto everyone.</a:t>
+              <a:t>Each package carries two versions, and the newer is always the newest release. The older is the open part: match what is deployed on the systems now so existing code keeps building, or just carry the previous release and move users up. Decide before the roster locks.</a:t>
             </a:r>
           </a:p>
         </p:txBody>
@@ -3977,8 +3977,8 @@
         </p:nvSpPr>
         <p:spPr>
           <a:xfrm>
-            <a:off x="548640" y="4425696"/>
-            <a:ext cx="11091672" cy="896112"/>
+            <a:off x="548640" y="4110228"/>
+            <a:ext cx="11091672" cy="822960"/>
           </a:xfrm>
           <a:prstGeom prst="roundRect">
             <a:avLst/>
@@ -4021,7 +4021,7 @@
         </p:nvSpPr>
         <p:spPr>
           <a:xfrm>
-            <a:off x="868680" y="4517136"/>
+            <a:off x="868680" y="4192524"/>
             <a:ext cx="10515600" cy="274320"/>
           </a:xfrm>
           <a:prstGeom prst="rect">
@@ -4038,13 +4038,13 @@
             <a:pPr algn="l">
               <a:defRPr sz="1300" b="1">
                 <a:solidFill>
-                  <a:srgbClr val="6D4EAA"/>
-                </a:solidFill>
-                <a:latin typeface="Avenir Next"/>
-              </a:defRPr>
-            </a:pPr>
-            <a:r>
-              <a:t>Performance targeting: baseline first, tuning after.</a:t>
+                  <a:srgbClr val="BA740E"/>
+                </a:solidFill>
+                <a:latin typeface="Avenir Next"/>
+              </a:defRPr>
+            </a:pPr>
+            <a:r>
+              <a:t>Does the Serial lane stay?</a:t>
             </a:r>
           </a:p>
         </p:txBody>
@@ -4057,8 +4057,8 @@
         </p:nvSpPr>
         <p:spPr>
           <a:xfrm>
-            <a:off x="868680" y="4800600"/>
-            <a:ext cx="10515600" cy="493776"/>
+            <a:off x="868680" y="4475988"/>
+            <a:ext cx="10515600" cy="457200"/>
           </a:xfrm>
           <a:prstGeom prst="rect">
             <a:avLst/>
@@ -4072,7 +4072,7 @@
           <a:lstStyle/>
           <a:p>
             <a:pPr algn="l">
-              <a:defRPr sz="1050" b="0">
+              <a:defRPr sz="1000" b="0">
                 <a:solidFill>
                   <a:srgbClr val="6E7B90"/>
                 </a:solidFill>
@@ -4080,7 +4080,7 @@
               </a:defRPr>
             </a:pPr>
             <a:r>
-              <a:t>The plan is to build every lane at the portable baseline, prove the model, then turn on per-lane tuning for Genoa, Milan, or Cascade Lake. Each target is a flag plus a full rebuild, so the open part is when, not whether.</a:t>
+              <a:t>Serial spares non-parallel users the MPI runtime: analysis, post-processing, small tools, anything linking HDF5 or NetCDF without libmpi behind it. An MPI build on one rank does the same work, so dropping Serial halves the build matrix but pushes the MPI runtime onto everyone.</a:t>
             </a:r>
           </a:p>
         </p:txBody>
@@ -4093,8 +4093,8 @@
         </p:nvSpPr>
         <p:spPr>
           <a:xfrm>
-            <a:off x="548640" y="5394960"/>
-            <a:ext cx="11091672" cy="896112"/>
+            <a:off x="548640" y="4992624"/>
+            <a:ext cx="11091672" cy="822960"/>
           </a:xfrm>
           <a:prstGeom prst="roundRect">
             <a:avLst/>
@@ -4137,7 +4137,7 @@
         </p:nvSpPr>
         <p:spPr>
           <a:xfrm>
-            <a:off x="868680" y="5486400"/>
+            <a:off x="868680" y="5074920"/>
             <a:ext cx="10515600" cy="274320"/>
           </a:xfrm>
           <a:prstGeom prst="rect">
@@ -4154,13 +4154,13 @@
             <a:pPr algn="l">
               <a:defRPr sz="1300" b="1">
                 <a:solidFill>
-                  <a:srgbClr val="9A7614"/>
-                </a:solidFill>
-                <a:latin typeface="Avenir Next"/>
-              </a:defRPr>
-            </a:pPr>
-            <a:r>
-              <a:t>Consistency means the same functionality, not the same implementations.</a:t>
+                  <a:srgbClr val="6D4EAA"/>
+                </a:solidFill>
+                <a:latin typeface="Avenir Next"/>
+              </a:defRPr>
+            </a:pPr>
+            <a:r>
+              <a:t>Performance targeting: baseline first, tuning after.</a:t>
             </a:r>
           </a:p>
         </p:txBody>
@@ -4173,8 +4173,8 @@
         </p:nvSpPr>
         <p:spPr>
           <a:xfrm>
-            <a:off x="868680" y="5769864"/>
-            <a:ext cx="10515600" cy="493776"/>
+            <a:off x="868680" y="5358384"/>
+            <a:ext cx="10515600" cy="457200"/>
           </a:xfrm>
           <a:prstGeom prst="rect">
             <a:avLst/>
@@ -4188,7 +4188,7 @@
           <a:lstStyle/>
           <a:p>
             <a:pPr algn="l">
-              <a:defRPr sz="1050" b="0">
+              <a:defRPr sz="1000" b="0">
                 <a:solidFill>
                   <a:srgbClr val="6E7B90"/>
                 </a:solidFill>
@@ -4196,7 +4196,123 @@
               </a:defRPr>
             </a:pPr>
             <a:r>
-              <a:t>A user builds and runs the same way on every system: same front door, same rosters, same workflow, with each machine's native MPI and compiler underneath. The open part is the floor: which capabilities every system must provide, and whether one pinned CSE GCC anchors the compilers.</a:t>
+              <a:t>Build every lane at the portable baseline, prove the model, then turn on per-lane tuning for Genoa, Milan, or Cascade Lake. Each target is a flag plus a full rebuild, so the open part is when, not whether.</a:t>
+            </a:r>
+          </a:p>
+        </p:txBody>
+      </p:sp>
+      <p:sp>
+        <p:nvSpPr>
+          <p:cNvPr id="20" name="Rounded Rectangle 19"/>
+          <p:cNvSpPr/>
+          <p:nvPr/>
+        </p:nvSpPr>
+        <p:spPr>
+          <a:xfrm>
+            <a:off x="548640" y="5875020"/>
+            <a:ext cx="11091672" cy="822960"/>
+          </a:xfrm>
+          <a:prstGeom prst="roundRect">
+            <a:avLst/>
+          </a:prstGeom>
+          <a:solidFill>
+            <a:srgbClr val="F2F4F7"/>
+          </a:solidFill>
+          <a:ln>
+            <a:noFill/>
+          </a:ln>
+          <a:effectLst/>
+        </p:spPr>
+        <p:style>
+          <a:lnRef idx="1">
+            <a:schemeClr val="accent1"/>
+          </a:lnRef>
+          <a:fillRef idx="3">
+            <a:schemeClr val="accent1"/>
+          </a:fillRef>
+          <a:effectRef idx="2">
+            <a:schemeClr val="accent1"/>
+          </a:effectRef>
+          <a:fontRef idx="minor">
+            <a:schemeClr val="lt1"/>
+          </a:fontRef>
+        </p:style>
+        <p:txBody>
+          <a:bodyPr rtlCol="0" anchor="ctr"/>
+          <a:lstStyle/>
+          <a:p>
+            <a:pPr algn="ctr"/>
+          </a:p>
+        </p:txBody>
+      </p:sp>
+      <p:sp>
+        <p:nvSpPr>
+          <p:cNvPr id="21" name="TextBox 20"/>
+          <p:cNvSpPr txBox="1"/>
+          <p:nvPr/>
+        </p:nvSpPr>
+        <p:spPr>
+          <a:xfrm>
+            <a:off x="868680" y="5957316"/>
+            <a:ext cx="10515600" cy="274320"/>
+          </a:xfrm>
+          <a:prstGeom prst="rect">
+            <a:avLst/>
+          </a:prstGeom>
+          <a:noFill/>
+        </p:spPr>
+        <p:txBody>
+          <a:bodyPr wrap="square" anchor="t">
+            <a:spAutoFit/>
+          </a:bodyPr>
+          <a:lstStyle/>
+          <a:p>
+            <a:pPr algn="l">
+              <a:defRPr sz="1300" b="1">
+                <a:solidFill>
+                  <a:srgbClr val="9A7614"/>
+                </a:solidFill>
+                <a:latin typeface="Avenir Next"/>
+              </a:defRPr>
+            </a:pPr>
+            <a:r>
+              <a:t>Consistency means the same functionality, not the same implementations.</a:t>
+            </a:r>
+          </a:p>
+        </p:txBody>
+      </p:sp>
+      <p:sp>
+        <p:nvSpPr>
+          <p:cNvPr id="22" name="TextBox 21"/>
+          <p:cNvSpPr txBox="1"/>
+          <p:nvPr/>
+        </p:nvSpPr>
+        <p:spPr>
+          <a:xfrm>
+            <a:off x="868680" y="6240780"/>
+            <a:ext cx="10515600" cy="457200"/>
+          </a:xfrm>
+          <a:prstGeom prst="rect">
+            <a:avLst/>
+          </a:prstGeom>
+          <a:noFill/>
+        </p:spPr>
+        <p:txBody>
+          <a:bodyPr wrap="square" anchor="t">
+            <a:spAutoFit/>
+          </a:bodyPr>
+          <a:lstStyle/>
+          <a:p>
+            <a:pPr algn="l">
+              <a:defRPr sz="1000" b="0">
+                <a:solidFill>
+                  <a:srgbClr val="6E7B90"/>
+                </a:solidFill>
+                <a:latin typeface="Avenir Next"/>
+              </a:defRPr>
+            </a:pPr>
+            <a:r>
+              <a:t>Same front door, same rosters, same workflow on every system, with each machine's native MPI and compiler underneath. The open part is the floor: which capabilities every system must provide, and whether one pinned CSE GCC anchors the compilers.</a:t>
             </a:r>
           </a:p>
         </p:txBody>
@@ -4343,8 +4459,8 @@
         </p:nvSpPr>
         <p:spPr>
           <a:xfrm>
-            <a:off x="548640" y="1517904"/>
-            <a:ext cx="11091672" cy="896112"/>
+            <a:off x="548640" y="1463040"/>
+            <a:ext cx="11091672" cy="822960"/>
           </a:xfrm>
           <a:prstGeom prst="roundRect">
             <a:avLst/>
@@ -4387,7 +4503,7 @@
         </p:nvSpPr>
         <p:spPr>
           <a:xfrm>
-            <a:off x="868680" y="1609344"/>
+            <a:off x="868680" y="1545336"/>
             <a:ext cx="10515600" cy="274320"/>
           </a:xfrm>
           <a:prstGeom prst="rect">
@@ -4423,8 +4539,8 @@
         </p:nvSpPr>
         <p:spPr>
           <a:xfrm>
-            <a:off x="868680" y="1892807"/>
-            <a:ext cx="10515600" cy="493776"/>
+            <a:off x="868680" y="1828800"/>
+            <a:ext cx="10515600" cy="457200"/>
           </a:xfrm>
           <a:prstGeom prst="rect">
             <a:avLst/>
@@ -4438,7 +4554,7 @@
           <a:lstStyle/>
           <a:p>
             <a:pPr algn="l">
-              <a:defRPr sz="1050" b="0">
+              <a:defRPr sz="1000" b="0">
                 <a:solidFill>
                   <a:srgbClr val="6E7B90"/>
                 </a:solidFill>
@@ -4446,7 +4562,7 @@
               </a:defRPr>
             </a:pPr>
             <a:r>
-              <a:t>Every package on a system builds against this choice, so it comes first. The system's own compiler, one common version everywhere, or something else?</a:t>
+              <a:t>It comes first, because everything else on the system is built with it. Each machine's own compiler, one shared version across systems, or a mix?</a:t>
             </a:r>
           </a:p>
         </p:txBody>
@@ -4459,8 +4575,8 @@
         </p:nvSpPr>
         <p:spPr>
           <a:xfrm>
-            <a:off x="548640" y="2487168"/>
-            <a:ext cx="11091672" cy="896112"/>
+            <a:off x="548640" y="2345436"/>
+            <a:ext cx="11091672" cy="822960"/>
           </a:xfrm>
           <a:prstGeom prst="roundRect">
             <a:avLst/>
@@ -4503,7 +4619,7 @@
         </p:nvSpPr>
         <p:spPr>
           <a:xfrm>
-            <a:off x="868680" y="2578608"/>
+            <a:off x="868680" y="2427732"/>
             <a:ext cx="10515600" cy="274320"/>
           </a:xfrm>
           <a:prstGeom prst="rect">
@@ -4520,13 +4636,13 @@
             <a:pPr algn="l">
               <a:defRPr sz="1300" b="1">
                 <a:solidFill>
-                  <a:srgbClr val="2B62B8"/>
-                </a:solidFill>
-                <a:latin typeface="Avenir Next"/>
-              </a:defRPr>
-            </a:pPr>
-            <a:r>
-              <a:t>Which MPI pairs with it on each system?</a:t>
+                  <a:srgbClr val="2C7A4B"/>
+                </a:solidFill>
+                <a:latin typeface="Avenir Next"/>
+              </a:defRPr>
+            </a:pPr>
+            <a:r>
+              <a:t>Which components do we take from the system instead of building?</a:t>
             </a:r>
           </a:p>
         </p:txBody>
@@ -4539,8 +4655,8 @@
         </p:nvSpPr>
         <p:spPr>
           <a:xfrm>
-            <a:off x="868680" y="2862072"/>
-            <a:ext cx="10515600" cy="493776"/>
+            <a:off x="868680" y="2711196"/>
+            <a:ext cx="10515600" cy="457200"/>
           </a:xfrm>
           <a:prstGeom prst="rect">
             <a:avLst/>
@@ -4554,7 +4670,7 @@
           <a:lstStyle/>
           <a:p>
             <a:pPr algn="l">
-              <a:defRPr sz="1050" b="0">
+              <a:defRPr sz="1000" b="0">
                 <a:solidFill>
                   <a:srgbClr val="6E7B90"/>
                 </a:solidFill>
@@ -4562,7 +4678,7 @@
               </a:defRPr>
             </a:pPr>
             <a:r>
-              <a:t>Whatever we pick has to work with each machine's fabric and job launcher. Do we take what each site provides, and what do we do where that answer is unclear?</a:t>
+              <a:t>OpenSSL and curl look like clear cases to start. Which others do we commit to as system-provided rather than build ourselves?</a:t>
             </a:r>
           </a:p>
         </p:txBody>
@@ -4575,8 +4691,8 @@
         </p:nvSpPr>
         <p:spPr>
           <a:xfrm>
-            <a:off x="548640" y="3456432"/>
-            <a:ext cx="11091672" cy="896112"/>
+            <a:off x="548640" y="3227832"/>
+            <a:ext cx="11091672" cy="822960"/>
           </a:xfrm>
           <a:prstGeom prst="roundRect">
             <a:avLst/>
@@ -4619,7 +4735,7 @@
         </p:nvSpPr>
         <p:spPr>
           <a:xfrm>
-            <a:off x="868680" y="3547872"/>
+            <a:off x="868680" y="3310128"/>
             <a:ext cx="10515600" cy="274320"/>
           </a:xfrm>
           <a:prstGeom prst="rect">
@@ -4636,13 +4752,13 @@
             <a:pPr algn="l">
               <a:defRPr sz="1300" b="1">
                 <a:solidFill>
-                  <a:srgbClr val="BA740E"/>
-                </a:solidFill>
-                <a:latin typeface="Avenir Next"/>
-              </a:defRPr>
-            </a:pPr>
-            <a:r>
-              <a:t>What CPU baseline do we build for?</a:t>
+                  <a:srgbClr val="2B62B8"/>
+                </a:solidFill>
+                <a:latin typeface="Avenir Next"/>
+              </a:defRPr>
+            </a:pPr>
+            <a:r>
+              <a:t>Which MPI do we use on each system?</a:t>
             </a:r>
           </a:p>
         </p:txBody>
@@ -4655,8 +4771,8 @@
         </p:nvSpPr>
         <p:spPr>
           <a:xfrm>
-            <a:off x="868680" y="3831336"/>
-            <a:ext cx="10515600" cy="493776"/>
+            <a:off x="868680" y="3593592"/>
+            <a:ext cx="10515600" cy="457200"/>
           </a:xfrm>
           <a:prstGeom prst="rect">
             <a:avLst/>
@@ -4670,7 +4786,7 @@
           <a:lstStyle/>
           <a:p>
             <a:pPr algn="l">
-              <a:defRPr sz="1050" b="0">
+              <a:defRPr sz="1000" b="0">
                 <a:solidFill>
                   <a:srgbClr val="6E7B90"/>
                 </a:solidFill>
@@ -4678,7 +4794,7 @@
               </a:defRPr>
             </a:pPr>
             <a:r>
-              <a:t>One portable target that runs on every pilot system, or per-system tuning from day one? This sets how many builds exist and where they can run.</a:t>
+              <a:t>cray-mpich on the Cray machines, once we confirm we can build against it; OpenMPI on the rest, ideally the same one across them.</a:t>
             </a:r>
           </a:p>
         </p:txBody>
@@ -4691,8 +4807,8 @@
         </p:nvSpPr>
         <p:spPr>
           <a:xfrm>
-            <a:off x="548640" y="4425696"/>
-            <a:ext cx="11091672" cy="896112"/>
+            <a:off x="548640" y="4110228"/>
+            <a:ext cx="11091672" cy="822960"/>
           </a:xfrm>
           <a:prstGeom prst="roundRect">
             <a:avLst/>
@@ -4735,7 +4851,7 @@
         </p:nvSpPr>
         <p:spPr>
           <a:xfrm>
-            <a:off x="868680" y="4517136"/>
+            <a:off x="868680" y="4192524"/>
             <a:ext cx="10515600" cy="274320"/>
           </a:xfrm>
           <a:prstGeom prst="rect">
@@ -4752,13 +4868,13 @@
             <a:pPr algn="l">
               <a:defRPr sz="1300" b="1">
                 <a:solidFill>
-                  <a:srgbClr val="6D4EAA"/>
-                </a:solidFill>
-                <a:latin typeface="Avenir Next"/>
-              </a:defRPr>
-            </a:pPr>
-            <a:r>
-              <a:t>Where does the software live on each system?</a:t>
+                  <a:srgbClr val="BA740E"/>
+                </a:solidFill>
+                <a:latin typeface="Avenir Next"/>
+              </a:defRPr>
+            </a:pPr>
+            <a:r>
+              <a:t>What CPU baseline do we set?</a:t>
             </a:r>
           </a:p>
         </p:txBody>
@@ -4771,8 +4887,8 @@
         </p:nvSpPr>
         <p:spPr>
           <a:xfrm>
-            <a:off x="868680" y="4800600"/>
-            <a:ext cx="10515600" cy="493776"/>
+            <a:off x="868680" y="4475988"/>
+            <a:ext cx="10515600" cy="457200"/>
           </a:xfrm>
           <a:prstGeom prst="rect">
             <a:avLst/>
@@ -4786,7 +4902,7 @@
           <a:lstStyle/>
           <a:p>
             <a:pPr algn="l">
-              <a:defRPr sz="1050" b="0">
+              <a:defRPr sz="1000" b="0">
                 <a:solidFill>
                   <a:srgbClr val="6E7B90"/>
                 </a:solidFill>
@@ -4794,7 +4910,7 @@
               </a:defRPr>
             </a:pPr>
             <a:r>
-              <a:t>Install locations, and who owns them, per system. Nothing installs until someone can answer this for their machine.</a:t>
+              <a:t>We name the target rather than let the tools choose it. Which baseline, and where do we allow per-system tuning later?</a:t>
             </a:r>
           </a:p>
         </p:txBody>
@@ -4807,8 +4923,8 @@
         </p:nvSpPr>
         <p:spPr>
           <a:xfrm>
-            <a:off x="548640" y="5394960"/>
-            <a:ext cx="11091672" cy="896112"/>
+            <a:off x="548640" y="4992624"/>
+            <a:ext cx="11091672" cy="822960"/>
           </a:xfrm>
           <a:prstGeom prst="roundRect">
             <a:avLst/>
@@ -4851,7 +4967,7 @@
         </p:nvSpPr>
         <p:spPr>
           <a:xfrm>
-            <a:off x="868680" y="5486400"/>
+            <a:off x="868680" y="5074920"/>
             <a:ext cx="10515600" cy="274320"/>
           </a:xfrm>
           <a:prstGeom prst="rect">
@@ -4868,13 +4984,13 @@
             <a:pPr algn="l">
               <a:defRPr sz="1300" b="1">
                 <a:solidFill>
-                  <a:srgbClr val="9A7614"/>
-                </a:solidFill>
-                <a:latin typeface="Avenir Next"/>
-              </a:defRPr>
-            </a:pPr>
-            <a:r>
-              <a:t>What has to pass before a build counts as done?</a:t>
+                  <a:srgbClr val="6D4EAA"/>
+                </a:solidFill>
+                <a:latin typeface="Avenir Next"/>
+              </a:defRPr>
+            </a:pPr>
+            <a:r>
+              <a:t>Where does the stack live, and which Spack builds it?</a:t>
             </a:r>
           </a:p>
         </p:txBody>
@@ -4887,8 +5003,8 @@
         </p:nvSpPr>
         <p:spPr>
           <a:xfrm>
-            <a:off x="868680" y="5769864"/>
-            <a:ext cx="10515600" cy="493776"/>
+            <a:off x="868680" y="5358384"/>
+            <a:ext cx="10515600" cy="457200"/>
           </a:xfrm>
           <a:prstGeom prst="rect">
             <a:avLst/>
@@ -4902,7 +5018,7 @@
           <a:lstStyle/>
           <a:p>
             <a:pPr algn="l">
-              <a:defRPr sz="1050" b="0">
+              <a:defRPr sz="1000" b="0">
                 <a:solidFill>
                   <a:srgbClr val="6E7B90"/>
                 </a:solidFill>
@@ -4910,7 +5026,7 @@
               </a:defRPr>
             </a:pPr>
             <a:r>
-              <a:t>A shared finish line, agreed before the first build starts: what compiles, what runs, and what we can rebuild from scratch.</a:t>
+              <a:t>Install locations per system, most likely the CSE directory, and the Spack version we standardize on for the pilot.</a:t>
             </a:r>
           </a:p>
         </p:txBody>
@@ -4923,14 +5039,14 @@
         </p:nvSpPr>
         <p:spPr>
           <a:xfrm>
-            <a:off x="548640" y="6382512"/>
-            <a:ext cx="11091672" cy="384048"/>
+            <a:off x="548640" y="5875020"/>
+            <a:ext cx="11091672" cy="822960"/>
           </a:xfrm>
           <a:prstGeom prst="roundRect">
             <a:avLst/>
           </a:prstGeom>
           <a:solidFill>
-            <a:srgbClr val="E3E7EE"/>
+            <a:srgbClr val="F2F4F7"/>
           </a:solidFill>
           <a:ln>
             <a:noFill/>
@@ -4952,19 +5068,81 @@
           </a:fontRef>
         </p:style>
         <p:txBody>
-          <a:bodyPr rtlCol="0" anchor="ctr" wrap="square" lIns="109728" rIns="109728"/>
-          <a:lstStyle/>
-          <a:p>
-            <a:pPr algn="ctr">
-              <a:defRPr sz="1200" b="1">
-                <a:solidFill>
-                  <a:srgbClr val="16243D"/>
-                </a:solidFill>
-                <a:latin typeface="Avenir Next"/>
-              </a:defRPr>
-            </a:pPr>
-            <a:r>
-              <a:t>And just as useful: which of these can wait until after the first builds?</a:t>
+          <a:bodyPr rtlCol="0" anchor="ctr"/>
+          <a:lstStyle/>
+          <a:p>
+            <a:pPr algn="ctr"/>
+          </a:p>
+        </p:txBody>
+      </p:sp>
+      <p:sp>
+        <p:nvSpPr>
+          <p:cNvPr id="21" name="TextBox 20"/>
+          <p:cNvSpPr txBox="1"/>
+          <p:nvPr/>
+        </p:nvSpPr>
+        <p:spPr>
+          <a:xfrm>
+            <a:off x="868680" y="5957316"/>
+            <a:ext cx="10515600" cy="274320"/>
+          </a:xfrm>
+          <a:prstGeom prst="rect">
+            <a:avLst/>
+          </a:prstGeom>
+          <a:noFill/>
+        </p:spPr>
+        <p:txBody>
+          <a:bodyPr wrap="square" anchor="t">
+            <a:spAutoFit/>
+          </a:bodyPr>
+          <a:lstStyle/>
+          <a:p>
+            <a:pPr algn="l">
+              <a:defRPr sz="1300" b="1">
+                <a:solidFill>
+                  <a:srgbClr val="9A7614"/>
+                </a:solidFill>
+                <a:latin typeface="Avenir Next"/>
+              </a:defRPr>
+            </a:pPr>
+            <a:r>
+              <a:t>What counts as done?</a:t>
+            </a:r>
+          </a:p>
+        </p:txBody>
+      </p:sp>
+      <p:sp>
+        <p:nvSpPr>
+          <p:cNvPr id="22" name="TextBox 21"/>
+          <p:cNvSpPr txBox="1"/>
+          <p:nvPr/>
+        </p:nvSpPr>
+        <p:spPr>
+          <a:xfrm>
+            <a:off x="868680" y="6240780"/>
+            <a:ext cx="10515600" cy="457200"/>
+          </a:xfrm>
+          <a:prstGeom prst="rect">
+            <a:avLst/>
+          </a:prstGeom>
+          <a:noFill/>
+        </p:spPr>
+        <p:txBody>
+          <a:bodyPr wrap="square" anchor="t">
+            <a:spAutoFit/>
+          </a:bodyPr>
+          <a:lstStyle/>
+          <a:p>
+            <a:pPr algn="l">
+              <a:defRPr sz="1000" b="0">
+                <a:solidFill>
+                  <a:srgbClr val="6E7B90"/>
+                </a:solidFill>
+                <a:latin typeface="Avenir Next"/>
+              </a:defRPr>
+            </a:pPr>
+            <a:r>
+              <a:t>The packages built and tested, or the full user environment stood up and ready to load?</a:t>
             </a:r>
           </a:p>
         </p:txBody>

</xml_diff>

<commit_message>
Order open questions by importance; make the consistency item a question
</commit_message>
<xml_diff>
--- a/presentations/cse_lanes_model.pptx
+++ b/presentations/cse_lanes_model.pptx
@@ -3690,13 +3690,13 @@
             <a:pPr algn="l">
               <a:defRPr sz="1300" b="1">
                 <a:solidFill>
-                  <a:srgbClr val="2C7A4B"/>
-                </a:solidFill>
-                <a:latin typeface="Avenir Next"/>
-              </a:defRPr>
-            </a:pPr>
-            <a:r>
-              <a:t>Do we offer the vendor's math libraries as well as OpenBLAS?</a:t>
+                  <a:srgbClr val="117A72"/>
+                </a:solidFill>
+                <a:latin typeface="Avenir Next"/>
+              </a:defRPr>
+            </a:pPr>
+            <a:r>
+              <a:t>Which compiler surfaces does the pilot carry?</a:t>
             </a:r>
           </a:p>
         </p:txBody>
@@ -3732,7 +3732,7 @@
               </a:defRPr>
             </a:pPr>
             <a:r>
-              <a:t>OpenBLAS is the one BLAS and LAPACK today. Cray LibSci is already on the path on the Cray systems, and Intel systems expect MKL. Both are registered rather than built, so this is policy per system, not build cost.</a:t>
+              <a:t>Two per system: the one the machine blesses as its baseline, plus GCC as the portable reference. CSEinit offers GCC and Intel today, so whether Intel stays one of the two on the systems that have it is the open part.</a:t>
             </a:r>
           </a:p>
         </p:txBody>
@@ -3806,13 +3806,13 @@
             <a:pPr algn="l">
               <a:defRPr sz="1300" b="1">
                 <a:solidFill>
-                  <a:srgbClr val="117A72"/>
-                </a:solidFill>
-                <a:latin typeface="Avenir Next"/>
-              </a:defRPr>
-            </a:pPr>
-            <a:r>
-              <a:t>Which compiler surfaces does the pilot carry?</a:t>
+                  <a:srgbClr val="BA740E"/>
+                </a:solidFill>
+                <a:latin typeface="Avenir Next"/>
+              </a:defRPr>
+            </a:pPr>
+            <a:r>
+              <a:t>Is a separate Serial lane worth its own builds?</a:t>
             </a:r>
           </a:p>
         </p:txBody>
@@ -3848,7 +3848,7 @@
               </a:defRPr>
             </a:pPr>
             <a:r>
-              <a:t>Two per system: the one the machine blesses as its baseline, plus GCC as the portable reference. CSEinit offers GCC and Intel today, so whether Intel stays one of the two on the systems that have it is the open part.</a:t>
+              <a:t>Serial spares users who are not running parallel from the MPI runtime: login-node analysis, post-processing, small tools, anything linking HDF5 or NetCDF without libmpi behind it. The cost is a second build of those packages. Worth it, or does one MPI build on a single rank cover them?</a:t>
             </a:r>
           </a:p>
         </p:txBody>
@@ -4038,13 +4038,13 @@
             <a:pPr algn="l">
               <a:defRPr sz="1300" b="1">
                 <a:solidFill>
-                  <a:srgbClr val="BA740E"/>
-                </a:solidFill>
-                <a:latin typeface="Avenir Next"/>
-              </a:defRPr>
-            </a:pPr>
-            <a:r>
-              <a:t>Does the Serial lane stay?</a:t>
+                  <a:srgbClr val="2C7A4B"/>
+                </a:solidFill>
+                <a:latin typeface="Avenir Next"/>
+              </a:defRPr>
+            </a:pPr>
+            <a:r>
+              <a:t>Do we offer the vendor's math libraries as well as OpenBLAS?</a:t>
             </a:r>
           </a:p>
         </p:txBody>
@@ -4080,7 +4080,7 @@
               </a:defRPr>
             </a:pPr>
             <a:r>
-              <a:t>Serial spares non-parallel users the MPI runtime: analysis, post-processing, small tools, anything linking HDF5 or NetCDF without libmpi behind it. An MPI build on one rank does the same work, so dropping Serial halves the build matrix but pushes the MPI runtime onto everyone.</a:t>
+              <a:t>OpenBLAS is the one BLAS and LAPACK today. Cray LibSci is already on the path on the Cray systems, and Intel systems expect MKL. Both are registered rather than built, so this is policy per system, not build cost.</a:t>
             </a:r>
           </a:p>
         </p:txBody>
@@ -4276,7 +4276,7 @@
               </a:defRPr>
             </a:pPr>
             <a:r>
-              <a:t>Consistency means the same functionality, not the same implementations.</a:t>
+              <a:t>What does consistency promise across systems?</a:t>
             </a:r>
           </a:p>
         </p:txBody>
@@ -4312,7 +4312,7 @@
               </a:defRPr>
             </a:pPr>
             <a:r>
-              <a:t>Same front door, same rosters, same workflow on every system, with each machine's native MPI and compiler underneath. The open part is the floor: which capabilities every system must provide, and whether one pinned CSE GCC anchors the compilers.</a:t>
+              <a:t>Users build, link, and run the same way everywhere: same front door, same rosters, same workflow. That much is the goal. The open part is what sits underneath: each machine's native MPI and compiler, or a pinned CSE compiler and a shared MPI? Which promise do we make?</a:t>
             </a:r>
           </a:p>
         </p:txBody>

</xml_diff>

<commit_message>
Drop the Serial-lane open question; it is a lane-exposure detail, not a build decision
</commit_message>
<xml_diff>
--- a/presentations/cse_lanes_model.pptx
+++ b/presentations/cse_lanes_model.pptx
@@ -3629,8 +3629,8 @@
         </p:nvSpPr>
         <p:spPr>
           <a:xfrm>
-            <a:off x="548640" y="1463040"/>
-            <a:ext cx="11091672" cy="822960"/>
+            <a:off x="548640" y="1517904"/>
+            <a:ext cx="11091672" cy="896112"/>
           </a:xfrm>
           <a:prstGeom prst="roundRect">
             <a:avLst/>
@@ -3673,7 +3673,7 @@
         </p:nvSpPr>
         <p:spPr>
           <a:xfrm>
-            <a:off x="868680" y="1545336"/>
+            <a:off x="868680" y="1609344"/>
             <a:ext cx="10515600" cy="274320"/>
           </a:xfrm>
           <a:prstGeom prst="rect">
@@ -3709,8 +3709,8 @@
         </p:nvSpPr>
         <p:spPr>
           <a:xfrm>
-            <a:off x="868680" y="1828800"/>
-            <a:ext cx="10515600" cy="457200"/>
+            <a:off x="868680" y="1892807"/>
+            <a:ext cx="10515600" cy="493776"/>
           </a:xfrm>
           <a:prstGeom prst="rect">
             <a:avLst/>
@@ -3724,7 +3724,7 @@
           <a:lstStyle/>
           <a:p>
             <a:pPr algn="l">
-              <a:defRPr sz="1000" b="0">
+              <a:defRPr sz="1050" b="0">
                 <a:solidFill>
                   <a:srgbClr val="6E7B90"/>
                 </a:solidFill>
@@ -3745,8 +3745,8 @@
         </p:nvSpPr>
         <p:spPr>
           <a:xfrm>
-            <a:off x="548640" y="2345436"/>
-            <a:ext cx="11091672" cy="822960"/>
+            <a:off x="548640" y="2487168"/>
+            <a:ext cx="11091672" cy="896112"/>
           </a:xfrm>
           <a:prstGeom prst="roundRect">
             <a:avLst/>
@@ -3789,7 +3789,7 @@
         </p:nvSpPr>
         <p:spPr>
           <a:xfrm>
-            <a:off x="868680" y="2427732"/>
+            <a:off x="868680" y="2578608"/>
             <a:ext cx="10515600" cy="274320"/>
           </a:xfrm>
           <a:prstGeom prst="rect">
@@ -3806,13 +3806,13 @@
             <a:pPr algn="l">
               <a:defRPr sz="1300" b="1">
                 <a:solidFill>
-                  <a:srgbClr val="BA740E"/>
-                </a:solidFill>
-                <a:latin typeface="Avenir Next"/>
-              </a:defRPr>
-            </a:pPr>
-            <a:r>
-              <a:t>Is a separate Serial lane worth its own builds?</a:t>
+                  <a:srgbClr val="2B62B8"/>
+                </a:solidFill>
+                <a:latin typeface="Avenir Next"/>
+              </a:defRPr>
+            </a:pPr>
+            <a:r>
+              <a:t>Do we anchor the older version to what the systems run today?</a:t>
             </a:r>
           </a:p>
         </p:txBody>
@@ -3825,8 +3825,8 @@
         </p:nvSpPr>
         <p:spPr>
           <a:xfrm>
-            <a:off x="868680" y="2711196"/>
-            <a:ext cx="10515600" cy="457200"/>
+            <a:off x="868680" y="2862072"/>
+            <a:ext cx="10515600" cy="493776"/>
           </a:xfrm>
           <a:prstGeom prst="rect">
             <a:avLst/>
@@ -3840,7 +3840,7 @@
           <a:lstStyle/>
           <a:p>
             <a:pPr algn="l">
-              <a:defRPr sz="1000" b="0">
+              <a:defRPr sz="1050" b="0">
                 <a:solidFill>
                   <a:srgbClr val="6E7B90"/>
                 </a:solidFill>
@@ -3848,7 +3848,7 @@
               </a:defRPr>
             </a:pPr>
             <a:r>
-              <a:t>Serial spares users who are not running parallel from the MPI runtime: login-node analysis, post-processing, small tools, anything linking HDF5 or NetCDF without libmpi behind it. The cost is a second build of those packages. Worth it, or does one MPI build on a single rank cover them?</a:t>
+              <a:t>Each package carries two versions, and the newer is always the newest release. The older is the open part: match what is deployed on the systems now so existing code keeps building, or just carry the previous release and move users up. Decide before the roster locks.</a:t>
             </a:r>
           </a:p>
         </p:txBody>
@@ -3861,8 +3861,8 @@
         </p:nvSpPr>
         <p:spPr>
           <a:xfrm>
-            <a:off x="548640" y="3227832"/>
-            <a:ext cx="11091672" cy="822960"/>
+            <a:off x="548640" y="3456432"/>
+            <a:ext cx="11091672" cy="896112"/>
           </a:xfrm>
           <a:prstGeom prst="roundRect">
             <a:avLst/>
@@ -3905,7 +3905,7 @@
         </p:nvSpPr>
         <p:spPr>
           <a:xfrm>
-            <a:off x="868680" y="3310128"/>
+            <a:off x="868680" y="3547872"/>
             <a:ext cx="10515600" cy="274320"/>
           </a:xfrm>
           <a:prstGeom prst="rect">
@@ -3922,13 +3922,13 @@
             <a:pPr algn="l">
               <a:defRPr sz="1300" b="1">
                 <a:solidFill>
-                  <a:srgbClr val="2B62B8"/>
-                </a:solidFill>
-                <a:latin typeface="Avenir Next"/>
-              </a:defRPr>
-            </a:pPr>
-            <a:r>
-              <a:t>Do we anchor the older version to what the systems run today?</a:t>
+                  <a:srgbClr val="2C7A4B"/>
+                </a:solidFill>
+                <a:latin typeface="Avenir Next"/>
+              </a:defRPr>
+            </a:pPr>
+            <a:r>
+              <a:t>Do we offer the vendor's math libraries as well as OpenBLAS?</a:t>
             </a:r>
           </a:p>
         </p:txBody>
@@ -3941,8 +3941,8 @@
         </p:nvSpPr>
         <p:spPr>
           <a:xfrm>
-            <a:off x="868680" y="3593592"/>
-            <a:ext cx="10515600" cy="457200"/>
+            <a:off x="868680" y="3831336"/>
+            <a:ext cx="10515600" cy="493776"/>
           </a:xfrm>
           <a:prstGeom prst="rect">
             <a:avLst/>
@@ -3956,7 +3956,7 @@
           <a:lstStyle/>
           <a:p>
             <a:pPr algn="l">
-              <a:defRPr sz="1000" b="0">
+              <a:defRPr sz="1050" b="0">
                 <a:solidFill>
                   <a:srgbClr val="6E7B90"/>
                 </a:solidFill>
@@ -3964,7 +3964,7 @@
               </a:defRPr>
             </a:pPr>
             <a:r>
-              <a:t>Each package carries two versions, and the newer is always the newest release. The older is the open part: match what is deployed on the systems now so existing code keeps building, or just carry the previous release and move users up. Decide before the roster locks.</a:t>
+              <a:t>OpenBLAS is the one BLAS and LAPACK today. Cray LibSci is already on the path on the Cray systems, and Intel systems expect MKL. Both are registered rather than built, so this is policy per system, not build cost.</a:t>
             </a:r>
           </a:p>
         </p:txBody>
@@ -3977,8 +3977,8 @@
         </p:nvSpPr>
         <p:spPr>
           <a:xfrm>
-            <a:off x="548640" y="4110228"/>
-            <a:ext cx="11091672" cy="822960"/>
+            <a:off x="548640" y="4425696"/>
+            <a:ext cx="11091672" cy="896112"/>
           </a:xfrm>
           <a:prstGeom prst="roundRect">
             <a:avLst/>
@@ -4021,7 +4021,7 @@
         </p:nvSpPr>
         <p:spPr>
           <a:xfrm>
-            <a:off x="868680" y="4192524"/>
+            <a:off x="868680" y="4517136"/>
             <a:ext cx="10515600" cy="274320"/>
           </a:xfrm>
           <a:prstGeom prst="rect">
@@ -4038,13 +4038,13 @@
             <a:pPr algn="l">
               <a:defRPr sz="1300" b="1">
                 <a:solidFill>
-                  <a:srgbClr val="2C7A4B"/>
-                </a:solidFill>
-                <a:latin typeface="Avenir Next"/>
-              </a:defRPr>
-            </a:pPr>
-            <a:r>
-              <a:t>Do we offer the vendor's math libraries as well as OpenBLAS?</a:t>
+                  <a:srgbClr val="6D4EAA"/>
+                </a:solidFill>
+                <a:latin typeface="Avenir Next"/>
+              </a:defRPr>
+            </a:pPr>
+            <a:r>
+              <a:t>Performance targeting: baseline first, tuning after.</a:t>
             </a:r>
           </a:p>
         </p:txBody>
@@ -4057,8 +4057,8 @@
         </p:nvSpPr>
         <p:spPr>
           <a:xfrm>
-            <a:off x="868680" y="4475988"/>
-            <a:ext cx="10515600" cy="457200"/>
+            <a:off x="868680" y="4800600"/>
+            <a:ext cx="10515600" cy="493776"/>
           </a:xfrm>
           <a:prstGeom prst="rect">
             <a:avLst/>
@@ -4072,7 +4072,7 @@
           <a:lstStyle/>
           <a:p>
             <a:pPr algn="l">
-              <a:defRPr sz="1000" b="0">
+              <a:defRPr sz="1050" b="0">
                 <a:solidFill>
                   <a:srgbClr val="6E7B90"/>
                 </a:solidFill>
@@ -4080,7 +4080,7 @@
               </a:defRPr>
             </a:pPr>
             <a:r>
-              <a:t>OpenBLAS is the one BLAS and LAPACK today. Cray LibSci is already on the path on the Cray systems, and Intel systems expect MKL. Both are registered rather than built, so this is policy per system, not build cost.</a:t>
+              <a:t>Build every lane at the portable baseline, prove the model, then turn on per-lane tuning for Genoa, Milan, or Cascade Lake. Each target is a flag plus a full rebuild, so the open part is when, not whether.</a:t>
             </a:r>
           </a:p>
         </p:txBody>
@@ -4093,8 +4093,8 @@
         </p:nvSpPr>
         <p:spPr>
           <a:xfrm>
-            <a:off x="548640" y="4992624"/>
-            <a:ext cx="11091672" cy="822960"/>
+            <a:off x="548640" y="5394960"/>
+            <a:ext cx="11091672" cy="896112"/>
           </a:xfrm>
           <a:prstGeom prst="roundRect">
             <a:avLst/>
@@ -4137,7 +4137,7 @@
         </p:nvSpPr>
         <p:spPr>
           <a:xfrm>
-            <a:off x="868680" y="5074920"/>
+            <a:off x="868680" y="5486400"/>
             <a:ext cx="10515600" cy="274320"/>
           </a:xfrm>
           <a:prstGeom prst="rect">
@@ -4154,13 +4154,13 @@
             <a:pPr algn="l">
               <a:defRPr sz="1300" b="1">
                 <a:solidFill>
-                  <a:srgbClr val="6D4EAA"/>
-                </a:solidFill>
-                <a:latin typeface="Avenir Next"/>
-              </a:defRPr>
-            </a:pPr>
-            <a:r>
-              <a:t>Performance targeting: baseline first, tuning after.</a:t>
+                  <a:srgbClr val="9A7614"/>
+                </a:solidFill>
+                <a:latin typeface="Avenir Next"/>
+              </a:defRPr>
+            </a:pPr>
+            <a:r>
+              <a:t>What does consistency promise across systems?</a:t>
             </a:r>
           </a:p>
         </p:txBody>
@@ -4173,8 +4173,8 @@
         </p:nvSpPr>
         <p:spPr>
           <a:xfrm>
-            <a:off x="868680" y="5358384"/>
-            <a:ext cx="10515600" cy="457200"/>
+            <a:off x="868680" y="5769864"/>
+            <a:ext cx="10515600" cy="493776"/>
           </a:xfrm>
           <a:prstGeom prst="rect">
             <a:avLst/>
@@ -4188,123 +4188,7 @@
           <a:lstStyle/>
           <a:p>
             <a:pPr algn="l">
-              <a:defRPr sz="1000" b="0">
-                <a:solidFill>
-                  <a:srgbClr val="6E7B90"/>
-                </a:solidFill>
-                <a:latin typeface="Avenir Next"/>
-              </a:defRPr>
-            </a:pPr>
-            <a:r>
-              <a:t>Build every lane at the portable baseline, prove the model, then turn on per-lane tuning for Genoa, Milan, or Cascade Lake. Each target is a flag plus a full rebuild, so the open part is when, not whether.</a:t>
-            </a:r>
-          </a:p>
-        </p:txBody>
-      </p:sp>
-      <p:sp>
-        <p:nvSpPr>
-          <p:cNvPr id="20" name="Rounded Rectangle 19"/>
-          <p:cNvSpPr/>
-          <p:nvPr/>
-        </p:nvSpPr>
-        <p:spPr>
-          <a:xfrm>
-            <a:off x="548640" y="5875020"/>
-            <a:ext cx="11091672" cy="822960"/>
-          </a:xfrm>
-          <a:prstGeom prst="roundRect">
-            <a:avLst/>
-          </a:prstGeom>
-          <a:solidFill>
-            <a:srgbClr val="F2F4F7"/>
-          </a:solidFill>
-          <a:ln>
-            <a:noFill/>
-          </a:ln>
-          <a:effectLst/>
-        </p:spPr>
-        <p:style>
-          <a:lnRef idx="1">
-            <a:schemeClr val="accent1"/>
-          </a:lnRef>
-          <a:fillRef idx="3">
-            <a:schemeClr val="accent1"/>
-          </a:fillRef>
-          <a:effectRef idx="2">
-            <a:schemeClr val="accent1"/>
-          </a:effectRef>
-          <a:fontRef idx="minor">
-            <a:schemeClr val="lt1"/>
-          </a:fontRef>
-        </p:style>
-        <p:txBody>
-          <a:bodyPr rtlCol="0" anchor="ctr"/>
-          <a:lstStyle/>
-          <a:p>
-            <a:pPr algn="ctr"/>
-          </a:p>
-        </p:txBody>
-      </p:sp>
-      <p:sp>
-        <p:nvSpPr>
-          <p:cNvPr id="21" name="TextBox 20"/>
-          <p:cNvSpPr txBox="1"/>
-          <p:nvPr/>
-        </p:nvSpPr>
-        <p:spPr>
-          <a:xfrm>
-            <a:off x="868680" y="5957316"/>
-            <a:ext cx="10515600" cy="274320"/>
-          </a:xfrm>
-          <a:prstGeom prst="rect">
-            <a:avLst/>
-          </a:prstGeom>
-          <a:noFill/>
-        </p:spPr>
-        <p:txBody>
-          <a:bodyPr wrap="square" anchor="t">
-            <a:spAutoFit/>
-          </a:bodyPr>
-          <a:lstStyle/>
-          <a:p>
-            <a:pPr algn="l">
-              <a:defRPr sz="1300" b="1">
-                <a:solidFill>
-                  <a:srgbClr val="9A7614"/>
-                </a:solidFill>
-                <a:latin typeface="Avenir Next"/>
-              </a:defRPr>
-            </a:pPr>
-            <a:r>
-              <a:t>What does consistency promise across systems?</a:t>
-            </a:r>
-          </a:p>
-        </p:txBody>
-      </p:sp>
-      <p:sp>
-        <p:nvSpPr>
-          <p:cNvPr id="22" name="TextBox 21"/>
-          <p:cNvSpPr txBox="1"/>
-          <p:nvPr/>
-        </p:nvSpPr>
-        <p:spPr>
-          <a:xfrm>
-            <a:off x="868680" y="6240780"/>
-            <a:ext cx="10515600" cy="457200"/>
-          </a:xfrm>
-          <a:prstGeom prst="rect">
-            <a:avLst/>
-          </a:prstGeom>
-          <a:noFill/>
-        </p:spPr>
-        <p:txBody>
-          <a:bodyPr wrap="square" anchor="t">
-            <a:spAutoFit/>
-          </a:bodyPr>
-          <a:lstStyle/>
-          <a:p>
-            <a:pPr algn="l">
-              <a:defRPr sz="1000" b="0">
+              <a:defRPr sz="1050" b="0">
                 <a:solidFill>
                   <a:srgbClr val="6E7B90"/>
                 </a:solidFill>

</xml_diff>

<commit_message>
Split the two discussion slides cleanly: setup blockers vs scope and policy
</commit_message>
<xml_diff>
--- a/presentations/cse_lanes_model.pptx
+++ b/presentations/cse_lanes_model.pptx
@@ -3580,7 +3580,7 @@
               </a:defRPr>
             </a:pPr>
             <a:r>
-              <a:t>DECISIONS WE NEED · NOT SETTLED YET</a:t>
+              <a:t>SCOPE AND POLICY · NOT SETTLED YET</a:t>
             </a:r>
           </a:p>
         </p:txBody>
@@ -3616,7 +3616,7 @@
               </a:defRPr>
             </a:pPr>
             <a:r>
-              <a:t>Open questions for the team</a:t>
+              <a:t>Bigger questions to settle together</a:t>
             </a:r>
           </a:p>
         </p:txBody>
@@ -3629,8 +3629,8 @@
         </p:nvSpPr>
         <p:spPr>
           <a:xfrm>
-            <a:off x="548640" y="1517904"/>
-            <a:ext cx="11091672" cy="896112"/>
+            <a:off x="548640" y="1600200"/>
+            <a:ext cx="11091672" cy="1024128"/>
           </a:xfrm>
           <a:prstGeom prst="roundRect">
             <a:avLst/>
@@ -3673,7 +3673,7 @@
         </p:nvSpPr>
         <p:spPr>
           <a:xfrm>
-            <a:off x="868680" y="1609344"/>
+            <a:off x="868680" y="1728216"/>
             <a:ext cx="10515600" cy="274320"/>
           </a:xfrm>
           <a:prstGeom prst="rect">
@@ -3690,13 +3690,13 @@
             <a:pPr algn="l">
               <a:defRPr sz="1300" b="1">
                 <a:solidFill>
-                  <a:srgbClr val="117A72"/>
-                </a:solidFill>
-                <a:latin typeface="Avenir Next"/>
-              </a:defRPr>
-            </a:pPr>
-            <a:r>
-              <a:t>Which compiler surfaces does the pilot carry?</a:t>
+                  <a:srgbClr val="2B62B8"/>
+                </a:solidFill>
+                <a:latin typeface="Avenir Next"/>
+              </a:defRPr>
+            </a:pPr>
+            <a:r>
+              <a:t>Do we anchor the older version to what the systems run today?</a:t>
             </a:r>
           </a:p>
         </p:txBody>
@@ -3709,8 +3709,8 @@
         </p:nvSpPr>
         <p:spPr>
           <a:xfrm>
-            <a:off x="868680" y="1892807"/>
-            <a:ext cx="10515600" cy="493776"/>
+            <a:off x="868680" y="2039112"/>
+            <a:ext cx="10515600" cy="512064"/>
           </a:xfrm>
           <a:prstGeom prst="rect">
             <a:avLst/>
@@ -3732,7 +3732,7 @@
               </a:defRPr>
             </a:pPr>
             <a:r>
-              <a:t>Two per system: the one the machine blesses as its baseline, plus GCC as the portable reference. CSEinit offers GCC and Intel today, so whether Intel stays one of the two on the systems that have it is the open part.</a:t>
+              <a:t>Each package carries two versions, and the newer is always the newest release. The older is the open part: match what is deployed on the systems now so existing code keeps building, or just carry the previous release and move users up. Decide before the roster locks.</a:t>
             </a:r>
           </a:p>
         </p:txBody>
@@ -3745,8 +3745,8 @@
         </p:nvSpPr>
         <p:spPr>
           <a:xfrm>
-            <a:off x="548640" y="2487168"/>
-            <a:ext cx="11091672" cy="896112"/>
+            <a:off x="548640" y="2770632"/>
+            <a:ext cx="11091672" cy="1024128"/>
           </a:xfrm>
           <a:prstGeom prst="roundRect">
             <a:avLst/>
@@ -3789,7 +3789,7 @@
         </p:nvSpPr>
         <p:spPr>
           <a:xfrm>
-            <a:off x="868680" y="2578608"/>
+            <a:off x="868680" y="2898648"/>
             <a:ext cx="10515600" cy="274320"/>
           </a:xfrm>
           <a:prstGeom prst="rect">
@@ -3806,13 +3806,13 @@
             <a:pPr algn="l">
               <a:defRPr sz="1300" b="1">
                 <a:solidFill>
-                  <a:srgbClr val="2B62B8"/>
-                </a:solidFill>
-                <a:latin typeface="Avenir Next"/>
-              </a:defRPr>
-            </a:pPr>
-            <a:r>
-              <a:t>Do we anchor the older version to what the systems run today?</a:t>
+                  <a:srgbClr val="2C7A4B"/>
+                </a:solidFill>
+                <a:latin typeface="Avenir Next"/>
+              </a:defRPr>
+            </a:pPr>
+            <a:r>
+              <a:t>Do we offer the vendor's math libraries as well as OpenBLAS?</a:t>
             </a:r>
           </a:p>
         </p:txBody>
@@ -3825,8 +3825,8 @@
         </p:nvSpPr>
         <p:spPr>
           <a:xfrm>
-            <a:off x="868680" y="2862072"/>
-            <a:ext cx="10515600" cy="493776"/>
+            <a:off x="868680" y="3209544"/>
+            <a:ext cx="10515600" cy="512064"/>
           </a:xfrm>
           <a:prstGeom prst="rect">
             <a:avLst/>
@@ -3848,7 +3848,7 @@
               </a:defRPr>
             </a:pPr>
             <a:r>
-              <a:t>Each package carries two versions, and the newer is always the newest release. The older is the open part: match what is deployed on the systems now so existing code keeps building, or just carry the previous release and move users up. Decide before the roster locks.</a:t>
+              <a:t>OpenBLAS is the one BLAS and LAPACK today. Cray LibSci is already on the path on the Cray systems, and Intel systems expect MKL. Both are registered rather than built, so this is policy per system, not build cost.</a:t>
             </a:r>
           </a:p>
         </p:txBody>
@@ -3861,8 +3861,8 @@
         </p:nvSpPr>
         <p:spPr>
           <a:xfrm>
-            <a:off x="548640" y="3456432"/>
-            <a:ext cx="11091672" cy="896112"/>
+            <a:off x="548640" y="3941064"/>
+            <a:ext cx="11091672" cy="1024128"/>
           </a:xfrm>
           <a:prstGeom prst="roundRect">
             <a:avLst/>
@@ -3905,7 +3905,7 @@
         </p:nvSpPr>
         <p:spPr>
           <a:xfrm>
-            <a:off x="868680" y="3547872"/>
+            <a:off x="868680" y="4069080"/>
             <a:ext cx="10515600" cy="274320"/>
           </a:xfrm>
           <a:prstGeom prst="rect">
@@ -3922,13 +3922,13 @@
             <a:pPr algn="l">
               <a:defRPr sz="1300" b="1">
                 <a:solidFill>
-                  <a:srgbClr val="2C7A4B"/>
-                </a:solidFill>
-                <a:latin typeface="Avenir Next"/>
-              </a:defRPr>
-            </a:pPr>
-            <a:r>
-              <a:t>Do we offer the vendor's math libraries as well as OpenBLAS?</a:t>
+                  <a:srgbClr val="6D4EAA"/>
+                </a:solidFill>
+                <a:latin typeface="Avenir Next"/>
+              </a:defRPr>
+            </a:pPr>
+            <a:r>
+              <a:t>Performance targeting: baseline first, tuning after.</a:t>
             </a:r>
           </a:p>
         </p:txBody>
@@ -3941,8 +3941,8 @@
         </p:nvSpPr>
         <p:spPr>
           <a:xfrm>
-            <a:off x="868680" y="3831336"/>
-            <a:ext cx="10515600" cy="493776"/>
+            <a:off x="868680" y="4379976"/>
+            <a:ext cx="10515600" cy="512064"/>
           </a:xfrm>
           <a:prstGeom prst="rect">
             <a:avLst/>
@@ -3964,7 +3964,7 @@
               </a:defRPr>
             </a:pPr>
             <a:r>
-              <a:t>OpenBLAS is the one BLAS and LAPACK today. Cray LibSci is already on the path on the Cray systems, and Intel systems expect MKL. Both are registered rather than built, so this is policy per system, not build cost.</a:t>
+              <a:t>Build every lane at the portable baseline, prove the model, then turn on per-lane tuning for Genoa, Milan, or Cascade Lake. Each target is a flag plus a full rebuild, so the open part is when, not whether.</a:t>
             </a:r>
           </a:p>
         </p:txBody>
@@ -3977,8 +3977,8 @@
         </p:nvSpPr>
         <p:spPr>
           <a:xfrm>
-            <a:off x="548640" y="4425696"/>
-            <a:ext cx="11091672" cy="896112"/>
+            <a:off x="548640" y="5111496"/>
+            <a:ext cx="11091672" cy="1024128"/>
           </a:xfrm>
           <a:prstGeom prst="roundRect">
             <a:avLst/>
@@ -4021,7 +4021,7 @@
         </p:nvSpPr>
         <p:spPr>
           <a:xfrm>
-            <a:off x="868680" y="4517136"/>
+            <a:off x="868680" y="5239512"/>
             <a:ext cx="10515600" cy="274320"/>
           </a:xfrm>
           <a:prstGeom prst="rect">
@@ -4038,13 +4038,13 @@
             <a:pPr algn="l">
               <a:defRPr sz="1300" b="1">
                 <a:solidFill>
-                  <a:srgbClr val="6D4EAA"/>
-                </a:solidFill>
-                <a:latin typeface="Avenir Next"/>
-              </a:defRPr>
-            </a:pPr>
-            <a:r>
-              <a:t>Performance targeting: baseline first, tuning after.</a:t>
+                  <a:srgbClr val="9A7614"/>
+                </a:solidFill>
+                <a:latin typeface="Avenir Next"/>
+              </a:defRPr>
+            </a:pPr>
+            <a:r>
+              <a:t>What does consistency promise across systems?</a:t>
             </a:r>
           </a:p>
         </p:txBody>
@@ -4057,124 +4057,8 @@
         </p:nvSpPr>
         <p:spPr>
           <a:xfrm>
-            <a:off x="868680" y="4800600"/>
-            <a:ext cx="10515600" cy="493776"/>
-          </a:xfrm>
-          <a:prstGeom prst="rect">
-            <a:avLst/>
-          </a:prstGeom>
-          <a:noFill/>
-        </p:spPr>
-        <p:txBody>
-          <a:bodyPr wrap="square" anchor="t">
-            <a:spAutoFit/>
-          </a:bodyPr>
-          <a:lstStyle/>
-          <a:p>
-            <a:pPr algn="l">
-              <a:defRPr sz="1050" b="0">
-                <a:solidFill>
-                  <a:srgbClr val="6E7B90"/>
-                </a:solidFill>
-                <a:latin typeface="Avenir Next"/>
-              </a:defRPr>
-            </a:pPr>
-            <a:r>
-              <a:t>Build every lane at the portable baseline, prove the model, then turn on per-lane tuning for Genoa, Milan, or Cascade Lake. Each target is a flag plus a full rebuild, so the open part is when, not whether.</a:t>
-            </a:r>
-          </a:p>
-        </p:txBody>
-      </p:sp>
-      <p:sp>
-        <p:nvSpPr>
-          <p:cNvPr id="17" name="Rounded Rectangle 16"/>
-          <p:cNvSpPr/>
-          <p:nvPr/>
-        </p:nvSpPr>
-        <p:spPr>
-          <a:xfrm>
-            <a:off x="548640" y="5394960"/>
-            <a:ext cx="11091672" cy="896112"/>
-          </a:xfrm>
-          <a:prstGeom prst="roundRect">
-            <a:avLst/>
-          </a:prstGeom>
-          <a:solidFill>
-            <a:srgbClr val="F2F4F7"/>
-          </a:solidFill>
-          <a:ln>
-            <a:noFill/>
-          </a:ln>
-          <a:effectLst/>
-        </p:spPr>
-        <p:style>
-          <a:lnRef idx="1">
-            <a:schemeClr val="accent1"/>
-          </a:lnRef>
-          <a:fillRef idx="3">
-            <a:schemeClr val="accent1"/>
-          </a:fillRef>
-          <a:effectRef idx="2">
-            <a:schemeClr val="accent1"/>
-          </a:effectRef>
-          <a:fontRef idx="minor">
-            <a:schemeClr val="lt1"/>
-          </a:fontRef>
-        </p:style>
-        <p:txBody>
-          <a:bodyPr rtlCol="0" anchor="ctr"/>
-          <a:lstStyle/>
-          <a:p>
-            <a:pPr algn="ctr"/>
-          </a:p>
-        </p:txBody>
-      </p:sp>
-      <p:sp>
-        <p:nvSpPr>
-          <p:cNvPr id="18" name="TextBox 17"/>
-          <p:cNvSpPr txBox="1"/>
-          <p:nvPr/>
-        </p:nvSpPr>
-        <p:spPr>
-          <a:xfrm>
-            <a:off x="868680" y="5486400"/>
-            <a:ext cx="10515600" cy="274320"/>
-          </a:xfrm>
-          <a:prstGeom prst="rect">
-            <a:avLst/>
-          </a:prstGeom>
-          <a:noFill/>
-        </p:spPr>
-        <p:txBody>
-          <a:bodyPr wrap="square" anchor="t">
-            <a:spAutoFit/>
-          </a:bodyPr>
-          <a:lstStyle/>
-          <a:p>
-            <a:pPr algn="l">
-              <a:defRPr sz="1300" b="1">
-                <a:solidFill>
-                  <a:srgbClr val="9A7614"/>
-                </a:solidFill>
-                <a:latin typeface="Avenir Next"/>
-              </a:defRPr>
-            </a:pPr>
-            <a:r>
-              <a:t>What does consistency promise across systems?</a:t>
-            </a:r>
-          </a:p>
-        </p:txBody>
-      </p:sp>
-      <p:sp>
-        <p:nvSpPr>
-          <p:cNvPr id="19" name="TextBox 18"/>
-          <p:cNvSpPr txBox="1"/>
-          <p:nvPr/>
-        </p:nvSpPr>
-        <p:spPr>
-          <a:xfrm>
-            <a:off x="868680" y="5769864"/>
-            <a:ext cx="10515600" cy="493776"/>
+            <a:off x="868680" y="5550408"/>
+            <a:ext cx="10515600" cy="512064"/>
           </a:xfrm>
           <a:prstGeom prst="rect">
             <a:avLst/>
@@ -4294,7 +4178,7 @@
               </a:defRPr>
             </a:pPr>
             <a:r>
-              <a:t>DISCUSSION · STARTER QUESTIONS FOR THE BUILD</a:t>
+              <a:t>SETUP · WHAT BLOCKS THE FIRST BUILD</a:t>
             </a:r>
           </a:p>
         </p:txBody>
@@ -4446,7 +4330,7 @@
               </a:defRPr>
             </a:pPr>
             <a:r>
-              <a:t>It comes first, because everything else on the system is built with it. Each machine's own compiler, one shared version across systems, or a mix?</a:t>
+              <a:t>It comes first, because everything else on the system is built with it: each machine's own compiler, one shared version across systems, or a mix. Whether Intel stays a surface where it still exists is part of this.</a:t>
             </a:r>
           </a:p>
         </p:txBody>

</xml_diff>